<commit_message>
Add editable project roadmap slide
Co-authored-by: arena-agent <297053741+arena-agent@users.noreply.github.com>
</commit_message>
<xml_diff>
--- a/midterm-report/presentation/中美外语院系英文简介_5分钟汇报.pptx
+++ b/midterm-report/presentation/中美外语院系英文简介_5分钟汇报.pptx
@@ -6,6 +6,7 @@
   </p:sldMasterIdLst>
   <p:sldIdLst>
     <p:sldId id="256" r:id="rId7"/>
+    <p:sldId id="257" r:id="rId8"/>
   </p:sldIdLst>
   <p:sldSz cx="12191695" cy="6858000" type="screen4x3"/>
   <p:notesSz cx="6858000" cy="9144000"/>
@@ -4992,6 +4993,2904 @@
                 <a:latin typeface="Microsoft YaHei"/>
               </a:rPr>
               <a:t>01 / 07</a:t>
+            </a:r>
+          </a:p>
+        </p:txBody>
+      </p:sp>
+    </p:spTree>
+  </p:cSld>
+  <p:clrMapOvr>
+    <a:masterClrMapping/>
+  </p:clrMapOvr>
+</p:sld>
+</file>
+
+<file path=ppt/slides/slide2.xml><?xml version="1.0" encoding="utf-8"?>
+<p:sld xmlns:a="http://schemas.openxmlformats.org/drawingml/2006/main" xmlns:p="http://schemas.openxmlformats.org/presentationml/2006/main" xmlns:r="http://schemas.openxmlformats.org/officeDocument/2006/relationships">
+  <p:cSld>
+    <p:spTree>
+      <p:nvGrpSpPr>
+        <p:cNvPr id="1" name=""/>
+        <p:cNvGrpSpPr/>
+        <p:nvPr/>
+      </p:nvGrpSpPr>
+      <p:grpSpPr/>
+      <p:sp>
+        <p:nvSpPr>
+          <p:cNvPr id="2" name="Rectangle 1"/>
+          <p:cNvSpPr/>
+          <p:nvPr/>
+        </p:nvSpPr>
+        <p:spPr>
+          <a:xfrm>
+            <a:off x="0" y="0"/>
+            <a:ext cx="12191695" cy="6858000"/>
+          </a:xfrm>
+          <a:prstGeom prst="rect">
+            <a:avLst/>
+          </a:prstGeom>
+          <a:solidFill>
+            <a:srgbClr val="F7F9FC"/>
+          </a:solidFill>
+          <a:ln>
+            <a:noFill/>
+          </a:ln>
+        </p:spPr>
+        <p:style>
+          <a:lnRef idx="1">
+            <a:schemeClr val="accent1"/>
+          </a:lnRef>
+          <a:fillRef idx="3">
+            <a:schemeClr val="accent1"/>
+          </a:fillRef>
+          <a:effectRef idx="2">
+            <a:schemeClr val="accent1"/>
+          </a:effectRef>
+          <a:fontRef idx="minor">
+            <a:schemeClr val="lt1"/>
+          </a:fontRef>
+        </p:style>
+        <p:txBody>
+          <a:bodyPr rtlCol="0" anchor="ctr"/>
+          <a:lstStyle/>
+          <a:p>
+            <a:pPr algn="ctr"/>
+          </a:p>
+        </p:txBody>
+      </p:sp>
+      <p:sp>
+        <p:nvSpPr>
+          <p:cNvPr id="3" name="Rectangle 2"/>
+          <p:cNvSpPr/>
+          <p:nvPr/>
+        </p:nvSpPr>
+        <p:spPr>
+          <a:xfrm>
+            <a:off x="0" y="0"/>
+            <a:ext cx="146304" cy="6858000"/>
+          </a:xfrm>
+          <a:prstGeom prst="rect">
+            <a:avLst/>
+          </a:prstGeom>
+          <a:solidFill>
+            <a:srgbClr val="17324D"/>
+          </a:solidFill>
+          <a:ln>
+            <a:noFill/>
+          </a:ln>
+        </p:spPr>
+        <p:style>
+          <a:lnRef idx="1">
+            <a:schemeClr val="accent1"/>
+          </a:lnRef>
+          <a:fillRef idx="3">
+            <a:schemeClr val="accent1"/>
+          </a:fillRef>
+          <a:effectRef idx="2">
+            <a:schemeClr val="accent1"/>
+          </a:effectRef>
+          <a:fontRef idx="minor">
+            <a:schemeClr val="lt1"/>
+          </a:fontRef>
+        </p:style>
+        <p:txBody>
+          <a:bodyPr rtlCol="0" anchor="ctr"/>
+          <a:lstStyle/>
+          <a:p>
+            <a:pPr algn="ctr"/>
+          </a:p>
+        </p:txBody>
+      </p:sp>
+      <p:sp>
+        <p:nvSpPr>
+          <p:cNvPr id="4" name="Rectangle 3"/>
+          <p:cNvSpPr/>
+          <p:nvPr/>
+        </p:nvSpPr>
+        <p:spPr>
+          <a:xfrm>
+            <a:off x="146304" y="0"/>
+            <a:ext cx="50292" cy="841248"/>
+          </a:xfrm>
+          <a:prstGeom prst="rect">
+            <a:avLst/>
+          </a:prstGeom>
+          <a:solidFill>
+            <a:srgbClr val="E38B36"/>
+          </a:solidFill>
+          <a:ln>
+            <a:noFill/>
+          </a:ln>
+        </p:spPr>
+        <p:style>
+          <a:lnRef idx="1">
+            <a:schemeClr val="accent1"/>
+          </a:lnRef>
+          <a:fillRef idx="3">
+            <a:schemeClr val="accent1"/>
+          </a:fillRef>
+          <a:effectRef idx="2">
+            <a:schemeClr val="accent1"/>
+          </a:effectRef>
+          <a:fontRef idx="minor">
+            <a:schemeClr val="lt1"/>
+          </a:fontRef>
+        </p:style>
+        <p:txBody>
+          <a:bodyPr rtlCol="0" anchor="ctr"/>
+          <a:lstStyle/>
+          <a:p>
+            <a:pPr algn="ctr"/>
+          </a:p>
+        </p:txBody>
+      </p:sp>
+      <p:sp>
+        <p:nvSpPr>
+          <p:cNvPr id="5" name="TextBox 4"/>
+          <p:cNvSpPr txBox="1"/>
+          <p:nvPr/>
+        </p:nvSpPr>
+        <p:spPr>
+          <a:xfrm>
+            <a:off x="731520" y="438912"/>
+            <a:ext cx="2926080" cy="274320"/>
+          </a:xfrm>
+          <a:prstGeom prst="rect">
+            <a:avLst/>
+          </a:prstGeom>
+          <a:noFill/>
+        </p:spPr>
+        <p:txBody>
+          <a:bodyPr wrap="square" lIns="0" rIns="0" tIns="0" bIns="0" anchor="t">
+            <a:spAutoFit/>
+          </a:bodyPr>
+          <a:lstStyle/>
+          <a:p>
+            <a:pPr algn="l">
+              <a:spcBef>
+                <a:spcPts val="0"/>
+              </a:spcBef>
+              <a:spcAft>
+                <a:spcPts val="0"/>
+              </a:spcAft>
+            </a:pPr>
+            <a:r>
+              <a:rPr sz="1100" b="1">
+                <a:solidFill>
+                  <a:srgbClr val="3568A8"/>
+                </a:solidFill>
+                <a:latin typeface="Microsoft YaHei"/>
+              </a:rPr>
+              <a:t>01　项目概览</a:t>
+            </a:r>
+          </a:p>
+        </p:txBody>
+      </p:sp>
+      <p:sp>
+        <p:nvSpPr>
+          <p:cNvPr id="6" name="TextBox 5"/>
+          <p:cNvSpPr txBox="1"/>
+          <p:nvPr/>
+        </p:nvSpPr>
+        <p:spPr>
+          <a:xfrm>
+            <a:off x="731520" y="768096"/>
+            <a:ext cx="5852160" cy="475488"/>
+          </a:xfrm>
+          <a:prstGeom prst="rect">
+            <a:avLst/>
+          </a:prstGeom>
+          <a:noFill/>
+        </p:spPr>
+        <p:txBody>
+          <a:bodyPr wrap="square" lIns="0" rIns="0" tIns="0" bIns="0" anchor="t">
+            <a:spAutoFit/>
+          </a:bodyPr>
+          <a:lstStyle/>
+          <a:p>
+            <a:pPr algn="l">
+              <a:spcBef>
+                <a:spcPts val="0"/>
+              </a:spcBef>
+              <a:spcAft>
+                <a:spcPts val="0"/>
+              </a:spcAft>
+            </a:pPr>
+            <a:r>
+              <a:rPr sz="2600" b="1">
+                <a:solidFill>
+                  <a:srgbClr val="17324D"/>
+                </a:solidFill>
+                <a:latin typeface="Microsoft YaHei"/>
+              </a:rPr>
+              <a:t>项目整体路线</a:t>
+            </a:r>
+          </a:p>
+        </p:txBody>
+      </p:sp>
+      <p:sp>
+        <p:nvSpPr>
+          <p:cNvPr id="7" name="TextBox 6"/>
+          <p:cNvSpPr txBox="1"/>
+          <p:nvPr/>
+        </p:nvSpPr>
+        <p:spPr>
+          <a:xfrm>
+            <a:off x="731520" y="1307592"/>
+            <a:ext cx="10515600" cy="384048"/>
+          </a:xfrm>
+          <a:prstGeom prst="rect">
+            <a:avLst/>
+          </a:prstGeom>
+          <a:noFill/>
+        </p:spPr>
+        <p:txBody>
+          <a:bodyPr wrap="square" lIns="0" rIns="0" tIns="0" bIns="0" anchor="ctr">
+            <a:spAutoFit/>
+          </a:bodyPr>
+          <a:lstStyle/>
+          <a:p>
+            <a:pPr algn="l">
+              <a:spcBef>
+                <a:spcPts val="0"/>
+              </a:spcBef>
+              <a:spcAft>
+                <a:spcPts val="0"/>
+              </a:spcAft>
+            </a:pPr>
+            <a:r>
+              <a:rPr sz="1400" b="0">
+                <a:solidFill>
+                  <a:srgbClr val="23364A"/>
+                </a:solidFill>
+                <a:latin typeface="Microsoft YaHei"/>
+              </a:rPr>
+              <a:t>定量比较已完成，下一阶段由“描述差异”转向“解释差异与策略转化”</a:t>
+            </a:r>
+          </a:p>
+        </p:txBody>
+      </p:sp>
+      <p:sp>
+        <p:nvSpPr>
+          <p:cNvPr id="8" name="Rectangle 7"/>
+          <p:cNvSpPr/>
+          <p:nvPr/>
+        </p:nvSpPr>
+        <p:spPr>
+          <a:xfrm>
+            <a:off x="731520" y="1773936"/>
+            <a:ext cx="594360" cy="41148"/>
+          </a:xfrm>
+          <a:prstGeom prst="rect">
+            <a:avLst/>
+          </a:prstGeom>
+          <a:solidFill>
+            <a:srgbClr val="E38B36"/>
+          </a:solidFill>
+          <a:ln>
+            <a:noFill/>
+          </a:ln>
+        </p:spPr>
+        <p:style>
+          <a:lnRef idx="1">
+            <a:schemeClr val="accent1"/>
+          </a:lnRef>
+          <a:fillRef idx="3">
+            <a:schemeClr val="accent1"/>
+          </a:fillRef>
+          <a:effectRef idx="2">
+            <a:schemeClr val="accent1"/>
+          </a:effectRef>
+          <a:fontRef idx="minor">
+            <a:schemeClr val="lt1"/>
+          </a:fontRef>
+        </p:style>
+        <p:txBody>
+          <a:bodyPr rtlCol="0" anchor="ctr"/>
+          <a:lstStyle/>
+          <a:p>
+            <a:pPr algn="ctr"/>
+          </a:p>
+        </p:txBody>
+      </p:sp>
+      <p:sp>
+        <p:nvSpPr>
+          <p:cNvPr id="9" name="Oval 8"/>
+          <p:cNvSpPr/>
+          <p:nvPr/>
+        </p:nvSpPr>
+        <p:spPr>
+          <a:xfrm>
+            <a:off x="9354312" y="521207"/>
+            <a:ext cx="109728" cy="109728"/>
+          </a:xfrm>
+          <a:prstGeom prst="ellipse">
+            <a:avLst/>
+          </a:prstGeom>
+          <a:solidFill>
+            <a:srgbClr val="3568A8"/>
+          </a:solidFill>
+          <a:ln>
+            <a:noFill/>
+          </a:ln>
+        </p:spPr>
+        <p:style>
+          <a:lnRef idx="1">
+            <a:schemeClr val="accent1"/>
+          </a:lnRef>
+          <a:fillRef idx="3">
+            <a:schemeClr val="accent1"/>
+          </a:fillRef>
+          <a:effectRef idx="2">
+            <a:schemeClr val="accent1"/>
+          </a:effectRef>
+          <a:fontRef idx="minor">
+            <a:schemeClr val="lt1"/>
+          </a:fontRef>
+        </p:style>
+        <p:txBody>
+          <a:bodyPr rtlCol="0" anchor="ctr"/>
+          <a:lstStyle/>
+          <a:p>
+            <a:pPr algn="ctr"/>
+          </a:p>
+        </p:txBody>
+      </p:sp>
+      <p:sp>
+        <p:nvSpPr>
+          <p:cNvPr id="10" name="TextBox 9"/>
+          <p:cNvSpPr txBox="1"/>
+          <p:nvPr/>
+        </p:nvSpPr>
+        <p:spPr>
+          <a:xfrm>
+            <a:off x="9528048" y="448056"/>
+            <a:ext cx="713232" cy="256032"/>
+          </a:xfrm>
+          <a:prstGeom prst="rect">
+            <a:avLst/>
+          </a:prstGeom>
+          <a:noFill/>
+        </p:spPr>
+        <p:txBody>
+          <a:bodyPr wrap="square" lIns="0" rIns="0" tIns="0" bIns="0" anchor="ctr">
+            <a:spAutoFit/>
+          </a:bodyPr>
+          <a:lstStyle/>
+          <a:p>
+            <a:pPr algn="l">
+              <a:spcBef>
+                <a:spcPts val="0"/>
+              </a:spcBef>
+              <a:spcAft>
+                <a:spcPts val="0"/>
+              </a:spcAft>
+            </a:pPr>
+            <a:r>
+              <a:rPr sz="1000" b="0">
+                <a:solidFill>
+                  <a:srgbClr val="62748A"/>
+                </a:solidFill>
+                <a:latin typeface="Microsoft YaHei"/>
+              </a:rPr>
+              <a:t>已完成</a:t>
+            </a:r>
+          </a:p>
+        </p:txBody>
+      </p:sp>
+      <p:sp>
+        <p:nvSpPr>
+          <p:cNvPr id="11" name="Oval 10"/>
+          <p:cNvSpPr/>
+          <p:nvPr/>
+        </p:nvSpPr>
+        <p:spPr>
+          <a:xfrm>
+            <a:off x="10360152" y="521207"/>
+            <a:ext cx="109728" cy="109728"/>
+          </a:xfrm>
+          <a:prstGeom prst="ellipse">
+            <a:avLst/>
+          </a:prstGeom>
+          <a:solidFill>
+            <a:srgbClr val="E38B36"/>
+          </a:solidFill>
+          <a:ln>
+            <a:noFill/>
+          </a:ln>
+        </p:spPr>
+        <p:style>
+          <a:lnRef idx="1">
+            <a:schemeClr val="accent1"/>
+          </a:lnRef>
+          <a:fillRef idx="3">
+            <a:schemeClr val="accent1"/>
+          </a:fillRef>
+          <a:effectRef idx="2">
+            <a:schemeClr val="accent1"/>
+          </a:effectRef>
+          <a:fontRef idx="minor">
+            <a:schemeClr val="lt1"/>
+          </a:fontRef>
+        </p:style>
+        <p:txBody>
+          <a:bodyPr rtlCol="0" anchor="ctr"/>
+          <a:lstStyle/>
+          <a:p>
+            <a:pPr algn="ctr"/>
+          </a:p>
+        </p:txBody>
+      </p:sp>
+      <p:sp>
+        <p:nvSpPr>
+          <p:cNvPr id="12" name="TextBox 11"/>
+          <p:cNvSpPr txBox="1"/>
+          <p:nvPr/>
+        </p:nvSpPr>
+        <p:spPr>
+          <a:xfrm>
+            <a:off x="10533888" y="448056"/>
+            <a:ext cx="932688" cy="256032"/>
+          </a:xfrm>
+          <a:prstGeom prst="rect">
+            <a:avLst/>
+          </a:prstGeom>
+          <a:noFill/>
+        </p:spPr>
+        <p:txBody>
+          <a:bodyPr wrap="square" lIns="0" rIns="0" tIns="0" bIns="0" anchor="ctr">
+            <a:spAutoFit/>
+          </a:bodyPr>
+          <a:lstStyle/>
+          <a:p>
+            <a:pPr algn="l">
+              <a:spcBef>
+                <a:spcPts val="0"/>
+              </a:spcBef>
+              <a:spcAft>
+                <a:spcPts val="0"/>
+              </a:spcAft>
+            </a:pPr>
+            <a:r>
+              <a:rPr sz="1000" b="0">
+                <a:solidFill>
+                  <a:srgbClr val="62748A"/>
+                </a:solidFill>
+                <a:latin typeface="Microsoft YaHei"/>
+              </a:rPr>
+              <a:t>下一阶段</a:t>
+            </a:r>
+          </a:p>
+        </p:txBody>
+      </p:sp>
+      <p:sp>
+        <p:nvSpPr>
+          <p:cNvPr id="13" name="Rounded Rectangle 12"/>
+          <p:cNvSpPr/>
+          <p:nvPr/>
+        </p:nvSpPr>
+        <p:spPr>
+          <a:xfrm>
+            <a:off x="731520" y="2011680"/>
+            <a:ext cx="1901952" cy="3200400"/>
+          </a:xfrm>
+          <a:prstGeom prst="roundRect">
+            <a:avLst/>
+          </a:prstGeom>
+          <a:solidFill>
+            <a:srgbClr val="FFFFFF"/>
+          </a:solidFill>
+          <a:ln w="10160">
+            <a:solidFill>
+              <a:srgbClr val="D8E1EB"/>
+            </a:solidFill>
+          </a:ln>
+        </p:spPr>
+        <p:style>
+          <a:lnRef idx="1">
+            <a:schemeClr val="accent1"/>
+          </a:lnRef>
+          <a:fillRef idx="3">
+            <a:schemeClr val="accent1"/>
+          </a:fillRef>
+          <a:effectRef idx="2">
+            <a:schemeClr val="accent1"/>
+          </a:effectRef>
+          <a:fontRef idx="minor">
+            <a:schemeClr val="lt1"/>
+          </a:fontRef>
+        </p:style>
+        <p:txBody>
+          <a:bodyPr rtlCol="0" anchor="ctr"/>
+          <a:lstStyle/>
+          <a:p>
+            <a:pPr algn="ctr"/>
+          </a:p>
+        </p:txBody>
+      </p:sp>
+      <p:sp>
+        <p:nvSpPr>
+          <p:cNvPr id="14" name="Rectangle 13"/>
+          <p:cNvSpPr/>
+          <p:nvPr/>
+        </p:nvSpPr>
+        <p:spPr>
+          <a:xfrm>
+            <a:off x="731520" y="2011680"/>
+            <a:ext cx="1901952" cy="64008"/>
+          </a:xfrm>
+          <a:prstGeom prst="rect">
+            <a:avLst/>
+          </a:prstGeom>
+          <a:solidFill>
+            <a:srgbClr val="3568A8"/>
+          </a:solidFill>
+          <a:ln>
+            <a:noFill/>
+          </a:ln>
+        </p:spPr>
+        <p:style>
+          <a:lnRef idx="1">
+            <a:schemeClr val="accent1"/>
+          </a:lnRef>
+          <a:fillRef idx="3">
+            <a:schemeClr val="accent1"/>
+          </a:fillRef>
+          <a:effectRef idx="2">
+            <a:schemeClr val="accent1"/>
+          </a:effectRef>
+          <a:fontRef idx="minor">
+            <a:schemeClr val="lt1"/>
+          </a:fontRef>
+        </p:style>
+        <p:txBody>
+          <a:bodyPr rtlCol="0" anchor="ctr"/>
+          <a:lstStyle/>
+          <a:p>
+            <a:pPr algn="ctr"/>
+          </a:p>
+        </p:txBody>
+      </p:sp>
+      <p:sp>
+        <p:nvSpPr>
+          <p:cNvPr id="15" name="Rounded Rectangle 14"/>
+          <p:cNvSpPr/>
+          <p:nvPr/>
+        </p:nvSpPr>
+        <p:spPr>
+          <a:xfrm>
+            <a:off x="896112" y="2240280"/>
+            <a:ext cx="658368" cy="274320"/>
+          </a:xfrm>
+          <a:prstGeom prst="roundRect">
+            <a:avLst/>
+          </a:prstGeom>
+          <a:solidFill>
+            <a:srgbClr val="EAF1F8"/>
+          </a:solidFill>
+          <a:ln>
+            <a:noFill/>
+          </a:ln>
+        </p:spPr>
+        <p:style>
+          <a:lnRef idx="1">
+            <a:schemeClr val="accent1"/>
+          </a:lnRef>
+          <a:fillRef idx="3">
+            <a:schemeClr val="accent1"/>
+          </a:fillRef>
+          <a:effectRef idx="2">
+            <a:schemeClr val="accent1"/>
+          </a:effectRef>
+          <a:fontRef idx="minor">
+            <a:schemeClr val="lt1"/>
+          </a:fontRef>
+        </p:style>
+        <p:txBody>
+          <a:bodyPr rtlCol="0" anchor="ctr"/>
+          <a:lstStyle/>
+          <a:p>
+            <a:pPr algn="ctr"/>
+          </a:p>
+        </p:txBody>
+      </p:sp>
+      <p:sp>
+        <p:nvSpPr>
+          <p:cNvPr id="16" name="TextBox 15"/>
+          <p:cNvSpPr txBox="1"/>
+          <p:nvPr/>
+        </p:nvSpPr>
+        <p:spPr>
+          <a:xfrm>
+            <a:off x="896112" y="2240280"/>
+            <a:ext cx="658368" cy="274320"/>
+          </a:xfrm>
+          <a:prstGeom prst="rect">
+            <a:avLst/>
+          </a:prstGeom>
+          <a:noFill/>
+        </p:spPr>
+        <p:txBody>
+          <a:bodyPr wrap="square" lIns="0" rIns="0" tIns="0" bIns="0" anchor="ctr">
+            <a:spAutoFit/>
+          </a:bodyPr>
+          <a:lstStyle/>
+          <a:p>
+            <a:pPr algn="ctr">
+              <a:spcBef>
+                <a:spcPts val="0"/>
+              </a:spcBef>
+              <a:spcAft>
+                <a:spcPts val="0"/>
+              </a:spcAft>
+            </a:pPr>
+            <a:r>
+              <a:rPr sz="900" b="1">
+                <a:solidFill>
+                  <a:srgbClr val="3568A8"/>
+                </a:solidFill>
+                <a:latin typeface="Microsoft YaHei"/>
+              </a:rPr>
+              <a:t>已完成</a:t>
+            </a:r>
+          </a:p>
+        </p:txBody>
+      </p:sp>
+      <p:sp>
+        <p:nvSpPr>
+          <p:cNvPr id="17" name="TextBox 16"/>
+          <p:cNvSpPr txBox="1"/>
+          <p:nvPr/>
+        </p:nvSpPr>
+        <p:spPr>
+          <a:xfrm>
+            <a:off x="896112" y="2679192"/>
+            <a:ext cx="1143000" cy="493776"/>
+          </a:xfrm>
+          <a:prstGeom prst="rect">
+            <a:avLst/>
+          </a:prstGeom>
+          <a:noFill/>
+        </p:spPr>
+        <p:txBody>
+          <a:bodyPr wrap="square" lIns="0" rIns="0" tIns="0" bIns="0" anchor="t">
+            <a:spAutoFit/>
+          </a:bodyPr>
+          <a:lstStyle/>
+          <a:p>
+            <a:pPr algn="l">
+              <a:spcBef>
+                <a:spcPts val="0"/>
+              </a:spcBef>
+              <a:spcAft>
+                <a:spcPts val="0"/>
+              </a:spcAft>
+            </a:pPr>
+            <a:r>
+              <a:rPr sz="2700" b="1">
+                <a:solidFill>
+                  <a:srgbClr val="3568A8"/>
+                </a:solidFill>
+                <a:latin typeface="Microsoft YaHei"/>
+              </a:rPr>
+              <a:t>01</a:t>
+            </a:r>
+          </a:p>
+        </p:txBody>
+      </p:sp>
+      <p:sp>
+        <p:nvSpPr>
+          <p:cNvPr id="18" name="TextBox 17"/>
+          <p:cNvSpPr txBox="1"/>
+          <p:nvPr/>
+        </p:nvSpPr>
+        <p:spPr>
+          <a:xfrm>
+            <a:off x="896112" y="3264408"/>
+            <a:ext cx="1581912" cy="384048"/>
+          </a:xfrm>
+          <a:prstGeom prst="rect">
+            <a:avLst/>
+          </a:prstGeom>
+          <a:noFill/>
+        </p:spPr>
+        <p:txBody>
+          <a:bodyPr wrap="square" lIns="0" rIns="0" tIns="0" bIns="0" anchor="ctr">
+            <a:spAutoFit/>
+          </a:bodyPr>
+          <a:lstStyle/>
+          <a:p>
+            <a:pPr algn="l">
+              <a:spcBef>
+                <a:spcPts val="0"/>
+              </a:spcBef>
+              <a:spcAft>
+                <a:spcPts val="0"/>
+              </a:spcAft>
+            </a:pPr>
+            <a:r>
+              <a:rPr sz="1600" b="1">
+                <a:solidFill>
+                  <a:srgbClr val="17324D"/>
+                </a:solidFill>
+                <a:latin typeface="Microsoft YaHei"/>
+              </a:rPr>
+              <a:t>语料构建</a:t>
+            </a:r>
+          </a:p>
+        </p:txBody>
+      </p:sp>
+      <p:sp>
+        <p:nvSpPr>
+          <p:cNvPr id="19" name="TextBox 18"/>
+          <p:cNvSpPr txBox="1"/>
+          <p:nvPr/>
+        </p:nvSpPr>
+        <p:spPr>
+          <a:xfrm>
+            <a:off x="896112" y="3822191"/>
+            <a:ext cx="1581912" cy="786384"/>
+          </a:xfrm>
+          <a:prstGeom prst="rect">
+            <a:avLst/>
+          </a:prstGeom>
+          <a:noFill/>
+        </p:spPr>
+        <p:txBody>
+          <a:bodyPr wrap="square" lIns="0" rIns="0" tIns="0" bIns="0" anchor="t">
+            <a:spAutoFit/>
+          </a:bodyPr>
+          <a:lstStyle/>
+          <a:p>
+            <a:pPr algn="l">
+              <a:spcBef>
+                <a:spcPts val="0"/>
+              </a:spcBef>
+              <a:spcAft>
+                <a:spcPts val="0"/>
+              </a:spcAft>
+            </a:pPr>
+            <a:r>
+              <a:rPr sz="1100" b="0">
+                <a:solidFill>
+                  <a:srgbClr val="62748A"/>
+                </a:solidFill>
+                <a:latin typeface="Microsoft YaHei"/>
+              </a:rPr>
+              <a:t>中国、美国各30个</a:t>
+            </a:r>
+          </a:p>
+          <a:p>
+            <a:pPr algn="l">
+              <a:spcBef>
+                <a:spcPts val="0"/>
+              </a:spcBef>
+              <a:spcAft>
+                <a:spcPts val="0"/>
+              </a:spcAft>
+            </a:pPr>
+            <a:r>
+              <a:rPr sz="1100" b="0">
+                <a:solidFill>
+                  <a:srgbClr val="62748A"/>
+                </a:solidFill>
+                <a:latin typeface="Microsoft YaHei"/>
+              </a:rPr>
+              <a:t>外语院系英文简介</a:t>
+            </a:r>
+          </a:p>
+        </p:txBody>
+      </p:sp>
+      <p:cxnSp>
+        <p:nvCxnSpPr>
+          <p:cNvPr id="20" name="Connector 19"/>
+          <p:cNvCxnSpPr/>
+          <p:nvPr/>
+        </p:nvCxnSpPr>
+        <p:spPr>
+          <a:xfrm>
+            <a:off x="896112" y="4690872"/>
+            <a:ext cx="1572768" cy="0"/>
+          </a:xfrm>
+          <a:prstGeom prst="line">
+            <a:avLst/>
+          </a:prstGeom>
+          <a:ln w="10160">
+            <a:solidFill>
+              <a:srgbClr val="D8E1EB"/>
+            </a:solidFill>
+          </a:ln>
+        </p:spPr>
+        <p:style>
+          <a:lnRef idx="2">
+            <a:schemeClr val="accent1"/>
+          </a:lnRef>
+          <a:fillRef idx="0">
+            <a:schemeClr val="accent1"/>
+          </a:fillRef>
+          <a:effectRef idx="1">
+            <a:schemeClr val="accent1"/>
+          </a:effectRef>
+          <a:fontRef idx="minor">
+            <a:schemeClr val="tx1"/>
+          </a:fontRef>
+        </p:style>
+      </p:cxnSp>
+      <p:sp>
+        <p:nvSpPr>
+          <p:cNvPr id="21" name="TextBox 20"/>
+          <p:cNvSpPr txBox="1"/>
+          <p:nvPr/>
+        </p:nvSpPr>
+        <p:spPr>
+          <a:xfrm>
+            <a:off x="896112" y="4809744"/>
+            <a:ext cx="1581912" cy="256032"/>
+          </a:xfrm>
+          <a:prstGeom prst="rect">
+            <a:avLst/>
+          </a:prstGeom>
+          <a:noFill/>
+        </p:spPr>
+        <p:txBody>
+          <a:bodyPr wrap="square" lIns="0" rIns="0" tIns="0" bIns="0" anchor="ctr">
+            <a:spAutoFit/>
+          </a:bodyPr>
+          <a:lstStyle/>
+          <a:p>
+            <a:pPr algn="l">
+              <a:spcBef>
+                <a:spcPts val="0"/>
+              </a:spcBef>
+              <a:spcAft>
+                <a:spcPts val="0"/>
+              </a:spcAft>
+            </a:pPr>
+            <a:r>
+              <a:rPr sz="1000" b="1">
+                <a:solidFill>
+                  <a:srgbClr val="3568A8"/>
+                </a:solidFill>
+                <a:latin typeface="Microsoft YaHei"/>
+              </a:rPr>
+              <a:t>60个院系文本</a:t>
+            </a:r>
+          </a:p>
+        </p:txBody>
+      </p:sp>
+      <p:sp>
+        <p:nvSpPr>
+          <p:cNvPr id="22" name="Rounded Rectangle 21"/>
+          <p:cNvSpPr/>
+          <p:nvPr/>
+        </p:nvSpPr>
+        <p:spPr>
+          <a:xfrm>
+            <a:off x="2907792" y="2011680"/>
+            <a:ext cx="1901952" cy="3200400"/>
+          </a:xfrm>
+          <a:prstGeom prst="roundRect">
+            <a:avLst/>
+          </a:prstGeom>
+          <a:solidFill>
+            <a:srgbClr val="FFFFFF"/>
+          </a:solidFill>
+          <a:ln w="10160">
+            <a:solidFill>
+              <a:srgbClr val="D8E1EB"/>
+            </a:solidFill>
+          </a:ln>
+        </p:spPr>
+        <p:style>
+          <a:lnRef idx="1">
+            <a:schemeClr val="accent1"/>
+          </a:lnRef>
+          <a:fillRef idx="3">
+            <a:schemeClr val="accent1"/>
+          </a:fillRef>
+          <a:effectRef idx="2">
+            <a:schemeClr val="accent1"/>
+          </a:effectRef>
+          <a:fontRef idx="minor">
+            <a:schemeClr val="lt1"/>
+          </a:fontRef>
+        </p:style>
+        <p:txBody>
+          <a:bodyPr rtlCol="0" anchor="ctr"/>
+          <a:lstStyle/>
+          <a:p>
+            <a:pPr algn="ctr"/>
+          </a:p>
+        </p:txBody>
+      </p:sp>
+      <p:sp>
+        <p:nvSpPr>
+          <p:cNvPr id="23" name="Rectangle 22"/>
+          <p:cNvSpPr/>
+          <p:nvPr/>
+        </p:nvSpPr>
+        <p:spPr>
+          <a:xfrm>
+            <a:off x="2907792" y="2011680"/>
+            <a:ext cx="1901952" cy="64008"/>
+          </a:xfrm>
+          <a:prstGeom prst="rect">
+            <a:avLst/>
+          </a:prstGeom>
+          <a:solidFill>
+            <a:srgbClr val="3568A8"/>
+          </a:solidFill>
+          <a:ln>
+            <a:noFill/>
+          </a:ln>
+        </p:spPr>
+        <p:style>
+          <a:lnRef idx="1">
+            <a:schemeClr val="accent1"/>
+          </a:lnRef>
+          <a:fillRef idx="3">
+            <a:schemeClr val="accent1"/>
+          </a:fillRef>
+          <a:effectRef idx="2">
+            <a:schemeClr val="accent1"/>
+          </a:effectRef>
+          <a:fontRef idx="minor">
+            <a:schemeClr val="lt1"/>
+          </a:fontRef>
+        </p:style>
+        <p:txBody>
+          <a:bodyPr rtlCol="0" anchor="ctr"/>
+          <a:lstStyle/>
+          <a:p>
+            <a:pPr algn="ctr"/>
+          </a:p>
+        </p:txBody>
+      </p:sp>
+      <p:sp>
+        <p:nvSpPr>
+          <p:cNvPr id="24" name="Rounded Rectangle 23"/>
+          <p:cNvSpPr/>
+          <p:nvPr/>
+        </p:nvSpPr>
+        <p:spPr>
+          <a:xfrm>
+            <a:off x="3072384" y="2240280"/>
+            <a:ext cx="658368" cy="274320"/>
+          </a:xfrm>
+          <a:prstGeom prst="roundRect">
+            <a:avLst/>
+          </a:prstGeom>
+          <a:solidFill>
+            <a:srgbClr val="EAF1F8"/>
+          </a:solidFill>
+          <a:ln>
+            <a:noFill/>
+          </a:ln>
+        </p:spPr>
+        <p:style>
+          <a:lnRef idx="1">
+            <a:schemeClr val="accent1"/>
+          </a:lnRef>
+          <a:fillRef idx="3">
+            <a:schemeClr val="accent1"/>
+          </a:fillRef>
+          <a:effectRef idx="2">
+            <a:schemeClr val="accent1"/>
+          </a:effectRef>
+          <a:fontRef idx="minor">
+            <a:schemeClr val="lt1"/>
+          </a:fontRef>
+        </p:style>
+        <p:txBody>
+          <a:bodyPr rtlCol="0" anchor="ctr"/>
+          <a:lstStyle/>
+          <a:p>
+            <a:pPr algn="ctr"/>
+          </a:p>
+        </p:txBody>
+      </p:sp>
+      <p:sp>
+        <p:nvSpPr>
+          <p:cNvPr id="25" name="TextBox 24"/>
+          <p:cNvSpPr txBox="1"/>
+          <p:nvPr/>
+        </p:nvSpPr>
+        <p:spPr>
+          <a:xfrm>
+            <a:off x="3072384" y="2240280"/>
+            <a:ext cx="658368" cy="274320"/>
+          </a:xfrm>
+          <a:prstGeom prst="rect">
+            <a:avLst/>
+          </a:prstGeom>
+          <a:noFill/>
+        </p:spPr>
+        <p:txBody>
+          <a:bodyPr wrap="square" lIns="0" rIns="0" tIns="0" bIns="0" anchor="ctr">
+            <a:spAutoFit/>
+          </a:bodyPr>
+          <a:lstStyle/>
+          <a:p>
+            <a:pPr algn="ctr">
+              <a:spcBef>
+                <a:spcPts val="0"/>
+              </a:spcBef>
+              <a:spcAft>
+                <a:spcPts val="0"/>
+              </a:spcAft>
+            </a:pPr>
+            <a:r>
+              <a:rPr sz="900" b="1">
+                <a:solidFill>
+                  <a:srgbClr val="3568A8"/>
+                </a:solidFill>
+                <a:latin typeface="Microsoft YaHei"/>
+              </a:rPr>
+              <a:t>已完成</a:t>
+            </a:r>
+          </a:p>
+        </p:txBody>
+      </p:sp>
+      <p:sp>
+        <p:nvSpPr>
+          <p:cNvPr id="26" name="TextBox 25"/>
+          <p:cNvSpPr txBox="1"/>
+          <p:nvPr/>
+        </p:nvSpPr>
+        <p:spPr>
+          <a:xfrm>
+            <a:off x="3072384" y="2679192"/>
+            <a:ext cx="1143000" cy="493776"/>
+          </a:xfrm>
+          <a:prstGeom prst="rect">
+            <a:avLst/>
+          </a:prstGeom>
+          <a:noFill/>
+        </p:spPr>
+        <p:txBody>
+          <a:bodyPr wrap="square" lIns="0" rIns="0" tIns="0" bIns="0" anchor="t">
+            <a:spAutoFit/>
+          </a:bodyPr>
+          <a:lstStyle/>
+          <a:p>
+            <a:pPr algn="l">
+              <a:spcBef>
+                <a:spcPts val="0"/>
+              </a:spcBef>
+              <a:spcAft>
+                <a:spcPts val="0"/>
+              </a:spcAft>
+            </a:pPr>
+            <a:r>
+              <a:rPr sz="2700" b="1">
+                <a:solidFill>
+                  <a:srgbClr val="3568A8"/>
+                </a:solidFill>
+                <a:latin typeface="Microsoft YaHei"/>
+              </a:rPr>
+              <a:t>02</a:t>
+            </a:r>
+          </a:p>
+        </p:txBody>
+      </p:sp>
+      <p:sp>
+        <p:nvSpPr>
+          <p:cNvPr id="27" name="TextBox 26"/>
+          <p:cNvSpPr txBox="1"/>
+          <p:nvPr/>
+        </p:nvSpPr>
+        <p:spPr>
+          <a:xfrm>
+            <a:off x="3072384" y="3264408"/>
+            <a:ext cx="1581912" cy="384048"/>
+          </a:xfrm>
+          <a:prstGeom prst="rect">
+            <a:avLst/>
+          </a:prstGeom>
+          <a:noFill/>
+        </p:spPr>
+        <p:txBody>
+          <a:bodyPr wrap="square" lIns="0" rIns="0" tIns="0" bIns="0" anchor="ctr">
+            <a:spAutoFit/>
+          </a:bodyPr>
+          <a:lstStyle/>
+          <a:p>
+            <a:pPr algn="l">
+              <a:spcBef>
+                <a:spcPts val="0"/>
+              </a:spcBef>
+              <a:spcAft>
+                <a:spcPts val="0"/>
+              </a:spcAft>
+            </a:pPr>
+            <a:r>
+              <a:rPr sz="1600" b="1">
+                <a:solidFill>
+                  <a:srgbClr val="17324D"/>
+                </a:solidFill>
+                <a:latin typeface="Microsoft YaHei"/>
+              </a:rPr>
+              <a:t>框架与校订</a:t>
+            </a:r>
+          </a:p>
+        </p:txBody>
+      </p:sp>
+      <p:sp>
+        <p:nvSpPr>
+          <p:cNvPr id="28" name="TextBox 27"/>
+          <p:cNvSpPr txBox="1"/>
+          <p:nvPr/>
+        </p:nvSpPr>
+        <p:spPr>
+          <a:xfrm>
+            <a:off x="3072384" y="3822191"/>
+            <a:ext cx="1581912" cy="786384"/>
+          </a:xfrm>
+          <a:prstGeom prst="rect">
+            <a:avLst/>
+          </a:prstGeom>
+          <a:noFill/>
+        </p:spPr>
+        <p:txBody>
+          <a:bodyPr wrap="square" lIns="0" rIns="0" tIns="0" bIns="0" anchor="t">
+            <a:spAutoFit/>
+          </a:bodyPr>
+          <a:lstStyle/>
+          <a:p>
+            <a:pPr algn="l">
+              <a:spcBef>
+                <a:spcPts val="0"/>
+              </a:spcBef>
+              <a:spcAft>
+                <a:spcPts val="0"/>
+              </a:spcAft>
+            </a:pPr>
+            <a:r>
+              <a:rPr sz="1100" b="0">
+                <a:solidFill>
+                  <a:srgbClr val="62748A"/>
+                </a:solidFill>
+                <a:latin typeface="Microsoft YaHei"/>
+              </a:rPr>
+              <a:t>AI预标注</a:t>
+            </a:r>
+          </a:p>
+          <a:p>
+            <a:pPr algn="l">
+              <a:spcBef>
+                <a:spcPts val="0"/>
+              </a:spcBef>
+              <a:spcAft>
+                <a:spcPts val="0"/>
+              </a:spcAft>
+            </a:pPr>
+            <a:r>
+              <a:rPr sz="1100" b="0">
+                <a:solidFill>
+                  <a:srgbClr val="62748A"/>
+                </a:solidFill>
+                <a:latin typeface="Microsoft YaHei"/>
+              </a:rPr>
+              <a:t>人工逐篇校订</a:t>
+            </a:r>
+          </a:p>
+        </p:txBody>
+      </p:sp>
+      <p:cxnSp>
+        <p:nvCxnSpPr>
+          <p:cNvPr id="29" name="Connector 28"/>
+          <p:cNvCxnSpPr/>
+          <p:nvPr/>
+        </p:nvCxnSpPr>
+        <p:spPr>
+          <a:xfrm>
+            <a:off x="3072384" y="4690872"/>
+            <a:ext cx="1572768" cy="0"/>
+          </a:xfrm>
+          <a:prstGeom prst="line">
+            <a:avLst/>
+          </a:prstGeom>
+          <a:ln w="10160">
+            <a:solidFill>
+              <a:srgbClr val="D8E1EB"/>
+            </a:solidFill>
+          </a:ln>
+        </p:spPr>
+        <p:style>
+          <a:lnRef idx="2">
+            <a:schemeClr val="accent1"/>
+          </a:lnRef>
+          <a:fillRef idx="0">
+            <a:schemeClr val="accent1"/>
+          </a:fillRef>
+          <a:effectRef idx="1">
+            <a:schemeClr val="accent1"/>
+          </a:effectRef>
+          <a:fontRef idx="minor">
+            <a:schemeClr val="tx1"/>
+          </a:fontRef>
+        </p:style>
+      </p:cxnSp>
+      <p:sp>
+        <p:nvSpPr>
+          <p:cNvPr id="30" name="TextBox 29"/>
+          <p:cNvSpPr txBox="1"/>
+          <p:nvPr/>
+        </p:nvSpPr>
+        <p:spPr>
+          <a:xfrm>
+            <a:off x="3072384" y="4809744"/>
+            <a:ext cx="1581912" cy="256032"/>
+          </a:xfrm>
+          <a:prstGeom prst="rect">
+            <a:avLst/>
+          </a:prstGeom>
+          <a:noFill/>
+        </p:spPr>
+        <p:txBody>
+          <a:bodyPr wrap="square" lIns="0" rIns="0" tIns="0" bIns="0" anchor="ctr">
+            <a:spAutoFit/>
+          </a:bodyPr>
+          <a:lstStyle/>
+          <a:p>
+            <a:pPr algn="l">
+              <a:spcBef>
+                <a:spcPts val="0"/>
+              </a:spcBef>
+              <a:spcAft>
+                <a:spcPts val="0"/>
+              </a:spcAft>
+            </a:pPr>
+            <a:r>
+              <a:rPr sz="1000" b="1">
+                <a:solidFill>
+                  <a:srgbClr val="3568A8"/>
+                </a:solidFill>
+                <a:latin typeface="Microsoft YaHei"/>
+              </a:rPr>
+              <a:t>10个核心语步</a:t>
+            </a:r>
+          </a:p>
+        </p:txBody>
+      </p:sp>
+      <p:sp>
+        <p:nvSpPr>
+          <p:cNvPr id="31" name="Rounded Rectangle 30"/>
+          <p:cNvSpPr/>
+          <p:nvPr/>
+        </p:nvSpPr>
+        <p:spPr>
+          <a:xfrm>
+            <a:off x="5084064" y="2011680"/>
+            <a:ext cx="1901952" cy="3200400"/>
+          </a:xfrm>
+          <a:prstGeom prst="roundRect">
+            <a:avLst/>
+          </a:prstGeom>
+          <a:solidFill>
+            <a:srgbClr val="FFFFFF"/>
+          </a:solidFill>
+          <a:ln w="10160">
+            <a:solidFill>
+              <a:srgbClr val="D8E1EB"/>
+            </a:solidFill>
+          </a:ln>
+        </p:spPr>
+        <p:style>
+          <a:lnRef idx="1">
+            <a:schemeClr val="accent1"/>
+          </a:lnRef>
+          <a:fillRef idx="3">
+            <a:schemeClr val="accent1"/>
+          </a:fillRef>
+          <a:effectRef idx="2">
+            <a:schemeClr val="accent1"/>
+          </a:effectRef>
+          <a:fontRef idx="minor">
+            <a:schemeClr val="lt1"/>
+          </a:fontRef>
+        </p:style>
+        <p:txBody>
+          <a:bodyPr rtlCol="0" anchor="ctr"/>
+          <a:lstStyle/>
+          <a:p>
+            <a:pPr algn="ctr"/>
+          </a:p>
+        </p:txBody>
+      </p:sp>
+      <p:sp>
+        <p:nvSpPr>
+          <p:cNvPr id="32" name="Rectangle 31"/>
+          <p:cNvSpPr/>
+          <p:nvPr/>
+        </p:nvSpPr>
+        <p:spPr>
+          <a:xfrm>
+            <a:off x="5084064" y="2011680"/>
+            <a:ext cx="1901952" cy="64008"/>
+          </a:xfrm>
+          <a:prstGeom prst="rect">
+            <a:avLst/>
+          </a:prstGeom>
+          <a:solidFill>
+            <a:srgbClr val="3568A8"/>
+          </a:solidFill>
+          <a:ln>
+            <a:noFill/>
+          </a:ln>
+        </p:spPr>
+        <p:style>
+          <a:lnRef idx="1">
+            <a:schemeClr val="accent1"/>
+          </a:lnRef>
+          <a:fillRef idx="3">
+            <a:schemeClr val="accent1"/>
+          </a:fillRef>
+          <a:effectRef idx="2">
+            <a:schemeClr val="accent1"/>
+          </a:effectRef>
+          <a:fontRef idx="minor">
+            <a:schemeClr val="lt1"/>
+          </a:fontRef>
+        </p:style>
+        <p:txBody>
+          <a:bodyPr rtlCol="0" anchor="ctr"/>
+          <a:lstStyle/>
+          <a:p>
+            <a:pPr algn="ctr"/>
+          </a:p>
+        </p:txBody>
+      </p:sp>
+      <p:sp>
+        <p:nvSpPr>
+          <p:cNvPr id="33" name="Rounded Rectangle 32"/>
+          <p:cNvSpPr/>
+          <p:nvPr/>
+        </p:nvSpPr>
+        <p:spPr>
+          <a:xfrm>
+            <a:off x="5248655" y="2240280"/>
+            <a:ext cx="658368" cy="274320"/>
+          </a:xfrm>
+          <a:prstGeom prst="roundRect">
+            <a:avLst/>
+          </a:prstGeom>
+          <a:solidFill>
+            <a:srgbClr val="EAF1F8"/>
+          </a:solidFill>
+          <a:ln>
+            <a:noFill/>
+          </a:ln>
+        </p:spPr>
+        <p:style>
+          <a:lnRef idx="1">
+            <a:schemeClr val="accent1"/>
+          </a:lnRef>
+          <a:fillRef idx="3">
+            <a:schemeClr val="accent1"/>
+          </a:fillRef>
+          <a:effectRef idx="2">
+            <a:schemeClr val="accent1"/>
+          </a:effectRef>
+          <a:fontRef idx="minor">
+            <a:schemeClr val="lt1"/>
+          </a:fontRef>
+        </p:style>
+        <p:txBody>
+          <a:bodyPr rtlCol="0" anchor="ctr"/>
+          <a:lstStyle/>
+          <a:p>
+            <a:pPr algn="ctr"/>
+          </a:p>
+        </p:txBody>
+      </p:sp>
+      <p:sp>
+        <p:nvSpPr>
+          <p:cNvPr id="34" name="TextBox 33"/>
+          <p:cNvSpPr txBox="1"/>
+          <p:nvPr/>
+        </p:nvSpPr>
+        <p:spPr>
+          <a:xfrm>
+            <a:off x="5248655" y="2240280"/>
+            <a:ext cx="658368" cy="274320"/>
+          </a:xfrm>
+          <a:prstGeom prst="rect">
+            <a:avLst/>
+          </a:prstGeom>
+          <a:noFill/>
+        </p:spPr>
+        <p:txBody>
+          <a:bodyPr wrap="square" lIns="0" rIns="0" tIns="0" bIns="0" anchor="ctr">
+            <a:spAutoFit/>
+          </a:bodyPr>
+          <a:lstStyle/>
+          <a:p>
+            <a:pPr algn="ctr">
+              <a:spcBef>
+                <a:spcPts val="0"/>
+              </a:spcBef>
+              <a:spcAft>
+                <a:spcPts val="0"/>
+              </a:spcAft>
+            </a:pPr>
+            <a:r>
+              <a:rPr sz="900" b="1">
+                <a:solidFill>
+                  <a:srgbClr val="3568A8"/>
+                </a:solidFill>
+                <a:latin typeface="Microsoft YaHei"/>
+              </a:rPr>
+              <a:t>已完成</a:t>
+            </a:r>
+          </a:p>
+        </p:txBody>
+      </p:sp>
+      <p:sp>
+        <p:nvSpPr>
+          <p:cNvPr id="35" name="TextBox 34"/>
+          <p:cNvSpPr txBox="1"/>
+          <p:nvPr/>
+        </p:nvSpPr>
+        <p:spPr>
+          <a:xfrm>
+            <a:off x="5248655" y="2679192"/>
+            <a:ext cx="1143000" cy="493776"/>
+          </a:xfrm>
+          <a:prstGeom prst="rect">
+            <a:avLst/>
+          </a:prstGeom>
+          <a:noFill/>
+        </p:spPr>
+        <p:txBody>
+          <a:bodyPr wrap="square" lIns="0" rIns="0" tIns="0" bIns="0" anchor="t">
+            <a:spAutoFit/>
+          </a:bodyPr>
+          <a:lstStyle/>
+          <a:p>
+            <a:pPr algn="l">
+              <a:spcBef>
+                <a:spcPts val="0"/>
+              </a:spcBef>
+              <a:spcAft>
+                <a:spcPts val="0"/>
+              </a:spcAft>
+            </a:pPr>
+            <a:r>
+              <a:rPr sz="2700" b="1">
+                <a:solidFill>
+                  <a:srgbClr val="3568A8"/>
+                </a:solidFill>
+                <a:latin typeface="Microsoft YaHei"/>
+              </a:rPr>
+              <a:t>03</a:t>
+            </a:r>
+          </a:p>
+        </p:txBody>
+      </p:sp>
+      <p:sp>
+        <p:nvSpPr>
+          <p:cNvPr id="36" name="TextBox 35"/>
+          <p:cNvSpPr txBox="1"/>
+          <p:nvPr/>
+        </p:nvSpPr>
+        <p:spPr>
+          <a:xfrm>
+            <a:off x="5248655" y="3264408"/>
+            <a:ext cx="1581912" cy="384048"/>
+          </a:xfrm>
+          <a:prstGeom prst="rect">
+            <a:avLst/>
+          </a:prstGeom>
+          <a:noFill/>
+        </p:spPr>
+        <p:txBody>
+          <a:bodyPr wrap="square" lIns="0" rIns="0" tIns="0" bIns="0" anchor="ctr">
+            <a:spAutoFit/>
+          </a:bodyPr>
+          <a:lstStyle/>
+          <a:p>
+            <a:pPr algn="l">
+              <a:spcBef>
+                <a:spcPts val="0"/>
+              </a:spcBef>
+              <a:spcAft>
+                <a:spcPts val="0"/>
+              </a:spcAft>
+            </a:pPr>
+            <a:r>
+              <a:rPr sz="1600" b="1">
+                <a:solidFill>
+                  <a:srgbClr val="17324D"/>
+                </a:solidFill>
+                <a:latin typeface="Microsoft YaHei"/>
+              </a:rPr>
+              <a:t>语步分布</a:t>
+            </a:r>
+          </a:p>
+        </p:txBody>
+      </p:sp>
+      <p:sp>
+        <p:nvSpPr>
+          <p:cNvPr id="37" name="TextBox 36"/>
+          <p:cNvSpPr txBox="1"/>
+          <p:nvPr/>
+        </p:nvSpPr>
+        <p:spPr>
+          <a:xfrm>
+            <a:off x="5248655" y="3822191"/>
+            <a:ext cx="1581912" cy="786384"/>
+          </a:xfrm>
+          <a:prstGeom prst="rect">
+            <a:avLst/>
+          </a:prstGeom>
+          <a:noFill/>
+        </p:spPr>
+        <p:txBody>
+          <a:bodyPr wrap="square" lIns="0" rIns="0" tIns="0" bIns="0" anchor="t">
+            <a:spAutoFit/>
+          </a:bodyPr>
+          <a:lstStyle/>
+          <a:p>
+            <a:pPr algn="l">
+              <a:spcBef>
+                <a:spcPts val="0"/>
+              </a:spcBef>
+              <a:spcAft>
+                <a:spcPts val="0"/>
+              </a:spcAft>
+            </a:pPr>
+            <a:r>
+              <a:rPr sz="1100" b="0">
+                <a:solidFill>
+                  <a:srgbClr val="62748A"/>
+                </a:solidFill>
+                <a:latin typeface="Microsoft YaHei"/>
+              </a:rPr>
+              <a:t>出现率 · 篇幅</a:t>
+            </a:r>
+          </a:p>
+          <a:p>
+            <a:pPr algn="l">
+              <a:spcBef>
+                <a:spcPts val="0"/>
+              </a:spcBef>
+              <a:spcAft>
+                <a:spcPts val="0"/>
+              </a:spcAft>
+            </a:pPr>
+            <a:r>
+              <a:rPr sz="1100" b="0">
+                <a:solidFill>
+                  <a:srgbClr val="62748A"/>
+                </a:solidFill>
+                <a:latin typeface="Microsoft YaHei"/>
+              </a:rPr>
+              <a:t>开篇位置</a:t>
+            </a:r>
+          </a:p>
+        </p:txBody>
+      </p:sp>
+      <p:cxnSp>
+        <p:nvCxnSpPr>
+          <p:cNvPr id="38" name="Connector 37"/>
+          <p:cNvCxnSpPr/>
+          <p:nvPr/>
+        </p:nvCxnSpPr>
+        <p:spPr>
+          <a:xfrm>
+            <a:off x="5248655" y="4690872"/>
+            <a:ext cx="1572768" cy="0"/>
+          </a:xfrm>
+          <a:prstGeom prst="line">
+            <a:avLst/>
+          </a:prstGeom>
+          <a:ln w="10160">
+            <a:solidFill>
+              <a:srgbClr val="D8E1EB"/>
+            </a:solidFill>
+          </a:ln>
+        </p:spPr>
+        <p:style>
+          <a:lnRef idx="2">
+            <a:schemeClr val="accent1"/>
+          </a:lnRef>
+          <a:fillRef idx="0">
+            <a:schemeClr val="accent1"/>
+          </a:fillRef>
+          <a:effectRef idx="1">
+            <a:schemeClr val="accent1"/>
+          </a:effectRef>
+          <a:fontRef idx="minor">
+            <a:schemeClr val="tx1"/>
+          </a:fontRef>
+        </p:style>
+      </p:cxnSp>
+      <p:sp>
+        <p:nvSpPr>
+          <p:cNvPr id="39" name="TextBox 38"/>
+          <p:cNvSpPr txBox="1"/>
+          <p:nvPr/>
+        </p:nvSpPr>
+        <p:spPr>
+          <a:xfrm>
+            <a:off x="5248655" y="4809744"/>
+            <a:ext cx="1581912" cy="256032"/>
+          </a:xfrm>
+          <a:prstGeom prst="rect">
+            <a:avLst/>
+          </a:prstGeom>
+          <a:noFill/>
+        </p:spPr>
+        <p:txBody>
+          <a:bodyPr wrap="square" lIns="0" rIns="0" tIns="0" bIns="0" anchor="ctr">
+            <a:spAutoFit/>
+          </a:bodyPr>
+          <a:lstStyle/>
+          <a:p>
+            <a:pPr algn="l">
+              <a:spcBef>
+                <a:spcPts val="0"/>
+              </a:spcBef>
+              <a:spcAft>
+                <a:spcPts val="0"/>
+              </a:spcAft>
+            </a:pPr>
+            <a:r>
+              <a:rPr sz="1000" b="1">
+                <a:solidFill>
+                  <a:srgbClr val="3568A8"/>
+                </a:solidFill>
+                <a:latin typeface="Microsoft YaHei"/>
+              </a:rPr>
+              <a:t>比较结构组织</a:t>
+            </a:r>
+          </a:p>
+        </p:txBody>
+      </p:sp>
+      <p:sp>
+        <p:nvSpPr>
+          <p:cNvPr id="40" name="Rounded Rectangle 39"/>
+          <p:cNvSpPr/>
+          <p:nvPr/>
+        </p:nvSpPr>
+        <p:spPr>
+          <a:xfrm>
+            <a:off x="7260336" y="2011680"/>
+            <a:ext cx="1901952" cy="3200400"/>
+          </a:xfrm>
+          <a:prstGeom prst="roundRect">
+            <a:avLst/>
+          </a:prstGeom>
+          <a:solidFill>
+            <a:srgbClr val="FFFFFF"/>
+          </a:solidFill>
+          <a:ln w="10160">
+            <a:solidFill>
+              <a:srgbClr val="D8E1EB"/>
+            </a:solidFill>
+          </a:ln>
+        </p:spPr>
+        <p:style>
+          <a:lnRef idx="1">
+            <a:schemeClr val="accent1"/>
+          </a:lnRef>
+          <a:fillRef idx="3">
+            <a:schemeClr val="accent1"/>
+          </a:fillRef>
+          <a:effectRef idx="2">
+            <a:schemeClr val="accent1"/>
+          </a:effectRef>
+          <a:fontRef idx="minor">
+            <a:schemeClr val="lt1"/>
+          </a:fontRef>
+        </p:style>
+        <p:txBody>
+          <a:bodyPr rtlCol="0" anchor="ctr"/>
+          <a:lstStyle/>
+          <a:p>
+            <a:pPr algn="ctr"/>
+          </a:p>
+        </p:txBody>
+      </p:sp>
+      <p:sp>
+        <p:nvSpPr>
+          <p:cNvPr id="41" name="Rectangle 40"/>
+          <p:cNvSpPr/>
+          <p:nvPr/>
+        </p:nvSpPr>
+        <p:spPr>
+          <a:xfrm>
+            <a:off x="7260336" y="2011680"/>
+            <a:ext cx="1901952" cy="64008"/>
+          </a:xfrm>
+          <a:prstGeom prst="rect">
+            <a:avLst/>
+          </a:prstGeom>
+          <a:solidFill>
+            <a:srgbClr val="3568A8"/>
+          </a:solidFill>
+          <a:ln>
+            <a:noFill/>
+          </a:ln>
+        </p:spPr>
+        <p:style>
+          <a:lnRef idx="1">
+            <a:schemeClr val="accent1"/>
+          </a:lnRef>
+          <a:fillRef idx="3">
+            <a:schemeClr val="accent1"/>
+          </a:fillRef>
+          <a:effectRef idx="2">
+            <a:schemeClr val="accent1"/>
+          </a:effectRef>
+          <a:fontRef idx="minor">
+            <a:schemeClr val="lt1"/>
+          </a:fontRef>
+        </p:style>
+        <p:txBody>
+          <a:bodyPr rtlCol="0" anchor="ctr"/>
+          <a:lstStyle/>
+          <a:p>
+            <a:pPr algn="ctr"/>
+          </a:p>
+        </p:txBody>
+      </p:sp>
+      <p:sp>
+        <p:nvSpPr>
+          <p:cNvPr id="42" name="Rounded Rectangle 41"/>
+          <p:cNvSpPr/>
+          <p:nvPr/>
+        </p:nvSpPr>
+        <p:spPr>
+          <a:xfrm>
+            <a:off x="7424928" y="2240280"/>
+            <a:ext cx="658368" cy="274320"/>
+          </a:xfrm>
+          <a:prstGeom prst="roundRect">
+            <a:avLst/>
+          </a:prstGeom>
+          <a:solidFill>
+            <a:srgbClr val="EAF1F8"/>
+          </a:solidFill>
+          <a:ln>
+            <a:noFill/>
+          </a:ln>
+        </p:spPr>
+        <p:style>
+          <a:lnRef idx="1">
+            <a:schemeClr val="accent1"/>
+          </a:lnRef>
+          <a:fillRef idx="3">
+            <a:schemeClr val="accent1"/>
+          </a:fillRef>
+          <a:effectRef idx="2">
+            <a:schemeClr val="accent1"/>
+          </a:effectRef>
+          <a:fontRef idx="minor">
+            <a:schemeClr val="lt1"/>
+          </a:fontRef>
+        </p:style>
+        <p:txBody>
+          <a:bodyPr rtlCol="0" anchor="ctr"/>
+          <a:lstStyle/>
+          <a:p>
+            <a:pPr algn="ctr"/>
+          </a:p>
+        </p:txBody>
+      </p:sp>
+      <p:sp>
+        <p:nvSpPr>
+          <p:cNvPr id="43" name="TextBox 42"/>
+          <p:cNvSpPr txBox="1"/>
+          <p:nvPr/>
+        </p:nvSpPr>
+        <p:spPr>
+          <a:xfrm>
+            <a:off x="7424928" y="2240280"/>
+            <a:ext cx="658368" cy="274320"/>
+          </a:xfrm>
+          <a:prstGeom prst="rect">
+            <a:avLst/>
+          </a:prstGeom>
+          <a:noFill/>
+        </p:spPr>
+        <p:txBody>
+          <a:bodyPr wrap="square" lIns="0" rIns="0" tIns="0" bIns="0" anchor="ctr">
+            <a:spAutoFit/>
+          </a:bodyPr>
+          <a:lstStyle/>
+          <a:p>
+            <a:pPr algn="ctr">
+              <a:spcBef>
+                <a:spcPts val="0"/>
+              </a:spcBef>
+              <a:spcAft>
+                <a:spcPts val="0"/>
+              </a:spcAft>
+            </a:pPr>
+            <a:r>
+              <a:rPr sz="900" b="1">
+                <a:solidFill>
+                  <a:srgbClr val="3568A8"/>
+                </a:solidFill>
+                <a:latin typeface="Microsoft YaHei"/>
+              </a:rPr>
+              <a:t>已完成</a:t>
+            </a:r>
+          </a:p>
+        </p:txBody>
+      </p:sp>
+      <p:sp>
+        <p:nvSpPr>
+          <p:cNvPr id="44" name="TextBox 43"/>
+          <p:cNvSpPr txBox="1"/>
+          <p:nvPr/>
+        </p:nvSpPr>
+        <p:spPr>
+          <a:xfrm>
+            <a:off x="7424928" y="2679192"/>
+            <a:ext cx="1143000" cy="493776"/>
+          </a:xfrm>
+          <a:prstGeom prst="rect">
+            <a:avLst/>
+          </a:prstGeom>
+          <a:noFill/>
+        </p:spPr>
+        <p:txBody>
+          <a:bodyPr wrap="square" lIns="0" rIns="0" tIns="0" bIns="0" anchor="t">
+            <a:spAutoFit/>
+          </a:bodyPr>
+          <a:lstStyle/>
+          <a:p>
+            <a:pPr algn="l">
+              <a:spcBef>
+                <a:spcPts val="0"/>
+              </a:spcBef>
+              <a:spcAft>
+                <a:spcPts val="0"/>
+              </a:spcAft>
+            </a:pPr>
+            <a:r>
+              <a:rPr sz="2700" b="1">
+                <a:solidFill>
+                  <a:srgbClr val="3568A8"/>
+                </a:solidFill>
+                <a:latin typeface="Microsoft YaHei"/>
+              </a:rPr>
+              <a:t>04</a:t>
+            </a:r>
+          </a:p>
+        </p:txBody>
+      </p:sp>
+      <p:sp>
+        <p:nvSpPr>
+          <p:cNvPr id="45" name="TextBox 44"/>
+          <p:cNvSpPr txBox="1"/>
+          <p:nvPr/>
+        </p:nvSpPr>
+        <p:spPr>
+          <a:xfrm>
+            <a:off x="7424928" y="3264408"/>
+            <a:ext cx="1581912" cy="384048"/>
+          </a:xfrm>
+          <a:prstGeom prst="rect">
+            <a:avLst/>
+          </a:prstGeom>
+          <a:noFill/>
+        </p:spPr>
+        <p:txBody>
+          <a:bodyPr wrap="square" lIns="0" rIns="0" tIns="0" bIns="0" anchor="ctr">
+            <a:spAutoFit/>
+          </a:bodyPr>
+          <a:lstStyle/>
+          <a:p>
+            <a:pPr algn="l">
+              <a:spcBef>
+                <a:spcPts val="0"/>
+              </a:spcBef>
+              <a:spcAft>
+                <a:spcPts val="0"/>
+              </a:spcAft>
+            </a:pPr>
+            <a:r>
+              <a:rPr sz="1600" b="1">
+                <a:solidFill>
+                  <a:srgbClr val="17324D"/>
+                </a:solidFill>
+                <a:latin typeface="Microsoft YaHei"/>
+              </a:rPr>
+              <a:t>语言实现</a:t>
+            </a:r>
+          </a:p>
+        </p:txBody>
+      </p:sp>
+      <p:sp>
+        <p:nvSpPr>
+          <p:cNvPr id="46" name="TextBox 45"/>
+          <p:cNvSpPr txBox="1"/>
+          <p:nvPr/>
+        </p:nvSpPr>
+        <p:spPr>
+          <a:xfrm>
+            <a:off x="7424928" y="3822191"/>
+            <a:ext cx="1581912" cy="786384"/>
+          </a:xfrm>
+          <a:prstGeom prst="rect">
+            <a:avLst/>
+          </a:prstGeom>
+          <a:noFill/>
+        </p:spPr>
+        <p:txBody>
+          <a:bodyPr wrap="square" lIns="0" rIns="0" tIns="0" bIns="0" anchor="t">
+            <a:spAutoFit/>
+          </a:bodyPr>
+          <a:lstStyle/>
+          <a:p>
+            <a:pPr algn="l">
+              <a:spcBef>
+                <a:spcPts val="0"/>
+              </a:spcBef>
+              <a:spcAft>
+                <a:spcPts val="0"/>
+              </a:spcAft>
+            </a:pPr>
+            <a:r>
+              <a:rPr sz="1100" b="0">
+                <a:solidFill>
+                  <a:srgbClr val="62748A"/>
+                </a:solidFill>
+                <a:latin typeface="Microsoft YaHei"/>
+              </a:rPr>
+              <a:t>关键词 · 词丛</a:t>
+            </a:r>
+          </a:p>
+          <a:p>
+            <a:pPr algn="l">
+              <a:spcBef>
+                <a:spcPts val="0"/>
+              </a:spcBef>
+              <a:spcAft>
+                <a:spcPts val="0"/>
+              </a:spcAft>
+            </a:pPr>
+            <a:r>
+              <a:rPr sz="1100" b="0">
+                <a:solidFill>
+                  <a:srgbClr val="62748A"/>
+                </a:solidFill>
+                <a:latin typeface="Microsoft YaHei"/>
+              </a:rPr>
+              <a:t>搭配与语义组</a:t>
+            </a:r>
+          </a:p>
+        </p:txBody>
+      </p:sp>
+      <p:cxnSp>
+        <p:nvCxnSpPr>
+          <p:cNvPr id="47" name="Connector 46"/>
+          <p:cNvCxnSpPr/>
+          <p:nvPr/>
+        </p:nvCxnSpPr>
+        <p:spPr>
+          <a:xfrm>
+            <a:off x="7424928" y="4690872"/>
+            <a:ext cx="1572768" cy="0"/>
+          </a:xfrm>
+          <a:prstGeom prst="line">
+            <a:avLst/>
+          </a:prstGeom>
+          <a:ln w="10160">
+            <a:solidFill>
+              <a:srgbClr val="D8E1EB"/>
+            </a:solidFill>
+          </a:ln>
+        </p:spPr>
+        <p:style>
+          <a:lnRef idx="2">
+            <a:schemeClr val="accent1"/>
+          </a:lnRef>
+          <a:fillRef idx="0">
+            <a:schemeClr val="accent1"/>
+          </a:fillRef>
+          <a:effectRef idx="1">
+            <a:schemeClr val="accent1"/>
+          </a:effectRef>
+          <a:fontRef idx="minor">
+            <a:schemeClr val="tx1"/>
+          </a:fontRef>
+        </p:style>
+      </p:cxnSp>
+      <p:sp>
+        <p:nvSpPr>
+          <p:cNvPr id="48" name="TextBox 47"/>
+          <p:cNvSpPr txBox="1"/>
+          <p:nvPr/>
+        </p:nvSpPr>
+        <p:spPr>
+          <a:xfrm>
+            <a:off x="7424928" y="4809744"/>
+            <a:ext cx="1581912" cy="256032"/>
+          </a:xfrm>
+          <a:prstGeom prst="rect">
+            <a:avLst/>
+          </a:prstGeom>
+          <a:noFill/>
+        </p:spPr>
+        <p:txBody>
+          <a:bodyPr wrap="square" lIns="0" rIns="0" tIns="0" bIns="0" anchor="ctr">
+            <a:spAutoFit/>
+          </a:bodyPr>
+          <a:lstStyle/>
+          <a:p>
+            <a:pPr algn="l">
+              <a:spcBef>
+                <a:spcPts val="0"/>
+              </a:spcBef>
+              <a:spcAft>
+                <a:spcPts val="0"/>
+              </a:spcAft>
+            </a:pPr>
+            <a:r>
+              <a:rPr sz="1000" b="1">
+                <a:solidFill>
+                  <a:srgbClr val="3568A8"/>
+                </a:solidFill>
+                <a:latin typeface="Microsoft YaHei"/>
+              </a:rPr>
+              <a:t>聚焦4个核心语步</a:t>
+            </a:r>
+          </a:p>
+        </p:txBody>
+      </p:sp>
+      <p:sp>
+        <p:nvSpPr>
+          <p:cNvPr id="49" name="Rounded Rectangle 48"/>
+          <p:cNvSpPr/>
+          <p:nvPr/>
+        </p:nvSpPr>
+        <p:spPr>
+          <a:xfrm>
+            <a:off x="9436608" y="2011680"/>
+            <a:ext cx="1901952" cy="3200400"/>
+          </a:xfrm>
+          <a:prstGeom prst="roundRect">
+            <a:avLst/>
+          </a:prstGeom>
+          <a:solidFill>
+            <a:srgbClr val="FFF3E5"/>
+          </a:solidFill>
+          <a:ln w="12700">
+            <a:solidFill>
+              <a:srgbClr val="E38B36"/>
+            </a:solidFill>
+          </a:ln>
+        </p:spPr>
+        <p:style>
+          <a:lnRef idx="1">
+            <a:schemeClr val="accent1"/>
+          </a:lnRef>
+          <a:fillRef idx="3">
+            <a:schemeClr val="accent1"/>
+          </a:fillRef>
+          <a:effectRef idx="2">
+            <a:schemeClr val="accent1"/>
+          </a:effectRef>
+          <a:fontRef idx="minor">
+            <a:schemeClr val="lt1"/>
+          </a:fontRef>
+        </p:style>
+        <p:txBody>
+          <a:bodyPr rtlCol="0" anchor="ctr"/>
+          <a:lstStyle/>
+          <a:p>
+            <a:pPr algn="ctr"/>
+          </a:p>
+        </p:txBody>
+      </p:sp>
+      <p:sp>
+        <p:nvSpPr>
+          <p:cNvPr id="50" name="Rectangle 49"/>
+          <p:cNvSpPr/>
+          <p:nvPr/>
+        </p:nvSpPr>
+        <p:spPr>
+          <a:xfrm>
+            <a:off x="9436608" y="2011680"/>
+            <a:ext cx="1901952" cy="64008"/>
+          </a:xfrm>
+          <a:prstGeom prst="rect">
+            <a:avLst/>
+          </a:prstGeom>
+          <a:solidFill>
+            <a:srgbClr val="E38B36"/>
+          </a:solidFill>
+          <a:ln>
+            <a:noFill/>
+          </a:ln>
+        </p:spPr>
+        <p:style>
+          <a:lnRef idx="1">
+            <a:schemeClr val="accent1"/>
+          </a:lnRef>
+          <a:fillRef idx="3">
+            <a:schemeClr val="accent1"/>
+          </a:fillRef>
+          <a:effectRef idx="2">
+            <a:schemeClr val="accent1"/>
+          </a:effectRef>
+          <a:fontRef idx="minor">
+            <a:schemeClr val="lt1"/>
+          </a:fontRef>
+        </p:style>
+        <p:txBody>
+          <a:bodyPr rtlCol="0" anchor="ctr"/>
+          <a:lstStyle/>
+          <a:p>
+            <a:pPr algn="ctr"/>
+          </a:p>
+        </p:txBody>
+      </p:sp>
+      <p:sp>
+        <p:nvSpPr>
+          <p:cNvPr id="51" name="Rounded Rectangle 50"/>
+          <p:cNvSpPr/>
+          <p:nvPr/>
+        </p:nvSpPr>
+        <p:spPr>
+          <a:xfrm>
+            <a:off x="9601200" y="2240280"/>
+            <a:ext cx="786384" cy="274320"/>
+          </a:xfrm>
+          <a:prstGeom prst="roundRect">
+            <a:avLst/>
+          </a:prstGeom>
+          <a:solidFill>
+            <a:srgbClr val="E38B36"/>
+          </a:solidFill>
+          <a:ln>
+            <a:noFill/>
+          </a:ln>
+        </p:spPr>
+        <p:style>
+          <a:lnRef idx="1">
+            <a:schemeClr val="accent1"/>
+          </a:lnRef>
+          <a:fillRef idx="3">
+            <a:schemeClr val="accent1"/>
+          </a:fillRef>
+          <a:effectRef idx="2">
+            <a:schemeClr val="accent1"/>
+          </a:effectRef>
+          <a:fontRef idx="minor">
+            <a:schemeClr val="lt1"/>
+          </a:fontRef>
+        </p:style>
+        <p:txBody>
+          <a:bodyPr rtlCol="0" anchor="ctr"/>
+          <a:lstStyle/>
+          <a:p>
+            <a:pPr algn="ctr"/>
+          </a:p>
+        </p:txBody>
+      </p:sp>
+      <p:sp>
+        <p:nvSpPr>
+          <p:cNvPr id="52" name="TextBox 51"/>
+          <p:cNvSpPr txBox="1"/>
+          <p:nvPr/>
+        </p:nvSpPr>
+        <p:spPr>
+          <a:xfrm>
+            <a:off x="9601200" y="2240280"/>
+            <a:ext cx="786384" cy="274320"/>
+          </a:xfrm>
+          <a:prstGeom prst="rect">
+            <a:avLst/>
+          </a:prstGeom>
+          <a:noFill/>
+        </p:spPr>
+        <p:txBody>
+          <a:bodyPr wrap="square" lIns="0" rIns="0" tIns="0" bIns="0" anchor="ctr">
+            <a:spAutoFit/>
+          </a:bodyPr>
+          <a:lstStyle/>
+          <a:p>
+            <a:pPr algn="ctr">
+              <a:spcBef>
+                <a:spcPts val="0"/>
+              </a:spcBef>
+              <a:spcAft>
+                <a:spcPts val="0"/>
+              </a:spcAft>
+            </a:pPr>
+            <a:r>
+              <a:rPr sz="900" b="1">
+                <a:solidFill>
+                  <a:srgbClr val="FFFFFF"/>
+                </a:solidFill>
+                <a:latin typeface="Microsoft YaHei"/>
+              </a:rPr>
+              <a:t>下一阶段</a:t>
+            </a:r>
+          </a:p>
+        </p:txBody>
+      </p:sp>
+      <p:sp>
+        <p:nvSpPr>
+          <p:cNvPr id="53" name="TextBox 52"/>
+          <p:cNvSpPr txBox="1"/>
+          <p:nvPr/>
+        </p:nvSpPr>
+        <p:spPr>
+          <a:xfrm>
+            <a:off x="9601200" y="2679192"/>
+            <a:ext cx="1143000" cy="493776"/>
+          </a:xfrm>
+          <a:prstGeom prst="rect">
+            <a:avLst/>
+          </a:prstGeom>
+          <a:noFill/>
+        </p:spPr>
+        <p:txBody>
+          <a:bodyPr wrap="square" lIns="0" rIns="0" tIns="0" bIns="0" anchor="t">
+            <a:spAutoFit/>
+          </a:bodyPr>
+          <a:lstStyle/>
+          <a:p>
+            <a:pPr algn="l">
+              <a:spcBef>
+                <a:spcPts val="0"/>
+              </a:spcBef>
+              <a:spcAft>
+                <a:spcPts val="0"/>
+              </a:spcAft>
+            </a:pPr>
+            <a:r>
+              <a:rPr sz="2700" b="1">
+                <a:solidFill>
+                  <a:srgbClr val="E38B36"/>
+                </a:solidFill>
+                <a:latin typeface="Microsoft YaHei"/>
+              </a:rPr>
+              <a:t>05</a:t>
+            </a:r>
+          </a:p>
+        </p:txBody>
+      </p:sp>
+      <p:sp>
+        <p:nvSpPr>
+          <p:cNvPr id="54" name="TextBox 53"/>
+          <p:cNvSpPr txBox="1"/>
+          <p:nvPr/>
+        </p:nvSpPr>
+        <p:spPr>
+          <a:xfrm>
+            <a:off x="9601200" y="3264408"/>
+            <a:ext cx="1581912" cy="384048"/>
+          </a:xfrm>
+          <a:prstGeom prst="rect">
+            <a:avLst/>
+          </a:prstGeom>
+          <a:noFill/>
+        </p:spPr>
+        <p:txBody>
+          <a:bodyPr wrap="square" lIns="0" rIns="0" tIns="0" bIns="0" anchor="ctr">
+            <a:spAutoFit/>
+          </a:bodyPr>
+          <a:lstStyle/>
+          <a:p>
+            <a:pPr algn="l">
+              <a:spcBef>
+                <a:spcPts val="0"/>
+              </a:spcBef>
+              <a:spcAft>
+                <a:spcPts val="0"/>
+              </a:spcAft>
+            </a:pPr>
+            <a:r>
+              <a:rPr sz="1600" b="1">
+                <a:solidFill>
+                  <a:srgbClr val="17324D"/>
+                </a:solidFill>
+                <a:latin typeface="Microsoft YaHei"/>
+              </a:rPr>
+              <a:t>语境与转化</a:t>
+            </a:r>
+          </a:p>
+        </p:txBody>
+      </p:sp>
+      <p:sp>
+        <p:nvSpPr>
+          <p:cNvPr id="55" name="TextBox 54"/>
+          <p:cNvSpPr txBox="1"/>
+          <p:nvPr/>
+        </p:nvSpPr>
+        <p:spPr>
+          <a:xfrm>
+            <a:off x="9601200" y="3822191"/>
+            <a:ext cx="1581912" cy="786384"/>
+          </a:xfrm>
+          <a:prstGeom prst="rect">
+            <a:avLst/>
+          </a:prstGeom>
+          <a:noFill/>
+        </p:spPr>
+        <p:txBody>
+          <a:bodyPr wrap="square" lIns="0" rIns="0" tIns="0" bIns="0" anchor="t">
+            <a:spAutoFit/>
+          </a:bodyPr>
+          <a:lstStyle/>
+          <a:p>
+            <a:pPr algn="l">
+              <a:spcBef>
+                <a:spcPts val="0"/>
+              </a:spcBef>
+              <a:spcAft>
+                <a:spcPts val="0"/>
+              </a:spcAft>
+            </a:pPr>
+            <a:r>
+              <a:rPr sz="1100" b="0">
+                <a:solidFill>
+                  <a:srgbClr val="62748A"/>
+                </a:solidFill>
+                <a:latin typeface="Microsoft YaHei"/>
+              </a:rPr>
+              <a:t>跨文化话语分析</a:t>
+            </a:r>
+          </a:p>
+          <a:p>
+            <a:pPr algn="l">
+              <a:spcBef>
+                <a:spcPts val="0"/>
+              </a:spcBef>
+              <a:spcAft>
+                <a:spcPts val="0"/>
+              </a:spcAft>
+            </a:pPr>
+            <a:r>
+              <a:rPr sz="1100" b="0">
+                <a:solidFill>
+                  <a:srgbClr val="62748A"/>
+                </a:solidFill>
+                <a:latin typeface="Microsoft YaHei"/>
+              </a:rPr>
+              <a:t>批评话语分析</a:t>
+            </a:r>
+          </a:p>
+          <a:p>
+            <a:pPr algn="l">
+              <a:spcBef>
+                <a:spcPts val="0"/>
+              </a:spcBef>
+              <a:spcAft>
+                <a:spcPts val="0"/>
+              </a:spcAft>
+            </a:pPr>
+            <a:r>
+              <a:rPr sz="1100" b="0">
+                <a:solidFill>
+                  <a:srgbClr val="62748A"/>
+                </a:solidFill>
+                <a:latin typeface="Microsoft YaHei"/>
+              </a:rPr>
+              <a:t>社会文化语境解释</a:t>
+            </a:r>
+          </a:p>
+        </p:txBody>
+      </p:sp>
+      <p:cxnSp>
+        <p:nvCxnSpPr>
+          <p:cNvPr id="56" name="Connector 55"/>
+          <p:cNvCxnSpPr/>
+          <p:nvPr/>
+        </p:nvCxnSpPr>
+        <p:spPr>
+          <a:xfrm>
+            <a:off x="9601200" y="4690872"/>
+            <a:ext cx="1572768" cy="0"/>
+          </a:xfrm>
+          <a:prstGeom prst="line">
+            <a:avLst/>
+          </a:prstGeom>
+          <a:ln w="10160">
+            <a:solidFill>
+              <a:srgbClr val="E38B36"/>
+            </a:solidFill>
+          </a:ln>
+        </p:spPr>
+        <p:style>
+          <a:lnRef idx="2">
+            <a:schemeClr val="accent1"/>
+          </a:lnRef>
+          <a:fillRef idx="0">
+            <a:schemeClr val="accent1"/>
+          </a:fillRef>
+          <a:effectRef idx="1">
+            <a:schemeClr val="accent1"/>
+          </a:effectRef>
+          <a:fontRef idx="minor">
+            <a:schemeClr val="tx1"/>
+          </a:fontRef>
+        </p:style>
+      </p:cxnSp>
+      <p:sp>
+        <p:nvSpPr>
+          <p:cNvPr id="57" name="TextBox 56"/>
+          <p:cNvSpPr txBox="1"/>
+          <p:nvPr/>
+        </p:nvSpPr>
+        <p:spPr>
+          <a:xfrm>
+            <a:off x="9601200" y="4809744"/>
+            <a:ext cx="1581912" cy="256032"/>
+          </a:xfrm>
+          <a:prstGeom prst="rect">
+            <a:avLst/>
+          </a:prstGeom>
+          <a:noFill/>
+        </p:spPr>
+        <p:txBody>
+          <a:bodyPr wrap="square" lIns="0" rIns="0" tIns="0" bIns="0" anchor="ctr">
+            <a:spAutoFit/>
+          </a:bodyPr>
+          <a:lstStyle/>
+          <a:p>
+            <a:pPr algn="l">
+              <a:spcBef>
+                <a:spcPts val="0"/>
+              </a:spcBef>
+              <a:spcAft>
+                <a:spcPts val="0"/>
+              </a:spcAft>
+            </a:pPr>
+            <a:r>
+              <a:rPr sz="1000" b="1">
+                <a:solidFill>
+                  <a:srgbClr val="E38B36"/>
+                </a:solidFill>
+                <a:latin typeface="Microsoft YaHei"/>
+              </a:rPr>
+              <a:t>策略建议库 · 论文</a:t>
+            </a:r>
+          </a:p>
+        </p:txBody>
+      </p:sp>
+      <p:sp>
+        <p:nvSpPr>
+          <p:cNvPr id="58" name="Chevron 57"/>
+          <p:cNvSpPr/>
+          <p:nvPr/>
+        </p:nvSpPr>
+        <p:spPr>
+          <a:xfrm>
+            <a:off x="2697480" y="3429000"/>
+            <a:ext cx="146304" cy="310896"/>
+          </a:xfrm>
+          <a:prstGeom prst="chevron">
+            <a:avLst/>
+          </a:prstGeom>
+          <a:solidFill>
+            <a:srgbClr val="D8E1EB"/>
+          </a:solidFill>
+          <a:ln>
+            <a:noFill/>
+          </a:ln>
+        </p:spPr>
+        <p:style>
+          <a:lnRef idx="1">
+            <a:schemeClr val="accent1"/>
+          </a:lnRef>
+          <a:fillRef idx="3">
+            <a:schemeClr val="accent1"/>
+          </a:fillRef>
+          <a:effectRef idx="2">
+            <a:schemeClr val="accent1"/>
+          </a:effectRef>
+          <a:fontRef idx="minor">
+            <a:schemeClr val="lt1"/>
+          </a:fontRef>
+        </p:style>
+        <p:txBody>
+          <a:bodyPr rtlCol="0" anchor="ctr"/>
+          <a:lstStyle/>
+          <a:p>
+            <a:pPr algn="ctr"/>
+          </a:p>
+        </p:txBody>
+      </p:sp>
+      <p:sp>
+        <p:nvSpPr>
+          <p:cNvPr id="59" name="Chevron 58"/>
+          <p:cNvSpPr/>
+          <p:nvPr/>
+        </p:nvSpPr>
+        <p:spPr>
+          <a:xfrm>
+            <a:off x="4873752" y="3429000"/>
+            <a:ext cx="146304" cy="310896"/>
+          </a:xfrm>
+          <a:prstGeom prst="chevron">
+            <a:avLst/>
+          </a:prstGeom>
+          <a:solidFill>
+            <a:srgbClr val="D8E1EB"/>
+          </a:solidFill>
+          <a:ln>
+            <a:noFill/>
+          </a:ln>
+        </p:spPr>
+        <p:style>
+          <a:lnRef idx="1">
+            <a:schemeClr val="accent1"/>
+          </a:lnRef>
+          <a:fillRef idx="3">
+            <a:schemeClr val="accent1"/>
+          </a:fillRef>
+          <a:effectRef idx="2">
+            <a:schemeClr val="accent1"/>
+          </a:effectRef>
+          <a:fontRef idx="minor">
+            <a:schemeClr val="lt1"/>
+          </a:fontRef>
+        </p:style>
+        <p:txBody>
+          <a:bodyPr rtlCol="0" anchor="ctr"/>
+          <a:lstStyle/>
+          <a:p>
+            <a:pPr algn="ctr"/>
+          </a:p>
+        </p:txBody>
+      </p:sp>
+      <p:sp>
+        <p:nvSpPr>
+          <p:cNvPr id="60" name="Chevron 59"/>
+          <p:cNvSpPr/>
+          <p:nvPr/>
+        </p:nvSpPr>
+        <p:spPr>
+          <a:xfrm>
+            <a:off x="7050024" y="3429000"/>
+            <a:ext cx="146304" cy="310896"/>
+          </a:xfrm>
+          <a:prstGeom prst="chevron">
+            <a:avLst/>
+          </a:prstGeom>
+          <a:solidFill>
+            <a:srgbClr val="D8E1EB"/>
+          </a:solidFill>
+          <a:ln>
+            <a:noFill/>
+          </a:ln>
+        </p:spPr>
+        <p:style>
+          <a:lnRef idx="1">
+            <a:schemeClr val="accent1"/>
+          </a:lnRef>
+          <a:fillRef idx="3">
+            <a:schemeClr val="accent1"/>
+          </a:fillRef>
+          <a:effectRef idx="2">
+            <a:schemeClr val="accent1"/>
+          </a:effectRef>
+          <a:fontRef idx="minor">
+            <a:schemeClr val="lt1"/>
+          </a:fontRef>
+        </p:style>
+        <p:txBody>
+          <a:bodyPr rtlCol="0" anchor="ctr"/>
+          <a:lstStyle/>
+          <a:p>
+            <a:pPr algn="ctr"/>
+          </a:p>
+        </p:txBody>
+      </p:sp>
+      <p:sp>
+        <p:nvSpPr>
+          <p:cNvPr id="61" name="Chevron 60"/>
+          <p:cNvSpPr/>
+          <p:nvPr/>
+        </p:nvSpPr>
+        <p:spPr>
+          <a:xfrm>
+            <a:off x="9226296" y="3429000"/>
+            <a:ext cx="146304" cy="310896"/>
+          </a:xfrm>
+          <a:prstGeom prst="chevron">
+            <a:avLst/>
+          </a:prstGeom>
+          <a:solidFill>
+            <a:srgbClr val="E38B36"/>
+          </a:solidFill>
+          <a:ln>
+            <a:noFill/>
+          </a:ln>
+        </p:spPr>
+        <p:style>
+          <a:lnRef idx="1">
+            <a:schemeClr val="accent1"/>
+          </a:lnRef>
+          <a:fillRef idx="3">
+            <a:schemeClr val="accent1"/>
+          </a:fillRef>
+          <a:effectRef idx="2">
+            <a:schemeClr val="accent1"/>
+          </a:effectRef>
+          <a:fontRef idx="minor">
+            <a:schemeClr val="lt1"/>
+          </a:fontRef>
+        </p:style>
+        <p:txBody>
+          <a:bodyPr rtlCol="0" anchor="ctr"/>
+          <a:lstStyle/>
+          <a:p>
+            <a:pPr algn="ctr"/>
+          </a:p>
+        </p:txBody>
+      </p:sp>
+      <p:sp>
+        <p:nvSpPr>
+          <p:cNvPr id="62" name="Rounded Rectangle 61"/>
+          <p:cNvSpPr/>
+          <p:nvPr/>
+        </p:nvSpPr>
+        <p:spPr>
+          <a:xfrm>
+            <a:off x="731520" y="5468112"/>
+            <a:ext cx="10607040" cy="438912"/>
+          </a:xfrm>
+          <a:prstGeom prst="roundRect">
+            <a:avLst/>
+          </a:prstGeom>
+          <a:solidFill>
+            <a:srgbClr val="EAF1F8"/>
+          </a:solidFill>
+          <a:ln>
+            <a:noFill/>
+          </a:ln>
+        </p:spPr>
+        <p:style>
+          <a:lnRef idx="1">
+            <a:schemeClr val="accent1"/>
+          </a:lnRef>
+          <a:fillRef idx="3">
+            <a:schemeClr val="accent1"/>
+          </a:fillRef>
+          <a:effectRef idx="2">
+            <a:schemeClr val="accent1"/>
+          </a:effectRef>
+          <a:fontRef idx="minor">
+            <a:schemeClr val="lt1"/>
+          </a:fontRef>
+        </p:style>
+        <p:txBody>
+          <a:bodyPr rtlCol="0" anchor="ctr"/>
+          <a:lstStyle/>
+          <a:p>
+            <a:pPr algn="ctr"/>
+          </a:p>
+        </p:txBody>
+      </p:sp>
+      <p:sp>
+        <p:nvSpPr>
+          <p:cNvPr id="63" name="TextBox 62"/>
+          <p:cNvSpPr txBox="1"/>
+          <p:nvPr/>
+        </p:nvSpPr>
+        <p:spPr>
+          <a:xfrm>
+            <a:off x="914400" y="5468112"/>
+            <a:ext cx="1143000" cy="438912"/>
+          </a:xfrm>
+          <a:prstGeom prst="rect">
+            <a:avLst/>
+          </a:prstGeom>
+          <a:noFill/>
+        </p:spPr>
+        <p:txBody>
+          <a:bodyPr wrap="square" lIns="0" rIns="0" tIns="0" bIns="0" anchor="ctr">
+            <a:spAutoFit/>
+          </a:bodyPr>
+          <a:lstStyle/>
+          <a:p>
+            <a:pPr algn="l">
+              <a:spcBef>
+                <a:spcPts val="0"/>
+              </a:spcBef>
+              <a:spcAft>
+                <a:spcPts val="0"/>
+              </a:spcAft>
+            </a:pPr>
+            <a:r>
+              <a:rPr sz="1000" b="1">
+                <a:solidFill>
+                  <a:srgbClr val="3568A8"/>
+                </a:solidFill>
+                <a:latin typeface="Microsoft YaHei"/>
+              </a:rPr>
+              <a:t>本次汇报重点</a:t>
+            </a:r>
+          </a:p>
+        </p:txBody>
+      </p:sp>
+      <p:sp>
+        <p:nvSpPr>
+          <p:cNvPr id="64" name="TextBox 63"/>
+          <p:cNvSpPr txBox="1"/>
+          <p:nvPr/>
+        </p:nvSpPr>
+        <p:spPr>
+          <a:xfrm>
+            <a:off x="2157984" y="5468112"/>
+            <a:ext cx="8869680" cy="438912"/>
+          </a:xfrm>
+          <a:prstGeom prst="rect">
+            <a:avLst/>
+          </a:prstGeom>
+          <a:noFill/>
+        </p:spPr>
+        <p:txBody>
+          <a:bodyPr wrap="square" lIns="0" rIns="0" tIns="0" bIns="0" anchor="ctr">
+            <a:spAutoFit/>
+          </a:bodyPr>
+          <a:lstStyle/>
+          <a:p>
+            <a:pPr algn="l">
+              <a:spcBef>
+                <a:spcPts val="0"/>
+              </a:spcBef>
+              <a:spcAft>
+                <a:spcPts val="0"/>
+              </a:spcAft>
+            </a:pPr>
+            <a:r>
+              <a:rPr sz="1100" b="0">
+                <a:solidFill>
+                  <a:srgbClr val="23364A"/>
+                </a:solidFill>
+                <a:latin typeface="Microsoft YaHei"/>
+              </a:rPr>
+              <a:t>03 语步分布　·　04 语言实现　　｜　　05 语境与转化为下一阶段计划</a:t>
+            </a:r>
+          </a:p>
+        </p:txBody>
+      </p:sp>
+      <p:cxnSp>
+        <p:nvCxnSpPr>
+          <p:cNvPr id="65" name="Connector 64"/>
+          <p:cNvCxnSpPr/>
+          <p:nvPr/>
+        </p:nvCxnSpPr>
+        <p:spPr>
+          <a:xfrm>
+            <a:off x="731520" y="6144768"/>
+            <a:ext cx="10744200" cy="0"/>
+          </a:xfrm>
+          <a:prstGeom prst="line">
+            <a:avLst/>
+          </a:prstGeom>
+          <a:ln w="10160">
+            <a:solidFill>
+              <a:srgbClr val="D8E1EB"/>
+            </a:solidFill>
+          </a:ln>
+        </p:spPr>
+        <p:style>
+          <a:lnRef idx="2">
+            <a:schemeClr val="accent1"/>
+          </a:lnRef>
+          <a:fillRef idx="0">
+            <a:schemeClr val="accent1"/>
+          </a:fillRef>
+          <a:effectRef idx="1">
+            <a:schemeClr val="accent1"/>
+          </a:effectRef>
+          <a:fontRef idx="minor">
+            <a:schemeClr val="tx1"/>
+          </a:fontRef>
+        </p:style>
+      </p:cxnSp>
+      <p:sp>
+        <p:nvSpPr>
+          <p:cNvPr id="66" name="TextBox 65"/>
+          <p:cNvSpPr txBox="1"/>
+          <p:nvPr/>
+        </p:nvSpPr>
+        <p:spPr>
+          <a:xfrm>
+            <a:off x="731520" y="6318504"/>
+            <a:ext cx="7772400" cy="256032"/>
+          </a:xfrm>
+          <a:prstGeom prst="rect">
+            <a:avLst/>
+          </a:prstGeom>
+          <a:noFill/>
+        </p:spPr>
+        <p:txBody>
+          <a:bodyPr wrap="square" lIns="0" rIns="0" tIns="0" bIns="0" anchor="t">
+            <a:spAutoFit/>
+          </a:bodyPr>
+          <a:lstStyle/>
+          <a:p>
+            <a:pPr algn="l">
+              <a:spcBef>
+                <a:spcPts val="0"/>
+              </a:spcBef>
+              <a:spcAft>
+                <a:spcPts val="0"/>
+              </a:spcAft>
+            </a:pPr>
+            <a:r>
+              <a:rPr sz="900" b="0">
+                <a:solidFill>
+                  <a:srgbClr val="62748A"/>
+                </a:solidFill>
+                <a:latin typeface="Microsoft YaHei"/>
+              </a:rPr>
+              <a:t>基于语料库技术的中美外语院系英文简介话语比较分析</a:t>
+            </a:r>
+          </a:p>
+        </p:txBody>
+      </p:sp>
+      <p:sp>
+        <p:nvSpPr>
+          <p:cNvPr id="67" name="TextBox 66"/>
+          <p:cNvSpPr txBox="1"/>
+          <p:nvPr/>
+        </p:nvSpPr>
+        <p:spPr>
+          <a:xfrm>
+            <a:off x="10881360" y="6318504"/>
+            <a:ext cx="594360" cy="256032"/>
+          </a:xfrm>
+          <a:prstGeom prst="rect">
+            <a:avLst/>
+          </a:prstGeom>
+          <a:noFill/>
+        </p:spPr>
+        <p:txBody>
+          <a:bodyPr wrap="square" lIns="0" rIns="0" tIns="0" bIns="0" anchor="t">
+            <a:spAutoFit/>
+          </a:bodyPr>
+          <a:lstStyle/>
+          <a:p>
+            <a:pPr algn="r">
+              <a:spcBef>
+                <a:spcPts val="0"/>
+              </a:spcBef>
+              <a:spcAft>
+                <a:spcPts val="0"/>
+              </a:spcAft>
+            </a:pPr>
+            <a:r>
+              <a:rPr sz="1000" b="0">
+                <a:solidFill>
+                  <a:srgbClr val="62748A"/>
+                </a:solidFill>
+                <a:latin typeface="Microsoft YaHei"/>
+              </a:rPr>
+              <a:t>02 / 07</a:t>
             </a:r>
           </a:p>
         </p:txBody>

</xml_diff>

<commit_message>
Add research content and objectives slide
Co-authored-by: arena-agent <297053741+arena-agent@users.noreply.github.com>
</commit_message>
<xml_diff>
--- a/midterm-report/presentation/中美外语院系英文简介_5分钟汇报.pptx
+++ b/midterm-report/presentation/中美外语院系英文简介_5分钟汇报.pptx
@@ -7,6 +7,7 @@
   <p:sldIdLst>
     <p:sldId id="256" r:id="rId7"/>
     <p:sldId id="257" r:id="rId8"/>
+    <p:sldId id="258" r:id="rId9"/>
   </p:sldIdLst>
   <p:sldSz cx="12191695" cy="6858000" type="screen4x3"/>
   <p:notesSz cx="6858000" cy="9144000"/>
@@ -4992,7 +4993,7 @@
                 </a:solidFill>
                 <a:latin typeface="Microsoft YaHei"/>
               </a:rPr>
-              <a:t>01 / 07</a:t>
+              <a:t>01 / 08</a:t>
             </a:r>
           </a:p>
         </p:txBody>
@@ -5181,7 +5182,7 @@
                 </a:solidFill>
                 <a:latin typeface="Microsoft YaHei"/>
               </a:rPr>
-              <a:t>01　项目概览</a:t>
+              <a:t>01　研究定位</a:t>
             </a:r>
           </a:p>
         </p:txBody>
@@ -5223,7 +5224,7 @@
                 </a:solidFill>
                 <a:latin typeface="Microsoft YaHei"/>
               </a:rPr>
-              <a:t>项目整体路线</a:t>
+              <a:t>研究内容与目标</a:t>
             </a:r>
           </a:p>
         </p:txBody>
@@ -5265,7 +5266,7 @@
                 </a:solidFill>
                 <a:latin typeface="Microsoft YaHei"/>
               </a:rPr>
-              <a:t>定量比较已完成，下一阶段由“描述差异”转向“解释差异与策略转化”</a:t>
+              <a:t>围绕五个相互关联的维度，比较中美外语院系英文简介的机构话语建构</a:t>
             </a:r>
           </a:p>
         </p:txBody>
@@ -5315,57 +5316,14 @@
       </p:sp>
       <p:sp>
         <p:nvSpPr>
-          <p:cNvPr id="9" name="Oval 8"/>
-          <p:cNvSpPr/>
-          <p:nvPr/>
-        </p:nvSpPr>
-        <p:spPr>
-          <a:xfrm>
-            <a:off x="9354312" y="521207"/>
-            <a:ext cx="109728" cy="109728"/>
-          </a:xfrm>
-          <a:prstGeom prst="ellipse">
-            <a:avLst/>
-          </a:prstGeom>
-          <a:solidFill>
-            <a:srgbClr val="3568A8"/>
-          </a:solidFill>
-          <a:ln>
-            <a:noFill/>
-          </a:ln>
-        </p:spPr>
-        <p:style>
-          <a:lnRef idx="1">
-            <a:schemeClr val="accent1"/>
-          </a:lnRef>
-          <a:fillRef idx="3">
-            <a:schemeClr val="accent1"/>
-          </a:fillRef>
-          <a:effectRef idx="2">
-            <a:schemeClr val="accent1"/>
-          </a:effectRef>
-          <a:fontRef idx="minor">
-            <a:schemeClr val="lt1"/>
-          </a:fontRef>
-        </p:style>
-        <p:txBody>
-          <a:bodyPr rtlCol="0" anchor="ctr"/>
-          <a:lstStyle/>
-          <a:p>
-            <a:pPr algn="ctr"/>
-          </a:p>
-        </p:txBody>
-      </p:sp>
-      <p:sp>
-        <p:nvSpPr>
-          <p:cNvPr id="10" name="TextBox 9"/>
+          <p:cNvPr id="9" name="TextBox 8"/>
           <p:cNvSpPr txBox="1"/>
           <p:nvPr/>
         </p:nvSpPr>
         <p:spPr>
           <a:xfrm>
-            <a:off x="9528048" y="448056"/>
-            <a:ext cx="713232" cy="256032"/>
+            <a:off x="731520" y="1965960"/>
+            <a:ext cx="4206240" cy="292608"/>
           </a:xfrm>
           <a:prstGeom prst="rect">
             <a:avLst/>
@@ -5373,7 +5331,7 @@
           <a:noFill/>
         </p:spPr>
         <p:txBody>
-          <a:bodyPr wrap="square" lIns="0" rIns="0" tIns="0" bIns="0" anchor="ctr">
+          <a:bodyPr wrap="square" lIns="0" rIns="0" tIns="0" bIns="0" anchor="t">
             <a:spAutoFit/>
           </a:bodyPr>
           <a:lstStyle/>
@@ -5387,112 +5345,27 @@
               </a:spcAft>
             </a:pPr>
             <a:r>
-              <a:rPr sz="1000" b="0">
-                <a:solidFill>
-                  <a:srgbClr val="62748A"/>
+              <a:rPr sz="1200" b="1">
+                <a:solidFill>
+                  <a:srgbClr val="3568A8"/>
                 </a:solidFill>
                 <a:latin typeface="Microsoft YaHei"/>
               </a:rPr>
-              <a:t>已完成</a:t>
-            </a:r>
-          </a:p>
-        </p:txBody>
-      </p:sp>
-      <p:sp>
-        <p:nvSpPr>
-          <p:cNvPr id="11" name="Oval 10"/>
+              <a:t>研究内容｜五个比较维度</a:t>
+            </a:r>
+          </a:p>
+        </p:txBody>
+      </p:sp>
+      <p:sp>
+        <p:nvSpPr>
+          <p:cNvPr id="10" name="Rounded Rectangle 9"/>
           <p:cNvSpPr/>
           <p:nvPr/>
         </p:nvSpPr>
         <p:spPr>
           <a:xfrm>
-            <a:off x="10360152" y="521207"/>
-            <a:ext cx="109728" cy="109728"/>
-          </a:xfrm>
-          <a:prstGeom prst="ellipse">
-            <a:avLst/>
-          </a:prstGeom>
-          <a:solidFill>
-            <a:srgbClr val="E38B36"/>
-          </a:solidFill>
-          <a:ln>
-            <a:noFill/>
-          </a:ln>
-        </p:spPr>
-        <p:style>
-          <a:lnRef idx="1">
-            <a:schemeClr val="accent1"/>
-          </a:lnRef>
-          <a:fillRef idx="3">
-            <a:schemeClr val="accent1"/>
-          </a:fillRef>
-          <a:effectRef idx="2">
-            <a:schemeClr val="accent1"/>
-          </a:effectRef>
-          <a:fontRef idx="minor">
-            <a:schemeClr val="lt1"/>
-          </a:fontRef>
-        </p:style>
-        <p:txBody>
-          <a:bodyPr rtlCol="0" anchor="ctr"/>
-          <a:lstStyle/>
-          <a:p>
-            <a:pPr algn="ctr"/>
-          </a:p>
-        </p:txBody>
-      </p:sp>
-      <p:sp>
-        <p:nvSpPr>
-          <p:cNvPr id="12" name="TextBox 11"/>
-          <p:cNvSpPr txBox="1"/>
-          <p:nvPr/>
-        </p:nvSpPr>
-        <p:spPr>
-          <a:xfrm>
-            <a:off x="10533888" y="448056"/>
-            <a:ext cx="932688" cy="256032"/>
-          </a:xfrm>
-          <a:prstGeom prst="rect">
-            <a:avLst/>
-          </a:prstGeom>
-          <a:noFill/>
-        </p:spPr>
-        <p:txBody>
-          <a:bodyPr wrap="square" lIns="0" rIns="0" tIns="0" bIns="0" anchor="ctr">
-            <a:spAutoFit/>
-          </a:bodyPr>
-          <a:lstStyle/>
-          <a:p>
-            <a:pPr algn="l">
-              <a:spcBef>
-                <a:spcPts val="0"/>
-              </a:spcBef>
-              <a:spcAft>
-                <a:spcPts val="0"/>
-              </a:spcAft>
-            </a:pPr>
-            <a:r>
-              <a:rPr sz="1000" b="0">
-                <a:solidFill>
-                  <a:srgbClr val="62748A"/>
-                </a:solidFill>
-                <a:latin typeface="Microsoft YaHei"/>
-              </a:rPr>
-              <a:t>下一阶段</a:t>
-            </a:r>
-          </a:p>
-        </p:txBody>
-      </p:sp>
-      <p:sp>
-        <p:nvSpPr>
-          <p:cNvPr id="13" name="Rounded Rectangle 12"/>
-          <p:cNvSpPr/>
-          <p:nvPr/>
-        </p:nvSpPr>
-        <p:spPr>
-          <a:xfrm>
-            <a:off x="731520" y="2011680"/>
-            <a:ext cx="1901952" cy="3200400"/>
+            <a:off x="731520" y="2359152"/>
+            <a:ext cx="6729984" cy="530352"/>
           </a:xfrm>
           <a:prstGeom prst="roundRect">
             <a:avLst/>
@@ -5530,16 +5403,16 @@
       </p:sp>
       <p:sp>
         <p:nvSpPr>
-          <p:cNvPr id="14" name="Rectangle 13"/>
+          <p:cNvPr id="11" name="Oval 10"/>
           <p:cNvSpPr/>
           <p:nvPr/>
         </p:nvSpPr>
         <p:spPr>
           <a:xfrm>
-            <a:off x="731520" y="2011680"/>
-            <a:ext cx="1901952" cy="64008"/>
-          </a:xfrm>
-          <a:prstGeom prst="rect">
+            <a:off x="914400" y="2468880"/>
+            <a:ext cx="310896" cy="310896"/>
+          </a:xfrm>
+          <a:prstGeom prst="ellipse">
             <a:avLst/>
           </a:prstGeom>
           <a:solidFill>
@@ -5573,57 +5446,14 @@
       </p:sp>
       <p:sp>
         <p:nvSpPr>
-          <p:cNvPr id="15" name="Rounded Rectangle 14"/>
-          <p:cNvSpPr/>
-          <p:nvPr/>
-        </p:nvSpPr>
-        <p:spPr>
-          <a:xfrm>
-            <a:off x="896112" y="2240280"/>
-            <a:ext cx="658368" cy="274320"/>
-          </a:xfrm>
-          <a:prstGeom prst="roundRect">
-            <a:avLst/>
-          </a:prstGeom>
-          <a:solidFill>
-            <a:srgbClr val="EAF1F8"/>
-          </a:solidFill>
-          <a:ln>
-            <a:noFill/>
-          </a:ln>
-        </p:spPr>
-        <p:style>
-          <a:lnRef idx="1">
-            <a:schemeClr val="accent1"/>
-          </a:lnRef>
-          <a:fillRef idx="3">
-            <a:schemeClr val="accent1"/>
-          </a:fillRef>
-          <a:effectRef idx="2">
-            <a:schemeClr val="accent1"/>
-          </a:effectRef>
-          <a:fontRef idx="minor">
-            <a:schemeClr val="lt1"/>
-          </a:fontRef>
-        </p:style>
-        <p:txBody>
-          <a:bodyPr rtlCol="0" anchor="ctr"/>
-          <a:lstStyle/>
-          <a:p>
-            <a:pPr algn="ctr"/>
-          </a:p>
-        </p:txBody>
-      </p:sp>
-      <p:sp>
-        <p:nvSpPr>
-          <p:cNvPr id="16" name="TextBox 15"/>
+          <p:cNvPr id="12" name="TextBox 11"/>
           <p:cNvSpPr txBox="1"/>
           <p:nvPr/>
         </p:nvSpPr>
         <p:spPr>
           <a:xfrm>
-            <a:off x="896112" y="2240280"/>
-            <a:ext cx="658368" cy="274320"/>
+            <a:off x="914400" y="2468880"/>
+            <a:ext cx="310896" cy="310896"/>
           </a:xfrm>
           <a:prstGeom prst="rect">
             <a:avLst/>
@@ -5645,51 +5475,9 @@
               </a:spcAft>
             </a:pPr>
             <a:r>
-              <a:rPr sz="900" b="1">
-                <a:solidFill>
-                  <a:srgbClr val="3568A8"/>
-                </a:solidFill>
-                <a:latin typeface="Microsoft YaHei"/>
-              </a:rPr>
-              <a:t>已完成</a:t>
-            </a:r>
-          </a:p>
-        </p:txBody>
-      </p:sp>
-      <p:sp>
-        <p:nvSpPr>
-          <p:cNvPr id="17" name="TextBox 16"/>
-          <p:cNvSpPr txBox="1"/>
-          <p:nvPr/>
-        </p:nvSpPr>
-        <p:spPr>
-          <a:xfrm>
-            <a:off x="896112" y="2679192"/>
-            <a:ext cx="1143000" cy="493776"/>
-          </a:xfrm>
-          <a:prstGeom prst="rect">
-            <a:avLst/>
-          </a:prstGeom>
-          <a:noFill/>
-        </p:spPr>
-        <p:txBody>
-          <a:bodyPr wrap="square" lIns="0" rIns="0" tIns="0" bIns="0" anchor="t">
-            <a:spAutoFit/>
-          </a:bodyPr>
-          <a:lstStyle/>
-          <a:p>
-            <a:pPr algn="l">
-              <a:spcBef>
-                <a:spcPts val="0"/>
-              </a:spcBef>
-              <a:spcAft>
-                <a:spcPts val="0"/>
-              </a:spcAft>
-            </a:pPr>
-            <a:r>
-              <a:rPr sz="2700" b="1">
-                <a:solidFill>
-                  <a:srgbClr val="3568A8"/>
+              <a:rPr sz="850" b="1">
+                <a:solidFill>
+                  <a:srgbClr val="FFFFFF"/>
                 </a:solidFill>
                 <a:latin typeface="Microsoft YaHei"/>
               </a:rPr>
@@ -5700,14 +5488,14 @@
       </p:sp>
       <p:sp>
         <p:nvSpPr>
-          <p:cNvPr id="18" name="TextBox 17"/>
+          <p:cNvPr id="13" name="TextBox 12"/>
           <p:cNvSpPr txBox="1"/>
           <p:nvPr/>
         </p:nvSpPr>
         <p:spPr>
           <a:xfrm>
-            <a:off x="896112" y="3264408"/>
-            <a:ext cx="1581912" cy="384048"/>
+            <a:off x="1389888" y="2423160"/>
+            <a:ext cx="2907792" cy="402336"/>
           </a:xfrm>
           <a:prstGeom prst="rect">
             <a:avLst/>
@@ -5729,123 +5517,27 @@
               </a:spcAft>
             </a:pPr>
             <a:r>
-              <a:rPr sz="1600" b="1">
+              <a:rPr sz="1250" b="1">
                 <a:solidFill>
                   <a:srgbClr val="17324D"/>
                 </a:solidFill>
                 <a:latin typeface="Microsoft YaHei"/>
               </a:rPr>
-              <a:t>语料构建</a:t>
-            </a:r>
-          </a:p>
-        </p:txBody>
-      </p:sp>
-      <p:sp>
-        <p:nvSpPr>
-          <p:cNvPr id="19" name="TextBox 18"/>
+              <a:t>体裁构成与语步模式</a:t>
+            </a:r>
+          </a:p>
+        </p:txBody>
+      </p:sp>
+      <p:sp>
+        <p:nvSpPr>
+          <p:cNvPr id="14" name="TextBox 13"/>
           <p:cNvSpPr txBox="1"/>
           <p:nvPr/>
         </p:nvSpPr>
         <p:spPr>
           <a:xfrm>
-            <a:off x="896112" y="3822191"/>
-            <a:ext cx="1581912" cy="786384"/>
-          </a:xfrm>
-          <a:prstGeom prst="rect">
-            <a:avLst/>
-          </a:prstGeom>
-          <a:noFill/>
-        </p:spPr>
-        <p:txBody>
-          <a:bodyPr wrap="square" lIns="0" rIns="0" tIns="0" bIns="0" anchor="t">
-            <a:spAutoFit/>
-          </a:bodyPr>
-          <a:lstStyle/>
-          <a:p>
-            <a:pPr algn="l">
-              <a:spcBef>
-                <a:spcPts val="0"/>
-              </a:spcBef>
-              <a:spcAft>
-                <a:spcPts val="0"/>
-              </a:spcAft>
-            </a:pPr>
-            <a:r>
-              <a:rPr sz="1100" b="0">
-                <a:solidFill>
-                  <a:srgbClr val="62748A"/>
-                </a:solidFill>
-                <a:latin typeface="Microsoft YaHei"/>
-              </a:rPr>
-              <a:t>中国、美国各30个</a:t>
-            </a:r>
-          </a:p>
-          <a:p>
-            <a:pPr algn="l">
-              <a:spcBef>
-                <a:spcPts val="0"/>
-              </a:spcBef>
-              <a:spcAft>
-                <a:spcPts val="0"/>
-              </a:spcAft>
-            </a:pPr>
-            <a:r>
-              <a:rPr sz="1100" b="0">
-                <a:solidFill>
-                  <a:srgbClr val="62748A"/>
-                </a:solidFill>
-                <a:latin typeface="Microsoft YaHei"/>
-              </a:rPr>
-              <a:t>外语院系英文简介</a:t>
-            </a:r>
-          </a:p>
-        </p:txBody>
-      </p:sp>
-      <p:cxnSp>
-        <p:nvCxnSpPr>
-          <p:cNvPr id="20" name="Connector 19"/>
-          <p:cNvCxnSpPr/>
-          <p:nvPr/>
-        </p:nvCxnSpPr>
-        <p:spPr>
-          <a:xfrm>
-            <a:off x="896112" y="4690872"/>
-            <a:ext cx="1572768" cy="0"/>
-          </a:xfrm>
-          <a:prstGeom prst="line">
-            <a:avLst/>
-          </a:prstGeom>
-          <a:ln w="10160">
-            <a:solidFill>
-              <a:srgbClr val="D8E1EB"/>
-            </a:solidFill>
-          </a:ln>
-        </p:spPr>
-        <p:style>
-          <a:lnRef idx="2">
-            <a:schemeClr val="accent1"/>
-          </a:lnRef>
-          <a:fillRef idx="0">
-            <a:schemeClr val="accent1"/>
-          </a:fillRef>
-          <a:effectRef idx="1">
-            <a:schemeClr val="accent1"/>
-          </a:effectRef>
-          <a:fontRef idx="minor">
-            <a:schemeClr val="tx1"/>
-          </a:fontRef>
-        </p:style>
-      </p:cxnSp>
-      <p:sp>
-        <p:nvSpPr>
-          <p:cNvPr id="21" name="TextBox 20"/>
-          <p:cNvSpPr txBox="1"/>
-          <p:nvPr/>
-        </p:nvSpPr>
-        <p:spPr>
-          <a:xfrm>
-            <a:off x="896112" y="4809744"/>
-            <a:ext cx="1581912" cy="256032"/>
+            <a:off x="4334256" y="2423160"/>
+            <a:ext cx="2907792" cy="402336"/>
           </a:xfrm>
           <a:prstGeom prst="rect">
             <a:avLst/>
@@ -5858,7 +5550,7 @@
           </a:bodyPr>
           <a:lstStyle/>
           <a:p>
-            <a:pPr algn="l">
+            <a:pPr algn="r">
               <a:spcBef>
                 <a:spcPts val="0"/>
               </a:spcBef>
@@ -5867,27 +5559,27 @@
               </a:spcAft>
             </a:pPr>
             <a:r>
-              <a:rPr sz="1000" b="1">
-                <a:solidFill>
-                  <a:srgbClr val="3568A8"/>
+              <a:rPr sz="1000" b="0">
+                <a:solidFill>
+                  <a:srgbClr val="62748A"/>
                 </a:solidFill>
                 <a:latin typeface="Microsoft YaHei"/>
               </a:rPr>
-              <a:t>60个院系文本</a:t>
-            </a:r>
-          </a:p>
-        </p:txBody>
-      </p:sp>
-      <p:sp>
-        <p:nvSpPr>
-          <p:cNvPr id="22" name="Rounded Rectangle 21"/>
+              <a:t>顺序 · 篇幅 · 出现率</a:t>
+            </a:r>
+          </a:p>
+        </p:txBody>
+      </p:sp>
+      <p:sp>
+        <p:nvSpPr>
+          <p:cNvPr id="15" name="Rounded Rectangle 14"/>
           <p:cNvSpPr/>
           <p:nvPr/>
         </p:nvSpPr>
         <p:spPr>
           <a:xfrm>
-            <a:off x="2907792" y="2011680"/>
-            <a:ext cx="1901952" cy="3200400"/>
+            <a:off x="731520" y="2999232"/>
+            <a:ext cx="6729984" cy="530352"/>
           </a:xfrm>
           <a:prstGeom prst="roundRect">
             <a:avLst/>
@@ -5925,16 +5617,16 @@
       </p:sp>
       <p:sp>
         <p:nvSpPr>
-          <p:cNvPr id="23" name="Rectangle 22"/>
+          <p:cNvPr id="16" name="Oval 15"/>
           <p:cNvSpPr/>
           <p:nvPr/>
         </p:nvSpPr>
         <p:spPr>
           <a:xfrm>
-            <a:off x="2907792" y="2011680"/>
-            <a:ext cx="1901952" cy="64008"/>
-          </a:xfrm>
-          <a:prstGeom prst="rect">
+            <a:off x="914400" y="3108960"/>
+            <a:ext cx="310896" cy="310896"/>
+          </a:xfrm>
+          <a:prstGeom prst="ellipse">
             <a:avLst/>
           </a:prstGeom>
           <a:solidFill>
@@ -5968,57 +5660,14 @@
       </p:sp>
       <p:sp>
         <p:nvSpPr>
-          <p:cNvPr id="24" name="Rounded Rectangle 23"/>
-          <p:cNvSpPr/>
-          <p:nvPr/>
-        </p:nvSpPr>
-        <p:spPr>
-          <a:xfrm>
-            <a:off x="3072384" y="2240280"/>
-            <a:ext cx="658368" cy="274320"/>
-          </a:xfrm>
-          <a:prstGeom prst="roundRect">
-            <a:avLst/>
-          </a:prstGeom>
-          <a:solidFill>
-            <a:srgbClr val="EAF1F8"/>
-          </a:solidFill>
-          <a:ln>
-            <a:noFill/>
-          </a:ln>
-        </p:spPr>
-        <p:style>
-          <a:lnRef idx="1">
-            <a:schemeClr val="accent1"/>
-          </a:lnRef>
-          <a:fillRef idx="3">
-            <a:schemeClr val="accent1"/>
-          </a:fillRef>
-          <a:effectRef idx="2">
-            <a:schemeClr val="accent1"/>
-          </a:effectRef>
-          <a:fontRef idx="minor">
-            <a:schemeClr val="lt1"/>
-          </a:fontRef>
-        </p:style>
-        <p:txBody>
-          <a:bodyPr rtlCol="0" anchor="ctr"/>
-          <a:lstStyle/>
-          <a:p>
-            <a:pPr algn="ctr"/>
-          </a:p>
-        </p:txBody>
-      </p:sp>
-      <p:sp>
-        <p:nvSpPr>
-          <p:cNvPr id="25" name="TextBox 24"/>
+          <p:cNvPr id="17" name="TextBox 16"/>
           <p:cNvSpPr txBox="1"/>
           <p:nvPr/>
         </p:nvSpPr>
         <p:spPr>
           <a:xfrm>
-            <a:off x="3072384" y="2240280"/>
-            <a:ext cx="658368" cy="274320"/>
+            <a:off x="914400" y="3108960"/>
+            <a:ext cx="310896" cy="310896"/>
           </a:xfrm>
           <a:prstGeom prst="rect">
             <a:avLst/>
@@ -6040,51 +5689,9 @@
               </a:spcAft>
             </a:pPr>
             <a:r>
-              <a:rPr sz="900" b="1">
-                <a:solidFill>
-                  <a:srgbClr val="3568A8"/>
-                </a:solidFill>
-                <a:latin typeface="Microsoft YaHei"/>
-              </a:rPr>
-              <a:t>已完成</a:t>
-            </a:r>
-          </a:p>
-        </p:txBody>
-      </p:sp>
-      <p:sp>
-        <p:nvSpPr>
-          <p:cNvPr id="26" name="TextBox 25"/>
-          <p:cNvSpPr txBox="1"/>
-          <p:nvPr/>
-        </p:nvSpPr>
-        <p:spPr>
-          <a:xfrm>
-            <a:off x="3072384" y="2679192"/>
-            <a:ext cx="1143000" cy="493776"/>
-          </a:xfrm>
-          <a:prstGeom prst="rect">
-            <a:avLst/>
-          </a:prstGeom>
-          <a:noFill/>
-        </p:spPr>
-        <p:txBody>
-          <a:bodyPr wrap="square" lIns="0" rIns="0" tIns="0" bIns="0" anchor="t">
-            <a:spAutoFit/>
-          </a:bodyPr>
-          <a:lstStyle/>
-          <a:p>
-            <a:pPr algn="l">
-              <a:spcBef>
-                <a:spcPts val="0"/>
-              </a:spcBef>
-              <a:spcAft>
-                <a:spcPts val="0"/>
-              </a:spcAft>
-            </a:pPr>
-            <a:r>
-              <a:rPr sz="2700" b="1">
-                <a:solidFill>
-                  <a:srgbClr val="3568A8"/>
+              <a:rPr sz="850" b="1">
+                <a:solidFill>
+                  <a:srgbClr val="FFFFFF"/>
                 </a:solidFill>
                 <a:latin typeface="Microsoft YaHei"/>
               </a:rPr>
@@ -6095,14 +5702,14 @@
       </p:sp>
       <p:sp>
         <p:nvSpPr>
-          <p:cNvPr id="27" name="TextBox 26"/>
+          <p:cNvPr id="18" name="TextBox 17"/>
           <p:cNvSpPr txBox="1"/>
           <p:nvPr/>
         </p:nvSpPr>
         <p:spPr>
           <a:xfrm>
-            <a:off x="3072384" y="3264408"/>
-            <a:ext cx="1581912" cy="384048"/>
+            <a:off x="1389888" y="3063240"/>
+            <a:ext cx="2907792" cy="402336"/>
           </a:xfrm>
           <a:prstGeom prst="rect">
             <a:avLst/>
@@ -6124,123 +5731,27 @@
               </a:spcAft>
             </a:pPr>
             <a:r>
-              <a:rPr sz="1600" b="1">
+              <a:rPr sz="1250" b="1">
                 <a:solidFill>
                   <a:srgbClr val="17324D"/>
                 </a:solidFill>
                 <a:latin typeface="Microsoft YaHei"/>
               </a:rPr>
-              <a:t>框架与校订</a:t>
-            </a:r>
-          </a:p>
-        </p:txBody>
-      </p:sp>
-      <p:sp>
-        <p:nvSpPr>
-          <p:cNvPr id="28" name="TextBox 27"/>
+              <a:t>教育理念与培养目标</a:t>
+            </a:r>
+          </a:p>
+        </p:txBody>
+      </p:sp>
+      <p:sp>
+        <p:nvSpPr>
+          <p:cNvPr id="19" name="TextBox 18"/>
           <p:cNvSpPr txBox="1"/>
           <p:nvPr/>
         </p:nvSpPr>
         <p:spPr>
           <a:xfrm>
-            <a:off x="3072384" y="3822191"/>
-            <a:ext cx="1581912" cy="786384"/>
-          </a:xfrm>
-          <a:prstGeom prst="rect">
-            <a:avLst/>
-          </a:prstGeom>
-          <a:noFill/>
-        </p:spPr>
-        <p:txBody>
-          <a:bodyPr wrap="square" lIns="0" rIns="0" tIns="0" bIns="0" anchor="t">
-            <a:spAutoFit/>
-          </a:bodyPr>
-          <a:lstStyle/>
-          <a:p>
-            <a:pPr algn="l">
-              <a:spcBef>
-                <a:spcPts val="0"/>
-              </a:spcBef>
-              <a:spcAft>
-                <a:spcPts val="0"/>
-              </a:spcAft>
-            </a:pPr>
-            <a:r>
-              <a:rPr sz="1100" b="0">
-                <a:solidFill>
-                  <a:srgbClr val="62748A"/>
-                </a:solidFill>
-                <a:latin typeface="Microsoft YaHei"/>
-              </a:rPr>
-              <a:t>AI预标注</a:t>
-            </a:r>
-          </a:p>
-          <a:p>
-            <a:pPr algn="l">
-              <a:spcBef>
-                <a:spcPts val="0"/>
-              </a:spcBef>
-              <a:spcAft>
-                <a:spcPts val="0"/>
-              </a:spcAft>
-            </a:pPr>
-            <a:r>
-              <a:rPr sz="1100" b="0">
-                <a:solidFill>
-                  <a:srgbClr val="62748A"/>
-                </a:solidFill>
-                <a:latin typeface="Microsoft YaHei"/>
-              </a:rPr>
-              <a:t>人工逐篇校订</a:t>
-            </a:r>
-          </a:p>
-        </p:txBody>
-      </p:sp>
-      <p:cxnSp>
-        <p:nvCxnSpPr>
-          <p:cNvPr id="29" name="Connector 28"/>
-          <p:cNvCxnSpPr/>
-          <p:nvPr/>
-        </p:nvCxnSpPr>
-        <p:spPr>
-          <a:xfrm>
-            <a:off x="3072384" y="4690872"/>
-            <a:ext cx="1572768" cy="0"/>
-          </a:xfrm>
-          <a:prstGeom prst="line">
-            <a:avLst/>
-          </a:prstGeom>
-          <a:ln w="10160">
-            <a:solidFill>
-              <a:srgbClr val="D8E1EB"/>
-            </a:solidFill>
-          </a:ln>
-        </p:spPr>
-        <p:style>
-          <a:lnRef idx="2">
-            <a:schemeClr val="accent1"/>
-          </a:lnRef>
-          <a:fillRef idx="0">
-            <a:schemeClr val="accent1"/>
-          </a:fillRef>
-          <a:effectRef idx="1">
-            <a:schemeClr val="accent1"/>
-          </a:effectRef>
-          <a:fontRef idx="minor">
-            <a:schemeClr val="tx1"/>
-          </a:fontRef>
-        </p:style>
-      </p:cxnSp>
-      <p:sp>
-        <p:nvSpPr>
-          <p:cNvPr id="30" name="TextBox 29"/>
-          <p:cNvSpPr txBox="1"/>
-          <p:nvPr/>
-        </p:nvSpPr>
-        <p:spPr>
-          <a:xfrm>
-            <a:off x="3072384" y="4809744"/>
-            <a:ext cx="1581912" cy="256032"/>
+            <a:off x="4334256" y="3063240"/>
+            <a:ext cx="2907792" cy="402336"/>
           </a:xfrm>
           <a:prstGeom prst="rect">
             <a:avLst/>
@@ -6253,7 +5764,7 @@
           </a:bodyPr>
           <a:lstStyle/>
           <a:p>
-            <a:pPr algn="l">
+            <a:pPr algn="r">
               <a:spcBef>
                 <a:spcPts val="0"/>
               </a:spcBef>
@@ -6262,27 +5773,27 @@
               </a:spcAft>
             </a:pPr>
             <a:r>
-              <a:rPr sz="1000" b="1">
-                <a:solidFill>
-                  <a:srgbClr val="3568A8"/>
+              <a:rPr sz="1000" b="0">
+                <a:solidFill>
+                  <a:srgbClr val="62748A"/>
                 </a:solidFill>
                 <a:latin typeface="Microsoft YaHei"/>
               </a:rPr>
-              <a:t>10个核心语步</a:t>
-            </a:r>
-          </a:p>
-        </p:txBody>
-      </p:sp>
-      <p:sp>
-        <p:nvSpPr>
-          <p:cNvPr id="31" name="Rounded Rectangle 30"/>
+              <a:t>核心能力 · 工具性—人文性</a:t>
+            </a:r>
+          </a:p>
+        </p:txBody>
+      </p:sp>
+      <p:sp>
+        <p:nvSpPr>
+          <p:cNvPr id="20" name="Rounded Rectangle 19"/>
           <p:cNvSpPr/>
           <p:nvPr/>
         </p:nvSpPr>
         <p:spPr>
           <a:xfrm>
-            <a:off x="5084064" y="2011680"/>
-            <a:ext cx="1901952" cy="3200400"/>
+            <a:off x="731520" y="3639312"/>
+            <a:ext cx="6729984" cy="530352"/>
           </a:xfrm>
           <a:prstGeom prst="roundRect">
             <a:avLst/>
@@ -6320,16 +5831,16 @@
       </p:sp>
       <p:sp>
         <p:nvSpPr>
-          <p:cNvPr id="32" name="Rectangle 31"/>
+          <p:cNvPr id="21" name="Oval 20"/>
           <p:cNvSpPr/>
           <p:nvPr/>
         </p:nvSpPr>
         <p:spPr>
           <a:xfrm>
-            <a:off x="5084064" y="2011680"/>
-            <a:ext cx="1901952" cy="64008"/>
-          </a:xfrm>
-          <a:prstGeom prst="rect">
+            <a:off x="914400" y="3749039"/>
+            <a:ext cx="310896" cy="310896"/>
+          </a:xfrm>
+          <a:prstGeom prst="ellipse">
             <a:avLst/>
           </a:prstGeom>
           <a:solidFill>
@@ -6363,57 +5874,14 @@
       </p:sp>
       <p:sp>
         <p:nvSpPr>
-          <p:cNvPr id="33" name="Rounded Rectangle 32"/>
-          <p:cNvSpPr/>
-          <p:nvPr/>
-        </p:nvSpPr>
-        <p:spPr>
-          <a:xfrm>
-            <a:off x="5248655" y="2240280"/>
-            <a:ext cx="658368" cy="274320"/>
-          </a:xfrm>
-          <a:prstGeom prst="roundRect">
-            <a:avLst/>
-          </a:prstGeom>
-          <a:solidFill>
-            <a:srgbClr val="EAF1F8"/>
-          </a:solidFill>
-          <a:ln>
-            <a:noFill/>
-          </a:ln>
-        </p:spPr>
-        <p:style>
-          <a:lnRef idx="1">
-            <a:schemeClr val="accent1"/>
-          </a:lnRef>
-          <a:fillRef idx="3">
-            <a:schemeClr val="accent1"/>
-          </a:fillRef>
-          <a:effectRef idx="2">
-            <a:schemeClr val="accent1"/>
-          </a:effectRef>
-          <a:fontRef idx="minor">
-            <a:schemeClr val="lt1"/>
-          </a:fontRef>
-        </p:style>
-        <p:txBody>
-          <a:bodyPr rtlCol="0" anchor="ctr"/>
-          <a:lstStyle/>
-          <a:p>
-            <a:pPr algn="ctr"/>
-          </a:p>
-        </p:txBody>
-      </p:sp>
-      <p:sp>
-        <p:nvSpPr>
-          <p:cNvPr id="34" name="TextBox 33"/>
+          <p:cNvPr id="22" name="TextBox 21"/>
           <p:cNvSpPr txBox="1"/>
           <p:nvPr/>
         </p:nvSpPr>
         <p:spPr>
           <a:xfrm>
-            <a:off x="5248655" y="2240280"/>
-            <a:ext cx="658368" cy="274320"/>
+            <a:off x="914400" y="3749039"/>
+            <a:ext cx="310896" cy="310896"/>
           </a:xfrm>
           <a:prstGeom prst="rect">
             <a:avLst/>
@@ -6435,51 +5903,9 @@
               </a:spcAft>
             </a:pPr>
             <a:r>
-              <a:rPr sz="900" b="1">
-                <a:solidFill>
-                  <a:srgbClr val="3568A8"/>
-                </a:solidFill>
-                <a:latin typeface="Microsoft YaHei"/>
-              </a:rPr>
-              <a:t>已完成</a:t>
-            </a:r>
-          </a:p>
-        </p:txBody>
-      </p:sp>
-      <p:sp>
-        <p:nvSpPr>
-          <p:cNvPr id="35" name="TextBox 34"/>
-          <p:cNvSpPr txBox="1"/>
-          <p:nvPr/>
-        </p:nvSpPr>
-        <p:spPr>
-          <a:xfrm>
-            <a:off x="5248655" y="2679192"/>
-            <a:ext cx="1143000" cy="493776"/>
-          </a:xfrm>
-          <a:prstGeom prst="rect">
-            <a:avLst/>
-          </a:prstGeom>
-          <a:noFill/>
-        </p:spPr>
-        <p:txBody>
-          <a:bodyPr wrap="square" lIns="0" rIns="0" tIns="0" bIns="0" anchor="t">
-            <a:spAutoFit/>
-          </a:bodyPr>
-          <a:lstStyle/>
-          <a:p>
-            <a:pPr algn="l">
-              <a:spcBef>
-                <a:spcPts val="0"/>
-              </a:spcBef>
-              <a:spcAft>
-                <a:spcPts val="0"/>
-              </a:spcAft>
-            </a:pPr>
-            <a:r>
-              <a:rPr sz="2700" b="1">
-                <a:solidFill>
-                  <a:srgbClr val="3568A8"/>
+              <a:rPr sz="850" b="1">
+                <a:solidFill>
+                  <a:srgbClr val="FFFFFF"/>
                 </a:solidFill>
                 <a:latin typeface="Microsoft YaHei"/>
               </a:rPr>
@@ -6490,14 +5916,14 @@
       </p:sp>
       <p:sp>
         <p:nvSpPr>
-          <p:cNvPr id="36" name="TextBox 35"/>
+          <p:cNvPr id="23" name="TextBox 22"/>
           <p:cNvSpPr txBox="1"/>
           <p:nvPr/>
         </p:nvSpPr>
         <p:spPr>
           <a:xfrm>
-            <a:off x="5248655" y="3264408"/>
-            <a:ext cx="1581912" cy="384048"/>
+            <a:off x="1389888" y="3703320"/>
+            <a:ext cx="2907792" cy="402336"/>
           </a:xfrm>
           <a:prstGeom prst="rect">
             <a:avLst/>
@@ -6519,123 +5945,27 @@
               </a:spcAft>
             </a:pPr>
             <a:r>
-              <a:rPr sz="1600" b="1">
+              <a:rPr sz="1250" b="1">
                 <a:solidFill>
                   <a:srgbClr val="17324D"/>
                 </a:solidFill>
                 <a:latin typeface="Microsoft YaHei"/>
               </a:rPr>
-              <a:t>语步分布</a:t>
-            </a:r>
-          </a:p>
-        </p:txBody>
-      </p:sp>
-      <p:sp>
-        <p:nvSpPr>
-          <p:cNvPr id="37" name="TextBox 36"/>
+              <a:t>学科形象与学术身份</a:t>
+            </a:r>
+          </a:p>
+        </p:txBody>
+      </p:sp>
+      <p:sp>
+        <p:nvSpPr>
+          <p:cNvPr id="24" name="TextBox 23"/>
           <p:cNvSpPr txBox="1"/>
           <p:nvPr/>
         </p:nvSpPr>
         <p:spPr>
           <a:xfrm>
-            <a:off x="5248655" y="3822191"/>
-            <a:ext cx="1581912" cy="786384"/>
-          </a:xfrm>
-          <a:prstGeom prst="rect">
-            <a:avLst/>
-          </a:prstGeom>
-          <a:noFill/>
-        </p:spPr>
-        <p:txBody>
-          <a:bodyPr wrap="square" lIns="0" rIns="0" tIns="0" bIns="0" anchor="t">
-            <a:spAutoFit/>
-          </a:bodyPr>
-          <a:lstStyle/>
-          <a:p>
-            <a:pPr algn="l">
-              <a:spcBef>
-                <a:spcPts val="0"/>
-              </a:spcBef>
-              <a:spcAft>
-                <a:spcPts val="0"/>
-              </a:spcAft>
-            </a:pPr>
-            <a:r>
-              <a:rPr sz="1100" b="0">
-                <a:solidFill>
-                  <a:srgbClr val="62748A"/>
-                </a:solidFill>
-                <a:latin typeface="Microsoft YaHei"/>
-              </a:rPr>
-              <a:t>出现率 · 篇幅</a:t>
-            </a:r>
-          </a:p>
-          <a:p>
-            <a:pPr algn="l">
-              <a:spcBef>
-                <a:spcPts val="0"/>
-              </a:spcBef>
-              <a:spcAft>
-                <a:spcPts val="0"/>
-              </a:spcAft>
-            </a:pPr>
-            <a:r>
-              <a:rPr sz="1100" b="0">
-                <a:solidFill>
-                  <a:srgbClr val="62748A"/>
-                </a:solidFill>
-                <a:latin typeface="Microsoft YaHei"/>
-              </a:rPr>
-              <a:t>开篇位置</a:t>
-            </a:r>
-          </a:p>
-        </p:txBody>
-      </p:sp>
-      <p:cxnSp>
-        <p:nvCxnSpPr>
-          <p:cNvPr id="38" name="Connector 37"/>
-          <p:cNvCxnSpPr/>
-          <p:nvPr/>
-        </p:nvCxnSpPr>
-        <p:spPr>
-          <a:xfrm>
-            <a:off x="5248655" y="4690872"/>
-            <a:ext cx="1572768" cy="0"/>
-          </a:xfrm>
-          <a:prstGeom prst="line">
-            <a:avLst/>
-          </a:prstGeom>
-          <a:ln w="10160">
-            <a:solidFill>
-              <a:srgbClr val="D8E1EB"/>
-            </a:solidFill>
-          </a:ln>
-        </p:spPr>
-        <p:style>
-          <a:lnRef idx="2">
-            <a:schemeClr val="accent1"/>
-          </a:lnRef>
-          <a:fillRef idx="0">
-            <a:schemeClr val="accent1"/>
-          </a:fillRef>
-          <a:effectRef idx="1">
-            <a:schemeClr val="accent1"/>
-          </a:effectRef>
-          <a:fontRef idx="minor">
-            <a:schemeClr val="tx1"/>
-          </a:fontRef>
-        </p:style>
-      </p:cxnSp>
-      <p:sp>
-        <p:nvSpPr>
-          <p:cNvPr id="39" name="TextBox 38"/>
-          <p:cNvSpPr txBox="1"/>
-          <p:nvPr/>
-        </p:nvSpPr>
-        <p:spPr>
-          <a:xfrm>
-            <a:off x="5248655" y="4809744"/>
-            <a:ext cx="1581912" cy="256032"/>
+            <a:off x="4334256" y="3703320"/>
+            <a:ext cx="2907792" cy="402336"/>
           </a:xfrm>
           <a:prstGeom prst="rect">
             <a:avLst/>
@@ -6648,7 +5978,7 @@
           </a:bodyPr>
           <a:lstStyle/>
           <a:p>
-            <a:pPr algn="l">
+            <a:pPr algn="r">
               <a:spcBef>
                 <a:spcPts val="0"/>
               </a:spcBef>
@@ -6657,27 +5987,27 @@
               </a:spcAft>
             </a:pPr>
             <a:r>
-              <a:rPr sz="1000" b="1">
-                <a:solidFill>
-                  <a:srgbClr val="3568A8"/>
+              <a:rPr sz="1000" b="0">
+                <a:solidFill>
+                  <a:srgbClr val="62748A"/>
                 </a:solidFill>
                 <a:latin typeface="Microsoft YaHei"/>
               </a:rPr>
-              <a:t>比较结构组织</a:t>
-            </a:r>
-          </a:p>
-        </p:txBody>
-      </p:sp>
-      <p:sp>
-        <p:nvSpPr>
-          <p:cNvPr id="40" name="Rounded Rectangle 39"/>
+              <a:t>评价表达 · 自我指称 · 名词化</a:t>
+            </a:r>
+          </a:p>
+        </p:txBody>
+      </p:sp>
+      <p:sp>
+        <p:nvSpPr>
+          <p:cNvPr id="25" name="Rounded Rectangle 24"/>
           <p:cNvSpPr/>
           <p:nvPr/>
         </p:nvSpPr>
         <p:spPr>
           <a:xfrm>
-            <a:off x="7260336" y="2011680"/>
-            <a:ext cx="1901952" cy="3200400"/>
+            <a:off x="731520" y="4279392"/>
+            <a:ext cx="6729984" cy="530352"/>
           </a:xfrm>
           <a:prstGeom prst="roundRect">
             <a:avLst/>
@@ -6715,6 +6045,2876 @@
       </p:sp>
       <p:sp>
         <p:nvSpPr>
+          <p:cNvPr id="26" name="Oval 25"/>
+          <p:cNvSpPr/>
+          <p:nvPr/>
+        </p:nvSpPr>
+        <p:spPr>
+          <a:xfrm>
+            <a:off x="914400" y="4389120"/>
+            <a:ext cx="310896" cy="310896"/>
+          </a:xfrm>
+          <a:prstGeom prst="ellipse">
+            <a:avLst/>
+          </a:prstGeom>
+          <a:solidFill>
+            <a:srgbClr val="3568A8"/>
+          </a:solidFill>
+          <a:ln>
+            <a:noFill/>
+          </a:ln>
+        </p:spPr>
+        <p:style>
+          <a:lnRef idx="1">
+            <a:schemeClr val="accent1"/>
+          </a:lnRef>
+          <a:fillRef idx="3">
+            <a:schemeClr val="accent1"/>
+          </a:fillRef>
+          <a:effectRef idx="2">
+            <a:schemeClr val="accent1"/>
+          </a:effectRef>
+          <a:fontRef idx="minor">
+            <a:schemeClr val="lt1"/>
+          </a:fontRef>
+        </p:style>
+        <p:txBody>
+          <a:bodyPr rtlCol="0" anchor="ctr"/>
+          <a:lstStyle/>
+          <a:p>
+            <a:pPr algn="ctr"/>
+          </a:p>
+        </p:txBody>
+      </p:sp>
+      <p:sp>
+        <p:nvSpPr>
+          <p:cNvPr id="27" name="TextBox 26"/>
+          <p:cNvSpPr txBox="1"/>
+          <p:nvPr/>
+        </p:nvSpPr>
+        <p:spPr>
+          <a:xfrm>
+            <a:off x="914400" y="4389120"/>
+            <a:ext cx="310896" cy="310896"/>
+          </a:xfrm>
+          <a:prstGeom prst="rect">
+            <a:avLst/>
+          </a:prstGeom>
+          <a:noFill/>
+        </p:spPr>
+        <p:txBody>
+          <a:bodyPr wrap="square" lIns="0" rIns="0" tIns="0" bIns="0" anchor="ctr">
+            <a:spAutoFit/>
+          </a:bodyPr>
+          <a:lstStyle/>
+          <a:p>
+            <a:pPr algn="ctr">
+              <a:spcBef>
+                <a:spcPts val="0"/>
+              </a:spcBef>
+              <a:spcAft>
+                <a:spcPts val="0"/>
+              </a:spcAft>
+            </a:pPr>
+            <a:r>
+              <a:rPr sz="850" b="1">
+                <a:solidFill>
+                  <a:srgbClr val="FFFFFF"/>
+                </a:solidFill>
+                <a:latin typeface="Microsoft YaHei"/>
+              </a:rPr>
+              <a:t>04</a:t>
+            </a:r>
+          </a:p>
+        </p:txBody>
+      </p:sp>
+      <p:sp>
+        <p:nvSpPr>
+          <p:cNvPr id="28" name="TextBox 27"/>
+          <p:cNvSpPr txBox="1"/>
+          <p:nvPr/>
+        </p:nvSpPr>
+        <p:spPr>
+          <a:xfrm>
+            <a:off x="1389888" y="4343400"/>
+            <a:ext cx="2907792" cy="402336"/>
+          </a:xfrm>
+          <a:prstGeom prst="rect">
+            <a:avLst/>
+          </a:prstGeom>
+          <a:noFill/>
+        </p:spPr>
+        <p:txBody>
+          <a:bodyPr wrap="square" lIns="0" rIns="0" tIns="0" bIns="0" anchor="ctr">
+            <a:spAutoFit/>
+          </a:bodyPr>
+          <a:lstStyle/>
+          <a:p>
+            <a:pPr algn="l">
+              <a:spcBef>
+                <a:spcPts val="0"/>
+              </a:spcBef>
+              <a:spcAft>
+                <a:spcPts val="0"/>
+              </a:spcAft>
+            </a:pPr>
+            <a:r>
+              <a:rPr sz="1250" b="1">
+                <a:solidFill>
+                  <a:srgbClr val="17324D"/>
+                </a:solidFill>
+                <a:latin typeface="Microsoft YaHei"/>
+              </a:rPr>
+              <a:t>国际化表述策略</a:t>
+            </a:r>
+          </a:p>
+        </p:txBody>
+      </p:sp>
+      <p:sp>
+        <p:nvSpPr>
+          <p:cNvPr id="29" name="TextBox 28"/>
+          <p:cNvSpPr txBox="1"/>
+          <p:nvPr/>
+        </p:nvSpPr>
+        <p:spPr>
+          <a:xfrm>
+            <a:off x="4334256" y="4343400"/>
+            <a:ext cx="2907792" cy="402336"/>
+          </a:xfrm>
+          <a:prstGeom prst="rect">
+            <a:avLst/>
+          </a:prstGeom>
+          <a:noFill/>
+        </p:spPr>
+        <p:txBody>
+          <a:bodyPr wrap="square" lIns="0" rIns="0" tIns="0" bIns="0" anchor="ctr">
+            <a:spAutoFit/>
+          </a:bodyPr>
+          <a:lstStyle/>
+          <a:p>
+            <a:pPr algn="r">
+              <a:spcBef>
+                <a:spcPts val="0"/>
+              </a:spcBef>
+              <a:spcAft>
+                <a:spcPts val="0"/>
+              </a:spcAft>
+            </a:pPr>
+            <a:r>
+              <a:rPr sz="1000" b="0">
+                <a:solidFill>
+                  <a:srgbClr val="62748A"/>
+                </a:solidFill>
+                <a:latin typeface="Microsoft YaHei"/>
+              </a:rPr>
+              <a:t>理想主义 · 工具主义 · 教育主义</a:t>
+            </a:r>
+          </a:p>
+        </p:txBody>
+      </p:sp>
+      <p:sp>
+        <p:nvSpPr>
+          <p:cNvPr id="30" name="Rounded Rectangle 29"/>
+          <p:cNvSpPr/>
+          <p:nvPr/>
+        </p:nvSpPr>
+        <p:spPr>
+          <a:xfrm>
+            <a:off x="731520" y="4919472"/>
+            <a:ext cx="6729984" cy="530352"/>
+          </a:xfrm>
+          <a:prstGeom prst="roundRect">
+            <a:avLst/>
+          </a:prstGeom>
+          <a:solidFill>
+            <a:srgbClr val="FFFFFF"/>
+          </a:solidFill>
+          <a:ln w="10160">
+            <a:solidFill>
+              <a:srgbClr val="D8E1EB"/>
+            </a:solidFill>
+          </a:ln>
+        </p:spPr>
+        <p:style>
+          <a:lnRef idx="1">
+            <a:schemeClr val="accent1"/>
+          </a:lnRef>
+          <a:fillRef idx="3">
+            <a:schemeClr val="accent1"/>
+          </a:fillRef>
+          <a:effectRef idx="2">
+            <a:schemeClr val="accent1"/>
+          </a:effectRef>
+          <a:fontRef idx="minor">
+            <a:schemeClr val="lt1"/>
+          </a:fontRef>
+        </p:style>
+        <p:txBody>
+          <a:bodyPr rtlCol="0" anchor="ctr"/>
+          <a:lstStyle/>
+          <a:p>
+            <a:pPr algn="ctr"/>
+          </a:p>
+        </p:txBody>
+      </p:sp>
+      <p:sp>
+        <p:nvSpPr>
+          <p:cNvPr id="31" name="Oval 30"/>
+          <p:cNvSpPr/>
+          <p:nvPr/>
+        </p:nvSpPr>
+        <p:spPr>
+          <a:xfrm>
+            <a:off x="914400" y="5029200"/>
+            <a:ext cx="310896" cy="310896"/>
+          </a:xfrm>
+          <a:prstGeom prst="ellipse">
+            <a:avLst/>
+          </a:prstGeom>
+          <a:solidFill>
+            <a:srgbClr val="2B7A78"/>
+          </a:solidFill>
+          <a:ln>
+            <a:noFill/>
+          </a:ln>
+        </p:spPr>
+        <p:style>
+          <a:lnRef idx="1">
+            <a:schemeClr val="accent1"/>
+          </a:lnRef>
+          <a:fillRef idx="3">
+            <a:schemeClr val="accent1"/>
+          </a:fillRef>
+          <a:effectRef idx="2">
+            <a:schemeClr val="accent1"/>
+          </a:effectRef>
+          <a:fontRef idx="minor">
+            <a:schemeClr val="lt1"/>
+          </a:fontRef>
+        </p:style>
+        <p:txBody>
+          <a:bodyPr rtlCol="0" anchor="ctr"/>
+          <a:lstStyle/>
+          <a:p>
+            <a:pPr algn="ctr"/>
+          </a:p>
+        </p:txBody>
+      </p:sp>
+      <p:sp>
+        <p:nvSpPr>
+          <p:cNvPr id="32" name="TextBox 31"/>
+          <p:cNvSpPr txBox="1"/>
+          <p:nvPr/>
+        </p:nvSpPr>
+        <p:spPr>
+          <a:xfrm>
+            <a:off x="914400" y="5029200"/>
+            <a:ext cx="310896" cy="310896"/>
+          </a:xfrm>
+          <a:prstGeom prst="rect">
+            <a:avLst/>
+          </a:prstGeom>
+          <a:noFill/>
+        </p:spPr>
+        <p:txBody>
+          <a:bodyPr wrap="square" lIns="0" rIns="0" tIns="0" bIns="0" anchor="ctr">
+            <a:spAutoFit/>
+          </a:bodyPr>
+          <a:lstStyle/>
+          <a:p>
+            <a:pPr algn="ctr">
+              <a:spcBef>
+                <a:spcPts val="0"/>
+              </a:spcBef>
+              <a:spcAft>
+                <a:spcPts val="0"/>
+              </a:spcAft>
+            </a:pPr>
+            <a:r>
+              <a:rPr sz="850" b="1">
+                <a:solidFill>
+                  <a:srgbClr val="FFFFFF"/>
+                </a:solidFill>
+                <a:latin typeface="Microsoft YaHei"/>
+              </a:rPr>
+              <a:t>05</a:t>
+            </a:r>
+          </a:p>
+        </p:txBody>
+      </p:sp>
+      <p:sp>
+        <p:nvSpPr>
+          <p:cNvPr id="33" name="TextBox 32"/>
+          <p:cNvSpPr txBox="1"/>
+          <p:nvPr/>
+        </p:nvSpPr>
+        <p:spPr>
+          <a:xfrm>
+            <a:off x="1389888" y="4983480"/>
+            <a:ext cx="2907792" cy="402336"/>
+          </a:xfrm>
+          <a:prstGeom prst="rect">
+            <a:avLst/>
+          </a:prstGeom>
+          <a:noFill/>
+        </p:spPr>
+        <p:txBody>
+          <a:bodyPr wrap="square" lIns="0" rIns="0" tIns="0" bIns="0" anchor="ctr">
+            <a:spAutoFit/>
+          </a:bodyPr>
+          <a:lstStyle/>
+          <a:p>
+            <a:pPr algn="l">
+              <a:spcBef>
+                <a:spcPts val="0"/>
+              </a:spcBef>
+              <a:spcAft>
+                <a:spcPts val="0"/>
+              </a:spcAft>
+            </a:pPr>
+            <a:r>
+              <a:rPr sz="1250" b="1">
+                <a:solidFill>
+                  <a:srgbClr val="17324D"/>
+                </a:solidFill>
+                <a:latin typeface="Microsoft YaHei"/>
+              </a:rPr>
+              <a:t>多语种资源与跨学科整合</a:t>
+            </a:r>
+          </a:p>
+        </p:txBody>
+      </p:sp>
+      <p:sp>
+        <p:nvSpPr>
+          <p:cNvPr id="34" name="TextBox 33"/>
+          <p:cNvSpPr txBox="1"/>
+          <p:nvPr/>
+        </p:nvSpPr>
+        <p:spPr>
+          <a:xfrm>
+            <a:off x="4334256" y="4983480"/>
+            <a:ext cx="2907792" cy="402336"/>
+          </a:xfrm>
+          <a:prstGeom prst="rect">
+            <a:avLst/>
+          </a:prstGeom>
+          <a:noFill/>
+        </p:spPr>
+        <p:txBody>
+          <a:bodyPr wrap="square" lIns="0" rIns="0" tIns="0" bIns="0" anchor="ctr">
+            <a:spAutoFit/>
+          </a:bodyPr>
+          <a:lstStyle/>
+          <a:p>
+            <a:pPr algn="r">
+              <a:spcBef>
+                <a:spcPts val="0"/>
+              </a:spcBef>
+              <a:spcAft>
+                <a:spcPts val="0"/>
+              </a:spcAft>
+            </a:pPr>
+            <a:r>
+              <a:rPr sz="1000" b="0">
+                <a:solidFill>
+                  <a:srgbClr val="62748A"/>
+                </a:solidFill>
+                <a:latin typeface="Microsoft YaHei"/>
+              </a:rPr>
+              <a:t>语种资源 · 学科融合 · 社会服务</a:t>
+            </a:r>
+          </a:p>
+        </p:txBody>
+      </p:sp>
+      <p:sp>
+        <p:nvSpPr>
+          <p:cNvPr id="35" name="Rounded Rectangle 34"/>
+          <p:cNvSpPr/>
+          <p:nvPr/>
+        </p:nvSpPr>
+        <p:spPr>
+          <a:xfrm>
+            <a:off x="7790688" y="1965960"/>
+            <a:ext cx="3547872" cy="3593592"/>
+          </a:xfrm>
+          <a:prstGeom prst="roundRect">
+            <a:avLst/>
+          </a:prstGeom>
+          <a:solidFill>
+            <a:srgbClr val="EAF1F8"/>
+          </a:solidFill>
+          <a:ln>
+            <a:noFill/>
+          </a:ln>
+        </p:spPr>
+        <p:style>
+          <a:lnRef idx="1">
+            <a:schemeClr val="accent1"/>
+          </a:lnRef>
+          <a:fillRef idx="3">
+            <a:schemeClr val="accent1"/>
+          </a:fillRef>
+          <a:effectRef idx="2">
+            <a:schemeClr val="accent1"/>
+          </a:effectRef>
+          <a:fontRef idx="minor">
+            <a:schemeClr val="lt1"/>
+          </a:fontRef>
+        </p:style>
+        <p:txBody>
+          <a:bodyPr rtlCol="0" anchor="ctr"/>
+          <a:lstStyle/>
+          <a:p>
+            <a:pPr algn="ctr"/>
+          </a:p>
+        </p:txBody>
+      </p:sp>
+      <p:sp>
+        <p:nvSpPr>
+          <p:cNvPr id="36" name="TextBox 35"/>
+          <p:cNvSpPr txBox="1"/>
+          <p:nvPr/>
+        </p:nvSpPr>
+        <p:spPr>
+          <a:xfrm>
+            <a:off x="8046720" y="2157984"/>
+            <a:ext cx="2999232" cy="310896"/>
+          </a:xfrm>
+          <a:prstGeom prst="rect">
+            <a:avLst/>
+          </a:prstGeom>
+          <a:noFill/>
+        </p:spPr>
+        <p:txBody>
+          <a:bodyPr wrap="square" lIns="0" rIns="0" tIns="0" bIns="0" anchor="t">
+            <a:spAutoFit/>
+          </a:bodyPr>
+          <a:lstStyle/>
+          <a:p>
+            <a:pPr algn="l">
+              <a:spcBef>
+                <a:spcPts val="0"/>
+              </a:spcBef>
+              <a:spcAft>
+                <a:spcPts val="0"/>
+              </a:spcAft>
+            </a:pPr>
+            <a:r>
+              <a:rPr sz="1200" b="1">
+                <a:solidFill>
+                  <a:srgbClr val="3568A8"/>
+                </a:solidFill>
+                <a:latin typeface="Microsoft YaHei"/>
+              </a:rPr>
+              <a:t>研究目标</a:t>
+            </a:r>
+          </a:p>
+        </p:txBody>
+      </p:sp>
+      <p:sp>
+        <p:nvSpPr>
+          <p:cNvPr id="37" name="Rounded Rectangle 36"/>
+          <p:cNvSpPr/>
+          <p:nvPr/>
+        </p:nvSpPr>
+        <p:spPr>
+          <a:xfrm>
+            <a:off x="8046720" y="2587752"/>
+            <a:ext cx="3035808" cy="749808"/>
+          </a:xfrm>
+          <a:prstGeom prst="roundRect">
+            <a:avLst/>
+          </a:prstGeom>
+          <a:solidFill>
+            <a:srgbClr val="FFFFFF"/>
+          </a:solidFill>
+          <a:ln>
+            <a:noFill/>
+          </a:ln>
+        </p:spPr>
+        <p:style>
+          <a:lnRef idx="1">
+            <a:schemeClr val="accent1"/>
+          </a:lnRef>
+          <a:fillRef idx="3">
+            <a:schemeClr val="accent1"/>
+          </a:fillRef>
+          <a:effectRef idx="2">
+            <a:schemeClr val="accent1"/>
+          </a:effectRef>
+          <a:fontRef idx="minor">
+            <a:schemeClr val="lt1"/>
+          </a:fontRef>
+        </p:style>
+        <p:txBody>
+          <a:bodyPr rtlCol="0" anchor="ctr"/>
+          <a:lstStyle/>
+          <a:p>
+            <a:pPr algn="ctr"/>
+          </a:p>
+        </p:txBody>
+      </p:sp>
+      <p:sp>
+        <p:nvSpPr>
+          <p:cNvPr id="38" name="Rounded Rectangle 37"/>
+          <p:cNvSpPr/>
+          <p:nvPr/>
+        </p:nvSpPr>
+        <p:spPr>
+          <a:xfrm>
+            <a:off x="8046720" y="2587752"/>
+            <a:ext cx="612648" cy="749808"/>
+          </a:xfrm>
+          <a:prstGeom prst="roundRect">
+            <a:avLst/>
+          </a:prstGeom>
+          <a:solidFill>
+            <a:srgbClr val="3568A8"/>
+          </a:solidFill>
+          <a:ln>
+            <a:noFill/>
+          </a:ln>
+        </p:spPr>
+        <p:style>
+          <a:lnRef idx="1">
+            <a:schemeClr val="accent1"/>
+          </a:lnRef>
+          <a:fillRef idx="3">
+            <a:schemeClr val="accent1"/>
+          </a:fillRef>
+          <a:effectRef idx="2">
+            <a:schemeClr val="accent1"/>
+          </a:effectRef>
+          <a:fontRef idx="minor">
+            <a:schemeClr val="lt1"/>
+          </a:fontRef>
+        </p:style>
+        <p:txBody>
+          <a:bodyPr rtlCol="0" anchor="ctr"/>
+          <a:lstStyle/>
+          <a:p>
+            <a:pPr algn="ctr"/>
+          </a:p>
+        </p:txBody>
+      </p:sp>
+      <p:sp>
+        <p:nvSpPr>
+          <p:cNvPr id="39" name="TextBox 38"/>
+          <p:cNvSpPr txBox="1"/>
+          <p:nvPr/>
+        </p:nvSpPr>
+        <p:spPr>
+          <a:xfrm>
+            <a:off x="8046720" y="2587752"/>
+            <a:ext cx="612648" cy="749808"/>
+          </a:xfrm>
+          <a:prstGeom prst="rect">
+            <a:avLst/>
+          </a:prstGeom>
+          <a:noFill/>
+        </p:spPr>
+        <p:txBody>
+          <a:bodyPr wrap="square" lIns="0" rIns="0" tIns="0" bIns="0" anchor="ctr">
+            <a:spAutoFit/>
+          </a:bodyPr>
+          <a:lstStyle/>
+          <a:p>
+            <a:pPr algn="ctr">
+              <a:spcBef>
+                <a:spcPts val="0"/>
+              </a:spcBef>
+              <a:spcAft>
+                <a:spcPts val="0"/>
+              </a:spcAft>
+            </a:pPr>
+            <a:r>
+              <a:rPr sz="1100" b="1">
+                <a:solidFill>
+                  <a:srgbClr val="FFFFFF"/>
+                </a:solidFill>
+                <a:latin typeface="Microsoft YaHei"/>
+              </a:rPr>
+              <a:t>描述</a:t>
+            </a:r>
+          </a:p>
+        </p:txBody>
+      </p:sp>
+      <p:sp>
+        <p:nvSpPr>
+          <p:cNvPr id="40" name="TextBox 39"/>
+          <p:cNvSpPr txBox="1"/>
+          <p:nvPr/>
+        </p:nvSpPr>
+        <p:spPr>
+          <a:xfrm>
+            <a:off x="8842248" y="2651760"/>
+            <a:ext cx="2011680" cy="621792"/>
+          </a:xfrm>
+          <a:prstGeom prst="rect">
+            <a:avLst/>
+          </a:prstGeom>
+          <a:noFill/>
+        </p:spPr>
+        <p:txBody>
+          <a:bodyPr wrap="square" lIns="0" rIns="0" tIns="0" bIns="0" anchor="ctr">
+            <a:spAutoFit/>
+          </a:bodyPr>
+          <a:lstStyle/>
+          <a:p>
+            <a:pPr algn="l">
+              <a:spcBef>
+                <a:spcPts val="0"/>
+              </a:spcBef>
+              <a:spcAft>
+                <a:spcPts val="0"/>
+              </a:spcAft>
+            </a:pPr>
+            <a:r>
+              <a:rPr sz="1050" b="0">
+                <a:solidFill>
+                  <a:srgbClr val="23364A"/>
+                </a:solidFill>
+                <a:latin typeface="Microsoft YaHei"/>
+              </a:rPr>
+              <a:t>识别文本结构与语言表达的</a:t>
+            </a:r>
+          </a:p>
+          <a:p>
+            <a:pPr algn="l">
+              <a:spcBef>
+                <a:spcPts val="0"/>
+              </a:spcBef>
+              <a:spcAft>
+                <a:spcPts val="0"/>
+              </a:spcAft>
+            </a:pPr>
+            <a:r>
+              <a:rPr sz="1050" b="0">
+                <a:solidFill>
+                  <a:srgbClr val="23364A"/>
+                </a:solidFill>
+                <a:latin typeface="Microsoft YaHei"/>
+              </a:rPr>
+              <a:t>共性及差异</a:t>
+            </a:r>
+          </a:p>
+        </p:txBody>
+      </p:sp>
+      <p:sp>
+        <p:nvSpPr>
+          <p:cNvPr id="41" name="Rounded Rectangle 40"/>
+          <p:cNvSpPr/>
+          <p:nvPr/>
+        </p:nvSpPr>
+        <p:spPr>
+          <a:xfrm>
+            <a:off x="8046720" y="3493008"/>
+            <a:ext cx="3035808" cy="749808"/>
+          </a:xfrm>
+          <a:prstGeom prst="roundRect">
+            <a:avLst/>
+          </a:prstGeom>
+          <a:solidFill>
+            <a:srgbClr val="FFFFFF"/>
+          </a:solidFill>
+          <a:ln>
+            <a:noFill/>
+          </a:ln>
+        </p:spPr>
+        <p:style>
+          <a:lnRef idx="1">
+            <a:schemeClr val="accent1"/>
+          </a:lnRef>
+          <a:fillRef idx="3">
+            <a:schemeClr val="accent1"/>
+          </a:fillRef>
+          <a:effectRef idx="2">
+            <a:schemeClr val="accent1"/>
+          </a:effectRef>
+          <a:fontRef idx="minor">
+            <a:schemeClr val="lt1"/>
+          </a:fontRef>
+        </p:style>
+        <p:txBody>
+          <a:bodyPr rtlCol="0" anchor="ctr"/>
+          <a:lstStyle/>
+          <a:p>
+            <a:pPr algn="ctr"/>
+          </a:p>
+        </p:txBody>
+      </p:sp>
+      <p:sp>
+        <p:nvSpPr>
+          <p:cNvPr id="42" name="Rounded Rectangle 41"/>
+          <p:cNvSpPr/>
+          <p:nvPr/>
+        </p:nvSpPr>
+        <p:spPr>
+          <a:xfrm>
+            <a:off x="8046720" y="3493008"/>
+            <a:ext cx="612648" cy="749808"/>
+          </a:xfrm>
+          <a:prstGeom prst="roundRect">
+            <a:avLst/>
+          </a:prstGeom>
+          <a:solidFill>
+            <a:srgbClr val="2B7A78"/>
+          </a:solidFill>
+          <a:ln>
+            <a:noFill/>
+          </a:ln>
+        </p:spPr>
+        <p:style>
+          <a:lnRef idx="1">
+            <a:schemeClr val="accent1"/>
+          </a:lnRef>
+          <a:fillRef idx="3">
+            <a:schemeClr val="accent1"/>
+          </a:fillRef>
+          <a:effectRef idx="2">
+            <a:schemeClr val="accent1"/>
+          </a:effectRef>
+          <a:fontRef idx="minor">
+            <a:schemeClr val="lt1"/>
+          </a:fontRef>
+        </p:style>
+        <p:txBody>
+          <a:bodyPr rtlCol="0" anchor="ctr"/>
+          <a:lstStyle/>
+          <a:p>
+            <a:pPr algn="ctr"/>
+          </a:p>
+        </p:txBody>
+      </p:sp>
+      <p:sp>
+        <p:nvSpPr>
+          <p:cNvPr id="43" name="TextBox 42"/>
+          <p:cNvSpPr txBox="1"/>
+          <p:nvPr/>
+        </p:nvSpPr>
+        <p:spPr>
+          <a:xfrm>
+            <a:off x="8046720" y="3493008"/>
+            <a:ext cx="612648" cy="749808"/>
+          </a:xfrm>
+          <a:prstGeom prst="rect">
+            <a:avLst/>
+          </a:prstGeom>
+          <a:noFill/>
+        </p:spPr>
+        <p:txBody>
+          <a:bodyPr wrap="square" lIns="0" rIns="0" tIns="0" bIns="0" anchor="ctr">
+            <a:spAutoFit/>
+          </a:bodyPr>
+          <a:lstStyle/>
+          <a:p>
+            <a:pPr algn="ctr">
+              <a:spcBef>
+                <a:spcPts val="0"/>
+              </a:spcBef>
+              <a:spcAft>
+                <a:spcPts val="0"/>
+              </a:spcAft>
+            </a:pPr>
+            <a:r>
+              <a:rPr sz="1100" b="1">
+                <a:solidFill>
+                  <a:srgbClr val="FFFFFF"/>
+                </a:solidFill>
+                <a:latin typeface="Microsoft YaHei"/>
+              </a:rPr>
+              <a:t>解释</a:t>
+            </a:r>
+          </a:p>
+        </p:txBody>
+      </p:sp>
+      <p:sp>
+        <p:nvSpPr>
+          <p:cNvPr id="44" name="TextBox 43"/>
+          <p:cNvSpPr txBox="1"/>
+          <p:nvPr/>
+        </p:nvSpPr>
+        <p:spPr>
+          <a:xfrm>
+            <a:off x="8842248" y="3557016"/>
+            <a:ext cx="2011680" cy="621792"/>
+          </a:xfrm>
+          <a:prstGeom prst="rect">
+            <a:avLst/>
+          </a:prstGeom>
+          <a:noFill/>
+        </p:spPr>
+        <p:txBody>
+          <a:bodyPr wrap="square" lIns="0" rIns="0" tIns="0" bIns="0" anchor="ctr">
+            <a:spAutoFit/>
+          </a:bodyPr>
+          <a:lstStyle/>
+          <a:p>
+            <a:pPr algn="l">
+              <a:spcBef>
+                <a:spcPts val="0"/>
+              </a:spcBef>
+              <a:spcAft>
+                <a:spcPts val="0"/>
+              </a:spcAft>
+            </a:pPr>
+            <a:r>
+              <a:rPr sz="1050" b="0">
+                <a:solidFill>
+                  <a:srgbClr val="23364A"/>
+                </a:solidFill>
+                <a:latin typeface="Microsoft YaHei"/>
+              </a:rPr>
+              <a:t>联系社会文化与制度语境</a:t>
+            </a:r>
+          </a:p>
+          <a:p>
+            <a:pPr algn="l">
+              <a:spcBef>
+                <a:spcPts val="0"/>
+              </a:spcBef>
+              <a:spcAft>
+                <a:spcPts val="0"/>
+              </a:spcAft>
+            </a:pPr>
+            <a:r>
+              <a:rPr sz="1050" b="0">
+                <a:solidFill>
+                  <a:srgbClr val="23364A"/>
+                </a:solidFill>
+                <a:latin typeface="Microsoft YaHei"/>
+              </a:rPr>
+              <a:t>阐释差异成因</a:t>
+            </a:r>
+          </a:p>
+        </p:txBody>
+      </p:sp>
+      <p:sp>
+        <p:nvSpPr>
+          <p:cNvPr id="45" name="Rounded Rectangle 44"/>
+          <p:cNvSpPr/>
+          <p:nvPr/>
+        </p:nvSpPr>
+        <p:spPr>
+          <a:xfrm>
+            <a:off x="8046720" y="4398264"/>
+            <a:ext cx="3035808" cy="749808"/>
+          </a:xfrm>
+          <a:prstGeom prst="roundRect">
+            <a:avLst/>
+          </a:prstGeom>
+          <a:solidFill>
+            <a:srgbClr val="FFFFFF"/>
+          </a:solidFill>
+          <a:ln>
+            <a:noFill/>
+          </a:ln>
+        </p:spPr>
+        <p:style>
+          <a:lnRef idx="1">
+            <a:schemeClr val="accent1"/>
+          </a:lnRef>
+          <a:fillRef idx="3">
+            <a:schemeClr val="accent1"/>
+          </a:fillRef>
+          <a:effectRef idx="2">
+            <a:schemeClr val="accent1"/>
+          </a:effectRef>
+          <a:fontRef idx="minor">
+            <a:schemeClr val="lt1"/>
+          </a:fontRef>
+        </p:style>
+        <p:txBody>
+          <a:bodyPr rtlCol="0" anchor="ctr"/>
+          <a:lstStyle/>
+          <a:p>
+            <a:pPr algn="ctr"/>
+          </a:p>
+        </p:txBody>
+      </p:sp>
+      <p:sp>
+        <p:nvSpPr>
+          <p:cNvPr id="46" name="Rounded Rectangle 45"/>
+          <p:cNvSpPr/>
+          <p:nvPr/>
+        </p:nvSpPr>
+        <p:spPr>
+          <a:xfrm>
+            <a:off x="8046720" y="4398264"/>
+            <a:ext cx="612648" cy="749808"/>
+          </a:xfrm>
+          <a:prstGeom prst="roundRect">
+            <a:avLst/>
+          </a:prstGeom>
+          <a:solidFill>
+            <a:srgbClr val="E38B36"/>
+          </a:solidFill>
+          <a:ln>
+            <a:noFill/>
+          </a:ln>
+        </p:spPr>
+        <p:style>
+          <a:lnRef idx="1">
+            <a:schemeClr val="accent1"/>
+          </a:lnRef>
+          <a:fillRef idx="3">
+            <a:schemeClr val="accent1"/>
+          </a:fillRef>
+          <a:effectRef idx="2">
+            <a:schemeClr val="accent1"/>
+          </a:effectRef>
+          <a:fontRef idx="minor">
+            <a:schemeClr val="lt1"/>
+          </a:fontRef>
+        </p:style>
+        <p:txBody>
+          <a:bodyPr rtlCol="0" anchor="ctr"/>
+          <a:lstStyle/>
+          <a:p>
+            <a:pPr algn="ctr"/>
+          </a:p>
+        </p:txBody>
+      </p:sp>
+      <p:sp>
+        <p:nvSpPr>
+          <p:cNvPr id="47" name="TextBox 46"/>
+          <p:cNvSpPr txBox="1"/>
+          <p:nvPr/>
+        </p:nvSpPr>
+        <p:spPr>
+          <a:xfrm>
+            <a:off x="8046720" y="4398264"/>
+            <a:ext cx="612648" cy="749808"/>
+          </a:xfrm>
+          <a:prstGeom prst="rect">
+            <a:avLst/>
+          </a:prstGeom>
+          <a:noFill/>
+        </p:spPr>
+        <p:txBody>
+          <a:bodyPr wrap="square" lIns="0" rIns="0" tIns="0" bIns="0" anchor="ctr">
+            <a:spAutoFit/>
+          </a:bodyPr>
+          <a:lstStyle/>
+          <a:p>
+            <a:pPr algn="ctr">
+              <a:spcBef>
+                <a:spcPts val="0"/>
+              </a:spcBef>
+              <a:spcAft>
+                <a:spcPts val="0"/>
+              </a:spcAft>
+            </a:pPr>
+            <a:r>
+              <a:rPr sz="1100" b="1">
+                <a:solidFill>
+                  <a:srgbClr val="FFFFFF"/>
+                </a:solidFill>
+                <a:latin typeface="Microsoft YaHei"/>
+              </a:rPr>
+              <a:t>转化</a:t>
+            </a:r>
+          </a:p>
+        </p:txBody>
+      </p:sp>
+      <p:sp>
+        <p:nvSpPr>
+          <p:cNvPr id="48" name="TextBox 47"/>
+          <p:cNvSpPr txBox="1"/>
+          <p:nvPr/>
+        </p:nvSpPr>
+        <p:spPr>
+          <a:xfrm>
+            <a:off x="8842248" y="4462272"/>
+            <a:ext cx="2011680" cy="621792"/>
+          </a:xfrm>
+          <a:prstGeom prst="rect">
+            <a:avLst/>
+          </a:prstGeom>
+          <a:noFill/>
+        </p:spPr>
+        <p:txBody>
+          <a:bodyPr wrap="square" lIns="0" rIns="0" tIns="0" bIns="0" anchor="ctr">
+            <a:spAutoFit/>
+          </a:bodyPr>
+          <a:lstStyle/>
+          <a:p>
+            <a:pPr algn="l">
+              <a:spcBef>
+                <a:spcPts val="0"/>
+              </a:spcBef>
+              <a:spcAft>
+                <a:spcPts val="0"/>
+              </a:spcAft>
+            </a:pPr>
+            <a:r>
+              <a:rPr sz="1050" b="0">
+                <a:solidFill>
+                  <a:srgbClr val="23364A"/>
+                </a:solidFill>
+                <a:latin typeface="Microsoft YaHei"/>
+              </a:rPr>
+              <a:t>形成话语策略建议库</a:t>
+            </a:r>
+          </a:p>
+          <a:p>
+            <a:pPr algn="l">
+              <a:spcBef>
+                <a:spcPts val="0"/>
+              </a:spcBef>
+              <a:spcAft>
+                <a:spcPts val="0"/>
+              </a:spcAft>
+            </a:pPr>
+            <a:r>
+              <a:rPr sz="1050" b="0">
+                <a:solidFill>
+                  <a:srgbClr val="23364A"/>
+                </a:solidFill>
+                <a:latin typeface="Microsoft YaHei"/>
+              </a:rPr>
+              <a:t>与研究论文</a:t>
+            </a:r>
+          </a:p>
+        </p:txBody>
+      </p:sp>
+      <p:cxnSp>
+        <p:nvCxnSpPr>
+          <p:cNvPr id="49" name="Connector 48"/>
+          <p:cNvCxnSpPr/>
+          <p:nvPr/>
+        </p:nvCxnSpPr>
+        <p:spPr>
+          <a:xfrm>
+            <a:off x="731520" y="6144768"/>
+            <a:ext cx="10744200" cy="0"/>
+          </a:xfrm>
+          <a:prstGeom prst="line">
+            <a:avLst/>
+          </a:prstGeom>
+          <a:ln w="10160">
+            <a:solidFill>
+              <a:srgbClr val="D8E1EB"/>
+            </a:solidFill>
+          </a:ln>
+        </p:spPr>
+        <p:style>
+          <a:lnRef idx="2">
+            <a:schemeClr val="accent1"/>
+          </a:lnRef>
+          <a:fillRef idx="0">
+            <a:schemeClr val="accent1"/>
+          </a:fillRef>
+          <a:effectRef idx="1">
+            <a:schemeClr val="accent1"/>
+          </a:effectRef>
+          <a:fontRef idx="minor">
+            <a:schemeClr val="tx1"/>
+          </a:fontRef>
+        </p:style>
+      </p:cxnSp>
+      <p:sp>
+        <p:nvSpPr>
+          <p:cNvPr id="50" name="TextBox 49"/>
+          <p:cNvSpPr txBox="1"/>
+          <p:nvPr/>
+        </p:nvSpPr>
+        <p:spPr>
+          <a:xfrm>
+            <a:off x="731520" y="6318504"/>
+            <a:ext cx="7772400" cy="256032"/>
+          </a:xfrm>
+          <a:prstGeom prst="rect">
+            <a:avLst/>
+          </a:prstGeom>
+          <a:noFill/>
+        </p:spPr>
+        <p:txBody>
+          <a:bodyPr wrap="square" lIns="0" rIns="0" tIns="0" bIns="0" anchor="t">
+            <a:spAutoFit/>
+          </a:bodyPr>
+          <a:lstStyle/>
+          <a:p>
+            <a:pPr algn="l">
+              <a:spcBef>
+                <a:spcPts val="0"/>
+              </a:spcBef>
+              <a:spcAft>
+                <a:spcPts val="0"/>
+              </a:spcAft>
+            </a:pPr>
+            <a:r>
+              <a:rPr sz="900" b="0">
+                <a:solidFill>
+                  <a:srgbClr val="62748A"/>
+                </a:solidFill>
+                <a:latin typeface="Microsoft YaHei"/>
+              </a:rPr>
+              <a:t>基于语料库技术的中美外语院系英文简介话语比较分析</a:t>
+            </a:r>
+          </a:p>
+        </p:txBody>
+      </p:sp>
+      <p:sp>
+        <p:nvSpPr>
+          <p:cNvPr id="51" name="TextBox 50"/>
+          <p:cNvSpPr txBox="1"/>
+          <p:nvPr/>
+        </p:nvSpPr>
+        <p:spPr>
+          <a:xfrm>
+            <a:off x="10881360" y="6318504"/>
+            <a:ext cx="594360" cy="256032"/>
+          </a:xfrm>
+          <a:prstGeom prst="rect">
+            <a:avLst/>
+          </a:prstGeom>
+          <a:noFill/>
+        </p:spPr>
+        <p:txBody>
+          <a:bodyPr wrap="square" lIns="0" rIns="0" tIns="0" bIns="0" anchor="t">
+            <a:spAutoFit/>
+          </a:bodyPr>
+          <a:lstStyle/>
+          <a:p>
+            <a:pPr algn="r">
+              <a:spcBef>
+                <a:spcPts val="0"/>
+              </a:spcBef>
+              <a:spcAft>
+                <a:spcPts val="0"/>
+              </a:spcAft>
+            </a:pPr>
+            <a:r>
+              <a:rPr sz="1000" b="0">
+                <a:solidFill>
+                  <a:srgbClr val="62748A"/>
+                </a:solidFill>
+                <a:latin typeface="Microsoft YaHei"/>
+              </a:rPr>
+              <a:t>02 / 08</a:t>
+            </a:r>
+          </a:p>
+        </p:txBody>
+      </p:sp>
+    </p:spTree>
+  </p:cSld>
+  <p:clrMapOvr>
+    <a:masterClrMapping/>
+  </p:clrMapOvr>
+</p:sld>
+</file>
+
+<file path=ppt/slides/slide3.xml><?xml version="1.0" encoding="utf-8"?>
+<p:sld xmlns:a="http://schemas.openxmlformats.org/drawingml/2006/main" xmlns:p="http://schemas.openxmlformats.org/presentationml/2006/main" xmlns:r="http://schemas.openxmlformats.org/officeDocument/2006/relationships">
+  <p:cSld>
+    <p:spTree>
+      <p:nvGrpSpPr>
+        <p:cNvPr id="1" name=""/>
+        <p:cNvGrpSpPr/>
+        <p:nvPr/>
+      </p:nvGrpSpPr>
+      <p:grpSpPr/>
+      <p:sp>
+        <p:nvSpPr>
+          <p:cNvPr id="2" name="Rectangle 1"/>
+          <p:cNvSpPr/>
+          <p:nvPr/>
+        </p:nvSpPr>
+        <p:spPr>
+          <a:xfrm>
+            <a:off x="0" y="0"/>
+            <a:ext cx="12191695" cy="6858000"/>
+          </a:xfrm>
+          <a:prstGeom prst="rect">
+            <a:avLst/>
+          </a:prstGeom>
+          <a:solidFill>
+            <a:srgbClr val="F7F9FC"/>
+          </a:solidFill>
+          <a:ln>
+            <a:noFill/>
+          </a:ln>
+        </p:spPr>
+        <p:style>
+          <a:lnRef idx="1">
+            <a:schemeClr val="accent1"/>
+          </a:lnRef>
+          <a:fillRef idx="3">
+            <a:schemeClr val="accent1"/>
+          </a:fillRef>
+          <a:effectRef idx="2">
+            <a:schemeClr val="accent1"/>
+          </a:effectRef>
+          <a:fontRef idx="minor">
+            <a:schemeClr val="lt1"/>
+          </a:fontRef>
+        </p:style>
+        <p:txBody>
+          <a:bodyPr rtlCol="0" anchor="ctr"/>
+          <a:lstStyle/>
+          <a:p>
+            <a:pPr algn="ctr"/>
+          </a:p>
+        </p:txBody>
+      </p:sp>
+      <p:sp>
+        <p:nvSpPr>
+          <p:cNvPr id="3" name="Rectangle 2"/>
+          <p:cNvSpPr/>
+          <p:nvPr/>
+        </p:nvSpPr>
+        <p:spPr>
+          <a:xfrm>
+            <a:off x="0" y="0"/>
+            <a:ext cx="146304" cy="6858000"/>
+          </a:xfrm>
+          <a:prstGeom prst="rect">
+            <a:avLst/>
+          </a:prstGeom>
+          <a:solidFill>
+            <a:srgbClr val="17324D"/>
+          </a:solidFill>
+          <a:ln>
+            <a:noFill/>
+          </a:ln>
+        </p:spPr>
+        <p:style>
+          <a:lnRef idx="1">
+            <a:schemeClr val="accent1"/>
+          </a:lnRef>
+          <a:fillRef idx="3">
+            <a:schemeClr val="accent1"/>
+          </a:fillRef>
+          <a:effectRef idx="2">
+            <a:schemeClr val="accent1"/>
+          </a:effectRef>
+          <a:fontRef idx="minor">
+            <a:schemeClr val="lt1"/>
+          </a:fontRef>
+        </p:style>
+        <p:txBody>
+          <a:bodyPr rtlCol="0" anchor="ctr"/>
+          <a:lstStyle/>
+          <a:p>
+            <a:pPr algn="ctr"/>
+          </a:p>
+        </p:txBody>
+      </p:sp>
+      <p:sp>
+        <p:nvSpPr>
+          <p:cNvPr id="4" name="Rectangle 3"/>
+          <p:cNvSpPr/>
+          <p:nvPr/>
+        </p:nvSpPr>
+        <p:spPr>
+          <a:xfrm>
+            <a:off x="146304" y="0"/>
+            <a:ext cx="50292" cy="841248"/>
+          </a:xfrm>
+          <a:prstGeom prst="rect">
+            <a:avLst/>
+          </a:prstGeom>
+          <a:solidFill>
+            <a:srgbClr val="E38B36"/>
+          </a:solidFill>
+          <a:ln>
+            <a:noFill/>
+          </a:ln>
+        </p:spPr>
+        <p:style>
+          <a:lnRef idx="1">
+            <a:schemeClr val="accent1"/>
+          </a:lnRef>
+          <a:fillRef idx="3">
+            <a:schemeClr val="accent1"/>
+          </a:fillRef>
+          <a:effectRef idx="2">
+            <a:schemeClr val="accent1"/>
+          </a:effectRef>
+          <a:fontRef idx="minor">
+            <a:schemeClr val="lt1"/>
+          </a:fontRef>
+        </p:style>
+        <p:txBody>
+          <a:bodyPr rtlCol="0" anchor="ctr"/>
+          <a:lstStyle/>
+          <a:p>
+            <a:pPr algn="ctr"/>
+          </a:p>
+        </p:txBody>
+      </p:sp>
+      <p:sp>
+        <p:nvSpPr>
+          <p:cNvPr id="5" name="TextBox 4"/>
+          <p:cNvSpPr txBox="1"/>
+          <p:nvPr/>
+        </p:nvSpPr>
+        <p:spPr>
+          <a:xfrm>
+            <a:off x="731520" y="438912"/>
+            <a:ext cx="2926080" cy="274320"/>
+          </a:xfrm>
+          <a:prstGeom prst="rect">
+            <a:avLst/>
+          </a:prstGeom>
+          <a:noFill/>
+        </p:spPr>
+        <p:txBody>
+          <a:bodyPr wrap="square" lIns="0" rIns="0" tIns="0" bIns="0" anchor="t">
+            <a:spAutoFit/>
+          </a:bodyPr>
+          <a:lstStyle/>
+          <a:p>
+            <a:pPr algn="l">
+              <a:spcBef>
+                <a:spcPts val="0"/>
+              </a:spcBef>
+              <a:spcAft>
+                <a:spcPts val="0"/>
+              </a:spcAft>
+            </a:pPr>
+            <a:r>
+              <a:rPr sz="1100" b="1">
+                <a:solidFill>
+                  <a:srgbClr val="3568A8"/>
+                </a:solidFill>
+                <a:latin typeface="Microsoft YaHei"/>
+              </a:rPr>
+              <a:t>02　项目概览</a:t>
+            </a:r>
+          </a:p>
+        </p:txBody>
+      </p:sp>
+      <p:sp>
+        <p:nvSpPr>
+          <p:cNvPr id="6" name="TextBox 5"/>
+          <p:cNvSpPr txBox="1"/>
+          <p:nvPr/>
+        </p:nvSpPr>
+        <p:spPr>
+          <a:xfrm>
+            <a:off x="731520" y="768096"/>
+            <a:ext cx="5852160" cy="475488"/>
+          </a:xfrm>
+          <a:prstGeom prst="rect">
+            <a:avLst/>
+          </a:prstGeom>
+          <a:noFill/>
+        </p:spPr>
+        <p:txBody>
+          <a:bodyPr wrap="square" lIns="0" rIns="0" tIns="0" bIns="0" anchor="t">
+            <a:spAutoFit/>
+          </a:bodyPr>
+          <a:lstStyle/>
+          <a:p>
+            <a:pPr algn="l">
+              <a:spcBef>
+                <a:spcPts val="0"/>
+              </a:spcBef>
+              <a:spcAft>
+                <a:spcPts val="0"/>
+              </a:spcAft>
+            </a:pPr>
+            <a:r>
+              <a:rPr sz="2600" b="1">
+                <a:solidFill>
+                  <a:srgbClr val="17324D"/>
+                </a:solidFill>
+                <a:latin typeface="Microsoft YaHei"/>
+              </a:rPr>
+              <a:t>项目整体路线</a:t>
+            </a:r>
+          </a:p>
+        </p:txBody>
+      </p:sp>
+      <p:sp>
+        <p:nvSpPr>
+          <p:cNvPr id="7" name="TextBox 6"/>
+          <p:cNvSpPr txBox="1"/>
+          <p:nvPr/>
+        </p:nvSpPr>
+        <p:spPr>
+          <a:xfrm>
+            <a:off x="731520" y="1307592"/>
+            <a:ext cx="10515600" cy="384048"/>
+          </a:xfrm>
+          <a:prstGeom prst="rect">
+            <a:avLst/>
+          </a:prstGeom>
+          <a:noFill/>
+        </p:spPr>
+        <p:txBody>
+          <a:bodyPr wrap="square" lIns="0" rIns="0" tIns="0" bIns="0" anchor="ctr">
+            <a:spAutoFit/>
+          </a:bodyPr>
+          <a:lstStyle/>
+          <a:p>
+            <a:pPr algn="l">
+              <a:spcBef>
+                <a:spcPts val="0"/>
+              </a:spcBef>
+              <a:spcAft>
+                <a:spcPts val="0"/>
+              </a:spcAft>
+            </a:pPr>
+            <a:r>
+              <a:rPr sz="1400" b="0">
+                <a:solidFill>
+                  <a:srgbClr val="23364A"/>
+                </a:solidFill>
+                <a:latin typeface="Microsoft YaHei"/>
+              </a:rPr>
+              <a:t>定量比较已完成，下一阶段由“描述差异”转向“解释差异与策略转化”</a:t>
+            </a:r>
+          </a:p>
+        </p:txBody>
+      </p:sp>
+      <p:sp>
+        <p:nvSpPr>
+          <p:cNvPr id="8" name="Rectangle 7"/>
+          <p:cNvSpPr/>
+          <p:nvPr/>
+        </p:nvSpPr>
+        <p:spPr>
+          <a:xfrm>
+            <a:off x="731520" y="1773936"/>
+            <a:ext cx="594360" cy="41148"/>
+          </a:xfrm>
+          <a:prstGeom prst="rect">
+            <a:avLst/>
+          </a:prstGeom>
+          <a:solidFill>
+            <a:srgbClr val="E38B36"/>
+          </a:solidFill>
+          <a:ln>
+            <a:noFill/>
+          </a:ln>
+        </p:spPr>
+        <p:style>
+          <a:lnRef idx="1">
+            <a:schemeClr val="accent1"/>
+          </a:lnRef>
+          <a:fillRef idx="3">
+            <a:schemeClr val="accent1"/>
+          </a:fillRef>
+          <a:effectRef idx="2">
+            <a:schemeClr val="accent1"/>
+          </a:effectRef>
+          <a:fontRef idx="minor">
+            <a:schemeClr val="lt1"/>
+          </a:fontRef>
+        </p:style>
+        <p:txBody>
+          <a:bodyPr rtlCol="0" anchor="ctr"/>
+          <a:lstStyle/>
+          <a:p>
+            <a:pPr algn="ctr"/>
+          </a:p>
+        </p:txBody>
+      </p:sp>
+      <p:sp>
+        <p:nvSpPr>
+          <p:cNvPr id="9" name="Oval 8"/>
+          <p:cNvSpPr/>
+          <p:nvPr/>
+        </p:nvSpPr>
+        <p:spPr>
+          <a:xfrm>
+            <a:off x="9354312" y="521207"/>
+            <a:ext cx="109728" cy="109728"/>
+          </a:xfrm>
+          <a:prstGeom prst="ellipse">
+            <a:avLst/>
+          </a:prstGeom>
+          <a:solidFill>
+            <a:srgbClr val="3568A8"/>
+          </a:solidFill>
+          <a:ln>
+            <a:noFill/>
+          </a:ln>
+        </p:spPr>
+        <p:style>
+          <a:lnRef idx="1">
+            <a:schemeClr val="accent1"/>
+          </a:lnRef>
+          <a:fillRef idx="3">
+            <a:schemeClr val="accent1"/>
+          </a:fillRef>
+          <a:effectRef idx="2">
+            <a:schemeClr val="accent1"/>
+          </a:effectRef>
+          <a:fontRef idx="minor">
+            <a:schemeClr val="lt1"/>
+          </a:fontRef>
+        </p:style>
+        <p:txBody>
+          <a:bodyPr rtlCol="0" anchor="ctr"/>
+          <a:lstStyle/>
+          <a:p>
+            <a:pPr algn="ctr"/>
+          </a:p>
+        </p:txBody>
+      </p:sp>
+      <p:sp>
+        <p:nvSpPr>
+          <p:cNvPr id="10" name="TextBox 9"/>
+          <p:cNvSpPr txBox="1"/>
+          <p:nvPr/>
+        </p:nvSpPr>
+        <p:spPr>
+          <a:xfrm>
+            <a:off x="9528048" y="448056"/>
+            <a:ext cx="713232" cy="256032"/>
+          </a:xfrm>
+          <a:prstGeom prst="rect">
+            <a:avLst/>
+          </a:prstGeom>
+          <a:noFill/>
+        </p:spPr>
+        <p:txBody>
+          <a:bodyPr wrap="square" lIns="0" rIns="0" tIns="0" bIns="0" anchor="ctr">
+            <a:spAutoFit/>
+          </a:bodyPr>
+          <a:lstStyle/>
+          <a:p>
+            <a:pPr algn="l">
+              <a:spcBef>
+                <a:spcPts val="0"/>
+              </a:spcBef>
+              <a:spcAft>
+                <a:spcPts val="0"/>
+              </a:spcAft>
+            </a:pPr>
+            <a:r>
+              <a:rPr sz="1000" b="0">
+                <a:solidFill>
+                  <a:srgbClr val="62748A"/>
+                </a:solidFill>
+                <a:latin typeface="Microsoft YaHei"/>
+              </a:rPr>
+              <a:t>已完成</a:t>
+            </a:r>
+          </a:p>
+        </p:txBody>
+      </p:sp>
+      <p:sp>
+        <p:nvSpPr>
+          <p:cNvPr id="11" name="Oval 10"/>
+          <p:cNvSpPr/>
+          <p:nvPr/>
+        </p:nvSpPr>
+        <p:spPr>
+          <a:xfrm>
+            <a:off x="10360152" y="521207"/>
+            <a:ext cx="109728" cy="109728"/>
+          </a:xfrm>
+          <a:prstGeom prst="ellipse">
+            <a:avLst/>
+          </a:prstGeom>
+          <a:solidFill>
+            <a:srgbClr val="E38B36"/>
+          </a:solidFill>
+          <a:ln>
+            <a:noFill/>
+          </a:ln>
+        </p:spPr>
+        <p:style>
+          <a:lnRef idx="1">
+            <a:schemeClr val="accent1"/>
+          </a:lnRef>
+          <a:fillRef idx="3">
+            <a:schemeClr val="accent1"/>
+          </a:fillRef>
+          <a:effectRef idx="2">
+            <a:schemeClr val="accent1"/>
+          </a:effectRef>
+          <a:fontRef idx="minor">
+            <a:schemeClr val="lt1"/>
+          </a:fontRef>
+        </p:style>
+        <p:txBody>
+          <a:bodyPr rtlCol="0" anchor="ctr"/>
+          <a:lstStyle/>
+          <a:p>
+            <a:pPr algn="ctr"/>
+          </a:p>
+        </p:txBody>
+      </p:sp>
+      <p:sp>
+        <p:nvSpPr>
+          <p:cNvPr id="12" name="TextBox 11"/>
+          <p:cNvSpPr txBox="1"/>
+          <p:nvPr/>
+        </p:nvSpPr>
+        <p:spPr>
+          <a:xfrm>
+            <a:off x="10533888" y="448056"/>
+            <a:ext cx="932688" cy="256032"/>
+          </a:xfrm>
+          <a:prstGeom prst="rect">
+            <a:avLst/>
+          </a:prstGeom>
+          <a:noFill/>
+        </p:spPr>
+        <p:txBody>
+          <a:bodyPr wrap="square" lIns="0" rIns="0" tIns="0" bIns="0" anchor="ctr">
+            <a:spAutoFit/>
+          </a:bodyPr>
+          <a:lstStyle/>
+          <a:p>
+            <a:pPr algn="l">
+              <a:spcBef>
+                <a:spcPts val="0"/>
+              </a:spcBef>
+              <a:spcAft>
+                <a:spcPts val="0"/>
+              </a:spcAft>
+            </a:pPr>
+            <a:r>
+              <a:rPr sz="1000" b="0">
+                <a:solidFill>
+                  <a:srgbClr val="62748A"/>
+                </a:solidFill>
+                <a:latin typeface="Microsoft YaHei"/>
+              </a:rPr>
+              <a:t>下一阶段</a:t>
+            </a:r>
+          </a:p>
+        </p:txBody>
+      </p:sp>
+      <p:sp>
+        <p:nvSpPr>
+          <p:cNvPr id="13" name="Rounded Rectangle 12"/>
+          <p:cNvSpPr/>
+          <p:nvPr/>
+        </p:nvSpPr>
+        <p:spPr>
+          <a:xfrm>
+            <a:off x="731520" y="2011680"/>
+            <a:ext cx="1901952" cy="3200400"/>
+          </a:xfrm>
+          <a:prstGeom prst="roundRect">
+            <a:avLst/>
+          </a:prstGeom>
+          <a:solidFill>
+            <a:srgbClr val="FFFFFF"/>
+          </a:solidFill>
+          <a:ln w="10160">
+            <a:solidFill>
+              <a:srgbClr val="D8E1EB"/>
+            </a:solidFill>
+          </a:ln>
+        </p:spPr>
+        <p:style>
+          <a:lnRef idx="1">
+            <a:schemeClr val="accent1"/>
+          </a:lnRef>
+          <a:fillRef idx="3">
+            <a:schemeClr val="accent1"/>
+          </a:fillRef>
+          <a:effectRef idx="2">
+            <a:schemeClr val="accent1"/>
+          </a:effectRef>
+          <a:fontRef idx="minor">
+            <a:schemeClr val="lt1"/>
+          </a:fontRef>
+        </p:style>
+        <p:txBody>
+          <a:bodyPr rtlCol="0" anchor="ctr"/>
+          <a:lstStyle/>
+          <a:p>
+            <a:pPr algn="ctr"/>
+          </a:p>
+        </p:txBody>
+      </p:sp>
+      <p:sp>
+        <p:nvSpPr>
+          <p:cNvPr id="14" name="Rectangle 13"/>
+          <p:cNvSpPr/>
+          <p:nvPr/>
+        </p:nvSpPr>
+        <p:spPr>
+          <a:xfrm>
+            <a:off x="731520" y="2011680"/>
+            <a:ext cx="1901952" cy="64008"/>
+          </a:xfrm>
+          <a:prstGeom prst="rect">
+            <a:avLst/>
+          </a:prstGeom>
+          <a:solidFill>
+            <a:srgbClr val="3568A8"/>
+          </a:solidFill>
+          <a:ln>
+            <a:noFill/>
+          </a:ln>
+        </p:spPr>
+        <p:style>
+          <a:lnRef idx="1">
+            <a:schemeClr val="accent1"/>
+          </a:lnRef>
+          <a:fillRef idx="3">
+            <a:schemeClr val="accent1"/>
+          </a:fillRef>
+          <a:effectRef idx="2">
+            <a:schemeClr val="accent1"/>
+          </a:effectRef>
+          <a:fontRef idx="minor">
+            <a:schemeClr val="lt1"/>
+          </a:fontRef>
+        </p:style>
+        <p:txBody>
+          <a:bodyPr rtlCol="0" anchor="ctr"/>
+          <a:lstStyle/>
+          <a:p>
+            <a:pPr algn="ctr"/>
+          </a:p>
+        </p:txBody>
+      </p:sp>
+      <p:sp>
+        <p:nvSpPr>
+          <p:cNvPr id="15" name="Rounded Rectangle 14"/>
+          <p:cNvSpPr/>
+          <p:nvPr/>
+        </p:nvSpPr>
+        <p:spPr>
+          <a:xfrm>
+            <a:off x="896112" y="2240280"/>
+            <a:ext cx="658368" cy="274320"/>
+          </a:xfrm>
+          <a:prstGeom prst="roundRect">
+            <a:avLst/>
+          </a:prstGeom>
+          <a:solidFill>
+            <a:srgbClr val="EAF1F8"/>
+          </a:solidFill>
+          <a:ln>
+            <a:noFill/>
+          </a:ln>
+        </p:spPr>
+        <p:style>
+          <a:lnRef idx="1">
+            <a:schemeClr val="accent1"/>
+          </a:lnRef>
+          <a:fillRef idx="3">
+            <a:schemeClr val="accent1"/>
+          </a:fillRef>
+          <a:effectRef idx="2">
+            <a:schemeClr val="accent1"/>
+          </a:effectRef>
+          <a:fontRef idx="minor">
+            <a:schemeClr val="lt1"/>
+          </a:fontRef>
+        </p:style>
+        <p:txBody>
+          <a:bodyPr rtlCol="0" anchor="ctr"/>
+          <a:lstStyle/>
+          <a:p>
+            <a:pPr algn="ctr"/>
+          </a:p>
+        </p:txBody>
+      </p:sp>
+      <p:sp>
+        <p:nvSpPr>
+          <p:cNvPr id="16" name="TextBox 15"/>
+          <p:cNvSpPr txBox="1"/>
+          <p:nvPr/>
+        </p:nvSpPr>
+        <p:spPr>
+          <a:xfrm>
+            <a:off x="896112" y="2240280"/>
+            <a:ext cx="658368" cy="274320"/>
+          </a:xfrm>
+          <a:prstGeom prst="rect">
+            <a:avLst/>
+          </a:prstGeom>
+          <a:noFill/>
+        </p:spPr>
+        <p:txBody>
+          <a:bodyPr wrap="square" lIns="0" rIns="0" tIns="0" bIns="0" anchor="ctr">
+            <a:spAutoFit/>
+          </a:bodyPr>
+          <a:lstStyle/>
+          <a:p>
+            <a:pPr algn="ctr">
+              <a:spcBef>
+                <a:spcPts val="0"/>
+              </a:spcBef>
+              <a:spcAft>
+                <a:spcPts val="0"/>
+              </a:spcAft>
+            </a:pPr>
+            <a:r>
+              <a:rPr sz="900" b="1">
+                <a:solidFill>
+                  <a:srgbClr val="3568A8"/>
+                </a:solidFill>
+                <a:latin typeface="Microsoft YaHei"/>
+              </a:rPr>
+              <a:t>已完成</a:t>
+            </a:r>
+          </a:p>
+        </p:txBody>
+      </p:sp>
+      <p:sp>
+        <p:nvSpPr>
+          <p:cNvPr id="17" name="TextBox 16"/>
+          <p:cNvSpPr txBox="1"/>
+          <p:nvPr/>
+        </p:nvSpPr>
+        <p:spPr>
+          <a:xfrm>
+            <a:off x="896112" y="2679192"/>
+            <a:ext cx="1143000" cy="493776"/>
+          </a:xfrm>
+          <a:prstGeom prst="rect">
+            <a:avLst/>
+          </a:prstGeom>
+          <a:noFill/>
+        </p:spPr>
+        <p:txBody>
+          <a:bodyPr wrap="square" lIns="0" rIns="0" tIns="0" bIns="0" anchor="t">
+            <a:spAutoFit/>
+          </a:bodyPr>
+          <a:lstStyle/>
+          <a:p>
+            <a:pPr algn="l">
+              <a:spcBef>
+                <a:spcPts val="0"/>
+              </a:spcBef>
+              <a:spcAft>
+                <a:spcPts val="0"/>
+              </a:spcAft>
+            </a:pPr>
+            <a:r>
+              <a:rPr sz="2700" b="1">
+                <a:solidFill>
+                  <a:srgbClr val="3568A8"/>
+                </a:solidFill>
+                <a:latin typeface="Microsoft YaHei"/>
+              </a:rPr>
+              <a:t>01</a:t>
+            </a:r>
+          </a:p>
+        </p:txBody>
+      </p:sp>
+      <p:sp>
+        <p:nvSpPr>
+          <p:cNvPr id="18" name="TextBox 17"/>
+          <p:cNvSpPr txBox="1"/>
+          <p:nvPr/>
+        </p:nvSpPr>
+        <p:spPr>
+          <a:xfrm>
+            <a:off x="896112" y="3264408"/>
+            <a:ext cx="1581912" cy="384048"/>
+          </a:xfrm>
+          <a:prstGeom prst="rect">
+            <a:avLst/>
+          </a:prstGeom>
+          <a:noFill/>
+        </p:spPr>
+        <p:txBody>
+          <a:bodyPr wrap="square" lIns="0" rIns="0" tIns="0" bIns="0" anchor="ctr">
+            <a:spAutoFit/>
+          </a:bodyPr>
+          <a:lstStyle/>
+          <a:p>
+            <a:pPr algn="l">
+              <a:spcBef>
+                <a:spcPts val="0"/>
+              </a:spcBef>
+              <a:spcAft>
+                <a:spcPts val="0"/>
+              </a:spcAft>
+            </a:pPr>
+            <a:r>
+              <a:rPr sz="1600" b="1">
+                <a:solidFill>
+                  <a:srgbClr val="17324D"/>
+                </a:solidFill>
+                <a:latin typeface="Microsoft YaHei"/>
+              </a:rPr>
+              <a:t>语料构建</a:t>
+            </a:r>
+          </a:p>
+        </p:txBody>
+      </p:sp>
+      <p:sp>
+        <p:nvSpPr>
+          <p:cNvPr id="19" name="TextBox 18"/>
+          <p:cNvSpPr txBox="1"/>
+          <p:nvPr/>
+        </p:nvSpPr>
+        <p:spPr>
+          <a:xfrm>
+            <a:off x="896112" y="3822191"/>
+            <a:ext cx="1581912" cy="786384"/>
+          </a:xfrm>
+          <a:prstGeom prst="rect">
+            <a:avLst/>
+          </a:prstGeom>
+          <a:noFill/>
+        </p:spPr>
+        <p:txBody>
+          <a:bodyPr wrap="square" lIns="0" rIns="0" tIns="0" bIns="0" anchor="t">
+            <a:spAutoFit/>
+          </a:bodyPr>
+          <a:lstStyle/>
+          <a:p>
+            <a:pPr algn="l">
+              <a:spcBef>
+                <a:spcPts val="0"/>
+              </a:spcBef>
+              <a:spcAft>
+                <a:spcPts val="0"/>
+              </a:spcAft>
+            </a:pPr>
+            <a:r>
+              <a:rPr sz="1100" b="0">
+                <a:solidFill>
+                  <a:srgbClr val="62748A"/>
+                </a:solidFill>
+                <a:latin typeface="Microsoft YaHei"/>
+              </a:rPr>
+              <a:t>中国、美国各30个</a:t>
+            </a:r>
+          </a:p>
+          <a:p>
+            <a:pPr algn="l">
+              <a:spcBef>
+                <a:spcPts val="0"/>
+              </a:spcBef>
+              <a:spcAft>
+                <a:spcPts val="0"/>
+              </a:spcAft>
+            </a:pPr>
+            <a:r>
+              <a:rPr sz="1100" b="0">
+                <a:solidFill>
+                  <a:srgbClr val="62748A"/>
+                </a:solidFill>
+                <a:latin typeface="Microsoft YaHei"/>
+              </a:rPr>
+              <a:t>外语院系英文简介</a:t>
+            </a:r>
+          </a:p>
+        </p:txBody>
+      </p:sp>
+      <p:cxnSp>
+        <p:nvCxnSpPr>
+          <p:cNvPr id="20" name="Connector 19"/>
+          <p:cNvCxnSpPr/>
+          <p:nvPr/>
+        </p:nvCxnSpPr>
+        <p:spPr>
+          <a:xfrm>
+            <a:off x="896112" y="4690872"/>
+            <a:ext cx="1572768" cy="0"/>
+          </a:xfrm>
+          <a:prstGeom prst="line">
+            <a:avLst/>
+          </a:prstGeom>
+          <a:ln w="10160">
+            <a:solidFill>
+              <a:srgbClr val="D8E1EB"/>
+            </a:solidFill>
+          </a:ln>
+        </p:spPr>
+        <p:style>
+          <a:lnRef idx="2">
+            <a:schemeClr val="accent1"/>
+          </a:lnRef>
+          <a:fillRef idx="0">
+            <a:schemeClr val="accent1"/>
+          </a:fillRef>
+          <a:effectRef idx="1">
+            <a:schemeClr val="accent1"/>
+          </a:effectRef>
+          <a:fontRef idx="minor">
+            <a:schemeClr val="tx1"/>
+          </a:fontRef>
+        </p:style>
+      </p:cxnSp>
+      <p:sp>
+        <p:nvSpPr>
+          <p:cNvPr id="21" name="TextBox 20"/>
+          <p:cNvSpPr txBox="1"/>
+          <p:nvPr/>
+        </p:nvSpPr>
+        <p:spPr>
+          <a:xfrm>
+            <a:off x="896112" y="4809744"/>
+            <a:ext cx="1581912" cy="256032"/>
+          </a:xfrm>
+          <a:prstGeom prst="rect">
+            <a:avLst/>
+          </a:prstGeom>
+          <a:noFill/>
+        </p:spPr>
+        <p:txBody>
+          <a:bodyPr wrap="square" lIns="0" rIns="0" tIns="0" bIns="0" anchor="ctr">
+            <a:spAutoFit/>
+          </a:bodyPr>
+          <a:lstStyle/>
+          <a:p>
+            <a:pPr algn="l">
+              <a:spcBef>
+                <a:spcPts val="0"/>
+              </a:spcBef>
+              <a:spcAft>
+                <a:spcPts val="0"/>
+              </a:spcAft>
+            </a:pPr>
+            <a:r>
+              <a:rPr sz="1000" b="1">
+                <a:solidFill>
+                  <a:srgbClr val="3568A8"/>
+                </a:solidFill>
+                <a:latin typeface="Microsoft YaHei"/>
+              </a:rPr>
+              <a:t>60个院系文本</a:t>
+            </a:r>
+          </a:p>
+        </p:txBody>
+      </p:sp>
+      <p:sp>
+        <p:nvSpPr>
+          <p:cNvPr id="22" name="Rounded Rectangle 21"/>
+          <p:cNvSpPr/>
+          <p:nvPr/>
+        </p:nvSpPr>
+        <p:spPr>
+          <a:xfrm>
+            <a:off x="2907792" y="2011680"/>
+            <a:ext cx="1901952" cy="3200400"/>
+          </a:xfrm>
+          <a:prstGeom prst="roundRect">
+            <a:avLst/>
+          </a:prstGeom>
+          <a:solidFill>
+            <a:srgbClr val="FFFFFF"/>
+          </a:solidFill>
+          <a:ln w="10160">
+            <a:solidFill>
+              <a:srgbClr val="D8E1EB"/>
+            </a:solidFill>
+          </a:ln>
+        </p:spPr>
+        <p:style>
+          <a:lnRef idx="1">
+            <a:schemeClr val="accent1"/>
+          </a:lnRef>
+          <a:fillRef idx="3">
+            <a:schemeClr val="accent1"/>
+          </a:fillRef>
+          <a:effectRef idx="2">
+            <a:schemeClr val="accent1"/>
+          </a:effectRef>
+          <a:fontRef idx="minor">
+            <a:schemeClr val="lt1"/>
+          </a:fontRef>
+        </p:style>
+        <p:txBody>
+          <a:bodyPr rtlCol="0" anchor="ctr"/>
+          <a:lstStyle/>
+          <a:p>
+            <a:pPr algn="ctr"/>
+          </a:p>
+        </p:txBody>
+      </p:sp>
+      <p:sp>
+        <p:nvSpPr>
+          <p:cNvPr id="23" name="Rectangle 22"/>
+          <p:cNvSpPr/>
+          <p:nvPr/>
+        </p:nvSpPr>
+        <p:spPr>
+          <a:xfrm>
+            <a:off x="2907792" y="2011680"/>
+            <a:ext cx="1901952" cy="64008"/>
+          </a:xfrm>
+          <a:prstGeom prst="rect">
+            <a:avLst/>
+          </a:prstGeom>
+          <a:solidFill>
+            <a:srgbClr val="3568A8"/>
+          </a:solidFill>
+          <a:ln>
+            <a:noFill/>
+          </a:ln>
+        </p:spPr>
+        <p:style>
+          <a:lnRef idx="1">
+            <a:schemeClr val="accent1"/>
+          </a:lnRef>
+          <a:fillRef idx="3">
+            <a:schemeClr val="accent1"/>
+          </a:fillRef>
+          <a:effectRef idx="2">
+            <a:schemeClr val="accent1"/>
+          </a:effectRef>
+          <a:fontRef idx="minor">
+            <a:schemeClr val="lt1"/>
+          </a:fontRef>
+        </p:style>
+        <p:txBody>
+          <a:bodyPr rtlCol="0" anchor="ctr"/>
+          <a:lstStyle/>
+          <a:p>
+            <a:pPr algn="ctr"/>
+          </a:p>
+        </p:txBody>
+      </p:sp>
+      <p:sp>
+        <p:nvSpPr>
+          <p:cNvPr id="24" name="Rounded Rectangle 23"/>
+          <p:cNvSpPr/>
+          <p:nvPr/>
+        </p:nvSpPr>
+        <p:spPr>
+          <a:xfrm>
+            <a:off x="3072384" y="2240280"/>
+            <a:ext cx="658368" cy="274320"/>
+          </a:xfrm>
+          <a:prstGeom prst="roundRect">
+            <a:avLst/>
+          </a:prstGeom>
+          <a:solidFill>
+            <a:srgbClr val="EAF1F8"/>
+          </a:solidFill>
+          <a:ln>
+            <a:noFill/>
+          </a:ln>
+        </p:spPr>
+        <p:style>
+          <a:lnRef idx="1">
+            <a:schemeClr val="accent1"/>
+          </a:lnRef>
+          <a:fillRef idx="3">
+            <a:schemeClr val="accent1"/>
+          </a:fillRef>
+          <a:effectRef idx="2">
+            <a:schemeClr val="accent1"/>
+          </a:effectRef>
+          <a:fontRef idx="minor">
+            <a:schemeClr val="lt1"/>
+          </a:fontRef>
+        </p:style>
+        <p:txBody>
+          <a:bodyPr rtlCol="0" anchor="ctr"/>
+          <a:lstStyle/>
+          <a:p>
+            <a:pPr algn="ctr"/>
+          </a:p>
+        </p:txBody>
+      </p:sp>
+      <p:sp>
+        <p:nvSpPr>
+          <p:cNvPr id="25" name="TextBox 24"/>
+          <p:cNvSpPr txBox="1"/>
+          <p:nvPr/>
+        </p:nvSpPr>
+        <p:spPr>
+          <a:xfrm>
+            <a:off x="3072384" y="2240280"/>
+            <a:ext cx="658368" cy="274320"/>
+          </a:xfrm>
+          <a:prstGeom prst="rect">
+            <a:avLst/>
+          </a:prstGeom>
+          <a:noFill/>
+        </p:spPr>
+        <p:txBody>
+          <a:bodyPr wrap="square" lIns="0" rIns="0" tIns="0" bIns="0" anchor="ctr">
+            <a:spAutoFit/>
+          </a:bodyPr>
+          <a:lstStyle/>
+          <a:p>
+            <a:pPr algn="ctr">
+              <a:spcBef>
+                <a:spcPts val="0"/>
+              </a:spcBef>
+              <a:spcAft>
+                <a:spcPts val="0"/>
+              </a:spcAft>
+            </a:pPr>
+            <a:r>
+              <a:rPr sz="900" b="1">
+                <a:solidFill>
+                  <a:srgbClr val="3568A8"/>
+                </a:solidFill>
+                <a:latin typeface="Microsoft YaHei"/>
+              </a:rPr>
+              <a:t>已完成</a:t>
+            </a:r>
+          </a:p>
+        </p:txBody>
+      </p:sp>
+      <p:sp>
+        <p:nvSpPr>
+          <p:cNvPr id="26" name="TextBox 25"/>
+          <p:cNvSpPr txBox="1"/>
+          <p:nvPr/>
+        </p:nvSpPr>
+        <p:spPr>
+          <a:xfrm>
+            <a:off x="3072384" y="2679192"/>
+            <a:ext cx="1143000" cy="493776"/>
+          </a:xfrm>
+          <a:prstGeom prst="rect">
+            <a:avLst/>
+          </a:prstGeom>
+          <a:noFill/>
+        </p:spPr>
+        <p:txBody>
+          <a:bodyPr wrap="square" lIns="0" rIns="0" tIns="0" bIns="0" anchor="t">
+            <a:spAutoFit/>
+          </a:bodyPr>
+          <a:lstStyle/>
+          <a:p>
+            <a:pPr algn="l">
+              <a:spcBef>
+                <a:spcPts val="0"/>
+              </a:spcBef>
+              <a:spcAft>
+                <a:spcPts val="0"/>
+              </a:spcAft>
+            </a:pPr>
+            <a:r>
+              <a:rPr sz="2700" b="1">
+                <a:solidFill>
+                  <a:srgbClr val="3568A8"/>
+                </a:solidFill>
+                <a:latin typeface="Microsoft YaHei"/>
+              </a:rPr>
+              <a:t>02</a:t>
+            </a:r>
+          </a:p>
+        </p:txBody>
+      </p:sp>
+      <p:sp>
+        <p:nvSpPr>
+          <p:cNvPr id="27" name="TextBox 26"/>
+          <p:cNvSpPr txBox="1"/>
+          <p:nvPr/>
+        </p:nvSpPr>
+        <p:spPr>
+          <a:xfrm>
+            <a:off x="3072384" y="3264408"/>
+            <a:ext cx="1581912" cy="384048"/>
+          </a:xfrm>
+          <a:prstGeom prst="rect">
+            <a:avLst/>
+          </a:prstGeom>
+          <a:noFill/>
+        </p:spPr>
+        <p:txBody>
+          <a:bodyPr wrap="square" lIns="0" rIns="0" tIns="0" bIns="0" anchor="ctr">
+            <a:spAutoFit/>
+          </a:bodyPr>
+          <a:lstStyle/>
+          <a:p>
+            <a:pPr algn="l">
+              <a:spcBef>
+                <a:spcPts val="0"/>
+              </a:spcBef>
+              <a:spcAft>
+                <a:spcPts val="0"/>
+              </a:spcAft>
+            </a:pPr>
+            <a:r>
+              <a:rPr sz="1600" b="1">
+                <a:solidFill>
+                  <a:srgbClr val="17324D"/>
+                </a:solidFill>
+                <a:latin typeface="Microsoft YaHei"/>
+              </a:rPr>
+              <a:t>框架与校订</a:t>
+            </a:r>
+          </a:p>
+        </p:txBody>
+      </p:sp>
+      <p:sp>
+        <p:nvSpPr>
+          <p:cNvPr id="28" name="TextBox 27"/>
+          <p:cNvSpPr txBox="1"/>
+          <p:nvPr/>
+        </p:nvSpPr>
+        <p:spPr>
+          <a:xfrm>
+            <a:off x="3072384" y="3822191"/>
+            <a:ext cx="1581912" cy="786384"/>
+          </a:xfrm>
+          <a:prstGeom prst="rect">
+            <a:avLst/>
+          </a:prstGeom>
+          <a:noFill/>
+        </p:spPr>
+        <p:txBody>
+          <a:bodyPr wrap="square" lIns="0" rIns="0" tIns="0" bIns="0" anchor="t">
+            <a:spAutoFit/>
+          </a:bodyPr>
+          <a:lstStyle/>
+          <a:p>
+            <a:pPr algn="l">
+              <a:spcBef>
+                <a:spcPts val="0"/>
+              </a:spcBef>
+              <a:spcAft>
+                <a:spcPts val="0"/>
+              </a:spcAft>
+            </a:pPr>
+            <a:r>
+              <a:rPr sz="1100" b="0">
+                <a:solidFill>
+                  <a:srgbClr val="62748A"/>
+                </a:solidFill>
+                <a:latin typeface="Microsoft YaHei"/>
+              </a:rPr>
+              <a:t>AI预标注</a:t>
+            </a:r>
+          </a:p>
+          <a:p>
+            <a:pPr algn="l">
+              <a:spcBef>
+                <a:spcPts val="0"/>
+              </a:spcBef>
+              <a:spcAft>
+                <a:spcPts val="0"/>
+              </a:spcAft>
+            </a:pPr>
+            <a:r>
+              <a:rPr sz="1100" b="0">
+                <a:solidFill>
+                  <a:srgbClr val="62748A"/>
+                </a:solidFill>
+                <a:latin typeface="Microsoft YaHei"/>
+              </a:rPr>
+              <a:t>人工逐篇校订</a:t>
+            </a:r>
+          </a:p>
+        </p:txBody>
+      </p:sp>
+      <p:cxnSp>
+        <p:nvCxnSpPr>
+          <p:cNvPr id="29" name="Connector 28"/>
+          <p:cNvCxnSpPr/>
+          <p:nvPr/>
+        </p:nvCxnSpPr>
+        <p:spPr>
+          <a:xfrm>
+            <a:off x="3072384" y="4690872"/>
+            <a:ext cx="1572768" cy="0"/>
+          </a:xfrm>
+          <a:prstGeom prst="line">
+            <a:avLst/>
+          </a:prstGeom>
+          <a:ln w="10160">
+            <a:solidFill>
+              <a:srgbClr val="D8E1EB"/>
+            </a:solidFill>
+          </a:ln>
+        </p:spPr>
+        <p:style>
+          <a:lnRef idx="2">
+            <a:schemeClr val="accent1"/>
+          </a:lnRef>
+          <a:fillRef idx="0">
+            <a:schemeClr val="accent1"/>
+          </a:fillRef>
+          <a:effectRef idx="1">
+            <a:schemeClr val="accent1"/>
+          </a:effectRef>
+          <a:fontRef idx="minor">
+            <a:schemeClr val="tx1"/>
+          </a:fontRef>
+        </p:style>
+      </p:cxnSp>
+      <p:sp>
+        <p:nvSpPr>
+          <p:cNvPr id="30" name="TextBox 29"/>
+          <p:cNvSpPr txBox="1"/>
+          <p:nvPr/>
+        </p:nvSpPr>
+        <p:spPr>
+          <a:xfrm>
+            <a:off x="3072384" y="4809744"/>
+            <a:ext cx="1581912" cy="256032"/>
+          </a:xfrm>
+          <a:prstGeom prst="rect">
+            <a:avLst/>
+          </a:prstGeom>
+          <a:noFill/>
+        </p:spPr>
+        <p:txBody>
+          <a:bodyPr wrap="square" lIns="0" rIns="0" tIns="0" bIns="0" anchor="ctr">
+            <a:spAutoFit/>
+          </a:bodyPr>
+          <a:lstStyle/>
+          <a:p>
+            <a:pPr algn="l">
+              <a:spcBef>
+                <a:spcPts val="0"/>
+              </a:spcBef>
+              <a:spcAft>
+                <a:spcPts val="0"/>
+              </a:spcAft>
+            </a:pPr>
+            <a:r>
+              <a:rPr sz="1000" b="1">
+                <a:solidFill>
+                  <a:srgbClr val="3568A8"/>
+                </a:solidFill>
+                <a:latin typeface="Microsoft YaHei"/>
+              </a:rPr>
+              <a:t>10个核心语步</a:t>
+            </a:r>
+          </a:p>
+        </p:txBody>
+      </p:sp>
+      <p:sp>
+        <p:nvSpPr>
+          <p:cNvPr id="31" name="Rounded Rectangle 30"/>
+          <p:cNvSpPr/>
+          <p:nvPr/>
+        </p:nvSpPr>
+        <p:spPr>
+          <a:xfrm>
+            <a:off x="5084064" y="2011680"/>
+            <a:ext cx="1901952" cy="3200400"/>
+          </a:xfrm>
+          <a:prstGeom prst="roundRect">
+            <a:avLst/>
+          </a:prstGeom>
+          <a:solidFill>
+            <a:srgbClr val="FFFFFF"/>
+          </a:solidFill>
+          <a:ln w="10160">
+            <a:solidFill>
+              <a:srgbClr val="D8E1EB"/>
+            </a:solidFill>
+          </a:ln>
+        </p:spPr>
+        <p:style>
+          <a:lnRef idx="1">
+            <a:schemeClr val="accent1"/>
+          </a:lnRef>
+          <a:fillRef idx="3">
+            <a:schemeClr val="accent1"/>
+          </a:fillRef>
+          <a:effectRef idx="2">
+            <a:schemeClr val="accent1"/>
+          </a:effectRef>
+          <a:fontRef idx="minor">
+            <a:schemeClr val="lt1"/>
+          </a:fontRef>
+        </p:style>
+        <p:txBody>
+          <a:bodyPr rtlCol="0" anchor="ctr"/>
+          <a:lstStyle/>
+          <a:p>
+            <a:pPr algn="ctr"/>
+          </a:p>
+        </p:txBody>
+      </p:sp>
+      <p:sp>
+        <p:nvSpPr>
+          <p:cNvPr id="32" name="Rectangle 31"/>
+          <p:cNvSpPr/>
+          <p:nvPr/>
+        </p:nvSpPr>
+        <p:spPr>
+          <a:xfrm>
+            <a:off x="5084064" y="2011680"/>
+            <a:ext cx="1901952" cy="64008"/>
+          </a:xfrm>
+          <a:prstGeom prst="rect">
+            <a:avLst/>
+          </a:prstGeom>
+          <a:solidFill>
+            <a:srgbClr val="3568A8"/>
+          </a:solidFill>
+          <a:ln>
+            <a:noFill/>
+          </a:ln>
+        </p:spPr>
+        <p:style>
+          <a:lnRef idx="1">
+            <a:schemeClr val="accent1"/>
+          </a:lnRef>
+          <a:fillRef idx="3">
+            <a:schemeClr val="accent1"/>
+          </a:fillRef>
+          <a:effectRef idx="2">
+            <a:schemeClr val="accent1"/>
+          </a:effectRef>
+          <a:fontRef idx="minor">
+            <a:schemeClr val="lt1"/>
+          </a:fontRef>
+        </p:style>
+        <p:txBody>
+          <a:bodyPr rtlCol="0" anchor="ctr"/>
+          <a:lstStyle/>
+          <a:p>
+            <a:pPr algn="ctr"/>
+          </a:p>
+        </p:txBody>
+      </p:sp>
+      <p:sp>
+        <p:nvSpPr>
+          <p:cNvPr id="33" name="Rounded Rectangle 32"/>
+          <p:cNvSpPr/>
+          <p:nvPr/>
+        </p:nvSpPr>
+        <p:spPr>
+          <a:xfrm>
+            <a:off x="5248655" y="2240280"/>
+            <a:ext cx="658368" cy="274320"/>
+          </a:xfrm>
+          <a:prstGeom prst="roundRect">
+            <a:avLst/>
+          </a:prstGeom>
+          <a:solidFill>
+            <a:srgbClr val="EAF1F8"/>
+          </a:solidFill>
+          <a:ln>
+            <a:noFill/>
+          </a:ln>
+        </p:spPr>
+        <p:style>
+          <a:lnRef idx="1">
+            <a:schemeClr val="accent1"/>
+          </a:lnRef>
+          <a:fillRef idx="3">
+            <a:schemeClr val="accent1"/>
+          </a:fillRef>
+          <a:effectRef idx="2">
+            <a:schemeClr val="accent1"/>
+          </a:effectRef>
+          <a:fontRef idx="minor">
+            <a:schemeClr val="lt1"/>
+          </a:fontRef>
+        </p:style>
+        <p:txBody>
+          <a:bodyPr rtlCol="0" anchor="ctr"/>
+          <a:lstStyle/>
+          <a:p>
+            <a:pPr algn="ctr"/>
+          </a:p>
+        </p:txBody>
+      </p:sp>
+      <p:sp>
+        <p:nvSpPr>
+          <p:cNvPr id="34" name="TextBox 33"/>
+          <p:cNvSpPr txBox="1"/>
+          <p:nvPr/>
+        </p:nvSpPr>
+        <p:spPr>
+          <a:xfrm>
+            <a:off x="5248655" y="2240280"/>
+            <a:ext cx="658368" cy="274320"/>
+          </a:xfrm>
+          <a:prstGeom prst="rect">
+            <a:avLst/>
+          </a:prstGeom>
+          <a:noFill/>
+        </p:spPr>
+        <p:txBody>
+          <a:bodyPr wrap="square" lIns="0" rIns="0" tIns="0" bIns="0" anchor="ctr">
+            <a:spAutoFit/>
+          </a:bodyPr>
+          <a:lstStyle/>
+          <a:p>
+            <a:pPr algn="ctr">
+              <a:spcBef>
+                <a:spcPts val="0"/>
+              </a:spcBef>
+              <a:spcAft>
+                <a:spcPts val="0"/>
+              </a:spcAft>
+            </a:pPr>
+            <a:r>
+              <a:rPr sz="900" b="1">
+                <a:solidFill>
+                  <a:srgbClr val="3568A8"/>
+                </a:solidFill>
+                <a:latin typeface="Microsoft YaHei"/>
+              </a:rPr>
+              <a:t>已完成</a:t>
+            </a:r>
+          </a:p>
+        </p:txBody>
+      </p:sp>
+      <p:sp>
+        <p:nvSpPr>
+          <p:cNvPr id="35" name="TextBox 34"/>
+          <p:cNvSpPr txBox="1"/>
+          <p:nvPr/>
+        </p:nvSpPr>
+        <p:spPr>
+          <a:xfrm>
+            <a:off x="5248655" y="2679192"/>
+            <a:ext cx="1143000" cy="493776"/>
+          </a:xfrm>
+          <a:prstGeom prst="rect">
+            <a:avLst/>
+          </a:prstGeom>
+          <a:noFill/>
+        </p:spPr>
+        <p:txBody>
+          <a:bodyPr wrap="square" lIns="0" rIns="0" tIns="0" bIns="0" anchor="t">
+            <a:spAutoFit/>
+          </a:bodyPr>
+          <a:lstStyle/>
+          <a:p>
+            <a:pPr algn="l">
+              <a:spcBef>
+                <a:spcPts val="0"/>
+              </a:spcBef>
+              <a:spcAft>
+                <a:spcPts val="0"/>
+              </a:spcAft>
+            </a:pPr>
+            <a:r>
+              <a:rPr sz="2700" b="1">
+                <a:solidFill>
+                  <a:srgbClr val="3568A8"/>
+                </a:solidFill>
+                <a:latin typeface="Microsoft YaHei"/>
+              </a:rPr>
+              <a:t>03</a:t>
+            </a:r>
+          </a:p>
+        </p:txBody>
+      </p:sp>
+      <p:sp>
+        <p:nvSpPr>
+          <p:cNvPr id="36" name="TextBox 35"/>
+          <p:cNvSpPr txBox="1"/>
+          <p:nvPr/>
+        </p:nvSpPr>
+        <p:spPr>
+          <a:xfrm>
+            <a:off x="5248655" y="3264408"/>
+            <a:ext cx="1581912" cy="384048"/>
+          </a:xfrm>
+          <a:prstGeom prst="rect">
+            <a:avLst/>
+          </a:prstGeom>
+          <a:noFill/>
+        </p:spPr>
+        <p:txBody>
+          <a:bodyPr wrap="square" lIns="0" rIns="0" tIns="0" bIns="0" anchor="ctr">
+            <a:spAutoFit/>
+          </a:bodyPr>
+          <a:lstStyle/>
+          <a:p>
+            <a:pPr algn="l">
+              <a:spcBef>
+                <a:spcPts val="0"/>
+              </a:spcBef>
+              <a:spcAft>
+                <a:spcPts val="0"/>
+              </a:spcAft>
+            </a:pPr>
+            <a:r>
+              <a:rPr sz="1600" b="1">
+                <a:solidFill>
+                  <a:srgbClr val="17324D"/>
+                </a:solidFill>
+                <a:latin typeface="Microsoft YaHei"/>
+              </a:rPr>
+              <a:t>语步分布</a:t>
+            </a:r>
+          </a:p>
+        </p:txBody>
+      </p:sp>
+      <p:sp>
+        <p:nvSpPr>
+          <p:cNvPr id="37" name="TextBox 36"/>
+          <p:cNvSpPr txBox="1"/>
+          <p:nvPr/>
+        </p:nvSpPr>
+        <p:spPr>
+          <a:xfrm>
+            <a:off x="5248655" y="3822191"/>
+            <a:ext cx="1581912" cy="786384"/>
+          </a:xfrm>
+          <a:prstGeom prst="rect">
+            <a:avLst/>
+          </a:prstGeom>
+          <a:noFill/>
+        </p:spPr>
+        <p:txBody>
+          <a:bodyPr wrap="square" lIns="0" rIns="0" tIns="0" bIns="0" anchor="t">
+            <a:spAutoFit/>
+          </a:bodyPr>
+          <a:lstStyle/>
+          <a:p>
+            <a:pPr algn="l">
+              <a:spcBef>
+                <a:spcPts val="0"/>
+              </a:spcBef>
+              <a:spcAft>
+                <a:spcPts val="0"/>
+              </a:spcAft>
+            </a:pPr>
+            <a:r>
+              <a:rPr sz="1100" b="0">
+                <a:solidFill>
+                  <a:srgbClr val="62748A"/>
+                </a:solidFill>
+                <a:latin typeface="Microsoft YaHei"/>
+              </a:rPr>
+              <a:t>出现率 · 篇幅</a:t>
+            </a:r>
+          </a:p>
+          <a:p>
+            <a:pPr algn="l">
+              <a:spcBef>
+                <a:spcPts val="0"/>
+              </a:spcBef>
+              <a:spcAft>
+                <a:spcPts val="0"/>
+              </a:spcAft>
+            </a:pPr>
+            <a:r>
+              <a:rPr sz="1100" b="0">
+                <a:solidFill>
+                  <a:srgbClr val="62748A"/>
+                </a:solidFill>
+                <a:latin typeface="Microsoft YaHei"/>
+              </a:rPr>
+              <a:t>开篇位置</a:t>
+            </a:r>
+          </a:p>
+        </p:txBody>
+      </p:sp>
+      <p:cxnSp>
+        <p:nvCxnSpPr>
+          <p:cNvPr id="38" name="Connector 37"/>
+          <p:cNvCxnSpPr/>
+          <p:nvPr/>
+        </p:nvCxnSpPr>
+        <p:spPr>
+          <a:xfrm>
+            <a:off x="5248655" y="4690872"/>
+            <a:ext cx="1572768" cy="0"/>
+          </a:xfrm>
+          <a:prstGeom prst="line">
+            <a:avLst/>
+          </a:prstGeom>
+          <a:ln w="10160">
+            <a:solidFill>
+              <a:srgbClr val="D8E1EB"/>
+            </a:solidFill>
+          </a:ln>
+        </p:spPr>
+        <p:style>
+          <a:lnRef idx="2">
+            <a:schemeClr val="accent1"/>
+          </a:lnRef>
+          <a:fillRef idx="0">
+            <a:schemeClr val="accent1"/>
+          </a:fillRef>
+          <a:effectRef idx="1">
+            <a:schemeClr val="accent1"/>
+          </a:effectRef>
+          <a:fontRef idx="minor">
+            <a:schemeClr val="tx1"/>
+          </a:fontRef>
+        </p:style>
+      </p:cxnSp>
+      <p:sp>
+        <p:nvSpPr>
+          <p:cNvPr id="39" name="TextBox 38"/>
+          <p:cNvSpPr txBox="1"/>
+          <p:nvPr/>
+        </p:nvSpPr>
+        <p:spPr>
+          <a:xfrm>
+            <a:off x="5248655" y="4809744"/>
+            <a:ext cx="1581912" cy="256032"/>
+          </a:xfrm>
+          <a:prstGeom prst="rect">
+            <a:avLst/>
+          </a:prstGeom>
+          <a:noFill/>
+        </p:spPr>
+        <p:txBody>
+          <a:bodyPr wrap="square" lIns="0" rIns="0" tIns="0" bIns="0" anchor="ctr">
+            <a:spAutoFit/>
+          </a:bodyPr>
+          <a:lstStyle/>
+          <a:p>
+            <a:pPr algn="l">
+              <a:spcBef>
+                <a:spcPts val="0"/>
+              </a:spcBef>
+              <a:spcAft>
+                <a:spcPts val="0"/>
+              </a:spcAft>
+            </a:pPr>
+            <a:r>
+              <a:rPr sz="1000" b="1">
+                <a:solidFill>
+                  <a:srgbClr val="3568A8"/>
+                </a:solidFill>
+                <a:latin typeface="Microsoft YaHei"/>
+              </a:rPr>
+              <a:t>比较结构组织</a:t>
+            </a:r>
+          </a:p>
+        </p:txBody>
+      </p:sp>
+      <p:sp>
+        <p:nvSpPr>
+          <p:cNvPr id="40" name="Rounded Rectangle 39"/>
+          <p:cNvSpPr/>
+          <p:nvPr/>
+        </p:nvSpPr>
+        <p:spPr>
+          <a:xfrm>
+            <a:off x="7260336" y="2011680"/>
+            <a:ext cx="1901952" cy="3200400"/>
+          </a:xfrm>
+          <a:prstGeom prst="roundRect">
+            <a:avLst/>
+          </a:prstGeom>
+          <a:solidFill>
+            <a:srgbClr val="FFFFFF"/>
+          </a:solidFill>
+          <a:ln w="10160">
+            <a:solidFill>
+              <a:srgbClr val="D8E1EB"/>
+            </a:solidFill>
+          </a:ln>
+        </p:spPr>
+        <p:style>
+          <a:lnRef idx="1">
+            <a:schemeClr val="accent1"/>
+          </a:lnRef>
+          <a:fillRef idx="3">
+            <a:schemeClr val="accent1"/>
+          </a:fillRef>
+          <a:effectRef idx="2">
+            <a:schemeClr val="accent1"/>
+          </a:effectRef>
+          <a:fontRef idx="minor">
+            <a:schemeClr val="lt1"/>
+          </a:fontRef>
+        </p:style>
+        <p:txBody>
+          <a:bodyPr rtlCol="0" anchor="ctr"/>
+          <a:lstStyle/>
+          <a:p>
+            <a:pPr algn="ctr"/>
+          </a:p>
+        </p:txBody>
+      </p:sp>
+      <p:sp>
+        <p:nvSpPr>
           <p:cNvPr id="41" name="Rectangle 40"/>
           <p:cNvSpPr/>
           <p:nvPr/>
@@ -7890,7 +10090,7 @@
                 </a:solidFill>
                 <a:latin typeface="Microsoft YaHei"/>
               </a:rPr>
-              <a:t>02 / 07</a:t>
+              <a:t>03 / 08</a:t>
             </a:r>
           </a:p>
         </p:txBody>

</xml_diff>

<commit_message>
Add editable research design slide
Co-authored-by: arena-agent <297053741+arena-agent@users.noreply.github.com>
</commit_message>
<xml_diff>
--- a/midterm-report/presentation/中美外语院系英文简介_5分钟汇报.pptx
+++ b/midterm-report/presentation/中美外语院系英文简介_5分钟汇报.pptx
@@ -8,6 +8,7 @@
     <p:sldId id="256" r:id="rId7"/>
     <p:sldId id="257" r:id="rId8"/>
     <p:sldId id="258" r:id="rId9"/>
+    <p:sldId id="259" r:id="rId10"/>
   </p:sldIdLst>
   <p:sldSz cx="12191695" cy="6858000" type="screen4x3"/>
   <p:notesSz cx="6858000" cy="9144000"/>
@@ -10091,6 +10092,2868 @@
                 <a:latin typeface="Microsoft YaHei"/>
               </a:rPr>
               <a:t>03 / 08</a:t>
+            </a:r>
+          </a:p>
+        </p:txBody>
+      </p:sp>
+    </p:spTree>
+  </p:cSld>
+  <p:clrMapOvr>
+    <a:masterClrMapping/>
+  </p:clrMapOvr>
+</p:sld>
+</file>
+
+<file path=ppt/slides/slide4.xml><?xml version="1.0" encoding="utf-8"?>
+<p:sld xmlns:a="http://schemas.openxmlformats.org/drawingml/2006/main" xmlns:p="http://schemas.openxmlformats.org/presentationml/2006/main" xmlns:r="http://schemas.openxmlformats.org/officeDocument/2006/relationships">
+  <p:cSld>
+    <p:spTree>
+      <p:nvGrpSpPr>
+        <p:cNvPr id="1" name=""/>
+        <p:cNvGrpSpPr/>
+        <p:nvPr/>
+      </p:nvGrpSpPr>
+      <p:grpSpPr/>
+      <p:sp>
+        <p:nvSpPr>
+          <p:cNvPr id="2" name="Rectangle 1"/>
+          <p:cNvSpPr/>
+          <p:nvPr/>
+        </p:nvSpPr>
+        <p:spPr>
+          <a:xfrm>
+            <a:off x="0" y="0"/>
+            <a:ext cx="12191695" cy="6858000"/>
+          </a:xfrm>
+          <a:prstGeom prst="rect">
+            <a:avLst/>
+          </a:prstGeom>
+          <a:solidFill>
+            <a:srgbClr val="F7F9FC"/>
+          </a:solidFill>
+          <a:ln>
+            <a:noFill/>
+          </a:ln>
+        </p:spPr>
+        <p:style>
+          <a:lnRef idx="1">
+            <a:schemeClr val="accent1"/>
+          </a:lnRef>
+          <a:fillRef idx="3">
+            <a:schemeClr val="accent1"/>
+          </a:fillRef>
+          <a:effectRef idx="2">
+            <a:schemeClr val="accent1"/>
+          </a:effectRef>
+          <a:fontRef idx="minor">
+            <a:schemeClr val="lt1"/>
+          </a:fontRef>
+        </p:style>
+        <p:txBody>
+          <a:bodyPr rtlCol="0" anchor="ctr"/>
+          <a:lstStyle/>
+          <a:p>
+            <a:pPr algn="ctr"/>
+          </a:p>
+        </p:txBody>
+      </p:sp>
+      <p:sp>
+        <p:nvSpPr>
+          <p:cNvPr id="3" name="Rectangle 2"/>
+          <p:cNvSpPr/>
+          <p:nvPr/>
+        </p:nvSpPr>
+        <p:spPr>
+          <a:xfrm>
+            <a:off x="0" y="0"/>
+            <a:ext cx="146304" cy="6858000"/>
+          </a:xfrm>
+          <a:prstGeom prst="rect">
+            <a:avLst/>
+          </a:prstGeom>
+          <a:solidFill>
+            <a:srgbClr val="17324D"/>
+          </a:solidFill>
+          <a:ln>
+            <a:noFill/>
+          </a:ln>
+        </p:spPr>
+        <p:style>
+          <a:lnRef idx="1">
+            <a:schemeClr val="accent1"/>
+          </a:lnRef>
+          <a:fillRef idx="3">
+            <a:schemeClr val="accent1"/>
+          </a:fillRef>
+          <a:effectRef idx="2">
+            <a:schemeClr val="accent1"/>
+          </a:effectRef>
+          <a:fontRef idx="minor">
+            <a:schemeClr val="lt1"/>
+          </a:fontRef>
+        </p:style>
+        <p:txBody>
+          <a:bodyPr rtlCol="0" anchor="ctr"/>
+          <a:lstStyle/>
+          <a:p>
+            <a:pPr algn="ctr"/>
+          </a:p>
+        </p:txBody>
+      </p:sp>
+      <p:sp>
+        <p:nvSpPr>
+          <p:cNvPr id="4" name="Rectangle 3"/>
+          <p:cNvSpPr/>
+          <p:nvPr/>
+        </p:nvSpPr>
+        <p:spPr>
+          <a:xfrm>
+            <a:off x="146304" y="0"/>
+            <a:ext cx="50292" cy="841248"/>
+          </a:xfrm>
+          <a:prstGeom prst="rect">
+            <a:avLst/>
+          </a:prstGeom>
+          <a:solidFill>
+            <a:srgbClr val="E38B36"/>
+          </a:solidFill>
+          <a:ln>
+            <a:noFill/>
+          </a:ln>
+        </p:spPr>
+        <p:style>
+          <a:lnRef idx="1">
+            <a:schemeClr val="accent1"/>
+          </a:lnRef>
+          <a:fillRef idx="3">
+            <a:schemeClr val="accent1"/>
+          </a:fillRef>
+          <a:effectRef idx="2">
+            <a:schemeClr val="accent1"/>
+          </a:effectRef>
+          <a:fontRef idx="minor">
+            <a:schemeClr val="lt1"/>
+          </a:fontRef>
+        </p:style>
+        <p:txBody>
+          <a:bodyPr rtlCol="0" anchor="ctr"/>
+          <a:lstStyle/>
+          <a:p>
+            <a:pPr algn="ctr"/>
+          </a:p>
+        </p:txBody>
+      </p:sp>
+      <p:sp>
+        <p:nvSpPr>
+          <p:cNvPr id="5" name="TextBox 4"/>
+          <p:cNvSpPr txBox="1"/>
+          <p:nvPr/>
+        </p:nvSpPr>
+        <p:spPr>
+          <a:xfrm>
+            <a:off x="731520" y="438912"/>
+            <a:ext cx="2926080" cy="274320"/>
+          </a:xfrm>
+          <a:prstGeom prst="rect">
+            <a:avLst/>
+          </a:prstGeom>
+          <a:noFill/>
+        </p:spPr>
+        <p:txBody>
+          <a:bodyPr wrap="square" lIns="0" rIns="0" tIns="0" bIns="0" anchor="t">
+            <a:spAutoFit/>
+          </a:bodyPr>
+          <a:lstStyle/>
+          <a:p>
+            <a:pPr algn="l">
+              <a:spcBef>
+                <a:spcPts val="0"/>
+              </a:spcBef>
+              <a:spcAft>
+                <a:spcPts val="0"/>
+              </a:spcAft>
+            </a:pPr>
+            <a:r>
+              <a:rPr sz="1100" b="1">
+                <a:solidFill>
+                  <a:srgbClr val="3568A8"/>
+                </a:solidFill>
+                <a:latin typeface="Microsoft YaHei"/>
+              </a:rPr>
+              <a:t>03　研究设计</a:t>
+            </a:r>
+          </a:p>
+        </p:txBody>
+      </p:sp>
+      <p:sp>
+        <p:nvSpPr>
+          <p:cNvPr id="6" name="TextBox 5"/>
+          <p:cNvSpPr txBox="1"/>
+          <p:nvPr/>
+        </p:nvSpPr>
+        <p:spPr>
+          <a:xfrm>
+            <a:off x="731520" y="768096"/>
+            <a:ext cx="7863840" cy="475488"/>
+          </a:xfrm>
+          <a:prstGeom prst="rect">
+            <a:avLst/>
+          </a:prstGeom>
+          <a:noFill/>
+        </p:spPr>
+        <p:txBody>
+          <a:bodyPr wrap="square" lIns="0" rIns="0" tIns="0" bIns="0" anchor="t">
+            <a:spAutoFit/>
+          </a:bodyPr>
+          <a:lstStyle/>
+          <a:p>
+            <a:pPr algn="l">
+              <a:spcBef>
+                <a:spcPts val="0"/>
+              </a:spcBef>
+              <a:spcAft>
+                <a:spcPts val="0"/>
+              </a:spcAft>
+            </a:pPr>
+            <a:r>
+              <a:rPr sz="2600" b="1">
+                <a:solidFill>
+                  <a:srgbClr val="17324D"/>
+                </a:solidFill>
+                <a:latin typeface="Microsoft YaHei"/>
+              </a:rPr>
+              <a:t>样本、语步与人机协作校订</a:t>
+            </a:r>
+          </a:p>
+        </p:txBody>
+      </p:sp>
+      <p:sp>
+        <p:nvSpPr>
+          <p:cNvPr id="7" name="TextBox 6"/>
+          <p:cNvSpPr txBox="1"/>
+          <p:nvPr/>
+        </p:nvSpPr>
+        <p:spPr>
+          <a:xfrm>
+            <a:off x="731520" y="1307592"/>
+            <a:ext cx="10515600" cy="384048"/>
+          </a:xfrm>
+          <a:prstGeom prst="rect">
+            <a:avLst/>
+          </a:prstGeom>
+          <a:noFill/>
+        </p:spPr>
+        <p:txBody>
+          <a:bodyPr wrap="square" lIns="0" rIns="0" tIns="0" bIns="0" anchor="ctr">
+            <a:spAutoFit/>
+          </a:bodyPr>
+          <a:lstStyle/>
+          <a:p>
+            <a:pPr algn="l">
+              <a:spcBef>
+                <a:spcPts val="0"/>
+              </a:spcBef>
+              <a:spcAft>
+                <a:spcPts val="0"/>
+              </a:spcAft>
+            </a:pPr>
+            <a:r>
+              <a:rPr sz="1400" b="0">
+                <a:solidFill>
+                  <a:srgbClr val="23364A"/>
+                </a:solidFill>
+                <a:latin typeface="Microsoft YaHei"/>
+              </a:rPr>
+              <a:t>以院系级文本为比较单位，后续统计与语言分析均基于人工校订标签</a:t>
+            </a:r>
+          </a:p>
+        </p:txBody>
+      </p:sp>
+      <p:sp>
+        <p:nvSpPr>
+          <p:cNvPr id="8" name="Rectangle 7"/>
+          <p:cNvSpPr/>
+          <p:nvPr/>
+        </p:nvSpPr>
+        <p:spPr>
+          <a:xfrm>
+            <a:off x="731520" y="1773936"/>
+            <a:ext cx="594360" cy="41148"/>
+          </a:xfrm>
+          <a:prstGeom prst="rect">
+            <a:avLst/>
+          </a:prstGeom>
+          <a:solidFill>
+            <a:srgbClr val="E38B36"/>
+          </a:solidFill>
+          <a:ln>
+            <a:noFill/>
+          </a:ln>
+        </p:spPr>
+        <p:style>
+          <a:lnRef idx="1">
+            <a:schemeClr val="accent1"/>
+          </a:lnRef>
+          <a:fillRef idx="3">
+            <a:schemeClr val="accent1"/>
+          </a:fillRef>
+          <a:effectRef idx="2">
+            <a:schemeClr val="accent1"/>
+          </a:effectRef>
+          <a:fontRef idx="minor">
+            <a:schemeClr val="lt1"/>
+          </a:fontRef>
+        </p:style>
+        <p:txBody>
+          <a:bodyPr rtlCol="0" anchor="ctr"/>
+          <a:lstStyle/>
+          <a:p>
+            <a:pPr algn="ctr"/>
+          </a:p>
+        </p:txBody>
+      </p:sp>
+      <p:sp>
+        <p:nvSpPr>
+          <p:cNvPr id="9" name="Rounded Rectangle 8"/>
+          <p:cNvSpPr/>
+          <p:nvPr/>
+        </p:nvSpPr>
+        <p:spPr>
+          <a:xfrm>
+            <a:off x="731520" y="2011680"/>
+            <a:ext cx="2514600" cy="3584448"/>
+          </a:xfrm>
+          <a:prstGeom prst="roundRect">
+            <a:avLst/>
+          </a:prstGeom>
+          <a:solidFill>
+            <a:srgbClr val="FFFFFF"/>
+          </a:solidFill>
+          <a:ln w="10160">
+            <a:solidFill>
+              <a:srgbClr val="D8E1EB"/>
+            </a:solidFill>
+          </a:ln>
+        </p:spPr>
+        <p:style>
+          <a:lnRef idx="1">
+            <a:schemeClr val="accent1"/>
+          </a:lnRef>
+          <a:fillRef idx="3">
+            <a:schemeClr val="accent1"/>
+          </a:fillRef>
+          <a:effectRef idx="2">
+            <a:schemeClr val="accent1"/>
+          </a:effectRef>
+          <a:fontRef idx="minor">
+            <a:schemeClr val="lt1"/>
+          </a:fontRef>
+        </p:style>
+        <p:txBody>
+          <a:bodyPr rtlCol="0" anchor="ctr"/>
+          <a:lstStyle/>
+          <a:p>
+            <a:pPr algn="ctr"/>
+          </a:p>
+        </p:txBody>
+      </p:sp>
+      <p:sp>
+        <p:nvSpPr>
+          <p:cNvPr id="10" name="TextBox 9"/>
+          <p:cNvSpPr txBox="1"/>
+          <p:nvPr/>
+        </p:nvSpPr>
+        <p:spPr>
+          <a:xfrm>
+            <a:off x="950976" y="2212848"/>
+            <a:ext cx="2057400" cy="292608"/>
+          </a:xfrm>
+          <a:prstGeom prst="rect">
+            <a:avLst/>
+          </a:prstGeom>
+          <a:noFill/>
+        </p:spPr>
+        <p:txBody>
+          <a:bodyPr wrap="square" lIns="0" rIns="0" tIns="0" bIns="0" anchor="t">
+            <a:spAutoFit/>
+          </a:bodyPr>
+          <a:lstStyle/>
+          <a:p>
+            <a:pPr algn="l">
+              <a:spcBef>
+                <a:spcPts val="0"/>
+              </a:spcBef>
+              <a:spcAft>
+                <a:spcPts val="0"/>
+              </a:spcAft>
+            </a:pPr>
+            <a:r>
+              <a:rPr sz="1200" b="1">
+                <a:solidFill>
+                  <a:srgbClr val="3568A8"/>
+                </a:solidFill>
+                <a:latin typeface="Microsoft YaHei"/>
+              </a:rPr>
+              <a:t>01　语料样本</a:t>
+            </a:r>
+          </a:p>
+        </p:txBody>
+      </p:sp>
+      <p:sp>
+        <p:nvSpPr>
+          <p:cNvPr id="11" name="TextBox 10"/>
+          <p:cNvSpPr txBox="1"/>
+          <p:nvPr/>
+        </p:nvSpPr>
+        <p:spPr>
+          <a:xfrm>
+            <a:off x="950976" y="2633472"/>
+            <a:ext cx="2057400" cy="603504"/>
+          </a:xfrm>
+          <a:prstGeom prst="rect">
+            <a:avLst/>
+          </a:prstGeom>
+          <a:noFill/>
+        </p:spPr>
+        <p:txBody>
+          <a:bodyPr wrap="square" lIns="0" rIns="0" tIns="0" bIns="0" anchor="t">
+            <a:spAutoFit/>
+          </a:bodyPr>
+          <a:lstStyle/>
+          <a:p>
+            <a:pPr algn="ctr">
+              <a:spcBef>
+                <a:spcPts val="0"/>
+              </a:spcBef>
+              <a:spcAft>
+                <a:spcPts val="0"/>
+              </a:spcAft>
+            </a:pPr>
+            <a:r>
+              <a:rPr sz="3500" b="1">
+                <a:solidFill>
+                  <a:srgbClr val="17324D"/>
+                </a:solidFill>
+                <a:latin typeface="Microsoft YaHei"/>
+              </a:rPr>
+              <a:t>60</a:t>
+            </a:r>
+          </a:p>
+        </p:txBody>
+      </p:sp>
+      <p:sp>
+        <p:nvSpPr>
+          <p:cNvPr id="12" name="TextBox 11"/>
+          <p:cNvSpPr txBox="1"/>
+          <p:nvPr/>
+        </p:nvSpPr>
+        <p:spPr>
+          <a:xfrm>
+            <a:off x="950976" y="3200400"/>
+            <a:ext cx="2057400" cy="274320"/>
+          </a:xfrm>
+          <a:prstGeom prst="rect">
+            <a:avLst/>
+          </a:prstGeom>
+          <a:noFill/>
+        </p:spPr>
+        <p:txBody>
+          <a:bodyPr wrap="square" lIns="0" rIns="0" tIns="0" bIns="0" anchor="t">
+            <a:spAutoFit/>
+          </a:bodyPr>
+          <a:lstStyle/>
+          <a:p>
+            <a:pPr algn="ctr">
+              <a:spcBef>
+                <a:spcPts val="0"/>
+              </a:spcBef>
+              <a:spcAft>
+                <a:spcPts val="0"/>
+              </a:spcAft>
+            </a:pPr>
+            <a:r>
+              <a:rPr sz="1100" b="0">
+                <a:solidFill>
+                  <a:srgbClr val="62748A"/>
+                </a:solidFill>
+                <a:latin typeface="Microsoft YaHei"/>
+              </a:rPr>
+              <a:t>个院系文本</a:t>
+            </a:r>
+          </a:p>
+        </p:txBody>
+      </p:sp>
+      <p:cxnSp>
+        <p:nvCxnSpPr>
+          <p:cNvPr id="13" name="Connector 12"/>
+          <p:cNvCxnSpPr/>
+          <p:nvPr/>
+        </p:nvCxnSpPr>
+        <p:spPr>
+          <a:xfrm>
+            <a:off x="950976" y="3593592"/>
+            <a:ext cx="2066544" cy="0"/>
+          </a:xfrm>
+          <a:prstGeom prst="line">
+            <a:avLst/>
+          </a:prstGeom>
+          <a:ln w="10160">
+            <a:solidFill>
+              <a:srgbClr val="D8E1EB"/>
+            </a:solidFill>
+          </a:ln>
+        </p:spPr>
+        <p:style>
+          <a:lnRef idx="2">
+            <a:schemeClr val="accent1"/>
+          </a:lnRef>
+          <a:fillRef idx="0">
+            <a:schemeClr val="accent1"/>
+          </a:fillRef>
+          <a:effectRef idx="1">
+            <a:schemeClr val="accent1"/>
+          </a:effectRef>
+          <a:fontRef idx="minor">
+            <a:schemeClr val="tx1"/>
+          </a:fontRef>
+        </p:style>
+      </p:cxnSp>
+      <p:sp>
+        <p:nvSpPr>
+          <p:cNvPr id="14" name="Rounded Rectangle 13"/>
+          <p:cNvSpPr/>
+          <p:nvPr/>
+        </p:nvSpPr>
+        <p:spPr>
+          <a:xfrm>
+            <a:off x="950976" y="3794760"/>
+            <a:ext cx="2066543" cy="438912"/>
+          </a:xfrm>
+          <a:prstGeom prst="roundRect">
+            <a:avLst/>
+          </a:prstGeom>
+          <a:solidFill>
+            <a:srgbClr val="EAF1F8"/>
+          </a:solidFill>
+          <a:ln>
+            <a:noFill/>
+          </a:ln>
+        </p:spPr>
+        <p:style>
+          <a:lnRef idx="1">
+            <a:schemeClr val="accent1"/>
+          </a:lnRef>
+          <a:fillRef idx="3">
+            <a:schemeClr val="accent1"/>
+          </a:fillRef>
+          <a:effectRef idx="2">
+            <a:schemeClr val="accent1"/>
+          </a:effectRef>
+          <a:fontRef idx="minor">
+            <a:schemeClr val="lt1"/>
+          </a:fontRef>
+        </p:style>
+        <p:txBody>
+          <a:bodyPr rtlCol="0" anchor="ctr"/>
+          <a:lstStyle/>
+          <a:p>
+            <a:pPr algn="ctr"/>
+          </a:p>
+        </p:txBody>
+      </p:sp>
+      <p:sp>
+        <p:nvSpPr>
+          <p:cNvPr id="15" name="Oval 14"/>
+          <p:cNvSpPr/>
+          <p:nvPr/>
+        </p:nvSpPr>
+        <p:spPr>
+          <a:xfrm>
+            <a:off x="1115568" y="3941063"/>
+            <a:ext cx="128016" cy="128016"/>
+          </a:xfrm>
+          <a:prstGeom prst="ellipse">
+            <a:avLst/>
+          </a:prstGeom>
+          <a:solidFill>
+            <a:srgbClr val="3568A8"/>
+          </a:solidFill>
+          <a:ln>
+            <a:noFill/>
+          </a:ln>
+        </p:spPr>
+        <p:style>
+          <a:lnRef idx="1">
+            <a:schemeClr val="accent1"/>
+          </a:lnRef>
+          <a:fillRef idx="3">
+            <a:schemeClr val="accent1"/>
+          </a:fillRef>
+          <a:effectRef idx="2">
+            <a:schemeClr val="accent1"/>
+          </a:effectRef>
+          <a:fontRef idx="minor">
+            <a:schemeClr val="lt1"/>
+          </a:fontRef>
+        </p:style>
+        <p:txBody>
+          <a:bodyPr rtlCol="0" anchor="ctr"/>
+          <a:lstStyle/>
+          <a:p>
+            <a:pPr algn="ctr"/>
+          </a:p>
+        </p:txBody>
+      </p:sp>
+      <p:sp>
+        <p:nvSpPr>
+          <p:cNvPr id="16" name="TextBox 15"/>
+          <p:cNvSpPr txBox="1"/>
+          <p:nvPr/>
+        </p:nvSpPr>
+        <p:spPr>
+          <a:xfrm>
+            <a:off x="1371600" y="3794760"/>
+            <a:ext cx="1444752" cy="438912"/>
+          </a:xfrm>
+          <a:prstGeom prst="rect">
+            <a:avLst/>
+          </a:prstGeom>
+          <a:noFill/>
+        </p:spPr>
+        <p:txBody>
+          <a:bodyPr wrap="square" lIns="0" rIns="0" tIns="0" bIns="0" anchor="ctr">
+            <a:spAutoFit/>
+          </a:bodyPr>
+          <a:lstStyle/>
+          <a:p>
+            <a:pPr algn="l">
+              <a:spcBef>
+                <a:spcPts val="0"/>
+              </a:spcBef>
+              <a:spcAft>
+                <a:spcPts val="0"/>
+              </a:spcAft>
+            </a:pPr>
+            <a:r>
+              <a:rPr sz="1100" b="1">
+                <a:solidFill>
+                  <a:srgbClr val="17324D"/>
+                </a:solidFill>
+                <a:latin typeface="Microsoft YaHei"/>
+              </a:rPr>
+              <a:t>中国　30个</a:t>
+            </a:r>
+          </a:p>
+        </p:txBody>
+      </p:sp>
+      <p:sp>
+        <p:nvSpPr>
+          <p:cNvPr id="17" name="Rounded Rectangle 16"/>
+          <p:cNvSpPr/>
+          <p:nvPr/>
+        </p:nvSpPr>
+        <p:spPr>
+          <a:xfrm>
+            <a:off x="950976" y="4361688"/>
+            <a:ext cx="2066543" cy="438912"/>
+          </a:xfrm>
+          <a:prstGeom prst="roundRect">
+            <a:avLst/>
+          </a:prstGeom>
+          <a:solidFill>
+            <a:srgbClr val="FFF3E5"/>
+          </a:solidFill>
+          <a:ln>
+            <a:noFill/>
+          </a:ln>
+        </p:spPr>
+        <p:style>
+          <a:lnRef idx="1">
+            <a:schemeClr val="accent1"/>
+          </a:lnRef>
+          <a:fillRef idx="3">
+            <a:schemeClr val="accent1"/>
+          </a:fillRef>
+          <a:effectRef idx="2">
+            <a:schemeClr val="accent1"/>
+          </a:effectRef>
+          <a:fontRef idx="minor">
+            <a:schemeClr val="lt1"/>
+          </a:fontRef>
+        </p:style>
+        <p:txBody>
+          <a:bodyPr rtlCol="0" anchor="ctr"/>
+          <a:lstStyle/>
+          <a:p>
+            <a:pPr algn="ctr"/>
+          </a:p>
+        </p:txBody>
+      </p:sp>
+      <p:sp>
+        <p:nvSpPr>
+          <p:cNvPr id="18" name="Oval 17"/>
+          <p:cNvSpPr/>
+          <p:nvPr/>
+        </p:nvSpPr>
+        <p:spPr>
+          <a:xfrm>
+            <a:off x="1115568" y="4507992"/>
+            <a:ext cx="128016" cy="128016"/>
+          </a:xfrm>
+          <a:prstGeom prst="ellipse">
+            <a:avLst/>
+          </a:prstGeom>
+          <a:solidFill>
+            <a:srgbClr val="E38B36"/>
+          </a:solidFill>
+          <a:ln>
+            <a:noFill/>
+          </a:ln>
+        </p:spPr>
+        <p:style>
+          <a:lnRef idx="1">
+            <a:schemeClr val="accent1"/>
+          </a:lnRef>
+          <a:fillRef idx="3">
+            <a:schemeClr val="accent1"/>
+          </a:fillRef>
+          <a:effectRef idx="2">
+            <a:schemeClr val="accent1"/>
+          </a:effectRef>
+          <a:fontRef idx="minor">
+            <a:schemeClr val="lt1"/>
+          </a:fontRef>
+        </p:style>
+        <p:txBody>
+          <a:bodyPr rtlCol="0" anchor="ctr"/>
+          <a:lstStyle/>
+          <a:p>
+            <a:pPr algn="ctr"/>
+          </a:p>
+        </p:txBody>
+      </p:sp>
+      <p:sp>
+        <p:nvSpPr>
+          <p:cNvPr id="19" name="TextBox 18"/>
+          <p:cNvSpPr txBox="1"/>
+          <p:nvPr/>
+        </p:nvSpPr>
+        <p:spPr>
+          <a:xfrm>
+            <a:off x="1371600" y="4361688"/>
+            <a:ext cx="1444752" cy="438912"/>
+          </a:xfrm>
+          <a:prstGeom prst="rect">
+            <a:avLst/>
+          </a:prstGeom>
+          <a:noFill/>
+        </p:spPr>
+        <p:txBody>
+          <a:bodyPr wrap="square" lIns="0" rIns="0" tIns="0" bIns="0" anchor="ctr">
+            <a:spAutoFit/>
+          </a:bodyPr>
+          <a:lstStyle/>
+          <a:p>
+            <a:pPr algn="l">
+              <a:spcBef>
+                <a:spcPts val="0"/>
+              </a:spcBef>
+              <a:spcAft>
+                <a:spcPts val="0"/>
+              </a:spcAft>
+            </a:pPr>
+            <a:r>
+              <a:rPr sz="1100" b="1">
+                <a:solidFill>
+                  <a:srgbClr val="17324D"/>
+                </a:solidFill>
+                <a:latin typeface="Microsoft YaHei"/>
+              </a:rPr>
+              <a:t>美国　30个</a:t>
+            </a:r>
+          </a:p>
+        </p:txBody>
+      </p:sp>
+      <p:sp>
+        <p:nvSpPr>
+          <p:cNvPr id="20" name="TextBox 19"/>
+          <p:cNvSpPr txBox="1"/>
+          <p:nvPr/>
+        </p:nvSpPr>
+        <p:spPr>
+          <a:xfrm>
+            <a:off x="950976" y="4983480"/>
+            <a:ext cx="2066543" cy="237744"/>
+          </a:xfrm>
+          <a:prstGeom prst="rect">
+            <a:avLst/>
+          </a:prstGeom>
+          <a:noFill/>
+        </p:spPr>
+        <p:txBody>
+          <a:bodyPr wrap="square" lIns="0" rIns="0" tIns="0" bIns="0" anchor="t">
+            <a:spAutoFit/>
+          </a:bodyPr>
+          <a:lstStyle/>
+          <a:p>
+            <a:pPr algn="ctr">
+              <a:spcBef>
+                <a:spcPts val="0"/>
+              </a:spcBef>
+              <a:spcAft>
+                <a:spcPts val="0"/>
+              </a:spcAft>
+            </a:pPr>
+            <a:r>
+              <a:rPr sz="950" b="0">
+                <a:solidFill>
+                  <a:srgbClr val="62748A"/>
+                </a:solidFill>
+                <a:latin typeface="Microsoft YaHei"/>
+              </a:rPr>
+              <a:t>官方网站英文 About Us</a:t>
+            </a:r>
+          </a:p>
+        </p:txBody>
+      </p:sp>
+      <p:sp>
+        <p:nvSpPr>
+          <p:cNvPr id="21" name="TextBox 20"/>
+          <p:cNvSpPr txBox="1"/>
+          <p:nvPr/>
+        </p:nvSpPr>
+        <p:spPr>
+          <a:xfrm>
+            <a:off x="950976" y="5257800"/>
+            <a:ext cx="2066543" cy="237744"/>
+          </a:xfrm>
+          <a:prstGeom prst="rect">
+            <a:avLst/>
+          </a:prstGeom>
+          <a:noFill/>
+        </p:spPr>
+        <p:txBody>
+          <a:bodyPr wrap="square" lIns="0" rIns="0" tIns="0" bIns="0" anchor="t">
+            <a:spAutoFit/>
+          </a:bodyPr>
+          <a:lstStyle/>
+          <a:p>
+            <a:pPr algn="ctr">
+              <a:spcBef>
+                <a:spcPts val="0"/>
+              </a:spcBef>
+              <a:spcAft>
+                <a:spcPts val="0"/>
+              </a:spcAft>
+            </a:pPr>
+            <a:r>
+              <a:rPr sz="1000" b="1">
+                <a:solidFill>
+                  <a:srgbClr val="3568A8"/>
+                </a:solidFill>
+                <a:latin typeface="Microsoft YaHei"/>
+              </a:rPr>
+              <a:t>院系级聚合文本</a:t>
+            </a:r>
+          </a:p>
+        </p:txBody>
+      </p:sp>
+      <p:sp>
+        <p:nvSpPr>
+          <p:cNvPr id="22" name="Rounded Rectangle 21"/>
+          <p:cNvSpPr/>
+          <p:nvPr/>
+        </p:nvSpPr>
+        <p:spPr>
+          <a:xfrm>
+            <a:off x="3474720" y="2011680"/>
+            <a:ext cx="4663440" cy="3584448"/>
+          </a:xfrm>
+          <a:prstGeom prst="roundRect">
+            <a:avLst/>
+          </a:prstGeom>
+          <a:solidFill>
+            <a:srgbClr val="FFFFFF"/>
+          </a:solidFill>
+          <a:ln w="10160">
+            <a:solidFill>
+              <a:srgbClr val="D8E1EB"/>
+            </a:solidFill>
+          </a:ln>
+        </p:spPr>
+        <p:style>
+          <a:lnRef idx="1">
+            <a:schemeClr val="accent1"/>
+          </a:lnRef>
+          <a:fillRef idx="3">
+            <a:schemeClr val="accent1"/>
+          </a:fillRef>
+          <a:effectRef idx="2">
+            <a:schemeClr val="accent1"/>
+          </a:effectRef>
+          <a:fontRef idx="minor">
+            <a:schemeClr val="lt1"/>
+          </a:fontRef>
+        </p:style>
+        <p:txBody>
+          <a:bodyPr rtlCol="0" anchor="ctr"/>
+          <a:lstStyle/>
+          <a:p>
+            <a:pPr algn="ctr"/>
+          </a:p>
+        </p:txBody>
+      </p:sp>
+      <p:sp>
+        <p:nvSpPr>
+          <p:cNvPr id="23" name="TextBox 22"/>
+          <p:cNvSpPr txBox="1"/>
+          <p:nvPr/>
+        </p:nvSpPr>
+        <p:spPr>
+          <a:xfrm>
+            <a:off x="3694176" y="2212848"/>
+            <a:ext cx="1691640" cy="292608"/>
+          </a:xfrm>
+          <a:prstGeom prst="rect">
+            <a:avLst/>
+          </a:prstGeom>
+          <a:noFill/>
+        </p:spPr>
+        <p:txBody>
+          <a:bodyPr wrap="square" lIns="0" rIns="0" tIns="0" bIns="0" anchor="t">
+            <a:spAutoFit/>
+          </a:bodyPr>
+          <a:lstStyle/>
+          <a:p>
+            <a:pPr algn="l">
+              <a:spcBef>
+                <a:spcPts val="0"/>
+              </a:spcBef>
+              <a:spcAft>
+                <a:spcPts val="0"/>
+              </a:spcAft>
+            </a:pPr>
+            <a:r>
+              <a:rPr sz="1200" b="1">
+                <a:solidFill>
+                  <a:srgbClr val="3568A8"/>
+                </a:solidFill>
+                <a:latin typeface="Microsoft YaHei"/>
+              </a:rPr>
+              <a:t>02　语步框架</a:t>
+            </a:r>
+          </a:p>
+        </p:txBody>
+      </p:sp>
+      <p:sp>
+        <p:nvSpPr>
+          <p:cNvPr id="24" name="TextBox 23"/>
+          <p:cNvSpPr txBox="1"/>
+          <p:nvPr/>
+        </p:nvSpPr>
+        <p:spPr>
+          <a:xfrm>
+            <a:off x="5394960" y="2212848"/>
+            <a:ext cx="2505456" cy="292608"/>
+          </a:xfrm>
+          <a:prstGeom prst="rect">
+            <a:avLst/>
+          </a:prstGeom>
+          <a:noFill/>
+        </p:spPr>
+        <p:txBody>
+          <a:bodyPr wrap="square" lIns="0" rIns="0" tIns="0" bIns="0" anchor="ctr">
+            <a:spAutoFit/>
+          </a:bodyPr>
+          <a:lstStyle/>
+          <a:p>
+            <a:pPr algn="r">
+              <a:spcBef>
+                <a:spcPts val="0"/>
+              </a:spcBef>
+              <a:spcAft>
+                <a:spcPts val="0"/>
+              </a:spcAft>
+            </a:pPr>
+            <a:r>
+              <a:rPr sz="1000" b="0">
+                <a:solidFill>
+                  <a:srgbClr val="62748A"/>
+                </a:solidFill>
+                <a:latin typeface="Microsoft YaHei"/>
+              </a:rPr>
+              <a:t>24个细类 → 10个核心语步</a:t>
+            </a:r>
+          </a:p>
+        </p:txBody>
+      </p:sp>
+      <p:cxnSp>
+        <p:nvCxnSpPr>
+          <p:cNvPr id="25" name="Connector 24"/>
+          <p:cNvCxnSpPr/>
+          <p:nvPr/>
+        </p:nvCxnSpPr>
+        <p:spPr>
+          <a:xfrm>
+            <a:off x="3694176" y="2596896"/>
+            <a:ext cx="4224528" cy="0"/>
+          </a:xfrm>
+          <a:prstGeom prst="line">
+            <a:avLst/>
+          </a:prstGeom>
+          <a:ln w="10160">
+            <a:solidFill>
+              <a:srgbClr val="D8E1EB"/>
+            </a:solidFill>
+          </a:ln>
+        </p:spPr>
+        <p:style>
+          <a:lnRef idx="2">
+            <a:schemeClr val="accent1"/>
+          </a:lnRef>
+          <a:fillRef idx="0">
+            <a:schemeClr val="accent1"/>
+          </a:fillRef>
+          <a:effectRef idx="1">
+            <a:schemeClr val="accent1"/>
+          </a:effectRef>
+          <a:fontRef idx="minor">
+            <a:schemeClr val="tx1"/>
+          </a:fontRef>
+        </p:style>
+      </p:cxnSp>
+      <p:sp>
+        <p:nvSpPr>
+          <p:cNvPr id="26" name="TextBox 25"/>
+          <p:cNvSpPr txBox="1"/>
+          <p:nvPr/>
+        </p:nvSpPr>
+        <p:spPr>
+          <a:xfrm>
+            <a:off x="3694176" y="2770632"/>
+            <a:ext cx="393192" cy="310896"/>
+          </a:xfrm>
+          <a:prstGeom prst="rect">
+            <a:avLst/>
+          </a:prstGeom>
+          <a:noFill/>
+        </p:spPr>
+        <p:txBody>
+          <a:bodyPr wrap="square" lIns="0" rIns="0" tIns="0" bIns="0" anchor="ctr">
+            <a:spAutoFit/>
+          </a:bodyPr>
+          <a:lstStyle/>
+          <a:p>
+            <a:pPr algn="l">
+              <a:spcBef>
+                <a:spcPts val="0"/>
+              </a:spcBef>
+              <a:spcAft>
+                <a:spcPts val="0"/>
+              </a:spcAft>
+            </a:pPr>
+            <a:r>
+              <a:rPr sz="900" b="1">
+                <a:solidFill>
+                  <a:srgbClr val="3568A8"/>
+                </a:solidFill>
+                <a:latin typeface="Microsoft YaHei"/>
+              </a:rPr>
+              <a:t>M01</a:t>
+            </a:r>
+          </a:p>
+        </p:txBody>
+      </p:sp>
+      <p:sp>
+        <p:nvSpPr>
+          <p:cNvPr id="27" name="TextBox 26"/>
+          <p:cNvSpPr txBox="1"/>
+          <p:nvPr/>
+        </p:nvSpPr>
+        <p:spPr>
+          <a:xfrm>
+            <a:off x="4114800" y="2770632"/>
+            <a:ext cx="1591056" cy="310896"/>
+          </a:xfrm>
+          <a:prstGeom prst="rect">
+            <a:avLst/>
+          </a:prstGeom>
+          <a:noFill/>
+        </p:spPr>
+        <p:txBody>
+          <a:bodyPr wrap="square" lIns="0" rIns="0" tIns="0" bIns="0" anchor="ctr">
+            <a:spAutoFit/>
+          </a:bodyPr>
+          <a:lstStyle/>
+          <a:p>
+            <a:pPr algn="l">
+              <a:spcBef>
+                <a:spcPts val="0"/>
+              </a:spcBef>
+              <a:spcAft>
+                <a:spcPts val="0"/>
+              </a:spcAft>
+            </a:pPr>
+            <a:r>
+              <a:rPr sz="950" b="0">
+                <a:solidFill>
+                  <a:srgbClr val="23364A"/>
+                </a:solidFill>
+                <a:latin typeface="Microsoft YaHei"/>
+              </a:rPr>
+              <a:t>机构身份与组织治理</a:t>
+            </a:r>
+          </a:p>
+        </p:txBody>
+      </p:sp>
+      <p:cxnSp>
+        <p:nvCxnSpPr>
+          <p:cNvPr id="28" name="Connector 27"/>
+          <p:cNvCxnSpPr/>
+          <p:nvPr/>
+        </p:nvCxnSpPr>
+        <p:spPr>
+          <a:xfrm>
+            <a:off x="3694176" y="3145536"/>
+            <a:ext cx="1993392" cy="0"/>
+          </a:xfrm>
+          <a:prstGeom prst="line">
+            <a:avLst/>
+          </a:prstGeom>
+          <a:ln w="6350">
+            <a:solidFill>
+              <a:srgbClr val="D8E1EB"/>
+            </a:solidFill>
+          </a:ln>
+        </p:spPr>
+        <p:style>
+          <a:lnRef idx="2">
+            <a:schemeClr val="accent1"/>
+          </a:lnRef>
+          <a:fillRef idx="0">
+            <a:schemeClr val="accent1"/>
+          </a:fillRef>
+          <a:effectRef idx="1">
+            <a:schemeClr val="accent1"/>
+          </a:effectRef>
+          <a:fontRef idx="minor">
+            <a:schemeClr val="tx1"/>
+          </a:fontRef>
+        </p:style>
+      </p:cxnSp>
+      <p:sp>
+        <p:nvSpPr>
+          <p:cNvPr id="29" name="TextBox 28"/>
+          <p:cNvSpPr txBox="1"/>
+          <p:nvPr/>
+        </p:nvSpPr>
+        <p:spPr>
+          <a:xfrm>
+            <a:off x="3694176" y="3236976"/>
+            <a:ext cx="393192" cy="310896"/>
+          </a:xfrm>
+          <a:prstGeom prst="rect">
+            <a:avLst/>
+          </a:prstGeom>
+          <a:noFill/>
+        </p:spPr>
+        <p:txBody>
+          <a:bodyPr wrap="square" lIns="0" rIns="0" tIns="0" bIns="0" anchor="ctr">
+            <a:spAutoFit/>
+          </a:bodyPr>
+          <a:lstStyle/>
+          <a:p>
+            <a:pPr algn="l">
+              <a:spcBef>
+                <a:spcPts val="0"/>
+              </a:spcBef>
+              <a:spcAft>
+                <a:spcPts val="0"/>
+              </a:spcAft>
+            </a:pPr>
+            <a:r>
+              <a:rPr sz="900" b="1">
+                <a:solidFill>
+                  <a:srgbClr val="3568A8"/>
+                </a:solidFill>
+                <a:latin typeface="Microsoft YaHei"/>
+              </a:rPr>
+              <a:t>M02</a:t>
+            </a:r>
+          </a:p>
+        </p:txBody>
+      </p:sp>
+      <p:sp>
+        <p:nvSpPr>
+          <p:cNvPr id="30" name="TextBox 29"/>
+          <p:cNvSpPr txBox="1"/>
+          <p:nvPr/>
+        </p:nvSpPr>
+        <p:spPr>
+          <a:xfrm>
+            <a:off x="4114800" y="3236976"/>
+            <a:ext cx="1591056" cy="310896"/>
+          </a:xfrm>
+          <a:prstGeom prst="rect">
+            <a:avLst/>
+          </a:prstGeom>
+          <a:noFill/>
+        </p:spPr>
+        <p:txBody>
+          <a:bodyPr wrap="square" lIns="0" rIns="0" tIns="0" bIns="0" anchor="ctr">
+            <a:spAutoFit/>
+          </a:bodyPr>
+          <a:lstStyle/>
+          <a:p>
+            <a:pPr algn="l">
+              <a:spcBef>
+                <a:spcPts val="0"/>
+              </a:spcBef>
+              <a:spcAft>
+                <a:spcPts val="0"/>
+              </a:spcAft>
+            </a:pPr>
+            <a:r>
+              <a:rPr sz="950" b="0">
+                <a:solidFill>
+                  <a:srgbClr val="23364A"/>
+                </a:solidFill>
+                <a:latin typeface="Microsoft YaHei"/>
+              </a:rPr>
+              <a:t>历史沿革与学脉传承</a:t>
+            </a:r>
+          </a:p>
+        </p:txBody>
+      </p:sp>
+      <p:cxnSp>
+        <p:nvCxnSpPr>
+          <p:cNvPr id="31" name="Connector 30"/>
+          <p:cNvCxnSpPr/>
+          <p:nvPr/>
+        </p:nvCxnSpPr>
+        <p:spPr>
+          <a:xfrm>
+            <a:off x="3694176" y="3611880"/>
+            <a:ext cx="1993392" cy="0"/>
+          </a:xfrm>
+          <a:prstGeom prst="line">
+            <a:avLst/>
+          </a:prstGeom>
+          <a:ln w="6350">
+            <a:solidFill>
+              <a:srgbClr val="D8E1EB"/>
+            </a:solidFill>
+          </a:ln>
+        </p:spPr>
+        <p:style>
+          <a:lnRef idx="2">
+            <a:schemeClr val="accent1"/>
+          </a:lnRef>
+          <a:fillRef idx="0">
+            <a:schemeClr val="accent1"/>
+          </a:fillRef>
+          <a:effectRef idx="1">
+            <a:schemeClr val="accent1"/>
+          </a:effectRef>
+          <a:fontRef idx="minor">
+            <a:schemeClr val="tx1"/>
+          </a:fontRef>
+        </p:style>
+      </p:cxnSp>
+      <p:sp>
+        <p:nvSpPr>
+          <p:cNvPr id="32" name="TextBox 31"/>
+          <p:cNvSpPr txBox="1"/>
+          <p:nvPr/>
+        </p:nvSpPr>
+        <p:spPr>
+          <a:xfrm>
+            <a:off x="3694176" y="3703320"/>
+            <a:ext cx="393192" cy="310896"/>
+          </a:xfrm>
+          <a:prstGeom prst="rect">
+            <a:avLst/>
+          </a:prstGeom>
+          <a:noFill/>
+        </p:spPr>
+        <p:txBody>
+          <a:bodyPr wrap="square" lIns="0" rIns="0" tIns="0" bIns="0" anchor="ctr">
+            <a:spAutoFit/>
+          </a:bodyPr>
+          <a:lstStyle/>
+          <a:p>
+            <a:pPr algn="l">
+              <a:spcBef>
+                <a:spcPts val="0"/>
+              </a:spcBef>
+              <a:spcAft>
+                <a:spcPts val="0"/>
+              </a:spcAft>
+            </a:pPr>
+            <a:r>
+              <a:rPr sz="900" b="1">
+                <a:solidFill>
+                  <a:srgbClr val="3568A8"/>
+                </a:solidFill>
+                <a:latin typeface="Microsoft YaHei"/>
+              </a:rPr>
+              <a:t>M03</a:t>
+            </a:r>
+          </a:p>
+        </p:txBody>
+      </p:sp>
+      <p:sp>
+        <p:nvSpPr>
+          <p:cNvPr id="33" name="TextBox 32"/>
+          <p:cNvSpPr txBox="1"/>
+          <p:nvPr/>
+        </p:nvSpPr>
+        <p:spPr>
+          <a:xfrm>
+            <a:off x="4114800" y="3703320"/>
+            <a:ext cx="1591056" cy="310896"/>
+          </a:xfrm>
+          <a:prstGeom prst="rect">
+            <a:avLst/>
+          </a:prstGeom>
+          <a:noFill/>
+        </p:spPr>
+        <p:txBody>
+          <a:bodyPr wrap="square" lIns="0" rIns="0" tIns="0" bIns="0" anchor="ctr">
+            <a:spAutoFit/>
+          </a:bodyPr>
+          <a:lstStyle/>
+          <a:p>
+            <a:pPr algn="l">
+              <a:spcBef>
+                <a:spcPts val="0"/>
+              </a:spcBef>
+              <a:spcAft>
+                <a:spcPts val="0"/>
+              </a:spcAft>
+            </a:pPr>
+            <a:r>
+              <a:rPr sz="950" b="0">
+                <a:solidFill>
+                  <a:srgbClr val="23364A"/>
+                </a:solidFill>
+                <a:latin typeface="Microsoft YaHei"/>
+              </a:rPr>
+              <a:t>使命愿景与公共价值</a:t>
+            </a:r>
+          </a:p>
+        </p:txBody>
+      </p:sp>
+      <p:cxnSp>
+        <p:nvCxnSpPr>
+          <p:cNvPr id="34" name="Connector 33"/>
+          <p:cNvCxnSpPr/>
+          <p:nvPr/>
+        </p:nvCxnSpPr>
+        <p:spPr>
+          <a:xfrm>
+            <a:off x="3694176" y="4078224"/>
+            <a:ext cx="1993392" cy="0"/>
+          </a:xfrm>
+          <a:prstGeom prst="line">
+            <a:avLst/>
+          </a:prstGeom>
+          <a:ln w="6350">
+            <a:solidFill>
+              <a:srgbClr val="D8E1EB"/>
+            </a:solidFill>
+          </a:ln>
+        </p:spPr>
+        <p:style>
+          <a:lnRef idx="2">
+            <a:schemeClr val="accent1"/>
+          </a:lnRef>
+          <a:fillRef idx="0">
+            <a:schemeClr val="accent1"/>
+          </a:fillRef>
+          <a:effectRef idx="1">
+            <a:schemeClr val="accent1"/>
+          </a:effectRef>
+          <a:fontRef idx="minor">
+            <a:schemeClr val="tx1"/>
+          </a:fontRef>
+        </p:style>
+      </p:cxnSp>
+      <p:sp>
+        <p:nvSpPr>
+          <p:cNvPr id="35" name="TextBox 34"/>
+          <p:cNvSpPr txBox="1"/>
+          <p:nvPr/>
+        </p:nvSpPr>
+        <p:spPr>
+          <a:xfrm>
+            <a:off x="3694176" y="4169663"/>
+            <a:ext cx="393192" cy="310896"/>
+          </a:xfrm>
+          <a:prstGeom prst="rect">
+            <a:avLst/>
+          </a:prstGeom>
+          <a:noFill/>
+        </p:spPr>
+        <p:txBody>
+          <a:bodyPr wrap="square" lIns="0" rIns="0" tIns="0" bIns="0" anchor="ctr">
+            <a:spAutoFit/>
+          </a:bodyPr>
+          <a:lstStyle/>
+          <a:p>
+            <a:pPr algn="l">
+              <a:spcBef>
+                <a:spcPts val="0"/>
+              </a:spcBef>
+              <a:spcAft>
+                <a:spcPts val="0"/>
+              </a:spcAft>
+            </a:pPr>
+            <a:r>
+              <a:rPr sz="900" b="1">
+                <a:solidFill>
+                  <a:srgbClr val="3568A8"/>
+                </a:solidFill>
+                <a:latin typeface="Microsoft YaHei"/>
+              </a:rPr>
+              <a:t>M04</a:t>
+            </a:r>
+          </a:p>
+        </p:txBody>
+      </p:sp>
+      <p:sp>
+        <p:nvSpPr>
+          <p:cNvPr id="36" name="TextBox 35"/>
+          <p:cNvSpPr txBox="1"/>
+          <p:nvPr/>
+        </p:nvSpPr>
+        <p:spPr>
+          <a:xfrm>
+            <a:off x="4114800" y="4169663"/>
+            <a:ext cx="1591056" cy="310896"/>
+          </a:xfrm>
+          <a:prstGeom prst="rect">
+            <a:avLst/>
+          </a:prstGeom>
+          <a:noFill/>
+        </p:spPr>
+        <p:txBody>
+          <a:bodyPr wrap="square" lIns="0" rIns="0" tIns="0" bIns="0" anchor="ctr">
+            <a:spAutoFit/>
+          </a:bodyPr>
+          <a:lstStyle/>
+          <a:p>
+            <a:pPr algn="l">
+              <a:spcBef>
+                <a:spcPts val="0"/>
+              </a:spcBef>
+              <a:spcAft>
+                <a:spcPts val="0"/>
+              </a:spcAft>
+            </a:pPr>
+            <a:r>
+              <a:rPr sz="950" b="0">
+                <a:solidFill>
+                  <a:srgbClr val="23364A"/>
+                </a:solidFill>
+                <a:latin typeface="Microsoft YaHei"/>
+              </a:rPr>
+              <a:t>学科价值与研究取向</a:t>
+            </a:r>
+          </a:p>
+        </p:txBody>
+      </p:sp>
+      <p:cxnSp>
+        <p:nvCxnSpPr>
+          <p:cNvPr id="37" name="Connector 36"/>
+          <p:cNvCxnSpPr/>
+          <p:nvPr/>
+        </p:nvCxnSpPr>
+        <p:spPr>
+          <a:xfrm>
+            <a:off x="3694176" y="4544568"/>
+            <a:ext cx="1993392" cy="0"/>
+          </a:xfrm>
+          <a:prstGeom prst="line">
+            <a:avLst/>
+          </a:prstGeom>
+          <a:ln w="6350">
+            <a:solidFill>
+              <a:srgbClr val="D8E1EB"/>
+            </a:solidFill>
+          </a:ln>
+        </p:spPr>
+        <p:style>
+          <a:lnRef idx="2">
+            <a:schemeClr val="accent1"/>
+          </a:lnRef>
+          <a:fillRef idx="0">
+            <a:schemeClr val="accent1"/>
+          </a:fillRef>
+          <a:effectRef idx="1">
+            <a:schemeClr val="accent1"/>
+          </a:effectRef>
+          <a:fontRef idx="minor">
+            <a:schemeClr val="tx1"/>
+          </a:fontRef>
+        </p:style>
+      </p:cxnSp>
+      <p:sp>
+        <p:nvSpPr>
+          <p:cNvPr id="38" name="TextBox 37"/>
+          <p:cNvSpPr txBox="1"/>
+          <p:nvPr/>
+        </p:nvSpPr>
+        <p:spPr>
+          <a:xfrm>
+            <a:off x="3694176" y="4636008"/>
+            <a:ext cx="393192" cy="310896"/>
+          </a:xfrm>
+          <a:prstGeom prst="rect">
+            <a:avLst/>
+          </a:prstGeom>
+          <a:noFill/>
+        </p:spPr>
+        <p:txBody>
+          <a:bodyPr wrap="square" lIns="0" rIns="0" tIns="0" bIns="0" anchor="ctr">
+            <a:spAutoFit/>
+          </a:bodyPr>
+          <a:lstStyle/>
+          <a:p>
+            <a:pPr algn="l">
+              <a:spcBef>
+                <a:spcPts val="0"/>
+              </a:spcBef>
+              <a:spcAft>
+                <a:spcPts val="0"/>
+              </a:spcAft>
+            </a:pPr>
+            <a:r>
+              <a:rPr sz="900" b="1">
+                <a:solidFill>
+                  <a:srgbClr val="3568A8"/>
+                </a:solidFill>
+                <a:latin typeface="Microsoft YaHei"/>
+              </a:rPr>
+              <a:t>M05</a:t>
+            </a:r>
+          </a:p>
+        </p:txBody>
+      </p:sp>
+      <p:sp>
+        <p:nvSpPr>
+          <p:cNvPr id="39" name="TextBox 38"/>
+          <p:cNvSpPr txBox="1"/>
+          <p:nvPr/>
+        </p:nvSpPr>
+        <p:spPr>
+          <a:xfrm>
+            <a:off x="4114800" y="4636008"/>
+            <a:ext cx="1591056" cy="310896"/>
+          </a:xfrm>
+          <a:prstGeom prst="rect">
+            <a:avLst/>
+          </a:prstGeom>
+          <a:noFill/>
+        </p:spPr>
+        <p:txBody>
+          <a:bodyPr wrap="square" lIns="0" rIns="0" tIns="0" bIns="0" anchor="ctr">
+            <a:spAutoFit/>
+          </a:bodyPr>
+          <a:lstStyle/>
+          <a:p>
+            <a:pPr algn="l">
+              <a:spcBef>
+                <a:spcPts val="0"/>
+              </a:spcBef>
+              <a:spcAft>
+                <a:spcPts val="0"/>
+              </a:spcAft>
+            </a:pPr>
+            <a:r>
+              <a:rPr sz="950" b="0">
+                <a:solidFill>
+                  <a:srgbClr val="23364A"/>
+                </a:solidFill>
+                <a:latin typeface="Microsoft YaHei"/>
+              </a:rPr>
+              <a:t>课程教学与培养目标</a:t>
+            </a:r>
+          </a:p>
+        </p:txBody>
+      </p:sp>
+      <p:sp>
+        <p:nvSpPr>
+          <p:cNvPr id="40" name="TextBox 39"/>
+          <p:cNvSpPr txBox="1"/>
+          <p:nvPr/>
+        </p:nvSpPr>
+        <p:spPr>
+          <a:xfrm>
+            <a:off x="5815583" y="2770632"/>
+            <a:ext cx="393192" cy="310896"/>
+          </a:xfrm>
+          <a:prstGeom prst="rect">
+            <a:avLst/>
+          </a:prstGeom>
+          <a:noFill/>
+        </p:spPr>
+        <p:txBody>
+          <a:bodyPr wrap="square" lIns="0" rIns="0" tIns="0" bIns="0" anchor="ctr">
+            <a:spAutoFit/>
+          </a:bodyPr>
+          <a:lstStyle/>
+          <a:p>
+            <a:pPr algn="l">
+              <a:spcBef>
+                <a:spcPts val="0"/>
+              </a:spcBef>
+              <a:spcAft>
+                <a:spcPts val="0"/>
+              </a:spcAft>
+            </a:pPr>
+            <a:r>
+              <a:rPr sz="900" b="1">
+                <a:solidFill>
+                  <a:srgbClr val="2B7A78"/>
+                </a:solidFill>
+                <a:latin typeface="Microsoft YaHei"/>
+              </a:rPr>
+              <a:t>M06</a:t>
+            </a:r>
+          </a:p>
+        </p:txBody>
+      </p:sp>
+      <p:sp>
+        <p:nvSpPr>
+          <p:cNvPr id="41" name="TextBox 40"/>
+          <p:cNvSpPr txBox="1"/>
+          <p:nvPr/>
+        </p:nvSpPr>
+        <p:spPr>
+          <a:xfrm>
+            <a:off x="6236207" y="2770632"/>
+            <a:ext cx="1591056" cy="310896"/>
+          </a:xfrm>
+          <a:prstGeom prst="rect">
+            <a:avLst/>
+          </a:prstGeom>
+          <a:noFill/>
+        </p:spPr>
+        <p:txBody>
+          <a:bodyPr wrap="square" lIns="0" rIns="0" tIns="0" bIns="0" anchor="ctr">
+            <a:spAutoFit/>
+          </a:bodyPr>
+          <a:lstStyle/>
+          <a:p>
+            <a:pPr algn="l">
+              <a:spcBef>
+                <a:spcPts val="0"/>
+              </a:spcBef>
+              <a:spcAft>
+                <a:spcPts val="0"/>
+              </a:spcAft>
+            </a:pPr>
+            <a:r>
+              <a:rPr sz="950" b="0">
+                <a:solidFill>
+                  <a:srgbClr val="23364A"/>
+                </a:solidFill>
+                <a:latin typeface="Microsoft YaHei"/>
+              </a:rPr>
+              <a:t>师资与办学支撑</a:t>
+            </a:r>
+          </a:p>
+        </p:txBody>
+      </p:sp>
+      <p:cxnSp>
+        <p:nvCxnSpPr>
+          <p:cNvPr id="42" name="Connector 41"/>
+          <p:cNvCxnSpPr/>
+          <p:nvPr/>
+        </p:nvCxnSpPr>
+        <p:spPr>
+          <a:xfrm>
+            <a:off x="5815583" y="3145536"/>
+            <a:ext cx="1993392" cy="0"/>
+          </a:xfrm>
+          <a:prstGeom prst="line">
+            <a:avLst/>
+          </a:prstGeom>
+          <a:ln w="6350">
+            <a:solidFill>
+              <a:srgbClr val="D8E1EB"/>
+            </a:solidFill>
+          </a:ln>
+        </p:spPr>
+        <p:style>
+          <a:lnRef idx="2">
+            <a:schemeClr val="accent1"/>
+          </a:lnRef>
+          <a:fillRef idx="0">
+            <a:schemeClr val="accent1"/>
+          </a:fillRef>
+          <a:effectRef idx="1">
+            <a:schemeClr val="accent1"/>
+          </a:effectRef>
+          <a:fontRef idx="minor">
+            <a:schemeClr val="tx1"/>
+          </a:fontRef>
+        </p:style>
+      </p:cxnSp>
+      <p:sp>
+        <p:nvSpPr>
+          <p:cNvPr id="43" name="TextBox 42"/>
+          <p:cNvSpPr txBox="1"/>
+          <p:nvPr/>
+        </p:nvSpPr>
+        <p:spPr>
+          <a:xfrm>
+            <a:off x="5815583" y="3236976"/>
+            <a:ext cx="393192" cy="310896"/>
+          </a:xfrm>
+          <a:prstGeom prst="rect">
+            <a:avLst/>
+          </a:prstGeom>
+          <a:noFill/>
+        </p:spPr>
+        <p:txBody>
+          <a:bodyPr wrap="square" lIns="0" rIns="0" tIns="0" bIns="0" anchor="ctr">
+            <a:spAutoFit/>
+          </a:bodyPr>
+          <a:lstStyle/>
+          <a:p>
+            <a:pPr algn="l">
+              <a:spcBef>
+                <a:spcPts val="0"/>
+              </a:spcBef>
+              <a:spcAft>
+                <a:spcPts val="0"/>
+              </a:spcAft>
+            </a:pPr>
+            <a:r>
+              <a:rPr sz="900" b="1">
+                <a:solidFill>
+                  <a:srgbClr val="2B7A78"/>
+                </a:solidFill>
+                <a:latin typeface="Microsoft YaHei"/>
+              </a:rPr>
+              <a:t>M07</a:t>
+            </a:r>
+          </a:p>
+        </p:txBody>
+      </p:sp>
+      <p:sp>
+        <p:nvSpPr>
+          <p:cNvPr id="44" name="TextBox 43"/>
+          <p:cNvSpPr txBox="1"/>
+          <p:nvPr/>
+        </p:nvSpPr>
+        <p:spPr>
+          <a:xfrm>
+            <a:off x="6236207" y="3236976"/>
+            <a:ext cx="1591056" cy="310896"/>
+          </a:xfrm>
+          <a:prstGeom prst="rect">
+            <a:avLst/>
+          </a:prstGeom>
+          <a:noFill/>
+        </p:spPr>
+        <p:txBody>
+          <a:bodyPr wrap="square" lIns="0" rIns="0" tIns="0" bIns="0" anchor="ctr">
+            <a:spAutoFit/>
+          </a:bodyPr>
+          <a:lstStyle/>
+          <a:p>
+            <a:pPr algn="l">
+              <a:spcBef>
+                <a:spcPts val="0"/>
+              </a:spcBef>
+              <a:spcAft>
+                <a:spcPts val="0"/>
+              </a:spcAft>
+            </a:pPr>
+            <a:r>
+              <a:rPr sz="950" b="0">
+                <a:solidFill>
+                  <a:srgbClr val="23364A"/>
+                </a:solidFill>
+                <a:latin typeface="Microsoft YaHei"/>
+              </a:rPr>
+              <a:t>办学声誉与育人成效</a:t>
+            </a:r>
+          </a:p>
+        </p:txBody>
+      </p:sp>
+      <p:cxnSp>
+        <p:nvCxnSpPr>
+          <p:cNvPr id="45" name="Connector 44"/>
+          <p:cNvCxnSpPr/>
+          <p:nvPr/>
+        </p:nvCxnSpPr>
+        <p:spPr>
+          <a:xfrm>
+            <a:off x="5815583" y="3611880"/>
+            <a:ext cx="1993392" cy="0"/>
+          </a:xfrm>
+          <a:prstGeom prst="line">
+            <a:avLst/>
+          </a:prstGeom>
+          <a:ln w="6350">
+            <a:solidFill>
+              <a:srgbClr val="D8E1EB"/>
+            </a:solidFill>
+          </a:ln>
+        </p:spPr>
+        <p:style>
+          <a:lnRef idx="2">
+            <a:schemeClr val="accent1"/>
+          </a:lnRef>
+          <a:fillRef idx="0">
+            <a:schemeClr val="accent1"/>
+          </a:fillRef>
+          <a:effectRef idx="1">
+            <a:schemeClr val="accent1"/>
+          </a:effectRef>
+          <a:fontRef idx="minor">
+            <a:schemeClr val="tx1"/>
+          </a:fontRef>
+        </p:style>
+      </p:cxnSp>
+      <p:sp>
+        <p:nvSpPr>
+          <p:cNvPr id="46" name="TextBox 45"/>
+          <p:cNvSpPr txBox="1"/>
+          <p:nvPr/>
+        </p:nvSpPr>
+        <p:spPr>
+          <a:xfrm>
+            <a:off x="5815583" y="3703320"/>
+            <a:ext cx="393192" cy="310896"/>
+          </a:xfrm>
+          <a:prstGeom prst="rect">
+            <a:avLst/>
+          </a:prstGeom>
+          <a:noFill/>
+        </p:spPr>
+        <p:txBody>
+          <a:bodyPr wrap="square" lIns="0" rIns="0" tIns="0" bIns="0" anchor="ctr">
+            <a:spAutoFit/>
+          </a:bodyPr>
+          <a:lstStyle/>
+          <a:p>
+            <a:pPr algn="l">
+              <a:spcBef>
+                <a:spcPts val="0"/>
+              </a:spcBef>
+              <a:spcAft>
+                <a:spcPts val="0"/>
+              </a:spcAft>
+            </a:pPr>
+            <a:r>
+              <a:rPr sz="900" b="1">
+                <a:solidFill>
+                  <a:srgbClr val="2B7A78"/>
+                </a:solidFill>
+                <a:latin typeface="Microsoft YaHei"/>
+              </a:rPr>
+              <a:t>M08</a:t>
+            </a:r>
+          </a:p>
+        </p:txBody>
+      </p:sp>
+      <p:sp>
+        <p:nvSpPr>
+          <p:cNvPr id="47" name="TextBox 46"/>
+          <p:cNvSpPr txBox="1"/>
+          <p:nvPr/>
+        </p:nvSpPr>
+        <p:spPr>
+          <a:xfrm>
+            <a:off x="6236207" y="3703320"/>
+            <a:ext cx="1591056" cy="310896"/>
+          </a:xfrm>
+          <a:prstGeom prst="rect">
+            <a:avLst/>
+          </a:prstGeom>
+          <a:noFill/>
+        </p:spPr>
+        <p:txBody>
+          <a:bodyPr wrap="square" lIns="0" rIns="0" tIns="0" bIns="0" anchor="ctr">
+            <a:spAutoFit/>
+          </a:bodyPr>
+          <a:lstStyle/>
+          <a:p>
+            <a:pPr algn="l">
+              <a:spcBef>
+                <a:spcPts val="0"/>
+              </a:spcBef>
+              <a:spcAft>
+                <a:spcPts val="0"/>
+              </a:spcAft>
+            </a:pPr>
+            <a:r>
+              <a:rPr sz="950" b="0">
+                <a:solidFill>
+                  <a:srgbClr val="23364A"/>
+                </a:solidFill>
+                <a:latin typeface="Microsoft YaHei"/>
+              </a:rPr>
+              <a:t>合作网络与社会服务</a:t>
+            </a:r>
+          </a:p>
+        </p:txBody>
+      </p:sp>
+      <p:cxnSp>
+        <p:nvCxnSpPr>
+          <p:cNvPr id="48" name="Connector 47"/>
+          <p:cNvCxnSpPr/>
+          <p:nvPr/>
+        </p:nvCxnSpPr>
+        <p:spPr>
+          <a:xfrm>
+            <a:off x="5815583" y="4078224"/>
+            <a:ext cx="1993392" cy="0"/>
+          </a:xfrm>
+          <a:prstGeom prst="line">
+            <a:avLst/>
+          </a:prstGeom>
+          <a:ln w="6350">
+            <a:solidFill>
+              <a:srgbClr val="D8E1EB"/>
+            </a:solidFill>
+          </a:ln>
+        </p:spPr>
+        <p:style>
+          <a:lnRef idx="2">
+            <a:schemeClr val="accent1"/>
+          </a:lnRef>
+          <a:fillRef idx="0">
+            <a:schemeClr val="accent1"/>
+          </a:fillRef>
+          <a:effectRef idx="1">
+            <a:schemeClr val="accent1"/>
+          </a:effectRef>
+          <a:fontRef idx="minor">
+            <a:schemeClr val="tx1"/>
+          </a:fontRef>
+        </p:style>
+      </p:cxnSp>
+      <p:sp>
+        <p:nvSpPr>
+          <p:cNvPr id="49" name="TextBox 48"/>
+          <p:cNvSpPr txBox="1"/>
+          <p:nvPr/>
+        </p:nvSpPr>
+        <p:spPr>
+          <a:xfrm>
+            <a:off x="5815583" y="4169663"/>
+            <a:ext cx="393192" cy="310896"/>
+          </a:xfrm>
+          <a:prstGeom prst="rect">
+            <a:avLst/>
+          </a:prstGeom>
+          <a:noFill/>
+        </p:spPr>
+        <p:txBody>
+          <a:bodyPr wrap="square" lIns="0" rIns="0" tIns="0" bIns="0" anchor="ctr">
+            <a:spAutoFit/>
+          </a:bodyPr>
+          <a:lstStyle/>
+          <a:p>
+            <a:pPr algn="l">
+              <a:spcBef>
+                <a:spcPts val="0"/>
+              </a:spcBef>
+              <a:spcAft>
+                <a:spcPts val="0"/>
+              </a:spcAft>
+            </a:pPr>
+            <a:r>
+              <a:rPr sz="900" b="1">
+                <a:solidFill>
+                  <a:srgbClr val="2B7A78"/>
+                </a:solidFill>
+                <a:latin typeface="Microsoft YaHei"/>
+              </a:rPr>
+              <a:t>M09</a:t>
+            </a:r>
+          </a:p>
+        </p:txBody>
+      </p:sp>
+      <p:sp>
+        <p:nvSpPr>
+          <p:cNvPr id="50" name="TextBox 49"/>
+          <p:cNvSpPr txBox="1"/>
+          <p:nvPr/>
+        </p:nvSpPr>
+        <p:spPr>
+          <a:xfrm>
+            <a:off x="6236207" y="4169663"/>
+            <a:ext cx="1591056" cy="310896"/>
+          </a:xfrm>
+          <a:prstGeom prst="rect">
+            <a:avLst/>
+          </a:prstGeom>
+          <a:noFill/>
+        </p:spPr>
+        <p:txBody>
+          <a:bodyPr wrap="square" lIns="0" rIns="0" tIns="0" bIns="0" anchor="ctr">
+            <a:spAutoFit/>
+          </a:bodyPr>
+          <a:lstStyle/>
+          <a:p>
+            <a:pPr algn="l">
+              <a:spcBef>
+                <a:spcPts val="0"/>
+              </a:spcBef>
+              <a:spcAft>
+                <a:spcPts val="0"/>
+              </a:spcAft>
+            </a:pPr>
+            <a:r>
+              <a:rPr sz="950" b="0">
+                <a:solidFill>
+                  <a:srgbClr val="23364A"/>
+                </a:solidFill>
+                <a:latin typeface="Microsoft YaHei"/>
+              </a:rPr>
+              <a:t>受众互动与行动引导</a:t>
+            </a:r>
+          </a:p>
+        </p:txBody>
+      </p:sp>
+      <p:cxnSp>
+        <p:nvCxnSpPr>
+          <p:cNvPr id="51" name="Connector 50"/>
+          <p:cNvCxnSpPr/>
+          <p:nvPr/>
+        </p:nvCxnSpPr>
+        <p:spPr>
+          <a:xfrm>
+            <a:off x="5815583" y="4544568"/>
+            <a:ext cx="1993392" cy="0"/>
+          </a:xfrm>
+          <a:prstGeom prst="line">
+            <a:avLst/>
+          </a:prstGeom>
+          <a:ln w="6350">
+            <a:solidFill>
+              <a:srgbClr val="D8E1EB"/>
+            </a:solidFill>
+          </a:ln>
+        </p:spPr>
+        <p:style>
+          <a:lnRef idx="2">
+            <a:schemeClr val="accent1"/>
+          </a:lnRef>
+          <a:fillRef idx="0">
+            <a:schemeClr val="accent1"/>
+          </a:fillRef>
+          <a:effectRef idx="1">
+            <a:schemeClr val="accent1"/>
+          </a:effectRef>
+          <a:fontRef idx="minor">
+            <a:schemeClr val="tx1"/>
+          </a:fontRef>
+        </p:style>
+      </p:cxnSp>
+      <p:sp>
+        <p:nvSpPr>
+          <p:cNvPr id="52" name="TextBox 51"/>
+          <p:cNvSpPr txBox="1"/>
+          <p:nvPr/>
+        </p:nvSpPr>
+        <p:spPr>
+          <a:xfrm>
+            <a:off x="5815583" y="4636008"/>
+            <a:ext cx="393192" cy="310896"/>
+          </a:xfrm>
+          <a:prstGeom prst="rect">
+            <a:avLst/>
+          </a:prstGeom>
+          <a:noFill/>
+        </p:spPr>
+        <p:txBody>
+          <a:bodyPr wrap="square" lIns="0" rIns="0" tIns="0" bIns="0" anchor="ctr">
+            <a:spAutoFit/>
+          </a:bodyPr>
+          <a:lstStyle/>
+          <a:p>
+            <a:pPr algn="l">
+              <a:spcBef>
+                <a:spcPts val="0"/>
+              </a:spcBef>
+              <a:spcAft>
+                <a:spcPts val="0"/>
+              </a:spcAft>
+            </a:pPr>
+            <a:r>
+              <a:rPr sz="900" b="1">
+                <a:solidFill>
+                  <a:srgbClr val="2B7A78"/>
+                </a:solidFill>
+                <a:latin typeface="Microsoft YaHei"/>
+              </a:rPr>
+              <a:t>M10</a:t>
+            </a:r>
+          </a:p>
+        </p:txBody>
+      </p:sp>
+      <p:sp>
+        <p:nvSpPr>
+          <p:cNvPr id="53" name="TextBox 52"/>
+          <p:cNvSpPr txBox="1"/>
+          <p:nvPr/>
+        </p:nvSpPr>
+        <p:spPr>
+          <a:xfrm>
+            <a:off x="6236207" y="4636008"/>
+            <a:ext cx="1591056" cy="310896"/>
+          </a:xfrm>
+          <a:prstGeom prst="rect">
+            <a:avLst/>
+          </a:prstGeom>
+          <a:noFill/>
+        </p:spPr>
+        <p:txBody>
+          <a:bodyPr wrap="square" lIns="0" rIns="0" tIns="0" bIns="0" anchor="ctr">
+            <a:spAutoFit/>
+          </a:bodyPr>
+          <a:lstStyle/>
+          <a:p>
+            <a:pPr algn="l">
+              <a:spcBef>
+                <a:spcPts val="0"/>
+              </a:spcBef>
+              <a:spcAft>
+                <a:spcPts val="0"/>
+              </a:spcAft>
+            </a:pPr>
+            <a:r>
+              <a:rPr sz="950" b="0">
+                <a:solidFill>
+                  <a:srgbClr val="23364A"/>
+                </a:solidFill>
+                <a:latin typeface="Microsoft YaHei"/>
+              </a:rPr>
+              <a:t>信息导引与运行通告</a:t>
+            </a:r>
+          </a:p>
+        </p:txBody>
+      </p:sp>
+      <p:sp>
+        <p:nvSpPr>
+          <p:cNvPr id="54" name="TextBox 53"/>
+          <p:cNvSpPr txBox="1"/>
+          <p:nvPr/>
+        </p:nvSpPr>
+        <p:spPr>
+          <a:xfrm>
+            <a:off x="3694176" y="5257800"/>
+            <a:ext cx="4224528" cy="228600"/>
+          </a:xfrm>
+          <a:prstGeom prst="rect">
+            <a:avLst/>
+          </a:prstGeom>
+          <a:noFill/>
+        </p:spPr>
+        <p:txBody>
+          <a:bodyPr wrap="square" lIns="0" rIns="0" tIns="0" bIns="0" anchor="t">
+            <a:spAutoFit/>
+          </a:bodyPr>
+          <a:lstStyle/>
+          <a:p>
+            <a:pPr algn="l">
+              <a:spcBef>
+                <a:spcPts val="0"/>
+              </a:spcBef>
+              <a:spcAft>
+                <a:spcPts val="0"/>
+              </a:spcAft>
+            </a:pPr>
+            <a:r>
+              <a:rPr sz="900" b="0">
+                <a:solidFill>
+                  <a:srgbClr val="62748A"/>
+                </a:solidFill>
+                <a:latin typeface="Microsoft YaHei"/>
+              </a:rPr>
+              <a:t>完整语步定义与语阶见附录</a:t>
+            </a:r>
+          </a:p>
+        </p:txBody>
+      </p:sp>
+      <p:sp>
+        <p:nvSpPr>
+          <p:cNvPr id="55" name="Rounded Rectangle 54"/>
+          <p:cNvSpPr/>
+          <p:nvPr/>
+        </p:nvSpPr>
+        <p:spPr>
+          <a:xfrm>
+            <a:off x="8366760" y="2011680"/>
+            <a:ext cx="2971800" cy="3584448"/>
+          </a:xfrm>
+          <a:prstGeom prst="roundRect">
+            <a:avLst/>
+          </a:prstGeom>
+          <a:solidFill>
+            <a:srgbClr val="FFFFFF"/>
+          </a:solidFill>
+          <a:ln w="10160">
+            <a:solidFill>
+              <a:srgbClr val="D8E1EB"/>
+            </a:solidFill>
+          </a:ln>
+        </p:spPr>
+        <p:style>
+          <a:lnRef idx="1">
+            <a:schemeClr val="accent1"/>
+          </a:lnRef>
+          <a:fillRef idx="3">
+            <a:schemeClr val="accent1"/>
+          </a:fillRef>
+          <a:effectRef idx="2">
+            <a:schemeClr val="accent1"/>
+          </a:effectRef>
+          <a:fontRef idx="minor">
+            <a:schemeClr val="lt1"/>
+          </a:fontRef>
+        </p:style>
+        <p:txBody>
+          <a:bodyPr rtlCol="0" anchor="ctr"/>
+          <a:lstStyle/>
+          <a:p>
+            <a:pPr algn="ctr"/>
+          </a:p>
+        </p:txBody>
+      </p:sp>
+      <p:sp>
+        <p:nvSpPr>
+          <p:cNvPr id="56" name="TextBox 55"/>
+          <p:cNvSpPr txBox="1"/>
+          <p:nvPr/>
+        </p:nvSpPr>
+        <p:spPr>
+          <a:xfrm>
+            <a:off x="8586216" y="2212848"/>
+            <a:ext cx="2532888" cy="292608"/>
+          </a:xfrm>
+          <a:prstGeom prst="rect">
+            <a:avLst/>
+          </a:prstGeom>
+          <a:noFill/>
+        </p:spPr>
+        <p:txBody>
+          <a:bodyPr wrap="square" lIns="0" rIns="0" tIns="0" bIns="0" anchor="t">
+            <a:spAutoFit/>
+          </a:bodyPr>
+          <a:lstStyle/>
+          <a:p>
+            <a:pPr algn="l">
+              <a:spcBef>
+                <a:spcPts val="0"/>
+              </a:spcBef>
+              <a:spcAft>
+                <a:spcPts val="0"/>
+              </a:spcAft>
+            </a:pPr>
+            <a:r>
+              <a:rPr sz="1200" b="1">
+                <a:solidFill>
+                  <a:srgbClr val="3568A8"/>
+                </a:solidFill>
+                <a:latin typeface="Microsoft YaHei"/>
+              </a:rPr>
+              <a:t>03　人机协作校订</a:t>
+            </a:r>
+          </a:p>
+        </p:txBody>
+      </p:sp>
+      <p:sp>
+        <p:nvSpPr>
+          <p:cNvPr id="57" name="Rounded Rectangle 56"/>
+          <p:cNvSpPr/>
+          <p:nvPr/>
+        </p:nvSpPr>
+        <p:spPr>
+          <a:xfrm>
+            <a:off x="8622792" y="2660904"/>
+            <a:ext cx="2459736" cy="438912"/>
+          </a:xfrm>
+          <a:prstGeom prst="roundRect">
+            <a:avLst/>
+          </a:prstGeom>
+          <a:solidFill>
+            <a:srgbClr val="EAF1F8"/>
+          </a:solidFill>
+          <a:ln>
+            <a:noFill/>
+          </a:ln>
+        </p:spPr>
+        <p:style>
+          <a:lnRef idx="1">
+            <a:schemeClr val="accent1"/>
+          </a:lnRef>
+          <a:fillRef idx="3">
+            <a:schemeClr val="accent1"/>
+          </a:fillRef>
+          <a:effectRef idx="2">
+            <a:schemeClr val="accent1"/>
+          </a:effectRef>
+          <a:fontRef idx="minor">
+            <a:schemeClr val="lt1"/>
+          </a:fontRef>
+        </p:style>
+        <p:txBody>
+          <a:bodyPr rtlCol="0" anchor="ctr"/>
+          <a:lstStyle/>
+          <a:p>
+            <a:pPr algn="ctr"/>
+          </a:p>
+        </p:txBody>
+      </p:sp>
+      <p:sp>
+        <p:nvSpPr>
+          <p:cNvPr id="58" name="TextBox 57"/>
+          <p:cNvSpPr txBox="1"/>
+          <p:nvPr/>
+        </p:nvSpPr>
+        <p:spPr>
+          <a:xfrm>
+            <a:off x="8622792" y="2660904"/>
+            <a:ext cx="2459736" cy="438912"/>
+          </a:xfrm>
+          <a:prstGeom prst="rect">
+            <a:avLst/>
+          </a:prstGeom>
+          <a:noFill/>
+        </p:spPr>
+        <p:txBody>
+          <a:bodyPr wrap="square" lIns="0" rIns="0" tIns="0" bIns="0" anchor="ctr">
+            <a:spAutoFit/>
+          </a:bodyPr>
+          <a:lstStyle/>
+          <a:p>
+            <a:pPr algn="ctr">
+              <a:spcBef>
+                <a:spcPts val="0"/>
+              </a:spcBef>
+              <a:spcAft>
+                <a:spcPts val="0"/>
+              </a:spcAft>
+            </a:pPr>
+            <a:r>
+              <a:rPr sz="1150" b="1">
+                <a:solidFill>
+                  <a:srgbClr val="3568A8"/>
+                </a:solidFill>
+                <a:latin typeface="Microsoft YaHei"/>
+              </a:rPr>
+              <a:t>AI预标注</a:t>
+            </a:r>
+          </a:p>
+        </p:txBody>
+      </p:sp>
+      <p:sp>
+        <p:nvSpPr>
+          <p:cNvPr id="59" name="Rounded Rectangle 58"/>
+          <p:cNvSpPr/>
+          <p:nvPr/>
+        </p:nvSpPr>
+        <p:spPr>
+          <a:xfrm>
+            <a:off x="8622792" y="3374136"/>
+            <a:ext cx="2459736" cy="438912"/>
+          </a:xfrm>
+          <a:prstGeom prst="roundRect">
+            <a:avLst/>
+          </a:prstGeom>
+          <a:solidFill>
+            <a:srgbClr val="FFFFFF"/>
+          </a:solidFill>
+          <a:ln w="10160">
+            <a:solidFill>
+              <a:srgbClr val="D8E1EB"/>
+            </a:solidFill>
+          </a:ln>
+        </p:spPr>
+        <p:style>
+          <a:lnRef idx="1">
+            <a:schemeClr val="accent1"/>
+          </a:lnRef>
+          <a:fillRef idx="3">
+            <a:schemeClr val="accent1"/>
+          </a:fillRef>
+          <a:effectRef idx="2">
+            <a:schemeClr val="accent1"/>
+          </a:effectRef>
+          <a:fontRef idx="minor">
+            <a:schemeClr val="lt1"/>
+          </a:fontRef>
+        </p:style>
+        <p:txBody>
+          <a:bodyPr rtlCol="0" anchor="ctr"/>
+          <a:lstStyle/>
+          <a:p>
+            <a:pPr algn="ctr"/>
+          </a:p>
+        </p:txBody>
+      </p:sp>
+      <p:sp>
+        <p:nvSpPr>
+          <p:cNvPr id="60" name="TextBox 59"/>
+          <p:cNvSpPr txBox="1"/>
+          <p:nvPr/>
+        </p:nvSpPr>
+        <p:spPr>
+          <a:xfrm>
+            <a:off x="8622792" y="3374136"/>
+            <a:ext cx="2459736" cy="438912"/>
+          </a:xfrm>
+          <a:prstGeom prst="rect">
+            <a:avLst/>
+          </a:prstGeom>
+          <a:noFill/>
+        </p:spPr>
+        <p:txBody>
+          <a:bodyPr wrap="square" lIns="0" rIns="0" tIns="0" bIns="0" anchor="ctr">
+            <a:spAutoFit/>
+          </a:bodyPr>
+          <a:lstStyle/>
+          <a:p>
+            <a:pPr algn="ctr">
+              <a:spcBef>
+                <a:spcPts val="0"/>
+              </a:spcBef>
+              <a:spcAft>
+                <a:spcPts val="0"/>
+              </a:spcAft>
+            </a:pPr>
+            <a:r>
+              <a:rPr sz="1150" b="1">
+                <a:solidFill>
+                  <a:srgbClr val="17324D"/>
+                </a:solidFill>
+                <a:latin typeface="Microsoft YaHei"/>
+              </a:rPr>
+              <a:t>人工逐篇审阅</a:t>
+            </a:r>
+          </a:p>
+        </p:txBody>
+      </p:sp>
+      <p:sp>
+        <p:nvSpPr>
+          <p:cNvPr id="61" name="Rounded Rectangle 60"/>
+          <p:cNvSpPr/>
+          <p:nvPr/>
+        </p:nvSpPr>
+        <p:spPr>
+          <a:xfrm>
+            <a:off x="8622792" y="4087368"/>
+            <a:ext cx="2459736" cy="438912"/>
+          </a:xfrm>
+          <a:prstGeom prst="roundRect">
+            <a:avLst/>
+          </a:prstGeom>
+          <a:solidFill>
+            <a:srgbClr val="FFF3E5"/>
+          </a:solidFill>
+          <a:ln>
+            <a:noFill/>
+          </a:ln>
+        </p:spPr>
+        <p:style>
+          <a:lnRef idx="1">
+            <a:schemeClr val="accent1"/>
+          </a:lnRef>
+          <a:fillRef idx="3">
+            <a:schemeClr val="accent1"/>
+          </a:fillRef>
+          <a:effectRef idx="2">
+            <a:schemeClr val="accent1"/>
+          </a:effectRef>
+          <a:fontRef idx="minor">
+            <a:schemeClr val="lt1"/>
+          </a:fontRef>
+        </p:style>
+        <p:txBody>
+          <a:bodyPr rtlCol="0" anchor="ctr"/>
+          <a:lstStyle/>
+          <a:p>
+            <a:pPr algn="ctr"/>
+          </a:p>
+        </p:txBody>
+      </p:sp>
+      <p:sp>
+        <p:nvSpPr>
+          <p:cNvPr id="62" name="TextBox 61"/>
+          <p:cNvSpPr txBox="1"/>
+          <p:nvPr/>
+        </p:nvSpPr>
+        <p:spPr>
+          <a:xfrm>
+            <a:off x="8622792" y="4087368"/>
+            <a:ext cx="2459736" cy="438912"/>
+          </a:xfrm>
+          <a:prstGeom prst="rect">
+            <a:avLst/>
+          </a:prstGeom>
+          <a:noFill/>
+        </p:spPr>
+        <p:txBody>
+          <a:bodyPr wrap="square" lIns="0" rIns="0" tIns="0" bIns="0" anchor="ctr">
+            <a:spAutoFit/>
+          </a:bodyPr>
+          <a:lstStyle/>
+          <a:p>
+            <a:pPr algn="ctr">
+              <a:spcBef>
+                <a:spcPts val="0"/>
+              </a:spcBef>
+              <a:spcAft>
+                <a:spcPts val="0"/>
+              </a:spcAft>
+            </a:pPr>
+            <a:r>
+              <a:rPr sz="1150" b="1">
+                <a:solidFill>
+                  <a:srgbClr val="E38B36"/>
+                </a:solidFill>
+                <a:latin typeface="Microsoft YaHei"/>
+              </a:rPr>
+              <a:t>立即修改并保存</a:t>
+            </a:r>
+          </a:p>
+        </p:txBody>
+      </p:sp>
+      <p:sp>
+        <p:nvSpPr>
+          <p:cNvPr id="63" name="TextBox 62"/>
+          <p:cNvSpPr txBox="1"/>
+          <p:nvPr/>
+        </p:nvSpPr>
+        <p:spPr>
+          <a:xfrm>
+            <a:off x="9637776" y="3099816"/>
+            <a:ext cx="420624" cy="256032"/>
+          </a:xfrm>
+          <a:prstGeom prst="rect">
+            <a:avLst/>
+          </a:prstGeom>
+          <a:noFill/>
+        </p:spPr>
+        <p:txBody>
+          <a:bodyPr wrap="square" lIns="0" rIns="0" tIns="0" bIns="0" anchor="t">
+            <a:spAutoFit/>
+          </a:bodyPr>
+          <a:lstStyle/>
+          <a:p>
+            <a:pPr algn="ctr">
+              <a:spcBef>
+                <a:spcPts val="0"/>
+              </a:spcBef>
+              <a:spcAft>
+                <a:spcPts val="0"/>
+              </a:spcAft>
+            </a:pPr>
+            <a:r>
+              <a:rPr sz="1500" b="0">
+                <a:solidFill>
+                  <a:srgbClr val="62748A"/>
+                </a:solidFill>
+                <a:latin typeface="Microsoft YaHei"/>
+              </a:rPr>
+              <a:t>↓</a:t>
+            </a:r>
+          </a:p>
+        </p:txBody>
+      </p:sp>
+      <p:sp>
+        <p:nvSpPr>
+          <p:cNvPr id="64" name="TextBox 63"/>
+          <p:cNvSpPr txBox="1"/>
+          <p:nvPr/>
+        </p:nvSpPr>
+        <p:spPr>
+          <a:xfrm>
+            <a:off x="9637776" y="3813048"/>
+            <a:ext cx="420624" cy="256032"/>
+          </a:xfrm>
+          <a:prstGeom prst="rect">
+            <a:avLst/>
+          </a:prstGeom>
+          <a:noFill/>
+        </p:spPr>
+        <p:txBody>
+          <a:bodyPr wrap="square" lIns="0" rIns="0" tIns="0" bIns="0" anchor="t">
+            <a:spAutoFit/>
+          </a:bodyPr>
+          <a:lstStyle/>
+          <a:p>
+            <a:pPr algn="ctr">
+              <a:spcBef>
+                <a:spcPts val="0"/>
+              </a:spcBef>
+              <a:spcAft>
+                <a:spcPts val="0"/>
+              </a:spcAft>
+            </a:pPr>
+            <a:r>
+              <a:rPr sz="1500" b="0">
+                <a:solidFill>
+                  <a:srgbClr val="62748A"/>
+                </a:solidFill>
+                <a:latin typeface="Microsoft YaHei"/>
+              </a:rPr>
+              <a:t>↓</a:t>
+            </a:r>
+          </a:p>
+        </p:txBody>
+      </p:sp>
+      <p:sp>
+        <p:nvSpPr>
+          <p:cNvPr id="65" name="Rounded Rectangle 64"/>
+          <p:cNvSpPr/>
+          <p:nvPr/>
+        </p:nvSpPr>
+        <p:spPr>
+          <a:xfrm>
+            <a:off x="8622792" y="4754880"/>
+            <a:ext cx="2459736" cy="621792"/>
+          </a:xfrm>
+          <a:prstGeom prst="roundRect">
+            <a:avLst/>
+          </a:prstGeom>
+          <a:solidFill>
+            <a:srgbClr val="17324D"/>
+          </a:solidFill>
+          <a:ln>
+            <a:noFill/>
+          </a:ln>
+        </p:spPr>
+        <p:style>
+          <a:lnRef idx="1">
+            <a:schemeClr val="accent1"/>
+          </a:lnRef>
+          <a:fillRef idx="3">
+            <a:schemeClr val="accent1"/>
+          </a:fillRef>
+          <a:effectRef idx="2">
+            <a:schemeClr val="accent1"/>
+          </a:effectRef>
+          <a:fontRef idx="minor">
+            <a:schemeClr val="lt1"/>
+          </a:fontRef>
+        </p:style>
+        <p:txBody>
+          <a:bodyPr rtlCol="0" anchor="ctr"/>
+          <a:lstStyle/>
+          <a:p>
+            <a:pPr algn="ctr"/>
+          </a:p>
+        </p:txBody>
+      </p:sp>
+      <p:sp>
+        <p:nvSpPr>
+          <p:cNvPr id="66" name="TextBox 65"/>
+          <p:cNvSpPr txBox="1"/>
+          <p:nvPr/>
+        </p:nvSpPr>
+        <p:spPr>
+          <a:xfrm>
+            <a:off x="8622792" y="4818888"/>
+            <a:ext cx="2459736" cy="182880"/>
+          </a:xfrm>
+          <a:prstGeom prst="rect">
+            <a:avLst/>
+          </a:prstGeom>
+          <a:noFill/>
+        </p:spPr>
+        <p:txBody>
+          <a:bodyPr wrap="square" lIns="0" rIns="0" tIns="0" bIns="0" anchor="t">
+            <a:spAutoFit/>
+          </a:bodyPr>
+          <a:lstStyle/>
+          <a:p>
+            <a:pPr algn="ctr">
+              <a:spcBef>
+                <a:spcPts val="0"/>
+              </a:spcBef>
+              <a:spcAft>
+                <a:spcPts val="0"/>
+              </a:spcAft>
+            </a:pPr>
+            <a:r>
+              <a:rPr sz="850" b="0">
+                <a:solidFill>
+                  <a:srgbClr val="FFFFFF"/>
+                </a:solidFill>
+                <a:latin typeface="Microsoft YaHei"/>
+              </a:rPr>
+              <a:t>最终分析对象</a:t>
+            </a:r>
+          </a:p>
+        </p:txBody>
+      </p:sp>
+      <p:sp>
+        <p:nvSpPr>
+          <p:cNvPr id="67" name="TextBox 66"/>
+          <p:cNvSpPr txBox="1"/>
+          <p:nvPr/>
+        </p:nvSpPr>
+        <p:spPr>
+          <a:xfrm>
+            <a:off x="8622792" y="5010912"/>
+            <a:ext cx="2459736" cy="274320"/>
+          </a:xfrm>
+          <a:prstGeom prst="rect">
+            <a:avLst/>
+          </a:prstGeom>
+          <a:noFill/>
+        </p:spPr>
+        <p:txBody>
+          <a:bodyPr wrap="square" lIns="0" rIns="0" tIns="0" bIns="0" anchor="t">
+            <a:spAutoFit/>
+          </a:bodyPr>
+          <a:lstStyle/>
+          <a:p>
+            <a:pPr algn="ctr">
+              <a:spcBef>
+                <a:spcPts val="0"/>
+              </a:spcBef>
+              <a:spcAft>
+                <a:spcPts val="0"/>
+              </a:spcAft>
+            </a:pPr>
+            <a:r>
+              <a:rPr sz="1300" b="1">
+                <a:solidFill>
+                  <a:srgbClr val="FFFFFF"/>
+                </a:solidFill>
+                <a:latin typeface="Microsoft YaHei"/>
+              </a:rPr>
+              <a:t>人工校订标签</a:t>
+            </a:r>
+          </a:p>
+        </p:txBody>
+      </p:sp>
+      <p:cxnSp>
+        <p:nvCxnSpPr>
+          <p:cNvPr id="68" name="Connector 67"/>
+          <p:cNvCxnSpPr/>
+          <p:nvPr/>
+        </p:nvCxnSpPr>
+        <p:spPr>
+          <a:xfrm>
+            <a:off x="731520" y="6144768"/>
+            <a:ext cx="10744200" cy="0"/>
+          </a:xfrm>
+          <a:prstGeom prst="line">
+            <a:avLst/>
+          </a:prstGeom>
+          <a:ln w="10160">
+            <a:solidFill>
+              <a:srgbClr val="D8E1EB"/>
+            </a:solidFill>
+          </a:ln>
+        </p:spPr>
+        <p:style>
+          <a:lnRef idx="2">
+            <a:schemeClr val="accent1"/>
+          </a:lnRef>
+          <a:fillRef idx="0">
+            <a:schemeClr val="accent1"/>
+          </a:fillRef>
+          <a:effectRef idx="1">
+            <a:schemeClr val="accent1"/>
+          </a:effectRef>
+          <a:fontRef idx="minor">
+            <a:schemeClr val="tx1"/>
+          </a:fontRef>
+        </p:style>
+      </p:cxnSp>
+      <p:sp>
+        <p:nvSpPr>
+          <p:cNvPr id="69" name="TextBox 68"/>
+          <p:cNvSpPr txBox="1"/>
+          <p:nvPr/>
+        </p:nvSpPr>
+        <p:spPr>
+          <a:xfrm>
+            <a:off x="731520" y="6318504"/>
+            <a:ext cx="7772400" cy="256032"/>
+          </a:xfrm>
+          <a:prstGeom prst="rect">
+            <a:avLst/>
+          </a:prstGeom>
+          <a:noFill/>
+        </p:spPr>
+        <p:txBody>
+          <a:bodyPr wrap="square" lIns="0" rIns="0" tIns="0" bIns="0" anchor="t">
+            <a:spAutoFit/>
+          </a:bodyPr>
+          <a:lstStyle/>
+          <a:p>
+            <a:pPr algn="l">
+              <a:spcBef>
+                <a:spcPts val="0"/>
+              </a:spcBef>
+              <a:spcAft>
+                <a:spcPts val="0"/>
+              </a:spcAft>
+            </a:pPr>
+            <a:r>
+              <a:rPr sz="900" b="0">
+                <a:solidFill>
+                  <a:srgbClr val="62748A"/>
+                </a:solidFill>
+                <a:latin typeface="Microsoft YaHei"/>
+              </a:rPr>
+              <a:t>基于语料库技术的中美外语院系英文简介话语比较分析</a:t>
+            </a:r>
+          </a:p>
+        </p:txBody>
+      </p:sp>
+      <p:sp>
+        <p:nvSpPr>
+          <p:cNvPr id="70" name="TextBox 69"/>
+          <p:cNvSpPr txBox="1"/>
+          <p:nvPr/>
+        </p:nvSpPr>
+        <p:spPr>
+          <a:xfrm>
+            <a:off x="10881360" y="6318504"/>
+            <a:ext cx="594360" cy="256032"/>
+          </a:xfrm>
+          <a:prstGeom prst="rect">
+            <a:avLst/>
+          </a:prstGeom>
+          <a:noFill/>
+        </p:spPr>
+        <p:txBody>
+          <a:bodyPr wrap="square" lIns="0" rIns="0" tIns="0" bIns="0" anchor="t">
+            <a:spAutoFit/>
+          </a:bodyPr>
+          <a:lstStyle/>
+          <a:p>
+            <a:pPr algn="r">
+              <a:spcBef>
+                <a:spcPts val="0"/>
+              </a:spcBef>
+              <a:spcAft>
+                <a:spcPts val="0"/>
+              </a:spcAft>
+            </a:pPr>
+            <a:r>
+              <a:rPr sz="1000" b="0">
+                <a:solidFill>
+                  <a:srgbClr val="62748A"/>
+                </a:solidFill>
+                <a:latin typeface="Microsoft YaHei"/>
+              </a:rPr>
+              <a:t>04 / 08</a:t>
             </a:r>
           </a:p>
         </p:txBody>

</xml_diff>

<commit_message>
Add editable move occurrence results slide
Co-authored-by: arena-agent <297053741+arena-agent@users.noreply.github.com>
</commit_message>
<xml_diff>
--- a/midterm-report/presentation/中美外语院系英文简介_5分钟汇报.pptx
+++ b/midterm-report/presentation/中美外语院系英文简介_5分钟汇报.pptx
@@ -9,6 +9,7 @@
     <p:sldId id="257" r:id="rId8"/>
     <p:sldId id="258" r:id="rId9"/>
     <p:sldId id="259" r:id="rId10"/>
+    <p:sldId id="260" r:id="rId11"/>
   </p:sldIdLst>
   <p:sldSz cx="12191695" cy="6858000" type="screen4x3"/>
   <p:notesSz cx="6858000" cy="9144000"/>
@@ -12954,6 +12955,3879 @@
                 <a:latin typeface="Microsoft YaHei"/>
               </a:rPr>
               <a:t>04 / 08</a:t>
+            </a:r>
+          </a:p>
+        </p:txBody>
+      </p:sp>
+    </p:spTree>
+  </p:cSld>
+  <p:clrMapOvr>
+    <a:masterClrMapping/>
+  </p:clrMapOvr>
+</p:sld>
+</file>
+
+<file path=ppt/slides/slide5.xml><?xml version="1.0" encoding="utf-8"?>
+<p:sld xmlns:a="http://schemas.openxmlformats.org/drawingml/2006/main" xmlns:p="http://schemas.openxmlformats.org/presentationml/2006/main" xmlns:r="http://schemas.openxmlformats.org/officeDocument/2006/relationships">
+  <p:cSld>
+    <p:spTree>
+      <p:nvGrpSpPr>
+        <p:cNvPr id="1" name=""/>
+        <p:cNvGrpSpPr/>
+        <p:nvPr/>
+      </p:nvGrpSpPr>
+      <p:grpSpPr/>
+      <p:sp>
+        <p:nvSpPr>
+          <p:cNvPr id="2" name="Rectangle 1"/>
+          <p:cNvSpPr/>
+          <p:nvPr/>
+        </p:nvSpPr>
+        <p:spPr>
+          <a:xfrm>
+            <a:off x="0" y="0"/>
+            <a:ext cx="12191695" cy="6858000"/>
+          </a:xfrm>
+          <a:prstGeom prst="rect">
+            <a:avLst/>
+          </a:prstGeom>
+          <a:solidFill>
+            <a:srgbClr val="F7F9FC"/>
+          </a:solidFill>
+          <a:ln>
+            <a:noFill/>
+          </a:ln>
+        </p:spPr>
+        <p:style>
+          <a:lnRef idx="1">
+            <a:schemeClr val="accent1"/>
+          </a:lnRef>
+          <a:fillRef idx="3">
+            <a:schemeClr val="accent1"/>
+          </a:fillRef>
+          <a:effectRef idx="2">
+            <a:schemeClr val="accent1"/>
+          </a:effectRef>
+          <a:fontRef idx="minor">
+            <a:schemeClr val="lt1"/>
+          </a:fontRef>
+        </p:style>
+        <p:txBody>
+          <a:bodyPr rtlCol="0" anchor="ctr"/>
+          <a:lstStyle/>
+          <a:p>
+            <a:pPr algn="ctr"/>
+          </a:p>
+        </p:txBody>
+      </p:sp>
+      <p:sp>
+        <p:nvSpPr>
+          <p:cNvPr id="3" name="Rectangle 2"/>
+          <p:cNvSpPr/>
+          <p:nvPr/>
+        </p:nvSpPr>
+        <p:spPr>
+          <a:xfrm>
+            <a:off x="0" y="0"/>
+            <a:ext cx="146304" cy="6858000"/>
+          </a:xfrm>
+          <a:prstGeom prst="rect">
+            <a:avLst/>
+          </a:prstGeom>
+          <a:solidFill>
+            <a:srgbClr val="17324D"/>
+          </a:solidFill>
+          <a:ln>
+            <a:noFill/>
+          </a:ln>
+        </p:spPr>
+        <p:style>
+          <a:lnRef idx="1">
+            <a:schemeClr val="accent1"/>
+          </a:lnRef>
+          <a:fillRef idx="3">
+            <a:schemeClr val="accent1"/>
+          </a:fillRef>
+          <a:effectRef idx="2">
+            <a:schemeClr val="accent1"/>
+          </a:effectRef>
+          <a:fontRef idx="minor">
+            <a:schemeClr val="lt1"/>
+          </a:fontRef>
+        </p:style>
+        <p:txBody>
+          <a:bodyPr rtlCol="0" anchor="ctr"/>
+          <a:lstStyle/>
+          <a:p>
+            <a:pPr algn="ctr"/>
+          </a:p>
+        </p:txBody>
+      </p:sp>
+      <p:sp>
+        <p:nvSpPr>
+          <p:cNvPr id="4" name="Rectangle 3"/>
+          <p:cNvSpPr/>
+          <p:nvPr/>
+        </p:nvSpPr>
+        <p:spPr>
+          <a:xfrm>
+            <a:off x="146304" y="0"/>
+            <a:ext cx="50292" cy="841248"/>
+          </a:xfrm>
+          <a:prstGeom prst="rect">
+            <a:avLst/>
+          </a:prstGeom>
+          <a:solidFill>
+            <a:srgbClr val="E38B36"/>
+          </a:solidFill>
+          <a:ln>
+            <a:noFill/>
+          </a:ln>
+        </p:spPr>
+        <p:style>
+          <a:lnRef idx="1">
+            <a:schemeClr val="accent1"/>
+          </a:lnRef>
+          <a:fillRef idx="3">
+            <a:schemeClr val="accent1"/>
+          </a:fillRef>
+          <a:effectRef idx="2">
+            <a:schemeClr val="accent1"/>
+          </a:effectRef>
+          <a:fontRef idx="minor">
+            <a:schemeClr val="lt1"/>
+          </a:fontRef>
+        </p:style>
+        <p:txBody>
+          <a:bodyPr rtlCol="0" anchor="ctr"/>
+          <a:lstStyle/>
+          <a:p>
+            <a:pPr algn="ctr"/>
+          </a:p>
+        </p:txBody>
+      </p:sp>
+      <p:sp>
+        <p:nvSpPr>
+          <p:cNvPr id="5" name="TextBox 4"/>
+          <p:cNvSpPr txBox="1"/>
+          <p:nvPr/>
+        </p:nvSpPr>
+        <p:spPr>
+          <a:xfrm>
+            <a:off x="731520" y="438912"/>
+            <a:ext cx="3840480" cy="274320"/>
+          </a:xfrm>
+          <a:prstGeom prst="rect">
+            <a:avLst/>
+          </a:prstGeom>
+          <a:noFill/>
+        </p:spPr>
+        <p:txBody>
+          <a:bodyPr wrap="square" lIns="0" rIns="0" tIns="0" bIns="0" anchor="t">
+            <a:spAutoFit/>
+          </a:bodyPr>
+          <a:lstStyle/>
+          <a:p>
+            <a:pPr algn="l">
+              <a:spcBef>
+                <a:spcPts val="0"/>
+              </a:spcBef>
+              <a:spcAft>
+                <a:spcPts val="0"/>
+              </a:spcAft>
+            </a:pPr>
+            <a:r>
+              <a:rPr sz="1100" b="1">
+                <a:solidFill>
+                  <a:srgbClr val="3568A8"/>
+                </a:solidFill>
+                <a:latin typeface="Microsoft YaHei"/>
+              </a:rPr>
+              <a:t>04　研究结果｜语步分布</a:t>
+            </a:r>
+          </a:p>
+        </p:txBody>
+      </p:sp>
+      <p:sp>
+        <p:nvSpPr>
+          <p:cNvPr id="6" name="TextBox 5"/>
+          <p:cNvSpPr txBox="1"/>
+          <p:nvPr/>
+        </p:nvSpPr>
+        <p:spPr>
+          <a:xfrm>
+            <a:off x="731520" y="768096"/>
+            <a:ext cx="9692640" cy="475488"/>
+          </a:xfrm>
+          <a:prstGeom prst="rect">
+            <a:avLst/>
+          </a:prstGeom>
+          <a:noFill/>
+        </p:spPr>
+        <p:txBody>
+          <a:bodyPr wrap="square" lIns="0" rIns="0" tIns="0" bIns="0" anchor="t">
+            <a:spAutoFit/>
+          </a:bodyPr>
+          <a:lstStyle/>
+          <a:p>
+            <a:pPr algn="l">
+              <a:spcBef>
+                <a:spcPts val="0"/>
+              </a:spcBef>
+              <a:spcAft>
+                <a:spcPts val="0"/>
+              </a:spcAft>
+            </a:pPr>
+            <a:r>
+              <a:rPr sz="2600" b="1">
+                <a:solidFill>
+                  <a:srgbClr val="17324D"/>
+                </a:solidFill>
+                <a:latin typeface="Microsoft YaHei"/>
+              </a:rPr>
+              <a:t>语步出现率：美国文本的覆盖更稳定</a:t>
+            </a:r>
+          </a:p>
+        </p:txBody>
+      </p:sp>
+      <p:sp>
+        <p:nvSpPr>
+          <p:cNvPr id="7" name="TextBox 6"/>
+          <p:cNvSpPr txBox="1"/>
+          <p:nvPr/>
+        </p:nvSpPr>
+        <p:spPr>
+          <a:xfrm>
+            <a:off x="731520" y="1307592"/>
+            <a:ext cx="10515600" cy="384048"/>
+          </a:xfrm>
+          <a:prstGeom prst="rect">
+            <a:avLst/>
+          </a:prstGeom>
+          <a:noFill/>
+        </p:spPr>
+        <p:txBody>
+          <a:bodyPr wrap="square" lIns="0" rIns="0" tIns="0" bIns="0" anchor="ctr">
+            <a:spAutoFit/>
+          </a:bodyPr>
+          <a:lstStyle/>
+          <a:p>
+            <a:pPr algn="l">
+              <a:spcBef>
+                <a:spcPts val="0"/>
+              </a:spcBef>
+              <a:spcAft>
+                <a:spcPts val="0"/>
+              </a:spcAft>
+            </a:pPr>
+            <a:r>
+              <a:rPr sz="1400" b="0">
+                <a:solidFill>
+                  <a:srgbClr val="23364A"/>
+                </a:solidFill>
+                <a:latin typeface="Microsoft YaHei"/>
+              </a:rPr>
+              <a:t>中美样本共享10个语步，国别差距主要集中于M09、M08与M03</a:t>
+            </a:r>
+          </a:p>
+        </p:txBody>
+      </p:sp>
+      <p:sp>
+        <p:nvSpPr>
+          <p:cNvPr id="8" name="Rectangle 7"/>
+          <p:cNvSpPr/>
+          <p:nvPr/>
+        </p:nvSpPr>
+        <p:spPr>
+          <a:xfrm>
+            <a:off x="731520" y="1773936"/>
+            <a:ext cx="594360" cy="41148"/>
+          </a:xfrm>
+          <a:prstGeom prst="rect">
+            <a:avLst/>
+          </a:prstGeom>
+          <a:solidFill>
+            <a:srgbClr val="E38B36"/>
+          </a:solidFill>
+          <a:ln>
+            <a:noFill/>
+          </a:ln>
+        </p:spPr>
+        <p:style>
+          <a:lnRef idx="1">
+            <a:schemeClr val="accent1"/>
+          </a:lnRef>
+          <a:fillRef idx="3">
+            <a:schemeClr val="accent1"/>
+          </a:fillRef>
+          <a:effectRef idx="2">
+            <a:schemeClr val="accent1"/>
+          </a:effectRef>
+          <a:fontRef idx="minor">
+            <a:schemeClr val="lt1"/>
+          </a:fontRef>
+        </p:style>
+        <p:txBody>
+          <a:bodyPr rtlCol="0" anchor="ctr"/>
+          <a:lstStyle/>
+          <a:p>
+            <a:pPr algn="ctr"/>
+          </a:p>
+        </p:txBody>
+      </p:sp>
+      <p:sp>
+        <p:nvSpPr>
+          <p:cNvPr id="9" name="Rounded Rectangle 8"/>
+          <p:cNvSpPr/>
+          <p:nvPr/>
+        </p:nvSpPr>
+        <p:spPr>
+          <a:xfrm>
+            <a:off x="731520" y="1993392"/>
+            <a:ext cx="7452360" cy="3767328"/>
+          </a:xfrm>
+          <a:prstGeom prst="roundRect">
+            <a:avLst/>
+          </a:prstGeom>
+          <a:solidFill>
+            <a:srgbClr val="FFFFFF"/>
+          </a:solidFill>
+          <a:ln w="10160">
+            <a:solidFill>
+              <a:srgbClr val="D8E1EB"/>
+            </a:solidFill>
+          </a:ln>
+        </p:spPr>
+        <p:style>
+          <a:lnRef idx="1">
+            <a:schemeClr val="accent1"/>
+          </a:lnRef>
+          <a:fillRef idx="3">
+            <a:schemeClr val="accent1"/>
+          </a:fillRef>
+          <a:effectRef idx="2">
+            <a:schemeClr val="accent1"/>
+          </a:effectRef>
+          <a:fontRef idx="minor">
+            <a:schemeClr val="lt1"/>
+          </a:fontRef>
+        </p:style>
+        <p:txBody>
+          <a:bodyPr rtlCol="0" anchor="ctr"/>
+          <a:lstStyle/>
+          <a:p>
+            <a:pPr algn="ctr"/>
+          </a:p>
+        </p:txBody>
+      </p:sp>
+      <p:sp>
+        <p:nvSpPr>
+          <p:cNvPr id="10" name="TextBox 9"/>
+          <p:cNvSpPr txBox="1"/>
+          <p:nvPr/>
+        </p:nvSpPr>
+        <p:spPr>
+          <a:xfrm>
+            <a:off x="941832" y="2167128"/>
+            <a:ext cx="2103120" cy="274320"/>
+          </a:xfrm>
+          <a:prstGeom prst="rect">
+            <a:avLst/>
+          </a:prstGeom>
+          <a:noFill/>
+        </p:spPr>
+        <p:txBody>
+          <a:bodyPr wrap="square" lIns="0" rIns="0" tIns="0" bIns="0" anchor="t">
+            <a:spAutoFit/>
+          </a:bodyPr>
+          <a:lstStyle/>
+          <a:p>
+            <a:pPr algn="l">
+              <a:spcBef>
+                <a:spcPts val="0"/>
+              </a:spcBef>
+              <a:spcAft>
+                <a:spcPts val="0"/>
+              </a:spcAft>
+            </a:pPr>
+            <a:r>
+              <a:rPr sz="1100" b="1">
+                <a:solidFill>
+                  <a:srgbClr val="3568A8"/>
+                </a:solidFill>
+                <a:latin typeface="Microsoft YaHei"/>
+              </a:rPr>
+              <a:t>文本出现率（%）</a:t>
+            </a:r>
+          </a:p>
+        </p:txBody>
+      </p:sp>
+      <p:sp>
+        <p:nvSpPr>
+          <p:cNvPr id="11" name="Rounded Rectangle 10"/>
+          <p:cNvSpPr/>
+          <p:nvPr/>
+        </p:nvSpPr>
+        <p:spPr>
+          <a:xfrm>
+            <a:off x="5623560" y="2221992"/>
+            <a:ext cx="146304" cy="91440"/>
+          </a:xfrm>
+          <a:prstGeom prst="roundRect">
+            <a:avLst/>
+          </a:prstGeom>
+          <a:solidFill>
+            <a:srgbClr val="3568A8"/>
+          </a:solidFill>
+          <a:ln>
+            <a:noFill/>
+          </a:ln>
+        </p:spPr>
+        <p:style>
+          <a:lnRef idx="1">
+            <a:schemeClr val="accent1"/>
+          </a:lnRef>
+          <a:fillRef idx="3">
+            <a:schemeClr val="accent1"/>
+          </a:fillRef>
+          <a:effectRef idx="2">
+            <a:schemeClr val="accent1"/>
+          </a:effectRef>
+          <a:fontRef idx="minor">
+            <a:schemeClr val="lt1"/>
+          </a:fontRef>
+        </p:style>
+        <p:txBody>
+          <a:bodyPr rtlCol="0" anchor="ctr"/>
+          <a:lstStyle/>
+          <a:p>
+            <a:pPr algn="ctr"/>
+          </a:p>
+        </p:txBody>
+      </p:sp>
+      <p:sp>
+        <p:nvSpPr>
+          <p:cNvPr id="12" name="TextBox 11"/>
+          <p:cNvSpPr txBox="1"/>
+          <p:nvPr/>
+        </p:nvSpPr>
+        <p:spPr>
+          <a:xfrm>
+            <a:off x="5843016" y="2139696"/>
+            <a:ext cx="566928" cy="256032"/>
+          </a:xfrm>
+          <a:prstGeom prst="rect">
+            <a:avLst/>
+          </a:prstGeom>
+          <a:noFill/>
+        </p:spPr>
+        <p:txBody>
+          <a:bodyPr wrap="square" lIns="0" rIns="0" tIns="0" bIns="0" anchor="ctr">
+            <a:spAutoFit/>
+          </a:bodyPr>
+          <a:lstStyle/>
+          <a:p>
+            <a:pPr algn="l">
+              <a:spcBef>
+                <a:spcPts val="0"/>
+              </a:spcBef>
+              <a:spcAft>
+                <a:spcPts val="0"/>
+              </a:spcAft>
+            </a:pPr>
+            <a:r>
+              <a:rPr sz="950" b="0">
+                <a:solidFill>
+                  <a:srgbClr val="62748A"/>
+                </a:solidFill>
+                <a:latin typeface="Microsoft YaHei"/>
+              </a:rPr>
+              <a:t>中国</a:t>
+            </a:r>
+          </a:p>
+        </p:txBody>
+      </p:sp>
+      <p:sp>
+        <p:nvSpPr>
+          <p:cNvPr id="13" name="Rounded Rectangle 12"/>
+          <p:cNvSpPr/>
+          <p:nvPr/>
+        </p:nvSpPr>
+        <p:spPr>
+          <a:xfrm>
+            <a:off x="6547104" y="2221992"/>
+            <a:ext cx="146304" cy="91440"/>
+          </a:xfrm>
+          <a:prstGeom prst="roundRect">
+            <a:avLst/>
+          </a:prstGeom>
+          <a:solidFill>
+            <a:srgbClr val="E38B36"/>
+          </a:solidFill>
+          <a:ln>
+            <a:noFill/>
+          </a:ln>
+        </p:spPr>
+        <p:style>
+          <a:lnRef idx="1">
+            <a:schemeClr val="accent1"/>
+          </a:lnRef>
+          <a:fillRef idx="3">
+            <a:schemeClr val="accent1"/>
+          </a:fillRef>
+          <a:effectRef idx="2">
+            <a:schemeClr val="accent1"/>
+          </a:effectRef>
+          <a:fontRef idx="minor">
+            <a:schemeClr val="lt1"/>
+          </a:fontRef>
+        </p:style>
+        <p:txBody>
+          <a:bodyPr rtlCol="0" anchor="ctr"/>
+          <a:lstStyle/>
+          <a:p>
+            <a:pPr algn="ctr"/>
+          </a:p>
+        </p:txBody>
+      </p:sp>
+      <p:sp>
+        <p:nvSpPr>
+          <p:cNvPr id="14" name="TextBox 13"/>
+          <p:cNvSpPr txBox="1"/>
+          <p:nvPr/>
+        </p:nvSpPr>
+        <p:spPr>
+          <a:xfrm>
+            <a:off x="6766560" y="2139696"/>
+            <a:ext cx="658368" cy="256032"/>
+          </a:xfrm>
+          <a:prstGeom prst="rect">
+            <a:avLst/>
+          </a:prstGeom>
+          <a:noFill/>
+        </p:spPr>
+        <p:txBody>
+          <a:bodyPr wrap="square" lIns="0" rIns="0" tIns="0" bIns="0" anchor="ctr">
+            <a:spAutoFit/>
+          </a:bodyPr>
+          <a:lstStyle/>
+          <a:p>
+            <a:pPr algn="l">
+              <a:spcBef>
+                <a:spcPts val="0"/>
+              </a:spcBef>
+              <a:spcAft>
+                <a:spcPts val="0"/>
+              </a:spcAft>
+            </a:pPr>
+            <a:r>
+              <a:rPr sz="950" b="0">
+                <a:solidFill>
+                  <a:srgbClr val="62748A"/>
+                </a:solidFill>
+                <a:latin typeface="Microsoft YaHei"/>
+              </a:rPr>
+              <a:t>美国</a:t>
+            </a:r>
+          </a:p>
+        </p:txBody>
+      </p:sp>
+      <p:cxnSp>
+        <p:nvCxnSpPr>
+          <p:cNvPr id="15" name="Connector 14"/>
+          <p:cNvCxnSpPr/>
+          <p:nvPr/>
+        </p:nvCxnSpPr>
+        <p:spPr>
+          <a:xfrm>
+            <a:off x="1417320" y="2633472"/>
+            <a:ext cx="0" cy="2880360"/>
+          </a:xfrm>
+          <a:prstGeom prst="line">
+            <a:avLst/>
+          </a:prstGeom>
+          <a:ln w="6350">
+            <a:solidFill>
+              <a:srgbClr val="D8E1EB"/>
+            </a:solidFill>
+          </a:ln>
+        </p:spPr>
+        <p:style>
+          <a:lnRef idx="2">
+            <a:schemeClr val="accent1"/>
+          </a:lnRef>
+          <a:fillRef idx="0">
+            <a:schemeClr val="accent1"/>
+          </a:fillRef>
+          <a:effectRef idx="1">
+            <a:schemeClr val="accent1"/>
+          </a:effectRef>
+          <a:fontRef idx="minor">
+            <a:schemeClr val="tx1"/>
+          </a:fontRef>
+        </p:style>
+      </p:cxnSp>
+      <p:sp>
+        <p:nvSpPr>
+          <p:cNvPr id="16" name="TextBox 15"/>
+          <p:cNvSpPr txBox="1"/>
+          <p:nvPr/>
+        </p:nvSpPr>
+        <p:spPr>
+          <a:xfrm>
+            <a:off x="1216152" y="2414016"/>
+            <a:ext cx="402336" cy="182880"/>
+          </a:xfrm>
+          <a:prstGeom prst="rect">
+            <a:avLst/>
+          </a:prstGeom>
+          <a:noFill/>
+        </p:spPr>
+        <p:txBody>
+          <a:bodyPr wrap="square" lIns="0" rIns="0" tIns="0" bIns="0" anchor="t">
+            <a:spAutoFit/>
+          </a:bodyPr>
+          <a:lstStyle/>
+          <a:p>
+            <a:pPr algn="ctr">
+              <a:spcBef>
+                <a:spcPts val="0"/>
+              </a:spcBef>
+              <a:spcAft>
+                <a:spcPts val="0"/>
+              </a:spcAft>
+            </a:pPr>
+            <a:r>
+              <a:rPr sz="800" b="0">
+                <a:solidFill>
+                  <a:srgbClr val="62748A"/>
+                </a:solidFill>
+                <a:latin typeface="Microsoft YaHei"/>
+              </a:rPr>
+              <a:t>0</a:t>
+            </a:r>
+          </a:p>
+        </p:txBody>
+      </p:sp>
+      <p:cxnSp>
+        <p:nvCxnSpPr>
+          <p:cNvPr id="17" name="Connector 16"/>
+          <p:cNvCxnSpPr/>
+          <p:nvPr/>
+        </p:nvCxnSpPr>
+        <p:spPr>
+          <a:xfrm>
+            <a:off x="2891790" y="2633472"/>
+            <a:ext cx="0" cy="2880360"/>
+          </a:xfrm>
+          <a:prstGeom prst="line">
+            <a:avLst/>
+          </a:prstGeom>
+          <a:ln w="6350">
+            <a:solidFill>
+              <a:srgbClr val="D8E1EB"/>
+            </a:solidFill>
+          </a:ln>
+        </p:spPr>
+        <p:style>
+          <a:lnRef idx="2">
+            <a:schemeClr val="accent1"/>
+          </a:lnRef>
+          <a:fillRef idx="0">
+            <a:schemeClr val="accent1"/>
+          </a:fillRef>
+          <a:effectRef idx="1">
+            <a:schemeClr val="accent1"/>
+          </a:effectRef>
+          <a:fontRef idx="minor">
+            <a:schemeClr val="tx1"/>
+          </a:fontRef>
+        </p:style>
+      </p:cxnSp>
+      <p:sp>
+        <p:nvSpPr>
+          <p:cNvPr id="18" name="TextBox 17"/>
+          <p:cNvSpPr txBox="1"/>
+          <p:nvPr/>
+        </p:nvSpPr>
+        <p:spPr>
+          <a:xfrm>
+            <a:off x="2690622" y="2414016"/>
+            <a:ext cx="402336" cy="182880"/>
+          </a:xfrm>
+          <a:prstGeom prst="rect">
+            <a:avLst/>
+          </a:prstGeom>
+          <a:noFill/>
+        </p:spPr>
+        <p:txBody>
+          <a:bodyPr wrap="square" lIns="0" rIns="0" tIns="0" bIns="0" anchor="t">
+            <a:spAutoFit/>
+          </a:bodyPr>
+          <a:lstStyle/>
+          <a:p>
+            <a:pPr algn="ctr">
+              <a:spcBef>
+                <a:spcPts val="0"/>
+              </a:spcBef>
+              <a:spcAft>
+                <a:spcPts val="0"/>
+              </a:spcAft>
+            </a:pPr>
+            <a:r>
+              <a:rPr sz="800" b="0">
+                <a:solidFill>
+                  <a:srgbClr val="62748A"/>
+                </a:solidFill>
+                <a:latin typeface="Microsoft YaHei"/>
+              </a:rPr>
+              <a:t>25</a:t>
+            </a:r>
+          </a:p>
+        </p:txBody>
+      </p:sp>
+      <p:cxnSp>
+        <p:nvCxnSpPr>
+          <p:cNvPr id="19" name="Connector 18"/>
+          <p:cNvCxnSpPr/>
+          <p:nvPr/>
+        </p:nvCxnSpPr>
+        <p:spPr>
+          <a:xfrm>
+            <a:off x="4366260" y="2633472"/>
+            <a:ext cx="0" cy="2880360"/>
+          </a:xfrm>
+          <a:prstGeom prst="line">
+            <a:avLst/>
+          </a:prstGeom>
+          <a:ln w="6350">
+            <a:solidFill>
+              <a:srgbClr val="D8E1EB"/>
+            </a:solidFill>
+          </a:ln>
+        </p:spPr>
+        <p:style>
+          <a:lnRef idx="2">
+            <a:schemeClr val="accent1"/>
+          </a:lnRef>
+          <a:fillRef idx="0">
+            <a:schemeClr val="accent1"/>
+          </a:fillRef>
+          <a:effectRef idx="1">
+            <a:schemeClr val="accent1"/>
+          </a:effectRef>
+          <a:fontRef idx="minor">
+            <a:schemeClr val="tx1"/>
+          </a:fontRef>
+        </p:style>
+      </p:cxnSp>
+      <p:sp>
+        <p:nvSpPr>
+          <p:cNvPr id="20" name="TextBox 19"/>
+          <p:cNvSpPr txBox="1"/>
+          <p:nvPr/>
+        </p:nvSpPr>
+        <p:spPr>
+          <a:xfrm>
+            <a:off x="4165092" y="2414016"/>
+            <a:ext cx="402336" cy="182880"/>
+          </a:xfrm>
+          <a:prstGeom prst="rect">
+            <a:avLst/>
+          </a:prstGeom>
+          <a:noFill/>
+        </p:spPr>
+        <p:txBody>
+          <a:bodyPr wrap="square" lIns="0" rIns="0" tIns="0" bIns="0" anchor="t">
+            <a:spAutoFit/>
+          </a:bodyPr>
+          <a:lstStyle/>
+          <a:p>
+            <a:pPr algn="ctr">
+              <a:spcBef>
+                <a:spcPts val="0"/>
+              </a:spcBef>
+              <a:spcAft>
+                <a:spcPts val="0"/>
+              </a:spcAft>
+            </a:pPr>
+            <a:r>
+              <a:rPr sz="800" b="0">
+                <a:solidFill>
+                  <a:srgbClr val="62748A"/>
+                </a:solidFill>
+                <a:latin typeface="Microsoft YaHei"/>
+              </a:rPr>
+              <a:t>50</a:t>
+            </a:r>
+          </a:p>
+        </p:txBody>
+      </p:sp>
+      <p:cxnSp>
+        <p:nvCxnSpPr>
+          <p:cNvPr id="21" name="Connector 20"/>
+          <p:cNvCxnSpPr/>
+          <p:nvPr/>
+        </p:nvCxnSpPr>
+        <p:spPr>
+          <a:xfrm>
+            <a:off x="5840730" y="2633472"/>
+            <a:ext cx="0" cy="2880360"/>
+          </a:xfrm>
+          <a:prstGeom prst="line">
+            <a:avLst/>
+          </a:prstGeom>
+          <a:ln w="6350">
+            <a:solidFill>
+              <a:srgbClr val="D8E1EB"/>
+            </a:solidFill>
+          </a:ln>
+        </p:spPr>
+        <p:style>
+          <a:lnRef idx="2">
+            <a:schemeClr val="accent1"/>
+          </a:lnRef>
+          <a:fillRef idx="0">
+            <a:schemeClr val="accent1"/>
+          </a:fillRef>
+          <a:effectRef idx="1">
+            <a:schemeClr val="accent1"/>
+          </a:effectRef>
+          <a:fontRef idx="minor">
+            <a:schemeClr val="tx1"/>
+          </a:fontRef>
+        </p:style>
+      </p:cxnSp>
+      <p:sp>
+        <p:nvSpPr>
+          <p:cNvPr id="22" name="TextBox 21"/>
+          <p:cNvSpPr txBox="1"/>
+          <p:nvPr/>
+        </p:nvSpPr>
+        <p:spPr>
+          <a:xfrm>
+            <a:off x="5639562" y="2414016"/>
+            <a:ext cx="402336" cy="182880"/>
+          </a:xfrm>
+          <a:prstGeom prst="rect">
+            <a:avLst/>
+          </a:prstGeom>
+          <a:noFill/>
+        </p:spPr>
+        <p:txBody>
+          <a:bodyPr wrap="square" lIns="0" rIns="0" tIns="0" bIns="0" anchor="t">
+            <a:spAutoFit/>
+          </a:bodyPr>
+          <a:lstStyle/>
+          <a:p>
+            <a:pPr algn="ctr">
+              <a:spcBef>
+                <a:spcPts val="0"/>
+              </a:spcBef>
+              <a:spcAft>
+                <a:spcPts val="0"/>
+              </a:spcAft>
+            </a:pPr>
+            <a:r>
+              <a:rPr sz="800" b="0">
+                <a:solidFill>
+                  <a:srgbClr val="62748A"/>
+                </a:solidFill>
+                <a:latin typeface="Microsoft YaHei"/>
+              </a:rPr>
+              <a:t>75</a:t>
+            </a:r>
+          </a:p>
+        </p:txBody>
+      </p:sp>
+      <p:cxnSp>
+        <p:nvCxnSpPr>
+          <p:cNvPr id="23" name="Connector 22"/>
+          <p:cNvCxnSpPr/>
+          <p:nvPr/>
+        </p:nvCxnSpPr>
+        <p:spPr>
+          <a:xfrm>
+            <a:off x="7315200" y="2633472"/>
+            <a:ext cx="0" cy="2880360"/>
+          </a:xfrm>
+          <a:prstGeom prst="line">
+            <a:avLst/>
+          </a:prstGeom>
+          <a:ln w="6350">
+            <a:solidFill>
+              <a:srgbClr val="D8E1EB"/>
+            </a:solidFill>
+          </a:ln>
+        </p:spPr>
+        <p:style>
+          <a:lnRef idx="2">
+            <a:schemeClr val="accent1"/>
+          </a:lnRef>
+          <a:fillRef idx="0">
+            <a:schemeClr val="accent1"/>
+          </a:fillRef>
+          <a:effectRef idx="1">
+            <a:schemeClr val="accent1"/>
+          </a:effectRef>
+          <a:fontRef idx="minor">
+            <a:schemeClr val="tx1"/>
+          </a:fontRef>
+        </p:style>
+      </p:cxnSp>
+      <p:sp>
+        <p:nvSpPr>
+          <p:cNvPr id="24" name="TextBox 23"/>
+          <p:cNvSpPr txBox="1"/>
+          <p:nvPr/>
+        </p:nvSpPr>
+        <p:spPr>
+          <a:xfrm>
+            <a:off x="7114032" y="2414016"/>
+            <a:ext cx="402336" cy="182880"/>
+          </a:xfrm>
+          <a:prstGeom prst="rect">
+            <a:avLst/>
+          </a:prstGeom>
+          <a:noFill/>
+        </p:spPr>
+        <p:txBody>
+          <a:bodyPr wrap="square" lIns="0" rIns="0" tIns="0" bIns="0" anchor="t">
+            <a:spAutoFit/>
+          </a:bodyPr>
+          <a:lstStyle/>
+          <a:p>
+            <a:pPr algn="ctr">
+              <a:spcBef>
+                <a:spcPts val="0"/>
+              </a:spcBef>
+              <a:spcAft>
+                <a:spcPts val="0"/>
+              </a:spcAft>
+            </a:pPr>
+            <a:r>
+              <a:rPr sz="800" b="0">
+                <a:solidFill>
+                  <a:srgbClr val="62748A"/>
+                </a:solidFill>
+                <a:latin typeface="Microsoft YaHei"/>
+              </a:rPr>
+              <a:t>100</a:t>
+            </a:r>
+          </a:p>
+        </p:txBody>
+      </p:sp>
+      <p:sp>
+        <p:nvSpPr>
+          <p:cNvPr id="25" name="TextBox 24"/>
+          <p:cNvSpPr txBox="1"/>
+          <p:nvPr/>
+        </p:nvSpPr>
+        <p:spPr>
+          <a:xfrm>
+            <a:off x="932688" y="2706624"/>
+            <a:ext cx="384048" cy="219456"/>
+          </a:xfrm>
+          <a:prstGeom prst="rect">
+            <a:avLst/>
+          </a:prstGeom>
+          <a:noFill/>
+        </p:spPr>
+        <p:txBody>
+          <a:bodyPr wrap="square" lIns="0" rIns="0" tIns="0" bIns="0" anchor="ctr">
+            <a:spAutoFit/>
+          </a:bodyPr>
+          <a:lstStyle/>
+          <a:p>
+            <a:pPr algn="l">
+              <a:spcBef>
+                <a:spcPts val="0"/>
+              </a:spcBef>
+              <a:spcAft>
+                <a:spcPts val="0"/>
+              </a:spcAft>
+            </a:pPr>
+            <a:r>
+              <a:rPr sz="850" b="1">
+                <a:solidFill>
+                  <a:srgbClr val="23364A"/>
+                </a:solidFill>
+                <a:latin typeface="Microsoft YaHei"/>
+              </a:rPr>
+              <a:t>M01</a:t>
+            </a:r>
+          </a:p>
+        </p:txBody>
+      </p:sp>
+      <p:sp>
+        <p:nvSpPr>
+          <p:cNvPr id="26" name="Rounded Rectangle 25"/>
+          <p:cNvSpPr/>
+          <p:nvPr/>
+        </p:nvSpPr>
+        <p:spPr>
+          <a:xfrm>
+            <a:off x="1417320" y="2720340"/>
+            <a:ext cx="5308092" cy="77724"/>
+          </a:xfrm>
+          <a:prstGeom prst="roundRect">
+            <a:avLst/>
+          </a:prstGeom>
+          <a:solidFill>
+            <a:srgbClr val="3568A8"/>
+          </a:solidFill>
+          <a:ln>
+            <a:noFill/>
+          </a:ln>
+        </p:spPr>
+        <p:style>
+          <a:lnRef idx="1">
+            <a:schemeClr val="accent1"/>
+          </a:lnRef>
+          <a:fillRef idx="3">
+            <a:schemeClr val="accent1"/>
+          </a:fillRef>
+          <a:effectRef idx="2">
+            <a:schemeClr val="accent1"/>
+          </a:effectRef>
+          <a:fontRef idx="minor">
+            <a:schemeClr val="lt1"/>
+          </a:fontRef>
+        </p:style>
+        <p:txBody>
+          <a:bodyPr rtlCol="0" anchor="ctr"/>
+          <a:lstStyle/>
+          <a:p>
+            <a:pPr algn="ctr"/>
+          </a:p>
+        </p:txBody>
+      </p:sp>
+      <p:sp>
+        <p:nvSpPr>
+          <p:cNvPr id="27" name="TextBox 26"/>
+          <p:cNvSpPr txBox="1"/>
+          <p:nvPr/>
+        </p:nvSpPr>
+        <p:spPr>
+          <a:xfrm>
+            <a:off x="6780275" y="2697480"/>
+            <a:ext cx="438912" cy="128016"/>
+          </a:xfrm>
+          <a:prstGeom prst="rect">
+            <a:avLst/>
+          </a:prstGeom>
+          <a:noFill/>
+        </p:spPr>
+        <p:txBody>
+          <a:bodyPr wrap="square" lIns="0" rIns="0" tIns="0" bIns="0" anchor="ctr">
+            <a:spAutoFit/>
+          </a:bodyPr>
+          <a:lstStyle/>
+          <a:p>
+            <a:pPr algn="l">
+              <a:spcBef>
+                <a:spcPts val="0"/>
+              </a:spcBef>
+              <a:spcAft>
+                <a:spcPts val="0"/>
+              </a:spcAft>
+            </a:pPr>
+            <a:r>
+              <a:rPr sz="750" b="0">
+                <a:solidFill>
+                  <a:srgbClr val="62748A"/>
+                </a:solidFill>
+                <a:latin typeface="Microsoft YaHei"/>
+              </a:rPr>
+              <a:t>90.0</a:t>
+            </a:r>
+          </a:p>
+        </p:txBody>
+      </p:sp>
+      <p:sp>
+        <p:nvSpPr>
+          <p:cNvPr id="28" name="Rounded Rectangle 27"/>
+          <p:cNvSpPr/>
+          <p:nvPr/>
+        </p:nvSpPr>
+        <p:spPr>
+          <a:xfrm>
+            <a:off x="1417320" y="2834640"/>
+            <a:ext cx="5897880" cy="77724"/>
+          </a:xfrm>
+          <a:prstGeom prst="roundRect">
+            <a:avLst/>
+          </a:prstGeom>
+          <a:solidFill>
+            <a:srgbClr val="E38B36"/>
+          </a:solidFill>
+          <a:ln>
+            <a:noFill/>
+          </a:ln>
+        </p:spPr>
+        <p:style>
+          <a:lnRef idx="1">
+            <a:schemeClr val="accent1"/>
+          </a:lnRef>
+          <a:fillRef idx="3">
+            <a:schemeClr val="accent1"/>
+          </a:fillRef>
+          <a:effectRef idx="2">
+            <a:schemeClr val="accent1"/>
+          </a:effectRef>
+          <a:fontRef idx="minor">
+            <a:schemeClr val="lt1"/>
+          </a:fontRef>
+        </p:style>
+        <p:txBody>
+          <a:bodyPr rtlCol="0" anchor="ctr"/>
+          <a:lstStyle/>
+          <a:p>
+            <a:pPr algn="ctr"/>
+          </a:p>
+        </p:txBody>
+      </p:sp>
+      <p:sp>
+        <p:nvSpPr>
+          <p:cNvPr id="29" name="TextBox 28"/>
+          <p:cNvSpPr txBox="1"/>
+          <p:nvPr/>
+        </p:nvSpPr>
+        <p:spPr>
+          <a:xfrm>
+            <a:off x="7370064" y="2811780"/>
+            <a:ext cx="438912" cy="128016"/>
+          </a:xfrm>
+          <a:prstGeom prst="rect">
+            <a:avLst/>
+          </a:prstGeom>
+          <a:noFill/>
+        </p:spPr>
+        <p:txBody>
+          <a:bodyPr wrap="square" lIns="0" rIns="0" tIns="0" bIns="0" anchor="ctr">
+            <a:spAutoFit/>
+          </a:bodyPr>
+          <a:lstStyle/>
+          <a:p>
+            <a:pPr algn="l">
+              <a:spcBef>
+                <a:spcPts val="0"/>
+              </a:spcBef>
+              <a:spcAft>
+                <a:spcPts val="0"/>
+              </a:spcAft>
+            </a:pPr>
+            <a:r>
+              <a:rPr sz="750" b="0">
+                <a:solidFill>
+                  <a:srgbClr val="62748A"/>
+                </a:solidFill>
+                <a:latin typeface="Microsoft YaHei"/>
+              </a:rPr>
+              <a:t>100.0</a:t>
+            </a:r>
+          </a:p>
+        </p:txBody>
+      </p:sp>
+      <p:sp>
+        <p:nvSpPr>
+          <p:cNvPr id="30" name="TextBox 29"/>
+          <p:cNvSpPr txBox="1"/>
+          <p:nvPr/>
+        </p:nvSpPr>
+        <p:spPr>
+          <a:xfrm>
+            <a:off x="932688" y="2990088"/>
+            <a:ext cx="384048" cy="219456"/>
+          </a:xfrm>
+          <a:prstGeom prst="rect">
+            <a:avLst/>
+          </a:prstGeom>
+          <a:noFill/>
+        </p:spPr>
+        <p:txBody>
+          <a:bodyPr wrap="square" lIns="0" rIns="0" tIns="0" bIns="0" anchor="ctr">
+            <a:spAutoFit/>
+          </a:bodyPr>
+          <a:lstStyle/>
+          <a:p>
+            <a:pPr algn="l">
+              <a:spcBef>
+                <a:spcPts val="0"/>
+              </a:spcBef>
+              <a:spcAft>
+                <a:spcPts val="0"/>
+              </a:spcAft>
+            </a:pPr>
+            <a:r>
+              <a:rPr sz="850" b="1">
+                <a:solidFill>
+                  <a:srgbClr val="23364A"/>
+                </a:solidFill>
+                <a:latin typeface="Microsoft YaHei"/>
+              </a:rPr>
+              <a:t>M02</a:t>
+            </a:r>
+          </a:p>
+        </p:txBody>
+      </p:sp>
+      <p:sp>
+        <p:nvSpPr>
+          <p:cNvPr id="31" name="Rounded Rectangle 30"/>
+          <p:cNvSpPr/>
+          <p:nvPr/>
+        </p:nvSpPr>
+        <p:spPr>
+          <a:xfrm>
+            <a:off x="1417320" y="3003804"/>
+            <a:ext cx="5502722" cy="77724"/>
+          </a:xfrm>
+          <a:prstGeom prst="roundRect">
+            <a:avLst/>
+          </a:prstGeom>
+          <a:solidFill>
+            <a:srgbClr val="3568A8"/>
+          </a:solidFill>
+          <a:ln>
+            <a:noFill/>
+          </a:ln>
+        </p:spPr>
+        <p:style>
+          <a:lnRef idx="1">
+            <a:schemeClr val="accent1"/>
+          </a:lnRef>
+          <a:fillRef idx="3">
+            <a:schemeClr val="accent1"/>
+          </a:fillRef>
+          <a:effectRef idx="2">
+            <a:schemeClr val="accent1"/>
+          </a:effectRef>
+          <a:fontRef idx="minor">
+            <a:schemeClr val="lt1"/>
+          </a:fontRef>
+        </p:style>
+        <p:txBody>
+          <a:bodyPr rtlCol="0" anchor="ctr"/>
+          <a:lstStyle/>
+          <a:p>
+            <a:pPr algn="ctr"/>
+          </a:p>
+        </p:txBody>
+      </p:sp>
+      <p:sp>
+        <p:nvSpPr>
+          <p:cNvPr id="32" name="TextBox 31"/>
+          <p:cNvSpPr txBox="1"/>
+          <p:nvPr/>
+        </p:nvSpPr>
+        <p:spPr>
+          <a:xfrm>
+            <a:off x="6974906" y="2980944"/>
+            <a:ext cx="438912" cy="128016"/>
+          </a:xfrm>
+          <a:prstGeom prst="rect">
+            <a:avLst/>
+          </a:prstGeom>
+          <a:noFill/>
+        </p:spPr>
+        <p:txBody>
+          <a:bodyPr wrap="square" lIns="0" rIns="0" tIns="0" bIns="0" anchor="ctr">
+            <a:spAutoFit/>
+          </a:bodyPr>
+          <a:lstStyle/>
+          <a:p>
+            <a:pPr algn="l">
+              <a:spcBef>
+                <a:spcPts val="0"/>
+              </a:spcBef>
+              <a:spcAft>
+                <a:spcPts val="0"/>
+              </a:spcAft>
+            </a:pPr>
+            <a:r>
+              <a:rPr sz="750" b="0">
+                <a:solidFill>
+                  <a:srgbClr val="62748A"/>
+                </a:solidFill>
+                <a:latin typeface="Microsoft YaHei"/>
+              </a:rPr>
+              <a:t>93.3</a:t>
+            </a:r>
+          </a:p>
+        </p:txBody>
+      </p:sp>
+      <p:sp>
+        <p:nvSpPr>
+          <p:cNvPr id="33" name="Rounded Rectangle 32"/>
+          <p:cNvSpPr/>
+          <p:nvPr/>
+        </p:nvSpPr>
+        <p:spPr>
+          <a:xfrm>
+            <a:off x="1417320" y="3118104"/>
+            <a:ext cx="5703249" cy="77724"/>
+          </a:xfrm>
+          <a:prstGeom prst="roundRect">
+            <a:avLst/>
+          </a:prstGeom>
+          <a:solidFill>
+            <a:srgbClr val="E38B36"/>
+          </a:solidFill>
+          <a:ln>
+            <a:noFill/>
+          </a:ln>
+        </p:spPr>
+        <p:style>
+          <a:lnRef idx="1">
+            <a:schemeClr val="accent1"/>
+          </a:lnRef>
+          <a:fillRef idx="3">
+            <a:schemeClr val="accent1"/>
+          </a:fillRef>
+          <a:effectRef idx="2">
+            <a:schemeClr val="accent1"/>
+          </a:effectRef>
+          <a:fontRef idx="minor">
+            <a:schemeClr val="lt1"/>
+          </a:fontRef>
+        </p:style>
+        <p:txBody>
+          <a:bodyPr rtlCol="0" anchor="ctr"/>
+          <a:lstStyle/>
+          <a:p>
+            <a:pPr algn="ctr"/>
+          </a:p>
+        </p:txBody>
+      </p:sp>
+      <p:sp>
+        <p:nvSpPr>
+          <p:cNvPr id="34" name="TextBox 33"/>
+          <p:cNvSpPr txBox="1"/>
+          <p:nvPr/>
+        </p:nvSpPr>
+        <p:spPr>
+          <a:xfrm>
+            <a:off x="7175433" y="3095244"/>
+            <a:ext cx="438912" cy="128016"/>
+          </a:xfrm>
+          <a:prstGeom prst="rect">
+            <a:avLst/>
+          </a:prstGeom>
+          <a:noFill/>
+        </p:spPr>
+        <p:txBody>
+          <a:bodyPr wrap="square" lIns="0" rIns="0" tIns="0" bIns="0" anchor="ctr">
+            <a:spAutoFit/>
+          </a:bodyPr>
+          <a:lstStyle/>
+          <a:p>
+            <a:pPr algn="l">
+              <a:spcBef>
+                <a:spcPts val="0"/>
+              </a:spcBef>
+              <a:spcAft>
+                <a:spcPts val="0"/>
+              </a:spcAft>
+            </a:pPr>
+            <a:r>
+              <a:rPr sz="750" b="0">
+                <a:solidFill>
+                  <a:srgbClr val="62748A"/>
+                </a:solidFill>
+                <a:latin typeface="Microsoft YaHei"/>
+              </a:rPr>
+              <a:t>96.7</a:t>
+            </a:r>
+          </a:p>
+        </p:txBody>
+      </p:sp>
+      <p:sp>
+        <p:nvSpPr>
+          <p:cNvPr id="35" name="TextBox 34"/>
+          <p:cNvSpPr txBox="1"/>
+          <p:nvPr/>
+        </p:nvSpPr>
+        <p:spPr>
+          <a:xfrm>
+            <a:off x="932688" y="3273552"/>
+            <a:ext cx="384048" cy="219456"/>
+          </a:xfrm>
+          <a:prstGeom prst="rect">
+            <a:avLst/>
+          </a:prstGeom>
+          <a:noFill/>
+        </p:spPr>
+        <p:txBody>
+          <a:bodyPr wrap="square" lIns="0" rIns="0" tIns="0" bIns="0" anchor="ctr">
+            <a:spAutoFit/>
+          </a:bodyPr>
+          <a:lstStyle/>
+          <a:p>
+            <a:pPr algn="l">
+              <a:spcBef>
+                <a:spcPts val="0"/>
+              </a:spcBef>
+              <a:spcAft>
+                <a:spcPts val="0"/>
+              </a:spcAft>
+            </a:pPr>
+            <a:r>
+              <a:rPr sz="850" b="1">
+                <a:solidFill>
+                  <a:srgbClr val="23364A"/>
+                </a:solidFill>
+                <a:latin typeface="Microsoft YaHei"/>
+              </a:rPr>
+              <a:t>M03</a:t>
+            </a:r>
+          </a:p>
+        </p:txBody>
+      </p:sp>
+      <p:sp>
+        <p:nvSpPr>
+          <p:cNvPr id="36" name="Rounded Rectangle 35"/>
+          <p:cNvSpPr/>
+          <p:nvPr/>
+        </p:nvSpPr>
+        <p:spPr>
+          <a:xfrm>
+            <a:off x="1417320" y="3287268"/>
+            <a:ext cx="4523673" cy="77724"/>
+          </a:xfrm>
+          <a:prstGeom prst="roundRect">
+            <a:avLst/>
+          </a:prstGeom>
+          <a:solidFill>
+            <a:srgbClr val="3568A8"/>
+          </a:solidFill>
+          <a:ln>
+            <a:noFill/>
+          </a:ln>
+        </p:spPr>
+        <p:style>
+          <a:lnRef idx="1">
+            <a:schemeClr val="accent1"/>
+          </a:lnRef>
+          <a:fillRef idx="3">
+            <a:schemeClr val="accent1"/>
+          </a:fillRef>
+          <a:effectRef idx="2">
+            <a:schemeClr val="accent1"/>
+          </a:effectRef>
+          <a:fontRef idx="minor">
+            <a:schemeClr val="lt1"/>
+          </a:fontRef>
+        </p:style>
+        <p:txBody>
+          <a:bodyPr rtlCol="0" anchor="ctr"/>
+          <a:lstStyle/>
+          <a:p>
+            <a:pPr algn="ctr"/>
+          </a:p>
+        </p:txBody>
+      </p:sp>
+      <p:sp>
+        <p:nvSpPr>
+          <p:cNvPr id="37" name="TextBox 36"/>
+          <p:cNvSpPr txBox="1"/>
+          <p:nvPr/>
+        </p:nvSpPr>
+        <p:spPr>
+          <a:xfrm>
+            <a:off x="5995857" y="3264408"/>
+            <a:ext cx="438912" cy="128016"/>
+          </a:xfrm>
+          <a:prstGeom prst="rect">
+            <a:avLst/>
+          </a:prstGeom>
+          <a:noFill/>
+        </p:spPr>
+        <p:txBody>
+          <a:bodyPr wrap="square" lIns="0" rIns="0" tIns="0" bIns="0" anchor="ctr">
+            <a:spAutoFit/>
+          </a:bodyPr>
+          <a:lstStyle/>
+          <a:p>
+            <a:pPr algn="l">
+              <a:spcBef>
+                <a:spcPts val="0"/>
+              </a:spcBef>
+              <a:spcAft>
+                <a:spcPts val="0"/>
+              </a:spcAft>
+            </a:pPr>
+            <a:r>
+              <a:rPr sz="750" b="0">
+                <a:solidFill>
+                  <a:srgbClr val="62748A"/>
+                </a:solidFill>
+                <a:latin typeface="Microsoft YaHei"/>
+              </a:rPr>
+              <a:t>76.7</a:t>
+            </a:r>
+          </a:p>
+        </p:txBody>
+      </p:sp>
+      <p:sp>
+        <p:nvSpPr>
+          <p:cNvPr id="38" name="Rounded Rectangle 37"/>
+          <p:cNvSpPr/>
+          <p:nvPr/>
+        </p:nvSpPr>
+        <p:spPr>
+          <a:xfrm>
+            <a:off x="1417320" y="3401568"/>
+            <a:ext cx="5703249" cy="77724"/>
+          </a:xfrm>
+          <a:prstGeom prst="roundRect">
+            <a:avLst/>
+          </a:prstGeom>
+          <a:solidFill>
+            <a:srgbClr val="E38B36"/>
+          </a:solidFill>
+          <a:ln>
+            <a:noFill/>
+          </a:ln>
+        </p:spPr>
+        <p:style>
+          <a:lnRef idx="1">
+            <a:schemeClr val="accent1"/>
+          </a:lnRef>
+          <a:fillRef idx="3">
+            <a:schemeClr val="accent1"/>
+          </a:fillRef>
+          <a:effectRef idx="2">
+            <a:schemeClr val="accent1"/>
+          </a:effectRef>
+          <a:fontRef idx="minor">
+            <a:schemeClr val="lt1"/>
+          </a:fontRef>
+        </p:style>
+        <p:txBody>
+          <a:bodyPr rtlCol="0" anchor="ctr"/>
+          <a:lstStyle/>
+          <a:p>
+            <a:pPr algn="ctr"/>
+          </a:p>
+        </p:txBody>
+      </p:sp>
+      <p:sp>
+        <p:nvSpPr>
+          <p:cNvPr id="39" name="TextBox 38"/>
+          <p:cNvSpPr txBox="1"/>
+          <p:nvPr/>
+        </p:nvSpPr>
+        <p:spPr>
+          <a:xfrm>
+            <a:off x="7175433" y="3378708"/>
+            <a:ext cx="438912" cy="128016"/>
+          </a:xfrm>
+          <a:prstGeom prst="rect">
+            <a:avLst/>
+          </a:prstGeom>
+          <a:noFill/>
+        </p:spPr>
+        <p:txBody>
+          <a:bodyPr wrap="square" lIns="0" rIns="0" tIns="0" bIns="0" anchor="ctr">
+            <a:spAutoFit/>
+          </a:bodyPr>
+          <a:lstStyle/>
+          <a:p>
+            <a:pPr algn="l">
+              <a:spcBef>
+                <a:spcPts val="0"/>
+              </a:spcBef>
+              <a:spcAft>
+                <a:spcPts val="0"/>
+              </a:spcAft>
+            </a:pPr>
+            <a:r>
+              <a:rPr sz="750" b="0">
+                <a:solidFill>
+                  <a:srgbClr val="62748A"/>
+                </a:solidFill>
+                <a:latin typeface="Microsoft YaHei"/>
+              </a:rPr>
+              <a:t>96.7</a:t>
+            </a:r>
+          </a:p>
+        </p:txBody>
+      </p:sp>
+      <p:sp>
+        <p:nvSpPr>
+          <p:cNvPr id="40" name="TextBox 39"/>
+          <p:cNvSpPr txBox="1"/>
+          <p:nvPr/>
+        </p:nvSpPr>
+        <p:spPr>
+          <a:xfrm>
+            <a:off x="932688" y="3557015"/>
+            <a:ext cx="384048" cy="219456"/>
+          </a:xfrm>
+          <a:prstGeom prst="rect">
+            <a:avLst/>
+          </a:prstGeom>
+          <a:noFill/>
+        </p:spPr>
+        <p:txBody>
+          <a:bodyPr wrap="square" lIns="0" rIns="0" tIns="0" bIns="0" anchor="ctr">
+            <a:spAutoFit/>
+          </a:bodyPr>
+          <a:lstStyle/>
+          <a:p>
+            <a:pPr algn="l">
+              <a:spcBef>
+                <a:spcPts val="0"/>
+              </a:spcBef>
+              <a:spcAft>
+                <a:spcPts val="0"/>
+              </a:spcAft>
+            </a:pPr>
+            <a:r>
+              <a:rPr sz="850" b="1">
+                <a:solidFill>
+                  <a:srgbClr val="23364A"/>
+                </a:solidFill>
+                <a:latin typeface="Microsoft YaHei"/>
+              </a:rPr>
+              <a:t>M04</a:t>
+            </a:r>
+          </a:p>
+        </p:txBody>
+      </p:sp>
+      <p:sp>
+        <p:nvSpPr>
+          <p:cNvPr id="41" name="Rounded Rectangle 40"/>
+          <p:cNvSpPr/>
+          <p:nvPr/>
+        </p:nvSpPr>
+        <p:spPr>
+          <a:xfrm>
+            <a:off x="1417320" y="3570732"/>
+            <a:ext cx="5308092" cy="77724"/>
+          </a:xfrm>
+          <a:prstGeom prst="roundRect">
+            <a:avLst/>
+          </a:prstGeom>
+          <a:solidFill>
+            <a:srgbClr val="3568A8"/>
+          </a:solidFill>
+          <a:ln>
+            <a:noFill/>
+          </a:ln>
+        </p:spPr>
+        <p:style>
+          <a:lnRef idx="1">
+            <a:schemeClr val="accent1"/>
+          </a:lnRef>
+          <a:fillRef idx="3">
+            <a:schemeClr val="accent1"/>
+          </a:fillRef>
+          <a:effectRef idx="2">
+            <a:schemeClr val="accent1"/>
+          </a:effectRef>
+          <a:fontRef idx="minor">
+            <a:schemeClr val="lt1"/>
+          </a:fontRef>
+        </p:style>
+        <p:txBody>
+          <a:bodyPr rtlCol="0" anchor="ctr"/>
+          <a:lstStyle/>
+          <a:p>
+            <a:pPr algn="ctr"/>
+          </a:p>
+        </p:txBody>
+      </p:sp>
+      <p:sp>
+        <p:nvSpPr>
+          <p:cNvPr id="42" name="TextBox 41"/>
+          <p:cNvSpPr txBox="1"/>
+          <p:nvPr/>
+        </p:nvSpPr>
+        <p:spPr>
+          <a:xfrm>
+            <a:off x="6780275" y="3547872"/>
+            <a:ext cx="438912" cy="128016"/>
+          </a:xfrm>
+          <a:prstGeom prst="rect">
+            <a:avLst/>
+          </a:prstGeom>
+          <a:noFill/>
+        </p:spPr>
+        <p:txBody>
+          <a:bodyPr wrap="square" lIns="0" rIns="0" tIns="0" bIns="0" anchor="ctr">
+            <a:spAutoFit/>
+          </a:bodyPr>
+          <a:lstStyle/>
+          <a:p>
+            <a:pPr algn="l">
+              <a:spcBef>
+                <a:spcPts val="0"/>
+              </a:spcBef>
+              <a:spcAft>
+                <a:spcPts val="0"/>
+              </a:spcAft>
+            </a:pPr>
+            <a:r>
+              <a:rPr sz="750" b="0">
+                <a:solidFill>
+                  <a:srgbClr val="62748A"/>
+                </a:solidFill>
+                <a:latin typeface="Microsoft YaHei"/>
+              </a:rPr>
+              <a:t>90.0</a:t>
+            </a:r>
+          </a:p>
+        </p:txBody>
+      </p:sp>
+      <p:sp>
+        <p:nvSpPr>
+          <p:cNvPr id="43" name="Rounded Rectangle 42"/>
+          <p:cNvSpPr/>
+          <p:nvPr/>
+        </p:nvSpPr>
+        <p:spPr>
+          <a:xfrm>
+            <a:off x="1417320" y="3685031"/>
+            <a:ext cx="5897880" cy="77724"/>
+          </a:xfrm>
+          <a:prstGeom prst="roundRect">
+            <a:avLst/>
+          </a:prstGeom>
+          <a:solidFill>
+            <a:srgbClr val="E38B36"/>
+          </a:solidFill>
+          <a:ln>
+            <a:noFill/>
+          </a:ln>
+        </p:spPr>
+        <p:style>
+          <a:lnRef idx="1">
+            <a:schemeClr val="accent1"/>
+          </a:lnRef>
+          <a:fillRef idx="3">
+            <a:schemeClr val="accent1"/>
+          </a:fillRef>
+          <a:effectRef idx="2">
+            <a:schemeClr val="accent1"/>
+          </a:effectRef>
+          <a:fontRef idx="minor">
+            <a:schemeClr val="lt1"/>
+          </a:fontRef>
+        </p:style>
+        <p:txBody>
+          <a:bodyPr rtlCol="0" anchor="ctr"/>
+          <a:lstStyle/>
+          <a:p>
+            <a:pPr algn="ctr"/>
+          </a:p>
+        </p:txBody>
+      </p:sp>
+      <p:sp>
+        <p:nvSpPr>
+          <p:cNvPr id="44" name="TextBox 43"/>
+          <p:cNvSpPr txBox="1"/>
+          <p:nvPr/>
+        </p:nvSpPr>
+        <p:spPr>
+          <a:xfrm>
+            <a:off x="7370064" y="3662171"/>
+            <a:ext cx="438912" cy="128016"/>
+          </a:xfrm>
+          <a:prstGeom prst="rect">
+            <a:avLst/>
+          </a:prstGeom>
+          <a:noFill/>
+        </p:spPr>
+        <p:txBody>
+          <a:bodyPr wrap="square" lIns="0" rIns="0" tIns="0" bIns="0" anchor="ctr">
+            <a:spAutoFit/>
+          </a:bodyPr>
+          <a:lstStyle/>
+          <a:p>
+            <a:pPr algn="l">
+              <a:spcBef>
+                <a:spcPts val="0"/>
+              </a:spcBef>
+              <a:spcAft>
+                <a:spcPts val="0"/>
+              </a:spcAft>
+            </a:pPr>
+            <a:r>
+              <a:rPr sz="750" b="0">
+                <a:solidFill>
+                  <a:srgbClr val="62748A"/>
+                </a:solidFill>
+                <a:latin typeface="Microsoft YaHei"/>
+              </a:rPr>
+              <a:t>100.0</a:t>
+            </a:r>
+          </a:p>
+        </p:txBody>
+      </p:sp>
+      <p:sp>
+        <p:nvSpPr>
+          <p:cNvPr id="45" name="TextBox 44"/>
+          <p:cNvSpPr txBox="1"/>
+          <p:nvPr/>
+        </p:nvSpPr>
+        <p:spPr>
+          <a:xfrm>
+            <a:off x="932688" y="3840480"/>
+            <a:ext cx="384048" cy="219456"/>
+          </a:xfrm>
+          <a:prstGeom prst="rect">
+            <a:avLst/>
+          </a:prstGeom>
+          <a:noFill/>
+        </p:spPr>
+        <p:txBody>
+          <a:bodyPr wrap="square" lIns="0" rIns="0" tIns="0" bIns="0" anchor="ctr">
+            <a:spAutoFit/>
+          </a:bodyPr>
+          <a:lstStyle/>
+          <a:p>
+            <a:pPr algn="l">
+              <a:spcBef>
+                <a:spcPts val="0"/>
+              </a:spcBef>
+              <a:spcAft>
+                <a:spcPts val="0"/>
+              </a:spcAft>
+            </a:pPr>
+            <a:r>
+              <a:rPr sz="850" b="1">
+                <a:solidFill>
+                  <a:srgbClr val="23364A"/>
+                </a:solidFill>
+                <a:latin typeface="Microsoft YaHei"/>
+              </a:rPr>
+              <a:t>M05</a:t>
+            </a:r>
+          </a:p>
+        </p:txBody>
+      </p:sp>
+      <p:sp>
+        <p:nvSpPr>
+          <p:cNvPr id="46" name="Rounded Rectangle 45"/>
+          <p:cNvSpPr/>
+          <p:nvPr/>
+        </p:nvSpPr>
+        <p:spPr>
+          <a:xfrm>
+            <a:off x="1417320" y="3854196"/>
+            <a:ext cx="5502722" cy="77724"/>
+          </a:xfrm>
+          <a:prstGeom prst="roundRect">
+            <a:avLst/>
+          </a:prstGeom>
+          <a:solidFill>
+            <a:srgbClr val="3568A8"/>
+          </a:solidFill>
+          <a:ln>
+            <a:noFill/>
+          </a:ln>
+        </p:spPr>
+        <p:style>
+          <a:lnRef idx="1">
+            <a:schemeClr val="accent1"/>
+          </a:lnRef>
+          <a:fillRef idx="3">
+            <a:schemeClr val="accent1"/>
+          </a:fillRef>
+          <a:effectRef idx="2">
+            <a:schemeClr val="accent1"/>
+          </a:effectRef>
+          <a:fontRef idx="minor">
+            <a:schemeClr val="lt1"/>
+          </a:fontRef>
+        </p:style>
+        <p:txBody>
+          <a:bodyPr rtlCol="0" anchor="ctr"/>
+          <a:lstStyle/>
+          <a:p>
+            <a:pPr algn="ctr"/>
+          </a:p>
+        </p:txBody>
+      </p:sp>
+      <p:sp>
+        <p:nvSpPr>
+          <p:cNvPr id="47" name="TextBox 46"/>
+          <p:cNvSpPr txBox="1"/>
+          <p:nvPr/>
+        </p:nvSpPr>
+        <p:spPr>
+          <a:xfrm>
+            <a:off x="6974906" y="3831336"/>
+            <a:ext cx="438912" cy="128016"/>
+          </a:xfrm>
+          <a:prstGeom prst="rect">
+            <a:avLst/>
+          </a:prstGeom>
+          <a:noFill/>
+        </p:spPr>
+        <p:txBody>
+          <a:bodyPr wrap="square" lIns="0" rIns="0" tIns="0" bIns="0" anchor="ctr">
+            <a:spAutoFit/>
+          </a:bodyPr>
+          <a:lstStyle/>
+          <a:p>
+            <a:pPr algn="l">
+              <a:spcBef>
+                <a:spcPts val="0"/>
+              </a:spcBef>
+              <a:spcAft>
+                <a:spcPts val="0"/>
+              </a:spcAft>
+            </a:pPr>
+            <a:r>
+              <a:rPr sz="750" b="0">
+                <a:solidFill>
+                  <a:srgbClr val="62748A"/>
+                </a:solidFill>
+                <a:latin typeface="Microsoft YaHei"/>
+              </a:rPr>
+              <a:t>93.3</a:t>
+            </a:r>
+          </a:p>
+        </p:txBody>
+      </p:sp>
+      <p:sp>
+        <p:nvSpPr>
+          <p:cNvPr id="48" name="Rounded Rectangle 47"/>
+          <p:cNvSpPr/>
+          <p:nvPr/>
+        </p:nvSpPr>
+        <p:spPr>
+          <a:xfrm>
+            <a:off x="1417320" y="3968496"/>
+            <a:ext cx="5897880" cy="77724"/>
+          </a:xfrm>
+          <a:prstGeom prst="roundRect">
+            <a:avLst/>
+          </a:prstGeom>
+          <a:solidFill>
+            <a:srgbClr val="E38B36"/>
+          </a:solidFill>
+          <a:ln>
+            <a:noFill/>
+          </a:ln>
+        </p:spPr>
+        <p:style>
+          <a:lnRef idx="1">
+            <a:schemeClr val="accent1"/>
+          </a:lnRef>
+          <a:fillRef idx="3">
+            <a:schemeClr val="accent1"/>
+          </a:fillRef>
+          <a:effectRef idx="2">
+            <a:schemeClr val="accent1"/>
+          </a:effectRef>
+          <a:fontRef idx="minor">
+            <a:schemeClr val="lt1"/>
+          </a:fontRef>
+        </p:style>
+        <p:txBody>
+          <a:bodyPr rtlCol="0" anchor="ctr"/>
+          <a:lstStyle/>
+          <a:p>
+            <a:pPr algn="ctr"/>
+          </a:p>
+        </p:txBody>
+      </p:sp>
+      <p:sp>
+        <p:nvSpPr>
+          <p:cNvPr id="49" name="TextBox 48"/>
+          <p:cNvSpPr txBox="1"/>
+          <p:nvPr/>
+        </p:nvSpPr>
+        <p:spPr>
+          <a:xfrm>
+            <a:off x="7370064" y="3945636"/>
+            <a:ext cx="438912" cy="128016"/>
+          </a:xfrm>
+          <a:prstGeom prst="rect">
+            <a:avLst/>
+          </a:prstGeom>
+          <a:noFill/>
+        </p:spPr>
+        <p:txBody>
+          <a:bodyPr wrap="square" lIns="0" rIns="0" tIns="0" bIns="0" anchor="ctr">
+            <a:spAutoFit/>
+          </a:bodyPr>
+          <a:lstStyle/>
+          <a:p>
+            <a:pPr algn="l">
+              <a:spcBef>
+                <a:spcPts val="0"/>
+              </a:spcBef>
+              <a:spcAft>
+                <a:spcPts val="0"/>
+              </a:spcAft>
+            </a:pPr>
+            <a:r>
+              <a:rPr sz="750" b="0">
+                <a:solidFill>
+                  <a:srgbClr val="62748A"/>
+                </a:solidFill>
+                <a:latin typeface="Microsoft YaHei"/>
+              </a:rPr>
+              <a:t>100.0</a:t>
+            </a:r>
+          </a:p>
+        </p:txBody>
+      </p:sp>
+      <p:sp>
+        <p:nvSpPr>
+          <p:cNvPr id="50" name="TextBox 49"/>
+          <p:cNvSpPr txBox="1"/>
+          <p:nvPr/>
+        </p:nvSpPr>
+        <p:spPr>
+          <a:xfrm>
+            <a:off x="932688" y="4123944"/>
+            <a:ext cx="384048" cy="219456"/>
+          </a:xfrm>
+          <a:prstGeom prst="rect">
+            <a:avLst/>
+          </a:prstGeom>
+          <a:noFill/>
+        </p:spPr>
+        <p:txBody>
+          <a:bodyPr wrap="square" lIns="0" rIns="0" tIns="0" bIns="0" anchor="ctr">
+            <a:spAutoFit/>
+          </a:bodyPr>
+          <a:lstStyle/>
+          <a:p>
+            <a:pPr algn="l">
+              <a:spcBef>
+                <a:spcPts val="0"/>
+              </a:spcBef>
+              <a:spcAft>
+                <a:spcPts val="0"/>
+              </a:spcAft>
+            </a:pPr>
+            <a:r>
+              <a:rPr sz="850" b="1">
+                <a:solidFill>
+                  <a:srgbClr val="23364A"/>
+                </a:solidFill>
+                <a:latin typeface="Microsoft YaHei"/>
+              </a:rPr>
+              <a:t>M06</a:t>
+            </a:r>
+          </a:p>
+        </p:txBody>
+      </p:sp>
+      <p:sp>
+        <p:nvSpPr>
+          <p:cNvPr id="51" name="Rounded Rectangle 50"/>
+          <p:cNvSpPr/>
+          <p:nvPr/>
+        </p:nvSpPr>
+        <p:spPr>
+          <a:xfrm>
+            <a:off x="1417320" y="4137660"/>
+            <a:ext cx="5113461" cy="77724"/>
+          </a:xfrm>
+          <a:prstGeom prst="roundRect">
+            <a:avLst/>
+          </a:prstGeom>
+          <a:solidFill>
+            <a:srgbClr val="3568A8"/>
+          </a:solidFill>
+          <a:ln>
+            <a:noFill/>
+          </a:ln>
+        </p:spPr>
+        <p:style>
+          <a:lnRef idx="1">
+            <a:schemeClr val="accent1"/>
+          </a:lnRef>
+          <a:fillRef idx="3">
+            <a:schemeClr val="accent1"/>
+          </a:fillRef>
+          <a:effectRef idx="2">
+            <a:schemeClr val="accent1"/>
+          </a:effectRef>
+          <a:fontRef idx="minor">
+            <a:schemeClr val="lt1"/>
+          </a:fontRef>
+        </p:style>
+        <p:txBody>
+          <a:bodyPr rtlCol="0" anchor="ctr"/>
+          <a:lstStyle/>
+          <a:p>
+            <a:pPr algn="ctr"/>
+          </a:p>
+        </p:txBody>
+      </p:sp>
+      <p:sp>
+        <p:nvSpPr>
+          <p:cNvPr id="52" name="TextBox 51"/>
+          <p:cNvSpPr txBox="1"/>
+          <p:nvPr/>
+        </p:nvSpPr>
+        <p:spPr>
+          <a:xfrm>
+            <a:off x="6585645" y="4114800"/>
+            <a:ext cx="438912" cy="128016"/>
+          </a:xfrm>
+          <a:prstGeom prst="rect">
+            <a:avLst/>
+          </a:prstGeom>
+          <a:noFill/>
+        </p:spPr>
+        <p:txBody>
+          <a:bodyPr wrap="square" lIns="0" rIns="0" tIns="0" bIns="0" anchor="ctr">
+            <a:spAutoFit/>
+          </a:bodyPr>
+          <a:lstStyle/>
+          <a:p>
+            <a:pPr algn="l">
+              <a:spcBef>
+                <a:spcPts val="0"/>
+              </a:spcBef>
+              <a:spcAft>
+                <a:spcPts val="0"/>
+              </a:spcAft>
+            </a:pPr>
+            <a:r>
+              <a:rPr sz="750" b="0">
+                <a:solidFill>
+                  <a:srgbClr val="62748A"/>
+                </a:solidFill>
+                <a:latin typeface="Microsoft YaHei"/>
+              </a:rPr>
+              <a:t>86.7</a:t>
+            </a:r>
+          </a:p>
+        </p:txBody>
+      </p:sp>
+      <p:sp>
+        <p:nvSpPr>
+          <p:cNvPr id="53" name="Rounded Rectangle 52"/>
+          <p:cNvSpPr/>
+          <p:nvPr/>
+        </p:nvSpPr>
+        <p:spPr>
+          <a:xfrm>
+            <a:off x="1417320" y="4251960"/>
+            <a:ext cx="5703249" cy="77724"/>
+          </a:xfrm>
+          <a:prstGeom prst="roundRect">
+            <a:avLst/>
+          </a:prstGeom>
+          <a:solidFill>
+            <a:srgbClr val="E38B36"/>
+          </a:solidFill>
+          <a:ln>
+            <a:noFill/>
+          </a:ln>
+        </p:spPr>
+        <p:style>
+          <a:lnRef idx="1">
+            <a:schemeClr val="accent1"/>
+          </a:lnRef>
+          <a:fillRef idx="3">
+            <a:schemeClr val="accent1"/>
+          </a:fillRef>
+          <a:effectRef idx="2">
+            <a:schemeClr val="accent1"/>
+          </a:effectRef>
+          <a:fontRef idx="minor">
+            <a:schemeClr val="lt1"/>
+          </a:fontRef>
+        </p:style>
+        <p:txBody>
+          <a:bodyPr rtlCol="0" anchor="ctr"/>
+          <a:lstStyle/>
+          <a:p>
+            <a:pPr algn="ctr"/>
+          </a:p>
+        </p:txBody>
+      </p:sp>
+      <p:sp>
+        <p:nvSpPr>
+          <p:cNvPr id="54" name="TextBox 53"/>
+          <p:cNvSpPr txBox="1"/>
+          <p:nvPr/>
+        </p:nvSpPr>
+        <p:spPr>
+          <a:xfrm>
+            <a:off x="7175433" y="4229100"/>
+            <a:ext cx="438912" cy="128016"/>
+          </a:xfrm>
+          <a:prstGeom prst="rect">
+            <a:avLst/>
+          </a:prstGeom>
+          <a:noFill/>
+        </p:spPr>
+        <p:txBody>
+          <a:bodyPr wrap="square" lIns="0" rIns="0" tIns="0" bIns="0" anchor="ctr">
+            <a:spAutoFit/>
+          </a:bodyPr>
+          <a:lstStyle/>
+          <a:p>
+            <a:pPr algn="l">
+              <a:spcBef>
+                <a:spcPts val="0"/>
+              </a:spcBef>
+              <a:spcAft>
+                <a:spcPts val="0"/>
+              </a:spcAft>
+            </a:pPr>
+            <a:r>
+              <a:rPr sz="750" b="0">
+                <a:solidFill>
+                  <a:srgbClr val="62748A"/>
+                </a:solidFill>
+                <a:latin typeface="Microsoft YaHei"/>
+              </a:rPr>
+              <a:t>96.7</a:t>
+            </a:r>
+          </a:p>
+        </p:txBody>
+      </p:sp>
+      <p:sp>
+        <p:nvSpPr>
+          <p:cNvPr id="55" name="TextBox 54"/>
+          <p:cNvSpPr txBox="1"/>
+          <p:nvPr/>
+        </p:nvSpPr>
+        <p:spPr>
+          <a:xfrm>
+            <a:off x="932688" y="4407408"/>
+            <a:ext cx="384048" cy="219456"/>
+          </a:xfrm>
+          <a:prstGeom prst="rect">
+            <a:avLst/>
+          </a:prstGeom>
+          <a:noFill/>
+        </p:spPr>
+        <p:txBody>
+          <a:bodyPr wrap="square" lIns="0" rIns="0" tIns="0" bIns="0" anchor="ctr">
+            <a:spAutoFit/>
+          </a:bodyPr>
+          <a:lstStyle/>
+          <a:p>
+            <a:pPr algn="l">
+              <a:spcBef>
+                <a:spcPts val="0"/>
+              </a:spcBef>
+              <a:spcAft>
+                <a:spcPts val="0"/>
+              </a:spcAft>
+            </a:pPr>
+            <a:r>
+              <a:rPr sz="850" b="1">
+                <a:solidFill>
+                  <a:srgbClr val="23364A"/>
+                </a:solidFill>
+                <a:latin typeface="Microsoft YaHei"/>
+              </a:rPr>
+              <a:t>M07</a:t>
+            </a:r>
+          </a:p>
+        </p:txBody>
+      </p:sp>
+      <p:sp>
+        <p:nvSpPr>
+          <p:cNvPr id="56" name="Rounded Rectangle 55"/>
+          <p:cNvSpPr/>
+          <p:nvPr/>
+        </p:nvSpPr>
+        <p:spPr>
+          <a:xfrm>
+            <a:off x="1417320" y="4421124"/>
+            <a:ext cx="5502722" cy="77724"/>
+          </a:xfrm>
+          <a:prstGeom prst="roundRect">
+            <a:avLst/>
+          </a:prstGeom>
+          <a:solidFill>
+            <a:srgbClr val="3568A8"/>
+          </a:solidFill>
+          <a:ln>
+            <a:noFill/>
+          </a:ln>
+        </p:spPr>
+        <p:style>
+          <a:lnRef idx="1">
+            <a:schemeClr val="accent1"/>
+          </a:lnRef>
+          <a:fillRef idx="3">
+            <a:schemeClr val="accent1"/>
+          </a:fillRef>
+          <a:effectRef idx="2">
+            <a:schemeClr val="accent1"/>
+          </a:effectRef>
+          <a:fontRef idx="minor">
+            <a:schemeClr val="lt1"/>
+          </a:fontRef>
+        </p:style>
+        <p:txBody>
+          <a:bodyPr rtlCol="0" anchor="ctr"/>
+          <a:lstStyle/>
+          <a:p>
+            <a:pPr algn="ctr"/>
+          </a:p>
+        </p:txBody>
+      </p:sp>
+      <p:sp>
+        <p:nvSpPr>
+          <p:cNvPr id="57" name="TextBox 56"/>
+          <p:cNvSpPr txBox="1"/>
+          <p:nvPr/>
+        </p:nvSpPr>
+        <p:spPr>
+          <a:xfrm>
+            <a:off x="6974906" y="4398264"/>
+            <a:ext cx="438912" cy="128016"/>
+          </a:xfrm>
+          <a:prstGeom prst="rect">
+            <a:avLst/>
+          </a:prstGeom>
+          <a:noFill/>
+        </p:spPr>
+        <p:txBody>
+          <a:bodyPr wrap="square" lIns="0" rIns="0" tIns="0" bIns="0" anchor="ctr">
+            <a:spAutoFit/>
+          </a:bodyPr>
+          <a:lstStyle/>
+          <a:p>
+            <a:pPr algn="l">
+              <a:spcBef>
+                <a:spcPts val="0"/>
+              </a:spcBef>
+              <a:spcAft>
+                <a:spcPts val="0"/>
+              </a:spcAft>
+            </a:pPr>
+            <a:r>
+              <a:rPr sz="750" b="0">
+                <a:solidFill>
+                  <a:srgbClr val="62748A"/>
+                </a:solidFill>
+                <a:latin typeface="Microsoft YaHei"/>
+              </a:rPr>
+              <a:t>93.3</a:t>
+            </a:r>
+          </a:p>
+        </p:txBody>
+      </p:sp>
+      <p:sp>
+        <p:nvSpPr>
+          <p:cNvPr id="58" name="Rounded Rectangle 57"/>
+          <p:cNvSpPr/>
+          <p:nvPr/>
+        </p:nvSpPr>
+        <p:spPr>
+          <a:xfrm>
+            <a:off x="1417320" y="4535424"/>
+            <a:ext cx="5897880" cy="77724"/>
+          </a:xfrm>
+          <a:prstGeom prst="roundRect">
+            <a:avLst/>
+          </a:prstGeom>
+          <a:solidFill>
+            <a:srgbClr val="E38B36"/>
+          </a:solidFill>
+          <a:ln>
+            <a:noFill/>
+          </a:ln>
+        </p:spPr>
+        <p:style>
+          <a:lnRef idx="1">
+            <a:schemeClr val="accent1"/>
+          </a:lnRef>
+          <a:fillRef idx="3">
+            <a:schemeClr val="accent1"/>
+          </a:fillRef>
+          <a:effectRef idx="2">
+            <a:schemeClr val="accent1"/>
+          </a:effectRef>
+          <a:fontRef idx="minor">
+            <a:schemeClr val="lt1"/>
+          </a:fontRef>
+        </p:style>
+        <p:txBody>
+          <a:bodyPr rtlCol="0" anchor="ctr"/>
+          <a:lstStyle/>
+          <a:p>
+            <a:pPr algn="ctr"/>
+          </a:p>
+        </p:txBody>
+      </p:sp>
+      <p:sp>
+        <p:nvSpPr>
+          <p:cNvPr id="59" name="TextBox 58"/>
+          <p:cNvSpPr txBox="1"/>
+          <p:nvPr/>
+        </p:nvSpPr>
+        <p:spPr>
+          <a:xfrm>
+            <a:off x="7370064" y="4512564"/>
+            <a:ext cx="438912" cy="128016"/>
+          </a:xfrm>
+          <a:prstGeom prst="rect">
+            <a:avLst/>
+          </a:prstGeom>
+          <a:noFill/>
+        </p:spPr>
+        <p:txBody>
+          <a:bodyPr wrap="square" lIns="0" rIns="0" tIns="0" bIns="0" anchor="ctr">
+            <a:spAutoFit/>
+          </a:bodyPr>
+          <a:lstStyle/>
+          <a:p>
+            <a:pPr algn="l">
+              <a:spcBef>
+                <a:spcPts val="0"/>
+              </a:spcBef>
+              <a:spcAft>
+                <a:spcPts val="0"/>
+              </a:spcAft>
+            </a:pPr>
+            <a:r>
+              <a:rPr sz="750" b="0">
+                <a:solidFill>
+                  <a:srgbClr val="62748A"/>
+                </a:solidFill>
+                <a:latin typeface="Microsoft YaHei"/>
+              </a:rPr>
+              <a:t>100.0</a:t>
+            </a:r>
+          </a:p>
+        </p:txBody>
+      </p:sp>
+      <p:sp>
+        <p:nvSpPr>
+          <p:cNvPr id="60" name="TextBox 59"/>
+          <p:cNvSpPr txBox="1"/>
+          <p:nvPr/>
+        </p:nvSpPr>
+        <p:spPr>
+          <a:xfrm>
+            <a:off x="932688" y="4690872"/>
+            <a:ext cx="384048" cy="219456"/>
+          </a:xfrm>
+          <a:prstGeom prst="rect">
+            <a:avLst/>
+          </a:prstGeom>
+          <a:noFill/>
+        </p:spPr>
+        <p:txBody>
+          <a:bodyPr wrap="square" lIns="0" rIns="0" tIns="0" bIns="0" anchor="ctr">
+            <a:spAutoFit/>
+          </a:bodyPr>
+          <a:lstStyle/>
+          <a:p>
+            <a:pPr algn="l">
+              <a:spcBef>
+                <a:spcPts val="0"/>
+              </a:spcBef>
+              <a:spcAft>
+                <a:spcPts val="0"/>
+              </a:spcAft>
+            </a:pPr>
+            <a:r>
+              <a:rPr sz="850" b="1">
+                <a:solidFill>
+                  <a:srgbClr val="23364A"/>
+                </a:solidFill>
+                <a:latin typeface="Microsoft YaHei"/>
+              </a:rPr>
+              <a:t>M08</a:t>
+            </a:r>
+          </a:p>
+        </p:txBody>
+      </p:sp>
+      <p:sp>
+        <p:nvSpPr>
+          <p:cNvPr id="61" name="Rounded Rectangle 60"/>
+          <p:cNvSpPr/>
+          <p:nvPr/>
+        </p:nvSpPr>
+        <p:spPr>
+          <a:xfrm>
+            <a:off x="1417320" y="4704588"/>
+            <a:ext cx="3344097" cy="77724"/>
+          </a:xfrm>
+          <a:prstGeom prst="roundRect">
+            <a:avLst/>
+          </a:prstGeom>
+          <a:solidFill>
+            <a:srgbClr val="3568A8"/>
+          </a:solidFill>
+          <a:ln>
+            <a:noFill/>
+          </a:ln>
+        </p:spPr>
+        <p:style>
+          <a:lnRef idx="1">
+            <a:schemeClr val="accent1"/>
+          </a:lnRef>
+          <a:fillRef idx="3">
+            <a:schemeClr val="accent1"/>
+          </a:fillRef>
+          <a:effectRef idx="2">
+            <a:schemeClr val="accent1"/>
+          </a:effectRef>
+          <a:fontRef idx="minor">
+            <a:schemeClr val="lt1"/>
+          </a:fontRef>
+        </p:style>
+        <p:txBody>
+          <a:bodyPr rtlCol="0" anchor="ctr"/>
+          <a:lstStyle/>
+          <a:p>
+            <a:pPr algn="ctr"/>
+          </a:p>
+        </p:txBody>
+      </p:sp>
+      <p:sp>
+        <p:nvSpPr>
+          <p:cNvPr id="62" name="TextBox 61"/>
+          <p:cNvSpPr txBox="1"/>
+          <p:nvPr/>
+        </p:nvSpPr>
+        <p:spPr>
+          <a:xfrm>
+            <a:off x="4816281" y="4681728"/>
+            <a:ext cx="438912" cy="128016"/>
+          </a:xfrm>
+          <a:prstGeom prst="rect">
+            <a:avLst/>
+          </a:prstGeom>
+          <a:noFill/>
+        </p:spPr>
+        <p:txBody>
+          <a:bodyPr wrap="square" lIns="0" rIns="0" tIns="0" bIns="0" anchor="ctr">
+            <a:spAutoFit/>
+          </a:bodyPr>
+          <a:lstStyle/>
+          <a:p>
+            <a:pPr algn="l">
+              <a:spcBef>
+                <a:spcPts val="0"/>
+              </a:spcBef>
+              <a:spcAft>
+                <a:spcPts val="0"/>
+              </a:spcAft>
+            </a:pPr>
+            <a:r>
+              <a:rPr sz="750" b="0">
+                <a:solidFill>
+                  <a:srgbClr val="62748A"/>
+                </a:solidFill>
+                <a:latin typeface="Microsoft YaHei"/>
+              </a:rPr>
+              <a:t>56.7</a:t>
+            </a:r>
+          </a:p>
+        </p:txBody>
+      </p:sp>
+      <p:sp>
+        <p:nvSpPr>
+          <p:cNvPr id="63" name="Rounded Rectangle 62"/>
+          <p:cNvSpPr/>
+          <p:nvPr/>
+        </p:nvSpPr>
+        <p:spPr>
+          <a:xfrm>
+            <a:off x="1417320" y="4818888"/>
+            <a:ext cx="5502722" cy="77724"/>
+          </a:xfrm>
+          <a:prstGeom prst="roundRect">
+            <a:avLst/>
+          </a:prstGeom>
+          <a:solidFill>
+            <a:srgbClr val="E38B36"/>
+          </a:solidFill>
+          <a:ln>
+            <a:noFill/>
+          </a:ln>
+        </p:spPr>
+        <p:style>
+          <a:lnRef idx="1">
+            <a:schemeClr val="accent1"/>
+          </a:lnRef>
+          <a:fillRef idx="3">
+            <a:schemeClr val="accent1"/>
+          </a:fillRef>
+          <a:effectRef idx="2">
+            <a:schemeClr val="accent1"/>
+          </a:effectRef>
+          <a:fontRef idx="minor">
+            <a:schemeClr val="lt1"/>
+          </a:fontRef>
+        </p:style>
+        <p:txBody>
+          <a:bodyPr rtlCol="0" anchor="ctr"/>
+          <a:lstStyle/>
+          <a:p>
+            <a:pPr algn="ctr"/>
+          </a:p>
+        </p:txBody>
+      </p:sp>
+      <p:sp>
+        <p:nvSpPr>
+          <p:cNvPr id="64" name="TextBox 63"/>
+          <p:cNvSpPr txBox="1"/>
+          <p:nvPr/>
+        </p:nvSpPr>
+        <p:spPr>
+          <a:xfrm>
+            <a:off x="6974906" y="4796028"/>
+            <a:ext cx="438912" cy="128016"/>
+          </a:xfrm>
+          <a:prstGeom prst="rect">
+            <a:avLst/>
+          </a:prstGeom>
+          <a:noFill/>
+        </p:spPr>
+        <p:txBody>
+          <a:bodyPr wrap="square" lIns="0" rIns="0" tIns="0" bIns="0" anchor="ctr">
+            <a:spAutoFit/>
+          </a:bodyPr>
+          <a:lstStyle/>
+          <a:p>
+            <a:pPr algn="l">
+              <a:spcBef>
+                <a:spcPts val="0"/>
+              </a:spcBef>
+              <a:spcAft>
+                <a:spcPts val="0"/>
+              </a:spcAft>
+            </a:pPr>
+            <a:r>
+              <a:rPr sz="750" b="0">
+                <a:solidFill>
+                  <a:srgbClr val="62748A"/>
+                </a:solidFill>
+                <a:latin typeface="Microsoft YaHei"/>
+              </a:rPr>
+              <a:t>93.3</a:t>
+            </a:r>
+          </a:p>
+        </p:txBody>
+      </p:sp>
+      <p:sp>
+        <p:nvSpPr>
+          <p:cNvPr id="65" name="TextBox 64"/>
+          <p:cNvSpPr txBox="1"/>
+          <p:nvPr/>
+        </p:nvSpPr>
+        <p:spPr>
+          <a:xfrm>
+            <a:off x="932688" y="4974336"/>
+            <a:ext cx="384048" cy="219456"/>
+          </a:xfrm>
+          <a:prstGeom prst="rect">
+            <a:avLst/>
+          </a:prstGeom>
+          <a:noFill/>
+        </p:spPr>
+        <p:txBody>
+          <a:bodyPr wrap="square" lIns="0" rIns="0" tIns="0" bIns="0" anchor="ctr">
+            <a:spAutoFit/>
+          </a:bodyPr>
+          <a:lstStyle/>
+          <a:p>
+            <a:pPr algn="l">
+              <a:spcBef>
+                <a:spcPts val="0"/>
+              </a:spcBef>
+              <a:spcAft>
+                <a:spcPts val="0"/>
+              </a:spcAft>
+            </a:pPr>
+            <a:r>
+              <a:rPr sz="850" b="1">
+                <a:solidFill>
+                  <a:srgbClr val="23364A"/>
+                </a:solidFill>
+                <a:latin typeface="Microsoft YaHei"/>
+              </a:rPr>
+              <a:t>M09</a:t>
+            </a:r>
+          </a:p>
+        </p:txBody>
+      </p:sp>
+      <p:sp>
+        <p:nvSpPr>
+          <p:cNvPr id="66" name="Rounded Rectangle 65"/>
+          <p:cNvSpPr/>
+          <p:nvPr/>
+        </p:nvSpPr>
+        <p:spPr>
+          <a:xfrm>
+            <a:off x="1417320" y="4988052"/>
+            <a:ext cx="1769364" cy="77724"/>
+          </a:xfrm>
+          <a:prstGeom prst="roundRect">
+            <a:avLst/>
+          </a:prstGeom>
+          <a:solidFill>
+            <a:srgbClr val="3568A8"/>
+          </a:solidFill>
+          <a:ln>
+            <a:noFill/>
+          </a:ln>
+        </p:spPr>
+        <p:style>
+          <a:lnRef idx="1">
+            <a:schemeClr val="accent1"/>
+          </a:lnRef>
+          <a:fillRef idx="3">
+            <a:schemeClr val="accent1"/>
+          </a:fillRef>
+          <a:effectRef idx="2">
+            <a:schemeClr val="accent1"/>
+          </a:effectRef>
+          <a:fontRef idx="minor">
+            <a:schemeClr val="lt1"/>
+          </a:fontRef>
+        </p:style>
+        <p:txBody>
+          <a:bodyPr rtlCol="0" anchor="ctr"/>
+          <a:lstStyle/>
+          <a:p>
+            <a:pPr algn="ctr"/>
+          </a:p>
+        </p:txBody>
+      </p:sp>
+      <p:sp>
+        <p:nvSpPr>
+          <p:cNvPr id="67" name="TextBox 66"/>
+          <p:cNvSpPr txBox="1"/>
+          <p:nvPr/>
+        </p:nvSpPr>
+        <p:spPr>
+          <a:xfrm>
+            <a:off x="3241548" y="4965192"/>
+            <a:ext cx="438912" cy="128016"/>
+          </a:xfrm>
+          <a:prstGeom prst="rect">
+            <a:avLst/>
+          </a:prstGeom>
+          <a:noFill/>
+        </p:spPr>
+        <p:txBody>
+          <a:bodyPr wrap="square" lIns="0" rIns="0" tIns="0" bIns="0" anchor="ctr">
+            <a:spAutoFit/>
+          </a:bodyPr>
+          <a:lstStyle/>
+          <a:p>
+            <a:pPr algn="l">
+              <a:spcBef>
+                <a:spcPts val="0"/>
+              </a:spcBef>
+              <a:spcAft>
+                <a:spcPts val="0"/>
+              </a:spcAft>
+            </a:pPr>
+            <a:r>
+              <a:rPr sz="750" b="0">
+                <a:solidFill>
+                  <a:srgbClr val="62748A"/>
+                </a:solidFill>
+                <a:latin typeface="Microsoft YaHei"/>
+              </a:rPr>
+              <a:t>30.0</a:t>
+            </a:r>
+          </a:p>
+        </p:txBody>
+      </p:sp>
+      <p:sp>
+        <p:nvSpPr>
+          <p:cNvPr id="68" name="Rounded Rectangle 67"/>
+          <p:cNvSpPr/>
+          <p:nvPr/>
+        </p:nvSpPr>
+        <p:spPr>
+          <a:xfrm>
+            <a:off x="1417320" y="5102352"/>
+            <a:ext cx="5703249" cy="77724"/>
+          </a:xfrm>
+          <a:prstGeom prst="roundRect">
+            <a:avLst/>
+          </a:prstGeom>
+          <a:solidFill>
+            <a:srgbClr val="E38B36"/>
+          </a:solidFill>
+          <a:ln>
+            <a:noFill/>
+          </a:ln>
+        </p:spPr>
+        <p:style>
+          <a:lnRef idx="1">
+            <a:schemeClr val="accent1"/>
+          </a:lnRef>
+          <a:fillRef idx="3">
+            <a:schemeClr val="accent1"/>
+          </a:fillRef>
+          <a:effectRef idx="2">
+            <a:schemeClr val="accent1"/>
+          </a:effectRef>
+          <a:fontRef idx="minor">
+            <a:schemeClr val="lt1"/>
+          </a:fontRef>
+        </p:style>
+        <p:txBody>
+          <a:bodyPr rtlCol="0" anchor="ctr"/>
+          <a:lstStyle/>
+          <a:p>
+            <a:pPr algn="ctr"/>
+          </a:p>
+        </p:txBody>
+      </p:sp>
+      <p:sp>
+        <p:nvSpPr>
+          <p:cNvPr id="69" name="TextBox 68"/>
+          <p:cNvSpPr txBox="1"/>
+          <p:nvPr/>
+        </p:nvSpPr>
+        <p:spPr>
+          <a:xfrm>
+            <a:off x="7175433" y="5079492"/>
+            <a:ext cx="438912" cy="128016"/>
+          </a:xfrm>
+          <a:prstGeom prst="rect">
+            <a:avLst/>
+          </a:prstGeom>
+          <a:noFill/>
+        </p:spPr>
+        <p:txBody>
+          <a:bodyPr wrap="square" lIns="0" rIns="0" tIns="0" bIns="0" anchor="ctr">
+            <a:spAutoFit/>
+          </a:bodyPr>
+          <a:lstStyle/>
+          <a:p>
+            <a:pPr algn="l">
+              <a:spcBef>
+                <a:spcPts val="0"/>
+              </a:spcBef>
+              <a:spcAft>
+                <a:spcPts val="0"/>
+              </a:spcAft>
+            </a:pPr>
+            <a:r>
+              <a:rPr sz="750" b="0">
+                <a:solidFill>
+                  <a:srgbClr val="62748A"/>
+                </a:solidFill>
+                <a:latin typeface="Microsoft YaHei"/>
+              </a:rPr>
+              <a:t>96.7</a:t>
+            </a:r>
+          </a:p>
+        </p:txBody>
+      </p:sp>
+      <p:sp>
+        <p:nvSpPr>
+          <p:cNvPr id="70" name="TextBox 69"/>
+          <p:cNvSpPr txBox="1"/>
+          <p:nvPr/>
+        </p:nvSpPr>
+        <p:spPr>
+          <a:xfrm>
+            <a:off x="932688" y="5257800"/>
+            <a:ext cx="384048" cy="219456"/>
+          </a:xfrm>
+          <a:prstGeom prst="rect">
+            <a:avLst/>
+          </a:prstGeom>
+          <a:noFill/>
+        </p:spPr>
+        <p:txBody>
+          <a:bodyPr wrap="square" lIns="0" rIns="0" tIns="0" bIns="0" anchor="ctr">
+            <a:spAutoFit/>
+          </a:bodyPr>
+          <a:lstStyle/>
+          <a:p>
+            <a:pPr algn="l">
+              <a:spcBef>
+                <a:spcPts val="0"/>
+              </a:spcBef>
+              <a:spcAft>
+                <a:spcPts val="0"/>
+              </a:spcAft>
+            </a:pPr>
+            <a:r>
+              <a:rPr sz="850" b="1">
+                <a:solidFill>
+                  <a:srgbClr val="23364A"/>
+                </a:solidFill>
+                <a:latin typeface="Microsoft YaHei"/>
+              </a:rPr>
+              <a:t>M10</a:t>
+            </a:r>
+          </a:p>
+        </p:txBody>
+      </p:sp>
+      <p:sp>
+        <p:nvSpPr>
+          <p:cNvPr id="71" name="Rounded Rectangle 70"/>
+          <p:cNvSpPr/>
+          <p:nvPr/>
+        </p:nvSpPr>
+        <p:spPr>
+          <a:xfrm>
+            <a:off x="1417320" y="5271516"/>
+            <a:ext cx="5502722" cy="77724"/>
+          </a:xfrm>
+          <a:prstGeom prst="roundRect">
+            <a:avLst/>
+          </a:prstGeom>
+          <a:solidFill>
+            <a:srgbClr val="3568A8"/>
+          </a:solidFill>
+          <a:ln>
+            <a:noFill/>
+          </a:ln>
+        </p:spPr>
+        <p:style>
+          <a:lnRef idx="1">
+            <a:schemeClr val="accent1"/>
+          </a:lnRef>
+          <a:fillRef idx="3">
+            <a:schemeClr val="accent1"/>
+          </a:fillRef>
+          <a:effectRef idx="2">
+            <a:schemeClr val="accent1"/>
+          </a:effectRef>
+          <a:fontRef idx="minor">
+            <a:schemeClr val="lt1"/>
+          </a:fontRef>
+        </p:style>
+        <p:txBody>
+          <a:bodyPr rtlCol="0" anchor="ctr"/>
+          <a:lstStyle/>
+          <a:p>
+            <a:pPr algn="ctr"/>
+          </a:p>
+        </p:txBody>
+      </p:sp>
+      <p:sp>
+        <p:nvSpPr>
+          <p:cNvPr id="72" name="TextBox 71"/>
+          <p:cNvSpPr txBox="1"/>
+          <p:nvPr/>
+        </p:nvSpPr>
+        <p:spPr>
+          <a:xfrm>
+            <a:off x="6974906" y="5248656"/>
+            <a:ext cx="438912" cy="128016"/>
+          </a:xfrm>
+          <a:prstGeom prst="rect">
+            <a:avLst/>
+          </a:prstGeom>
+          <a:noFill/>
+        </p:spPr>
+        <p:txBody>
+          <a:bodyPr wrap="square" lIns="0" rIns="0" tIns="0" bIns="0" anchor="ctr">
+            <a:spAutoFit/>
+          </a:bodyPr>
+          <a:lstStyle/>
+          <a:p>
+            <a:pPr algn="l">
+              <a:spcBef>
+                <a:spcPts val="0"/>
+              </a:spcBef>
+              <a:spcAft>
+                <a:spcPts val="0"/>
+              </a:spcAft>
+            </a:pPr>
+            <a:r>
+              <a:rPr sz="750" b="0">
+                <a:solidFill>
+                  <a:srgbClr val="62748A"/>
+                </a:solidFill>
+                <a:latin typeface="Microsoft YaHei"/>
+              </a:rPr>
+              <a:t>93.3</a:t>
+            </a:r>
+          </a:p>
+        </p:txBody>
+      </p:sp>
+      <p:sp>
+        <p:nvSpPr>
+          <p:cNvPr id="73" name="Rounded Rectangle 72"/>
+          <p:cNvSpPr/>
+          <p:nvPr/>
+        </p:nvSpPr>
+        <p:spPr>
+          <a:xfrm>
+            <a:off x="1417320" y="5385816"/>
+            <a:ext cx="5897880" cy="77724"/>
+          </a:xfrm>
+          <a:prstGeom prst="roundRect">
+            <a:avLst/>
+          </a:prstGeom>
+          <a:solidFill>
+            <a:srgbClr val="E38B36"/>
+          </a:solidFill>
+          <a:ln>
+            <a:noFill/>
+          </a:ln>
+        </p:spPr>
+        <p:style>
+          <a:lnRef idx="1">
+            <a:schemeClr val="accent1"/>
+          </a:lnRef>
+          <a:fillRef idx="3">
+            <a:schemeClr val="accent1"/>
+          </a:fillRef>
+          <a:effectRef idx="2">
+            <a:schemeClr val="accent1"/>
+          </a:effectRef>
+          <a:fontRef idx="minor">
+            <a:schemeClr val="lt1"/>
+          </a:fontRef>
+        </p:style>
+        <p:txBody>
+          <a:bodyPr rtlCol="0" anchor="ctr"/>
+          <a:lstStyle/>
+          <a:p>
+            <a:pPr algn="ctr"/>
+          </a:p>
+        </p:txBody>
+      </p:sp>
+      <p:sp>
+        <p:nvSpPr>
+          <p:cNvPr id="74" name="TextBox 73"/>
+          <p:cNvSpPr txBox="1"/>
+          <p:nvPr/>
+        </p:nvSpPr>
+        <p:spPr>
+          <a:xfrm>
+            <a:off x="7370064" y="5362956"/>
+            <a:ext cx="438912" cy="128016"/>
+          </a:xfrm>
+          <a:prstGeom prst="rect">
+            <a:avLst/>
+          </a:prstGeom>
+          <a:noFill/>
+        </p:spPr>
+        <p:txBody>
+          <a:bodyPr wrap="square" lIns="0" rIns="0" tIns="0" bIns="0" anchor="ctr">
+            <a:spAutoFit/>
+          </a:bodyPr>
+          <a:lstStyle/>
+          <a:p>
+            <a:pPr algn="l">
+              <a:spcBef>
+                <a:spcPts val="0"/>
+              </a:spcBef>
+              <a:spcAft>
+                <a:spcPts val="0"/>
+              </a:spcAft>
+            </a:pPr>
+            <a:r>
+              <a:rPr sz="750" b="0">
+                <a:solidFill>
+                  <a:srgbClr val="62748A"/>
+                </a:solidFill>
+                <a:latin typeface="Microsoft YaHei"/>
+              </a:rPr>
+              <a:t>100.0</a:t>
+            </a:r>
+          </a:p>
+        </p:txBody>
+      </p:sp>
+      <p:sp>
+        <p:nvSpPr>
+          <p:cNvPr id="75" name="Rounded Rectangle 74"/>
+          <p:cNvSpPr/>
+          <p:nvPr/>
+        </p:nvSpPr>
+        <p:spPr>
+          <a:xfrm>
+            <a:off x="8366760" y="1993392"/>
+            <a:ext cx="2971800" cy="3767328"/>
+          </a:xfrm>
+          <a:prstGeom prst="roundRect">
+            <a:avLst/>
+          </a:prstGeom>
+          <a:solidFill>
+            <a:srgbClr val="EAF1F8"/>
+          </a:solidFill>
+          <a:ln>
+            <a:noFill/>
+          </a:ln>
+        </p:spPr>
+        <p:style>
+          <a:lnRef idx="1">
+            <a:schemeClr val="accent1"/>
+          </a:lnRef>
+          <a:fillRef idx="3">
+            <a:schemeClr val="accent1"/>
+          </a:fillRef>
+          <a:effectRef idx="2">
+            <a:schemeClr val="accent1"/>
+          </a:effectRef>
+          <a:fontRef idx="minor">
+            <a:schemeClr val="lt1"/>
+          </a:fontRef>
+        </p:style>
+        <p:txBody>
+          <a:bodyPr rtlCol="0" anchor="ctr"/>
+          <a:lstStyle/>
+          <a:p>
+            <a:pPr algn="ctr"/>
+          </a:p>
+        </p:txBody>
+      </p:sp>
+      <p:sp>
+        <p:nvSpPr>
+          <p:cNvPr id="76" name="TextBox 75"/>
+          <p:cNvSpPr txBox="1"/>
+          <p:nvPr/>
+        </p:nvSpPr>
+        <p:spPr>
+          <a:xfrm>
+            <a:off x="8586216" y="2167128"/>
+            <a:ext cx="2532888" cy="347472"/>
+          </a:xfrm>
+          <a:prstGeom prst="rect">
+            <a:avLst/>
+          </a:prstGeom>
+          <a:noFill/>
+        </p:spPr>
+        <p:txBody>
+          <a:bodyPr wrap="square" lIns="0" rIns="0" tIns="0" bIns="0" anchor="t">
+            <a:spAutoFit/>
+          </a:bodyPr>
+          <a:lstStyle/>
+          <a:p>
+            <a:pPr algn="l">
+              <a:spcBef>
+                <a:spcPts val="0"/>
+              </a:spcBef>
+              <a:spcAft>
+                <a:spcPts val="0"/>
+              </a:spcAft>
+            </a:pPr>
+            <a:r>
+              <a:rPr sz="1100" b="1">
+                <a:solidFill>
+                  <a:srgbClr val="3568A8"/>
+                </a:solidFill>
+                <a:latin typeface="Microsoft YaHei"/>
+              </a:rPr>
+              <a:t>关键差距（百分点）</a:t>
+            </a:r>
+          </a:p>
+        </p:txBody>
+      </p:sp>
+      <p:sp>
+        <p:nvSpPr>
+          <p:cNvPr id="77" name="Rounded Rectangle 76"/>
+          <p:cNvSpPr/>
+          <p:nvPr/>
+        </p:nvSpPr>
+        <p:spPr>
+          <a:xfrm>
+            <a:off x="8586216" y="2633472"/>
+            <a:ext cx="2532888" cy="768096"/>
+          </a:xfrm>
+          <a:prstGeom prst="roundRect">
+            <a:avLst/>
+          </a:prstGeom>
+          <a:solidFill>
+            <a:srgbClr val="FFFFFF"/>
+          </a:solidFill>
+          <a:ln>
+            <a:noFill/>
+          </a:ln>
+        </p:spPr>
+        <p:style>
+          <a:lnRef idx="1">
+            <a:schemeClr val="accent1"/>
+          </a:lnRef>
+          <a:fillRef idx="3">
+            <a:schemeClr val="accent1"/>
+          </a:fillRef>
+          <a:effectRef idx="2">
+            <a:schemeClr val="accent1"/>
+          </a:effectRef>
+          <a:fontRef idx="minor">
+            <a:schemeClr val="lt1"/>
+          </a:fontRef>
+        </p:style>
+        <p:txBody>
+          <a:bodyPr rtlCol="0" anchor="ctr"/>
+          <a:lstStyle/>
+          <a:p>
+            <a:pPr algn="ctr"/>
+          </a:p>
+        </p:txBody>
+      </p:sp>
+      <p:sp>
+        <p:nvSpPr>
+          <p:cNvPr id="78" name="TextBox 77"/>
+          <p:cNvSpPr txBox="1"/>
+          <p:nvPr/>
+        </p:nvSpPr>
+        <p:spPr>
+          <a:xfrm>
+            <a:off x="8750808" y="2724912"/>
+            <a:ext cx="2194560" cy="237744"/>
+          </a:xfrm>
+          <a:prstGeom prst="rect">
+            <a:avLst/>
+          </a:prstGeom>
+          <a:noFill/>
+        </p:spPr>
+        <p:txBody>
+          <a:bodyPr wrap="square" lIns="0" rIns="0" tIns="0" bIns="0" anchor="t">
+            <a:spAutoFit/>
+          </a:bodyPr>
+          <a:lstStyle/>
+          <a:p>
+            <a:pPr algn="l">
+              <a:spcBef>
+                <a:spcPts val="0"/>
+              </a:spcBef>
+              <a:spcAft>
+                <a:spcPts val="0"/>
+              </a:spcAft>
+            </a:pPr>
+            <a:r>
+              <a:rPr sz="1000" b="1">
+                <a:solidFill>
+                  <a:srgbClr val="17324D"/>
+                </a:solidFill>
+                <a:latin typeface="Microsoft YaHei"/>
+              </a:rPr>
+              <a:t>M09　受众互动与行动引导</a:t>
+            </a:r>
+          </a:p>
+        </p:txBody>
+      </p:sp>
+      <p:sp>
+        <p:nvSpPr>
+          <p:cNvPr id="79" name="TextBox 78"/>
+          <p:cNvSpPr txBox="1"/>
+          <p:nvPr/>
+        </p:nvSpPr>
+        <p:spPr>
+          <a:xfrm>
+            <a:off x="8750808" y="3026664"/>
+            <a:ext cx="1554480" cy="246888"/>
+          </a:xfrm>
+          <a:prstGeom prst="rect">
+            <a:avLst/>
+          </a:prstGeom>
+          <a:noFill/>
+        </p:spPr>
+        <p:txBody>
+          <a:bodyPr wrap="square" lIns="0" rIns="0" tIns="0" bIns="0" anchor="ctr">
+            <a:spAutoFit/>
+          </a:bodyPr>
+          <a:lstStyle/>
+          <a:p>
+            <a:pPr algn="l">
+              <a:spcBef>
+                <a:spcPts val="0"/>
+              </a:spcBef>
+              <a:spcAft>
+                <a:spcPts val="0"/>
+              </a:spcAft>
+            </a:pPr>
+            <a:r>
+              <a:rPr sz="1150" b="1">
+                <a:solidFill>
+                  <a:srgbClr val="23364A"/>
+                </a:solidFill>
+                <a:latin typeface="Microsoft YaHei"/>
+              </a:rPr>
+              <a:t>30.0% → 96.7%</a:t>
+            </a:r>
+          </a:p>
+        </p:txBody>
+      </p:sp>
+      <p:sp>
+        <p:nvSpPr>
+          <p:cNvPr id="80" name="TextBox 79"/>
+          <p:cNvSpPr txBox="1"/>
+          <p:nvPr/>
+        </p:nvSpPr>
+        <p:spPr>
+          <a:xfrm>
+            <a:off x="10241280" y="2999232"/>
+            <a:ext cx="685800" cy="274320"/>
+          </a:xfrm>
+          <a:prstGeom prst="rect">
+            <a:avLst/>
+          </a:prstGeom>
+          <a:noFill/>
+        </p:spPr>
+        <p:txBody>
+          <a:bodyPr wrap="square" lIns="0" rIns="0" tIns="0" bIns="0" anchor="ctr">
+            <a:spAutoFit/>
+          </a:bodyPr>
+          <a:lstStyle/>
+          <a:p>
+            <a:pPr algn="r">
+              <a:spcBef>
+                <a:spcPts val="0"/>
+              </a:spcBef>
+              <a:spcAft>
+                <a:spcPts val="0"/>
+              </a:spcAft>
+            </a:pPr>
+            <a:r>
+              <a:rPr sz="1400" b="1">
+                <a:solidFill>
+                  <a:srgbClr val="E38B36"/>
+                </a:solidFill>
+                <a:latin typeface="Microsoft YaHei"/>
+              </a:rPr>
+              <a:t>+66.7</a:t>
+            </a:r>
+          </a:p>
+        </p:txBody>
+      </p:sp>
+      <p:sp>
+        <p:nvSpPr>
+          <p:cNvPr id="81" name="Rounded Rectangle 80"/>
+          <p:cNvSpPr/>
+          <p:nvPr/>
+        </p:nvSpPr>
+        <p:spPr>
+          <a:xfrm>
+            <a:off x="8586216" y="3547872"/>
+            <a:ext cx="2532888" cy="768096"/>
+          </a:xfrm>
+          <a:prstGeom prst="roundRect">
+            <a:avLst/>
+          </a:prstGeom>
+          <a:solidFill>
+            <a:srgbClr val="FFFFFF"/>
+          </a:solidFill>
+          <a:ln>
+            <a:noFill/>
+          </a:ln>
+        </p:spPr>
+        <p:style>
+          <a:lnRef idx="1">
+            <a:schemeClr val="accent1"/>
+          </a:lnRef>
+          <a:fillRef idx="3">
+            <a:schemeClr val="accent1"/>
+          </a:fillRef>
+          <a:effectRef idx="2">
+            <a:schemeClr val="accent1"/>
+          </a:effectRef>
+          <a:fontRef idx="minor">
+            <a:schemeClr val="lt1"/>
+          </a:fontRef>
+        </p:style>
+        <p:txBody>
+          <a:bodyPr rtlCol="0" anchor="ctr"/>
+          <a:lstStyle/>
+          <a:p>
+            <a:pPr algn="ctr"/>
+          </a:p>
+        </p:txBody>
+      </p:sp>
+      <p:sp>
+        <p:nvSpPr>
+          <p:cNvPr id="82" name="TextBox 81"/>
+          <p:cNvSpPr txBox="1"/>
+          <p:nvPr/>
+        </p:nvSpPr>
+        <p:spPr>
+          <a:xfrm>
+            <a:off x="8750808" y="3639312"/>
+            <a:ext cx="2194560" cy="237744"/>
+          </a:xfrm>
+          <a:prstGeom prst="rect">
+            <a:avLst/>
+          </a:prstGeom>
+          <a:noFill/>
+        </p:spPr>
+        <p:txBody>
+          <a:bodyPr wrap="square" lIns="0" rIns="0" tIns="0" bIns="0" anchor="t">
+            <a:spAutoFit/>
+          </a:bodyPr>
+          <a:lstStyle/>
+          <a:p>
+            <a:pPr algn="l">
+              <a:spcBef>
+                <a:spcPts val="0"/>
+              </a:spcBef>
+              <a:spcAft>
+                <a:spcPts val="0"/>
+              </a:spcAft>
+            </a:pPr>
+            <a:r>
+              <a:rPr sz="1000" b="1">
+                <a:solidFill>
+                  <a:srgbClr val="17324D"/>
+                </a:solidFill>
+                <a:latin typeface="Microsoft YaHei"/>
+              </a:rPr>
+              <a:t>M08　合作网络与社会服务</a:t>
+            </a:r>
+          </a:p>
+        </p:txBody>
+      </p:sp>
+      <p:sp>
+        <p:nvSpPr>
+          <p:cNvPr id="83" name="TextBox 82"/>
+          <p:cNvSpPr txBox="1"/>
+          <p:nvPr/>
+        </p:nvSpPr>
+        <p:spPr>
+          <a:xfrm>
+            <a:off x="8750808" y="3941063"/>
+            <a:ext cx="1554480" cy="246888"/>
+          </a:xfrm>
+          <a:prstGeom prst="rect">
+            <a:avLst/>
+          </a:prstGeom>
+          <a:noFill/>
+        </p:spPr>
+        <p:txBody>
+          <a:bodyPr wrap="square" lIns="0" rIns="0" tIns="0" bIns="0" anchor="ctr">
+            <a:spAutoFit/>
+          </a:bodyPr>
+          <a:lstStyle/>
+          <a:p>
+            <a:pPr algn="l">
+              <a:spcBef>
+                <a:spcPts val="0"/>
+              </a:spcBef>
+              <a:spcAft>
+                <a:spcPts val="0"/>
+              </a:spcAft>
+            </a:pPr>
+            <a:r>
+              <a:rPr sz="1150" b="1">
+                <a:solidFill>
+                  <a:srgbClr val="23364A"/>
+                </a:solidFill>
+                <a:latin typeface="Microsoft YaHei"/>
+              </a:rPr>
+              <a:t>56.7% → 93.3%</a:t>
+            </a:r>
+          </a:p>
+        </p:txBody>
+      </p:sp>
+      <p:sp>
+        <p:nvSpPr>
+          <p:cNvPr id="84" name="TextBox 83"/>
+          <p:cNvSpPr txBox="1"/>
+          <p:nvPr/>
+        </p:nvSpPr>
+        <p:spPr>
+          <a:xfrm>
+            <a:off x="10241280" y="3913632"/>
+            <a:ext cx="685800" cy="274320"/>
+          </a:xfrm>
+          <a:prstGeom prst="rect">
+            <a:avLst/>
+          </a:prstGeom>
+          <a:noFill/>
+        </p:spPr>
+        <p:txBody>
+          <a:bodyPr wrap="square" lIns="0" rIns="0" tIns="0" bIns="0" anchor="ctr">
+            <a:spAutoFit/>
+          </a:bodyPr>
+          <a:lstStyle/>
+          <a:p>
+            <a:pPr algn="r">
+              <a:spcBef>
+                <a:spcPts val="0"/>
+              </a:spcBef>
+              <a:spcAft>
+                <a:spcPts val="0"/>
+              </a:spcAft>
+            </a:pPr>
+            <a:r>
+              <a:rPr sz="1400" b="1">
+                <a:solidFill>
+                  <a:srgbClr val="E38B36"/>
+                </a:solidFill>
+                <a:latin typeface="Microsoft YaHei"/>
+              </a:rPr>
+              <a:t>+36.7</a:t>
+            </a:r>
+          </a:p>
+        </p:txBody>
+      </p:sp>
+      <p:sp>
+        <p:nvSpPr>
+          <p:cNvPr id="85" name="Rounded Rectangle 84"/>
+          <p:cNvSpPr/>
+          <p:nvPr/>
+        </p:nvSpPr>
+        <p:spPr>
+          <a:xfrm>
+            <a:off x="8586216" y="4462272"/>
+            <a:ext cx="2532888" cy="768096"/>
+          </a:xfrm>
+          <a:prstGeom prst="roundRect">
+            <a:avLst/>
+          </a:prstGeom>
+          <a:solidFill>
+            <a:srgbClr val="FFFFFF"/>
+          </a:solidFill>
+          <a:ln>
+            <a:noFill/>
+          </a:ln>
+        </p:spPr>
+        <p:style>
+          <a:lnRef idx="1">
+            <a:schemeClr val="accent1"/>
+          </a:lnRef>
+          <a:fillRef idx="3">
+            <a:schemeClr val="accent1"/>
+          </a:fillRef>
+          <a:effectRef idx="2">
+            <a:schemeClr val="accent1"/>
+          </a:effectRef>
+          <a:fontRef idx="minor">
+            <a:schemeClr val="lt1"/>
+          </a:fontRef>
+        </p:style>
+        <p:txBody>
+          <a:bodyPr rtlCol="0" anchor="ctr"/>
+          <a:lstStyle/>
+          <a:p>
+            <a:pPr algn="ctr"/>
+          </a:p>
+        </p:txBody>
+      </p:sp>
+      <p:sp>
+        <p:nvSpPr>
+          <p:cNvPr id="86" name="TextBox 85"/>
+          <p:cNvSpPr txBox="1"/>
+          <p:nvPr/>
+        </p:nvSpPr>
+        <p:spPr>
+          <a:xfrm>
+            <a:off x="8750808" y="4553712"/>
+            <a:ext cx="2194560" cy="237744"/>
+          </a:xfrm>
+          <a:prstGeom prst="rect">
+            <a:avLst/>
+          </a:prstGeom>
+          <a:noFill/>
+        </p:spPr>
+        <p:txBody>
+          <a:bodyPr wrap="square" lIns="0" rIns="0" tIns="0" bIns="0" anchor="t">
+            <a:spAutoFit/>
+          </a:bodyPr>
+          <a:lstStyle/>
+          <a:p>
+            <a:pPr algn="l">
+              <a:spcBef>
+                <a:spcPts val="0"/>
+              </a:spcBef>
+              <a:spcAft>
+                <a:spcPts val="0"/>
+              </a:spcAft>
+            </a:pPr>
+            <a:r>
+              <a:rPr sz="1000" b="1">
+                <a:solidFill>
+                  <a:srgbClr val="17324D"/>
+                </a:solidFill>
+                <a:latin typeface="Microsoft YaHei"/>
+              </a:rPr>
+              <a:t>M03　使命愿景与公共价值</a:t>
+            </a:r>
+          </a:p>
+        </p:txBody>
+      </p:sp>
+      <p:sp>
+        <p:nvSpPr>
+          <p:cNvPr id="87" name="TextBox 86"/>
+          <p:cNvSpPr txBox="1"/>
+          <p:nvPr/>
+        </p:nvSpPr>
+        <p:spPr>
+          <a:xfrm>
+            <a:off x="8750808" y="4855464"/>
+            <a:ext cx="1554480" cy="246888"/>
+          </a:xfrm>
+          <a:prstGeom prst="rect">
+            <a:avLst/>
+          </a:prstGeom>
+          <a:noFill/>
+        </p:spPr>
+        <p:txBody>
+          <a:bodyPr wrap="square" lIns="0" rIns="0" tIns="0" bIns="0" anchor="ctr">
+            <a:spAutoFit/>
+          </a:bodyPr>
+          <a:lstStyle/>
+          <a:p>
+            <a:pPr algn="l">
+              <a:spcBef>
+                <a:spcPts val="0"/>
+              </a:spcBef>
+              <a:spcAft>
+                <a:spcPts val="0"/>
+              </a:spcAft>
+            </a:pPr>
+            <a:r>
+              <a:rPr sz="1150" b="1">
+                <a:solidFill>
+                  <a:srgbClr val="23364A"/>
+                </a:solidFill>
+                <a:latin typeface="Microsoft YaHei"/>
+              </a:rPr>
+              <a:t>76.7% → 96.7%</a:t>
+            </a:r>
+          </a:p>
+        </p:txBody>
+      </p:sp>
+      <p:sp>
+        <p:nvSpPr>
+          <p:cNvPr id="88" name="TextBox 87"/>
+          <p:cNvSpPr txBox="1"/>
+          <p:nvPr/>
+        </p:nvSpPr>
+        <p:spPr>
+          <a:xfrm>
+            <a:off x="10241280" y="4828032"/>
+            <a:ext cx="685800" cy="274320"/>
+          </a:xfrm>
+          <a:prstGeom prst="rect">
+            <a:avLst/>
+          </a:prstGeom>
+          <a:noFill/>
+        </p:spPr>
+        <p:txBody>
+          <a:bodyPr wrap="square" lIns="0" rIns="0" tIns="0" bIns="0" anchor="ctr">
+            <a:spAutoFit/>
+          </a:bodyPr>
+          <a:lstStyle/>
+          <a:p>
+            <a:pPr algn="r">
+              <a:spcBef>
+                <a:spcPts val="0"/>
+              </a:spcBef>
+              <a:spcAft>
+                <a:spcPts val="0"/>
+              </a:spcAft>
+            </a:pPr>
+            <a:r>
+              <a:rPr sz="1400" b="1">
+                <a:solidFill>
+                  <a:srgbClr val="E38B36"/>
+                </a:solidFill>
+                <a:latin typeface="Microsoft YaHei"/>
+              </a:rPr>
+              <a:t>+20.0</a:t>
+            </a:r>
+          </a:p>
+        </p:txBody>
+      </p:sp>
+      <p:sp>
+        <p:nvSpPr>
+          <p:cNvPr id="89" name="TextBox 88"/>
+          <p:cNvSpPr txBox="1"/>
+          <p:nvPr/>
+        </p:nvSpPr>
+        <p:spPr>
+          <a:xfrm>
+            <a:off x="8586216" y="5431536"/>
+            <a:ext cx="2532888" cy="201168"/>
+          </a:xfrm>
+          <a:prstGeom prst="rect">
+            <a:avLst/>
+          </a:prstGeom>
+          <a:noFill/>
+        </p:spPr>
+        <p:txBody>
+          <a:bodyPr wrap="square" lIns="0" rIns="0" tIns="0" bIns="0" anchor="t">
+            <a:spAutoFit/>
+          </a:bodyPr>
+          <a:lstStyle/>
+          <a:p>
+            <a:pPr algn="ctr">
+              <a:spcBef>
+                <a:spcPts val="0"/>
+              </a:spcBef>
+              <a:spcAft>
+                <a:spcPts val="0"/>
+              </a:spcAft>
+            </a:pPr>
+            <a:r>
+              <a:rPr sz="850" b="0">
+                <a:solidFill>
+                  <a:srgbClr val="62748A"/>
+                </a:solidFill>
+                <a:latin typeface="Microsoft YaHei"/>
+              </a:rPr>
+              <a:t>其余7个语步差距均≤10个百分点</a:t>
+            </a:r>
+          </a:p>
+        </p:txBody>
+      </p:sp>
+      <p:sp>
+        <p:nvSpPr>
+          <p:cNvPr id="90" name="TextBox 89"/>
+          <p:cNvSpPr txBox="1"/>
+          <p:nvPr/>
+        </p:nvSpPr>
+        <p:spPr>
+          <a:xfrm>
+            <a:off x="768096" y="5852160"/>
+            <a:ext cx="7315200" cy="182880"/>
+          </a:xfrm>
+          <a:prstGeom prst="rect">
+            <a:avLst/>
+          </a:prstGeom>
+          <a:noFill/>
+        </p:spPr>
+        <p:txBody>
+          <a:bodyPr wrap="square" lIns="0" rIns="0" tIns="0" bIns="0" anchor="t">
+            <a:spAutoFit/>
+          </a:bodyPr>
+          <a:lstStyle/>
+          <a:p>
+            <a:pPr algn="l">
+              <a:spcBef>
+                <a:spcPts val="0"/>
+              </a:spcBef>
+              <a:spcAft>
+                <a:spcPts val="0"/>
+              </a:spcAft>
+            </a:pPr>
+            <a:r>
+              <a:rPr sz="850" b="0">
+                <a:solidFill>
+                  <a:srgbClr val="62748A"/>
+                </a:solidFill>
+                <a:latin typeface="Microsoft YaHei"/>
+              </a:rPr>
+              <a:t>注：出现率为该国30个文本中包含相应语步的文本比例。</a:t>
+            </a:r>
+          </a:p>
+        </p:txBody>
+      </p:sp>
+      <p:cxnSp>
+        <p:nvCxnSpPr>
+          <p:cNvPr id="91" name="Connector 90"/>
+          <p:cNvCxnSpPr/>
+          <p:nvPr/>
+        </p:nvCxnSpPr>
+        <p:spPr>
+          <a:xfrm>
+            <a:off x="731520" y="6144768"/>
+            <a:ext cx="10744200" cy="0"/>
+          </a:xfrm>
+          <a:prstGeom prst="line">
+            <a:avLst/>
+          </a:prstGeom>
+          <a:ln w="10160">
+            <a:solidFill>
+              <a:srgbClr val="D8E1EB"/>
+            </a:solidFill>
+          </a:ln>
+        </p:spPr>
+        <p:style>
+          <a:lnRef idx="2">
+            <a:schemeClr val="accent1"/>
+          </a:lnRef>
+          <a:fillRef idx="0">
+            <a:schemeClr val="accent1"/>
+          </a:fillRef>
+          <a:effectRef idx="1">
+            <a:schemeClr val="accent1"/>
+          </a:effectRef>
+          <a:fontRef idx="minor">
+            <a:schemeClr val="tx1"/>
+          </a:fontRef>
+        </p:style>
+      </p:cxnSp>
+      <p:sp>
+        <p:nvSpPr>
+          <p:cNvPr id="92" name="TextBox 91"/>
+          <p:cNvSpPr txBox="1"/>
+          <p:nvPr/>
+        </p:nvSpPr>
+        <p:spPr>
+          <a:xfrm>
+            <a:off x="731520" y="6318504"/>
+            <a:ext cx="7772400" cy="256032"/>
+          </a:xfrm>
+          <a:prstGeom prst="rect">
+            <a:avLst/>
+          </a:prstGeom>
+          <a:noFill/>
+        </p:spPr>
+        <p:txBody>
+          <a:bodyPr wrap="square" lIns="0" rIns="0" tIns="0" bIns="0" anchor="t">
+            <a:spAutoFit/>
+          </a:bodyPr>
+          <a:lstStyle/>
+          <a:p>
+            <a:pPr algn="l">
+              <a:spcBef>
+                <a:spcPts val="0"/>
+              </a:spcBef>
+              <a:spcAft>
+                <a:spcPts val="0"/>
+              </a:spcAft>
+            </a:pPr>
+            <a:r>
+              <a:rPr sz="900" b="0">
+                <a:solidFill>
+                  <a:srgbClr val="62748A"/>
+                </a:solidFill>
+                <a:latin typeface="Microsoft YaHei"/>
+              </a:rPr>
+              <a:t>基于语料库技术的中美外语院系英文简介话语比较分析</a:t>
+            </a:r>
+          </a:p>
+        </p:txBody>
+      </p:sp>
+      <p:sp>
+        <p:nvSpPr>
+          <p:cNvPr id="93" name="TextBox 92"/>
+          <p:cNvSpPr txBox="1"/>
+          <p:nvPr/>
+        </p:nvSpPr>
+        <p:spPr>
+          <a:xfrm>
+            <a:off x="10881360" y="6318504"/>
+            <a:ext cx="594360" cy="256032"/>
+          </a:xfrm>
+          <a:prstGeom prst="rect">
+            <a:avLst/>
+          </a:prstGeom>
+          <a:noFill/>
+        </p:spPr>
+        <p:txBody>
+          <a:bodyPr wrap="square" lIns="0" rIns="0" tIns="0" bIns="0" anchor="t">
+            <a:spAutoFit/>
+          </a:bodyPr>
+          <a:lstStyle/>
+          <a:p>
+            <a:pPr algn="r">
+              <a:spcBef>
+                <a:spcPts val="0"/>
+              </a:spcBef>
+              <a:spcAft>
+                <a:spcPts val="0"/>
+              </a:spcAft>
+            </a:pPr>
+            <a:r>
+              <a:rPr sz="1000" b="0">
+                <a:solidFill>
+                  <a:srgbClr val="62748A"/>
+                </a:solidFill>
+                <a:latin typeface="Microsoft YaHei"/>
+              </a:rPr>
+              <a:t>05 / 08</a:t>
             </a:r>
           </a:p>
         </p:txBody>

</xml_diff>

<commit_message>
Add editable move length and opening slide
Co-authored-by: arena-agent <297053741+arena-agent@users.noreply.github.com>
</commit_message>
<xml_diff>
--- a/midterm-report/presentation/中美外语院系英文简介_5分钟汇报.pptx
+++ b/midterm-report/presentation/中美外语院系英文简介_5分钟汇报.pptx
@@ -10,6 +10,7 @@
     <p:sldId id="258" r:id="rId9"/>
     <p:sldId id="259" r:id="rId10"/>
     <p:sldId id="260" r:id="rId11"/>
+    <p:sldId id="261" r:id="rId12"/>
   </p:sldIdLst>
   <p:sldSz cx="12191695" cy="6858000" type="screen4x3"/>
   <p:notesSz cx="6858000" cy="9144000"/>
@@ -16828,6 +16829,3832 @@
                 <a:latin typeface="Microsoft YaHei"/>
               </a:rPr>
               <a:t>05 / 08</a:t>
+            </a:r>
+          </a:p>
+        </p:txBody>
+      </p:sp>
+    </p:spTree>
+  </p:cSld>
+  <p:clrMapOvr>
+    <a:masterClrMapping/>
+  </p:clrMapOvr>
+</p:sld>
+</file>
+
+<file path=ppt/slides/slide6.xml><?xml version="1.0" encoding="utf-8"?>
+<p:sld xmlns:a="http://schemas.openxmlformats.org/drawingml/2006/main" xmlns:p="http://schemas.openxmlformats.org/presentationml/2006/main" xmlns:r="http://schemas.openxmlformats.org/officeDocument/2006/relationships">
+  <p:cSld>
+    <p:spTree>
+      <p:nvGrpSpPr>
+        <p:cNvPr id="1" name=""/>
+        <p:cNvGrpSpPr/>
+        <p:nvPr/>
+      </p:nvGrpSpPr>
+      <p:grpSpPr/>
+      <p:sp>
+        <p:nvSpPr>
+          <p:cNvPr id="2" name="Rectangle 1"/>
+          <p:cNvSpPr/>
+          <p:nvPr/>
+        </p:nvSpPr>
+        <p:spPr>
+          <a:xfrm>
+            <a:off x="0" y="0"/>
+            <a:ext cx="12191695" cy="6858000"/>
+          </a:xfrm>
+          <a:prstGeom prst="rect">
+            <a:avLst/>
+          </a:prstGeom>
+          <a:solidFill>
+            <a:srgbClr val="F7F9FC"/>
+          </a:solidFill>
+          <a:ln>
+            <a:noFill/>
+          </a:ln>
+        </p:spPr>
+        <p:style>
+          <a:lnRef idx="1">
+            <a:schemeClr val="accent1"/>
+          </a:lnRef>
+          <a:fillRef idx="3">
+            <a:schemeClr val="accent1"/>
+          </a:fillRef>
+          <a:effectRef idx="2">
+            <a:schemeClr val="accent1"/>
+          </a:effectRef>
+          <a:fontRef idx="minor">
+            <a:schemeClr val="lt1"/>
+          </a:fontRef>
+        </p:style>
+        <p:txBody>
+          <a:bodyPr rtlCol="0" anchor="ctr"/>
+          <a:lstStyle/>
+          <a:p>
+            <a:pPr algn="ctr"/>
+          </a:p>
+        </p:txBody>
+      </p:sp>
+      <p:sp>
+        <p:nvSpPr>
+          <p:cNvPr id="3" name="Rectangle 2"/>
+          <p:cNvSpPr/>
+          <p:nvPr/>
+        </p:nvSpPr>
+        <p:spPr>
+          <a:xfrm>
+            <a:off x="0" y="0"/>
+            <a:ext cx="146304" cy="6858000"/>
+          </a:xfrm>
+          <a:prstGeom prst="rect">
+            <a:avLst/>
+          </a:prstGeom>
+          <a:solidFill>
+            <a:srgbClr val="17324D"/>
+          </a:solidFill>
+          <a:ln>
+            <a:noFill/>
+          </a:ln>
+        </p:spPr>
+        <p:style>
+          <a:lnRef idx="1">
+            <a:schemeClr val="accent1"/>
+          </a:lnRef>
+          <a:fillRef idx="3">
+            <a:schemeClr val="accent1"/>
+          </a:fillRef>
+          <a:effectRef idx="2">
+            <a:schemeClr val="accent1"/>
+          </a:effectRef>
+          <a:fontRef idx="minor">
+            <a:schemeClr val="lt1"/>
+          </a:fontRef>
+        </p:style>
+        <p:txBody>
+          <a:bodyPr rtlCol="0" anchor="ctr"/>
+          <a:lstStyle/>
+          <a:p>
+            <a:pPr algn="ctr"/>
+          </a:p>
+        </p:txBody>
+      </p:sp>
+      <p:sp>
+        <p:nvSpPr>
+          <p:cNvPr id="4" name="Rectangle 3"/>
+          <p:cNvSpPr/>
+          <p:nvPr/>
+        </p:nvSpPr>
+        <p:spPr>
+          <a:xfrm>
+            <a:off x="146304" y="0"/>
+            <a:ext cx="50292" cy="841248"/>
+          </a:xfrm>
+          <a:prstGeom prst="rect">
+            <a:avLst/>
+          </a:prstGeom>
+          <a:solidFill>
+            <a:srgbClr val="E38B36"/>
+          </a:solidFill>
+          <a:ln>
+            <a:noFill/>
+          </a:ln>
+        </p:spPr>
+        <p:style>
+          <a:lnRef idx="1">
+            <a:schemeClr val="accent1"/>
+          </a:lnRef>
+          <a:fillRef idx="3">
+            <a:schemeClr val="accent1"/>
+          </a:fillRef>
+          <a:effectRef idx="2">
+            <a:schemeClr val="accent1"/>
+          </a:effectRef>
+          <a:fontRef idx="minor">
+            <a:schemeClr val="lt1"/>
+          </a:fontRef>
+        </p:style>
+        <p:txBody>
+          <a:bodyPr rtlCol="0" anchor="ctr"/>
+          <a:lstStyle/>
+          <a:p>
+            <a:pPr algn="ctr"/>
+          </a:p>
+        </p:txBody>
+      </p:sp>
+      <p:sp>
+        <p:nvSpPr>
+          <p:cNvPr id="5" name="TextBox 4"/>
+          <p:cNvSpPr txBox="1"/>
+          <p:nvPr/>
+        </p:nvSpPr>
+        <p:spPr>
+          <a:xfrm>
+            <a:off x="731520" y="438912"/>
+            <a:ext cx="3840480" cy="274320"/>
+          </a:xfrm>
+          <a:prstGeom prst="rect">
+            <a:avLst/>
+          </a:prstGeom>
+          <a:noFill/>
+        </p:spPr>
+        <p:txBody>
+          <a:bodyPr wrap="square" lIns="0" rIns="0" tIns="0" bIns="0" anchor="t">
+            <a:spAutoFit/>
+          </a:bodyPr>
+          <a:lstStyle/>
+          <a:p>
+            <a:pPr algn="l">
+              <a:spcBef>
+                <a:spcPts val="0"/>
+              </a:spcBef>
+              <a:spcAft>
+                <a:spcPts val="0"/>
+              </a:spcAft>
+            </a:pPr>
+            <a:r>
+              <a:rPr sz="1100" b="1">
+                <a:solidFill>
+                  <a:srgbClr val="3568A8"/>
+                </a:solidFill>
+                <a:latin typeface="Microsoft YaHei"/>
+              </a:rPr>
+              <a:t>04　研究结果｜语步分布</a:t>
+            </a:r>
+          </a:p>
+        </p:txBody>
+      </p:sp>
+      <p:sp>
+        <p:nvSpPr>
+          <p:cNvPr id="6" name="TextBox 5"/>
+          <p:cNvSpPr txBox="1"/>
+          <p:nvPr/>
+        </p:nvSpPr>
+        <p:spPr>
+          <a:xfrm>
+            <a:off x="731520" y="768096"/>
+            <a:ext cx="10241280" cy="475488"/>
+          </a:xfrm>
+          <a:prstGeom prst="rect">
+            <a:avLst/>
+          </a:prstGeom>
+          <a:noFill/>
+        </p:spPr>
+        <p:txBody>
+          <a:bodyPr wrap="square" lIns="0" rIns="0" tIns="0" bIns="0" anchor="t">
+            <a:spAutoFit/>
+          </a:bodyPr>
+          <a:lstStyle/>
+          <a:p>
+            <a:pPr algn="l">
+              <a:spcBef>
+                <a:spcPts val="0"/>
+              </a:spcBef>
+              <a:spcAft>
+                <a:spcPts val="0"/>
+              </a:spcAft>
+            </a:pPr>
+            <a:r>
+              <a:rPr sz="2600" b="1">
+                <a:solidFill>
+                  <a:srgbClr val="17324D"/>
+                </a:solidFill>
+                <a:latin typeface="Microsoft YaHei"/>
+              </a:rPr>
+              <a:t>篇幅与开篇：M05为共同核心，开篇功能不同</a:t>
+            </a:r>
+          </a:p>
+        </p:txBody>
+      </p:sp>
+      <p:sp>
+        <p:nvSpPr>
+          <p:cNvPr id="7" name="TextBox 6"/>
+          <p:cNvSpPr txBox="1"/>
+          <p:nvPr/>
+        </p:nvSpPr>
+        <p:spPr>
+          <a:xfrm>
+            <a:off x="731520" y="1307592"/>
+            <a:ext cx="10515600" cy="384048"/>
+          </a:xfrm>
+          <a:prstGeom prst="rect">
+            <a:avLst/>
+          </a:prstGeom>
+          <a:noFill/>
+        </p:spPr>
+        <p:txBody>
+          <a:bodyPr wrap="square" lIns="0" rIns="0" tIns="0" bIns="0" anchor="ctr">
+            <a:spAutoFit/>
+          </a:bodyPr>
+          <a:lstStyle/>
+          <a:p>
+            <a:pPr algn="l">
+              <a:spcBef>
+                <a:spcPts val="0"/>
+              </a:spcBef>
+              <a:spcAft>
+                <a:spcPts val="0"/>
+              </a:spcAft>
+            </a:pPr>
+            <a:r>
+              <a:rPr sz="1400" b="0">
+                <a:solidFill>
+                  <a:srgbClr val="23364A"/>
+                </a:solidFill>
+                <a:latin typeface="Microsoft YaHei"/>
+              </a:rPr>
+              <a:t>M05的篇幅占比中位数在两国均约20%；M02更常开启中国文本，M05更常开启美国文本</a:t>
+            </a:r>
+          </a:p>
+        </p:txBody>
+      </p:sp>
+      <p:sp>
+        <p:nvSpPr>
+          <p:cNvPr id="8" name="Rectangle 7"/>
+          <p:cNvSpPr/>
+          <p:nvPr/>
+        </p:nvSpPr>
+        <p:spPr>
+          <a:xfrm>
+            <a:off x="731520" y="1773936"/>
+            <a:ext cx="594360" cy="41148"/>
+          </a:xfrm>
+          <a:prstGeom prst="rect">
+            <a:avLst/>
+          </a:prstGeom>
+          <a:solidFill>
+            <a:srgbClr val="E38B36"/>
+          </a:solidFill>
+          <a:ln>
+            <a:noFill/>
+          </a:ln>
+        </p:spPr>
+        <p:style>
+          <a:lnRef idx="1">
+            <a:schemeClr val="accent1"/>
+          </a:lnRef>
+          <a:fillRef idx="3">
+            <a:schemeClr val="accent1"/>
+          </a:fillRef>
+          <a:effectRef idx="2">
+            <a:schemeClr val="accent1"/>
+          </a:effectRef>
+          <a:fontRef idx="minor">
+            <a:schemeClr val="lt1"/>
+          </a:fontRef>
+        </p:style>
+        <p:txBody>
+          <a:bodyPr rtlCol="0" anchor="ctr"/>
+          <a:lstStyle/>
+          <a:p>
+            <a:pPr algn="ctr"/>
+          </a:p>
+        </p:txBody>
+      </p:sp>
+      <p:sp>
+        <p:nvSpPr>
+          <p:cNvPr id="9" name="Rounded Rectangle 8"/>
+          <p:cNvSpPr/>
+          <p:nvPr/>
+        </p:nvSpPr>
+        <p:spPr>
+          <a:xfrm>
+            <a:off x="731520" y="1993392"/>
+            <a:ext cx="6995160" cy="3767328"/>
+          </a:xfrm>
+          <a:prstGeom prst="roundRect">
+            <a:avLst/>
+          </a:prstGeom>
+          <a:solidFill>
+            <a:srgbClr val="FFFFFF"/>
+          </a:solidFill>
+          <a:ln w="10160">
+            <a:solidFill>
+              <a:srgbClr val="D8E1EB"/>
+            </a:solidFill>
+          </a:ln>
+        </p:spPr>
+        <p:style>
+          <a:lnRef idx="1">
+            <a:schemeClr val="accent1"/>
+          </a:lnRef>
+          <a:fillRef idx="3">
+            <a:schemeClr val="accent1"/>
+          </a:fillRef>
+          <a:effectRef idx="2">
+            <a:schemeClr val="accent1"/>
+          </a:effectRef>
+          <a:fontRef idx="minor">
+            <a:schemeClr val="lt1"/>
+          </a:fontRef>
+        </p:style>
+        <p:txBody>
+          <a:bodyPr rtlCol="0" anchor="ctr"/>
+          <a:lstStyle/>
+          <a:p>
+            <a:pPr algn="ctr"/>
+          </a:p>
+        </p:txBody>
+      </p:sp>
+      <p:sp>
+        <p:nvSpPr>
+          <p:cNvPr id="10" name="TextBox 9"/>
+          <p:cNvSpPr txBox="1"/>
+          <p:nvPr/>
+        </p:nvSpPr>
+        <p:spPr>
+          <a:xfrm>
+            <a:off x="941832" y="2167128"/>
+            <a:ext cx="2651760" cy="274320"/>
+          </a:xfrm>
+          <a:prstGeom prst="rect">
+            <a:avLst/>
+          </a:prstGeom>
+          <a:noFill/>
+        </p:spPr>
+        <p:txBody>
+          <a:bodyPr wrap="square" lIns="0" rIns="0" tIns="0" bIns="0" anchor="t">
+            <a:spAutoFit/>
+          </a:bodyPr>
+          <a:lstStyle/>
+          <a:p>
+            <a:pPr algn="l">
+              <a:spcBef>
+                <a:spcPts val="0"/>
+              </a:spcBef>
+              <a:spcAft>
+                <a:spcPts val="0"/>
+              </a:spcAft>
+            </a:pPr>
+            <a:r>
+              <a:rPr sz="1100" b="1">
+                <a:solidFill>
+                  <a:srgbClr val="3568A8"/>
+                </a:solidFill>
+                <a:latin typeface="Microsoft YaHei"/>
+              </a:rPr>
+              <a:t>语步词数占比中位数（%）</a:t>
+            </a:r>
+          </a:p>
+        </p:txBody>
+      </p:sp>
+      <p:sp>
+        <p:nvSpPr>
+          <p:cNvPr id="11" name="Oval 10"/>
+          <p:cNvSpPr/>
+          <p:nvPr/>
+        </p:nvSpPr>
+        <p:spPr>
+          <a:xfrm>
+            <a:off x="5413248" y="2221992"/>
+            <a:ext cx="109728" cy="109728"/>
+          </a:xfrm>
+          <a:prstGeom prst="ellipse">
+            <a:avLst/>
+          </a:prstGeom>
+          <a:solidFill>
+            <a:srgbClr val="3568A8"/>
+          </a:solidFill>
+          <a:ln>
+            <a:noFill/>
+          </a:ln>
+        </p:spPr>
+        <p:style>
+          <a:lnRef idx="1">
+            <a:schemeClr val="accent1"/>
+          </a:lnRef>
+          <a:fillRef idx="3">
+            <a:schemeClr val="accent1"/>
+          </a:fillRef>
+          <a:effectRef idx="2">
+            <a:schemeClr val="accent1"/>
+          </a:effectRef>
+          <a:fontRef idx="minor">
+            <a:schemeClr val="lt1"/>
+          </a:fontRef>
+        </p:style>
+        <p:txBody>
+          <a:bodyPr rtlCol="0" anchor="ctr"/>
+          <a:lstStyle/>
+          <a:p>
+            <a:pPr algn="ctr"/>
+          </a:p>
+        </p:txBody>
+      </p:sp>
+      <p:sp>
+        <p:nvSpPr>
+          <p:cNvPr id="12" name="TextBox 11"/>
+          <p:cNvSpPr txBox="1"/>
+          <p:nvPr/>
+        </p:nvSpPr>
+        <p:spPr>
+          <a:xfrm>
+            <a:off x="5586984" y="2139696"/>
+            <a:ext cx="502920" cy="256032"/>
+          </a:xfrm>
+          <a:prstGeom prst="rect">
+            <a:avLst/>
+          </a:prstGeom>
+          <a:noFill/>
+        </p:spPr>
+        <p:txBody>
+          <a:bodyPr wrap="square" lIns="0" rIns="0" tIns="0" bIns="0" anchor="ctr">
+            <a:spAutoFit/>
+          </a:bodyPr>
+          <a:lstStyle/>
+          <a:p>
+            <a:pPr algn="l">
+              <a:spcBef>
+                <a:spcPts val="0"/>
+              </a:spcBef>
+              <a:spcAft>
+                <a:spcPts val="0"/>
+              </a:spcAft>
+            </a:pPr>
+            <a:r>
+              <a:rPr sz="950" b="0">
+                <a:solidFill>
+                  <a:srgbClr val="62748A"/>
+                </a:solidFill>
+                <a:latin typeface="Microsoft YaHei"/>
+              </a:rPr>
+              <a:t>中国</a:t>
+            </a:r>
+          </a:p>
+        </p:txBody>
+      </p:sp>
+      <p:sp>
+        <p:nvSpPr>
+          <p:cNvPr id="13" name="Oval 12"/>
+          <p:cNvSpPr/>
+          <p:nvPr/>
+        </p:nvSpPr>
+        <p:spPr>
+          <a:xfrm>
+            <a:off x="6272784" y="2221992"/>
+            <a:ext cx="109728" cy="109728"/>
+          </a:xfrm>
+          <a:prstGeom prst="ellipse">
+            <a:avLst/>
+          </a:prstGeom>
+          <a:solidFill>
+            <a:srgbClr val="E38B36"/>
+          </a:solidFill>
+          <a:ln>
+            <a:noFill/>
+          </a:ln>
+        </p:spPr>
+        <p:style>
+          <a:lnRef idx="1">
+            <a:schemeClr val="accent1"/>
+          </a:lnRef>
+          <a:fillRef idx="3">
+            <a:schemeClr val="accent1"/>
+          </a:fillRef>
+          <a:effectRef idx="2">
+            <a:schemeClr val="accent1"/>
+          </a:effectRef>
+          <a:fontRef idx="minor">
+            <a:schemeClr val="lt1"/>
+          </a:fontRef>
+        </p:style>
+        <p:txBody>
+          <a:bodyPr rtlCol="0" anchor="ctr"/>
+          <a:lstStyle/>
+          <a:p>
+            <a:pPr algn="ctr"/>
+          </a:p>
+        </p:txBody>
+      </p:sp>
+      <p:sp>
+        <p:nvSpPr>
+          <p:cNvPr id="14" name="TextBox 13"/>
+          <p:cNvSpPr txBox="1"/>
+          <p:nvPr/>
+        </p:nvSpPr>
+        <p:spPr>
+          <a:xfrm>
+            <a:off x="6446520" y="2139696"/>
+            <a:ext cx="502920" cy="256032"/>
+          </a:xfrm>
+          <a:prstGeom prst="rect">
+            <a:avLst/>
+          </a:prstGeom>
+          <a:noFill/>
+        </p:spPr>
+        <p:txBody>
+          <a:bodyPr wrap="square" lIns="0" rIns="0" tIns="0" bIns="0" anchor="ctr">
+            <a:spAutoFit/>
+          </a:bodyPr>
+          <a:lstStyle/>
+          <a:p>
+            <a:pPr algn="l">
+              <a:spcBef>
+                <a:spcPts val="0"/>
+              </a:spcBef>
+              <a:spcAft>
+                <a:spcPts val="0"/>
+              </a:spcAft>
+            </a:pPr>
+            <a:r>
+              <a:rPr sz="950" b="0">
+                <a:solidFill>
+                  <a:srgbClr val="62748A"/>
+                </a:solidFill>
+                <a:latin typeface="Microsoft YaHei"/>
+              </a:rPr>
+              <a:t>美国</a:t>
+            </a:r>
+          </a:p>
+        </p:txBody>
+      </p:sp>
+      <p:sp>
+        <p:nvSpPr>
+          <p:cNvPr id="15" name="Rounded Rectangle 14"/>
+          <p:cNvSpPr/>
+          <p:nvPr/>
+        </p:nvSpPr>
+        <p:spPr>
+          <a:xfrm>
+            <a:off x="914400" y="3767328"/>
+            <a:ext cx="6537960" cy="256032"/>
+          </a:xfrm>
+          <a:prstGeom prst="roundRect">
+            <a:avLst/>
+          </a:prstGeom>
+          <a:solidFill>
+            <a:srgbClr val="EAF1F8"/>
+          </a:solidFill>
+          <a:ln>
+            <a:noFill/>
+          </a:ln>
+        </p:spPr>
+        <p:style>
+          <a:lnRef idx="1">
+            <a:schemeClr val="accent1"/>
+          </a:lnRef>
+          <a:fillRef idx="3">
+            <a:schemeClr val="accent1"/>
+          </a:fillRef>
+          <a:effectRef idx="2">
+            <a:schemeClr val="accent1"/>
+          </a:effectRef>
+          <a:fontRef idx="minor">
+            <a:schemeClr val="lt1"/>
+          </a:fontRef>
+        </p:style>
+        <p:txBody>
+          <a:bodyPr rtlCol="0" anchor="ctr"/>
+          <a:lstStyle/>
+          <a:p>
+            <a:pPr algn="ctr"/>
+          </a:p>
+        </p:txBody>
+      </p:sp>
+      <p:cxnSp>
+        <p:nvCxnSpPr>
+          <p:cNvPr id="16" name="Connector 15"/>
+          <p:cNvCxnSpPr/>
+          <p:nvPr/>
+        </p:nvCxnSpPr>
+        <p:spPr>
+          <a:xfrm>
+            <a:off x="1389888" y="2633472"/>
+            <a:ext cx="0" cy="2852928"/>
+          </a:xfrm>
+          <a:prstGeom prst="line">
+            <a:avLst/>
+          </a:prstGeom>
+          <a:ln w="6350">
+            <a:solidFill>
+              <a:srgbClr val="D8E1EB"/>
+            </a:solidFill>
+          </a:ln>
+        </p:spPr>
+        <p:style>
+          <a:lnRef idx="2">
+            <a:schemeClr val="accent1"/>
+          </a:lnRef>
+          <a:fillRef idx="0">
+            <a:schemeClr val="accent1"/>
+          </a:fillRef>
+          <a:effectRef idx="1">
+            <a:schemeClr val="accent1"/>
+          </a:effectRef>
+          <a:fontRef idx="minor">
+            <a:schemeClr val="tx1"/>
+          </a:fontRef>
+        </p:style>
+      </p:cxnSp>
+      <p:sp>
+        <p:nvSpPr>
+          <p:cNvPr id="17" name="TextBox 16"/>
+          <p:cNvSpPr txBox="1"/>
+          <p:nvPr/>
+        </p:nvSpPr>
+        <p:spPr>
+          <a:xfrm>
+            <a:off x="1188720" y="2414016"/>
+            <a:ext cx="402336" cy="182880"/>
+          </a:xfrm>
+          <a:prstGeom prst="rect">
+            <a:avLst/>
+          </a:prstGeom>
+          <a:noFill/>
+        </p:spPr>
+        <p:txBody>
+          <a:bodyPr wrap="square" lIns="0" rIns="0" tIns="0" bIns="0" anchor="t">
+            <a:spAutoFit/>
+          </a:bodyPr>
+          <a:lstStyle/>
+          <a:p>
+            <a:pPr algn="ctr">
+              <a:spcBef>
+                <a:spcPts val="0"/>
+              </a:spcBef>
+              <a:spcAft>
+                <a:spcPts val="0"/>
+              </a:spcAft>
+            </a:pPr>
+            <a:r>
+              <a:rPr sz="800" b="0">
+                <a:solidFill>
+                  <a:srgbClr val="62748A"/>
+                </a:solidFill>
+                <a:latin typeface="Microsoft YaHei"/>
+              </a:rPr>
+              <a:t>0</a:t>
+            </a:r>
+          </a:p>
+        </p:txBody>
+      </p:sp>
+      <p:cxnSp>
+        <p:nvCxnSpPr>
+          <p:cNvPr id="18" name="Connector 17"/>
+          <p:cNvCxnSpPr/>
+          <p:nvPr/>
+        </p:nvCxnSpPr>
+        <p:spPr>
+          <a:xfrm>
+            <a:off x="2543278" y="2633472"/>
+            <a:ext cx="0" cy="2852928"/>
+          </a:xfrm>
+          <a:prstGeom prst="line">
+            <a:avLst/>
+          </a:prstGeom>
+          <a:ln w="6350">
+            <a:solidFill>
+              <a:srgbClr val="D8E1EB"/>
+            </a:solidFill>
+          </a:ln>
+        </p:spPr>
+        <p:style>
+          <a:lnRef idx="2">
+            <a:schemeClr val="accent1"/>
+          </a:lnRef>
+          <a:fillRef idx="0">
+            <a:schemeClr val="accent1"/>
+          </a:fillRef>
+          <a:effectRef idx="1">
+            <a:schemeClr val="accent1"/>
+          </a:effectRef>
+          <a:fontRef idx="minor">
+            <a:schemeClr val="tx1"/>
+          </a:fontRef>
+        </p:style>
+      </p:cxnSp>
+      <p:sp>
+        <p:nvSpPr>
+          <p:cNvPr id="19" name="TextBox 18"/>
+          <p:cNvSpPr txBox="1"/>
+          <p:nvPr/>
+        </p:nvSpPr>
+        <p:spPr>
+          <a:xfrm>
+            <a:off x="2342110" y="2414016"/>
+            <a:ext cx="402336" cy="182880"/>
+          </a:xfrm>
+          <a:prstGeom prst="rect">
+            <a:avLst/>
+          </a:prstGeom>
+          <a:noFill/>
+        </p:spPr>
+        <p:txBody>
+          <a:bodyPr wrap="square" lIns="0" rIns="0" tIns="0" bIns="0" anchor="t">
+            <a:spAutoFit/>
+          </a:bodyPr>
+          <a:lstStyle/>
+          <a:p>
+            <a:pPr algn="ctr">
+              <a:spcBef>
+                <a:spcPts val="0"/>
+              </a:spcBef>
+              <a:spcAft>
+                <a:spcPts val="0"/>
+              </a:spcAft>
+            </a:pPr>
+            <a:r>
+              <a:rPr sz="800" b="0">
+                <a:solidFill>
+                  <a:srgbClr val="62748A"/>
+                </a:solidFill>
+                <a:latin typeface="Microsoft YaHei"/>
+              </a:rPr>
+              <a:t>5</a:t>
+            </a:r>
+          </a:p>
+        </p:txBody>
+      </p:sp>
+      <p:cxnSp>
+        <p:nvCxnSpPr>
+          <p:cNvPr id="20" name="Connector 19"/>
+          <p:cNvCxnSpPr/>
+          <p:nvPr/>
+        </p:nvCxnSpPr>
+        <p:spPr>
+          <a:xfrm>
+            <a:off x="3696669" y="2633472"/>
+            <a:ext cx="0" cy="2852928"/>
+          </a:xfrm>
+          <a:prstGeom prst="line">
+            <a:avLst/>
+          </a:prstGeom>
+          <a:ln w="6350">
+            <a:solidFill>
+              <a:srgbClr val="D8E1EB"/>
+            </a:solidFill>
+          </a:ln>
+        </p:spPr>
+        <p:style>
+          <a:lnRef idx="2">
+            <a:schemeClr val="accent1"/>
+          </a:lnRef>
+          <a:fillRef idx="0">
+            <a:schemeClr val="accent1"/>
+          </a:fillRef>
+          <a:effectRef idx="1">
+            <a:schemeClr val="accent1"/>
+          </a:effectRef>
+          <a:fontRef idx="minor">
+            <a:schemeClr val="tx1"/>
+          </a:fontRef>
+        </p:style>
+      </p:cxnSp>
+      <p:sp>
+        <p:nvSpPr>
+          <p:cNvPr id="21" name="TextBox 20"/>
+          <p:cNvSpPr txBox="1"/>
+          <p:nvPr/>
+        </p:nvSpPr>
+        <p:spPr>
+          <a:xfrm>
+            <a:off x="3495501" y="2414016"/>
+            <a:ext cx="402336" cy="182880"/>
+          </a:xfrm>
+          <a:prstGeom prst="rect">
+            <a:avLst/>
+          </a:prstGeom>
+          <a:noFill/>
+        </p:spPr>
+        <p:txBody>
+          <a:bodyPr wrap="square" lIns="0" rIns="0" tIns="0" bIns="0" anchor="t">
+            <a:spAutoFit/>
+          </a:bodyPr>
+          <a:lstStyle/>
+          <a:p>
+            <a:pPr algn="ctr">
+              <a:spcBef>
+                <a:spcPts val="0"/>
+              </a:spcBef>
+              <a:spcAft>
+                <a:spcPts val="0"/>
+              </a:spcAft>
+            </a:pPr>
+            <a:r>
+              <a:rPr sz="800" b="0">
+                <a:solidFill>
+                  <a:srgbClr val="62748A"/>
+                </a:solidFill>
+                <a:latin typeface="Microsoft YaHei"/>
+              </a:rPr>
+              <a:t>10</a:t>
+            </a:r>
+          </a:p>
+        </p:txBody>
+      </p:sp>
+      <p:cxnSp>
+        <p:nvCxnSpPr>
+          <p:cNvPr id="22" name="Connector 21"/>
+          <p:cNvCxnSpPr/>
+          <p:nvPr/>
+        </p:nvCxnSpPr>
+        <p:spPr>
+          <a:xfrm>
+            <a:off x="4850060" y="2633472"/>
+            <a:ext cx="0" cy="2852928"/>
+          </a:xfrm>
+          <a:prstGeom prst="line">
+            <a:avLst/>
+          </a:prstGeom>
+          <a:ln w="6350">
+            <a:solidFill>
+              <a:srgbClr val="D8E1EB"/>
+            </a:solidFill>
+          </a:ln>
+        </p:spPr>
+        <p:style>
+          <a:lnRef idx="2">
+            <a:schemeClr val="accent1"/>
+          </a:lnRef>
+          <a:fillRef idx="0">
+            <a:schemeClr val="accent1"/>
+          </a:fillRef>
+          <a:effectRef idx="1">
+            <a:schemeClr val="accent1"/>
+          </a:effectRef>
+          <a:fontRef idx="minor">
+            <a:schemeClr val="tx1"/>
+          </a:fontRef>
+        </p:style>
+      </p:cxnSp>
+      <p:sp>
+        <p:nvSpPr>
+          <p:cNvPr id="23" name="TextBox 22"/>
+          <p:cNvSpPr txBox="1"/>
+          <p:nvPr/>
+        </p:nvSpPr>
+        <p:spPr>
+          <a:xfrm>
+            <a:off x="4648892" y="2414016"/>
+            <a:ext cx="402336" cy="182880"/>
+          </a:xfrm>
+          <a:prstGeom prst="rect">
+            <a:avLst/>
+          </a:prstGeom>
+          <a:noFill/>
+        </p:spPr>
+        <p:txBody>
+          <a:bodyPr wrap="square" lIns="0" rIns="0" tIns="0" bIns="0" anchor="t">
+            <a:spAutoFit/>
+          </a:bodyPr>
+          <a:lstStyle/>
+          <a:p>
+            <a:pPr algn="ctr">
+              <a:spcBef>
+                <a:spcPts val="0"/>
+              </a:spcBef>
+              <a:spcAft>
+                <a:spcPts val="0"/>
+              </a:spcAft>
+            </a:pPr>
+            <a:r>
+              <a:rPr sz="800" b="0">
+                <a:solidFill>
+                  <a:srgbClr val="62748A"/>
+                </a:solidFill>
+                <a:latin typeface="Microsoft YaHei"/>
+              </a:rPr>
+              <a:t>15</a:t>
+            </a:r>
+          </a:p>
+        </p:txBody>
+      </p:sp>
+      <p:cxnSp>
+        <p:nvCxnSpPr>
+          <p:cNvPr id="24" name="Connector 23"/>
+          <p:cNvCxnSpPr/>
+          <p:nvPr/>
+        </p:nvCxnSpPr>
+        <p:spPr>
+          <a:xfrm>
+            <a:off x="6003451" y="2633472"/>
+            <a:ext cx="0" cy="2852928"/>
+          </a:xfrm>
+          <a:prstGeom prst="line">
+            <a:avLst/>
+          </a:prstGeom>
+          <a:ln w="6350">
+            <a:solidFill>
+              <a:srgbClr val="D8E1EB"/>
+            </a:solidFill>
+          </a:ln>
+        </p:spPr>
+        <p:style>
+          <a:lnRef idx="2">
+            <a:schemeClr val="accent1"/>
+          </a:lnRef>
+          <a:fillRef idx="0">
+            <a:schemeClr val="accent1"/>
+          </a:fillRef>
+          <a:effectRef idx="1">
+            <a:schemeClr val="accent1"/>
+          </a:effectRef>
+          <a:fontRef idx="minor">
+            <a:schemeClr val="tx1"/>
+          </a:fontRef>
+        </p:style>
+      </p:cxnSp>
+      <p:sp>
+        <p:nvSpPr>
+          <p:cNvPr id="25" name="TextBox 24"/>
+          <p:cNvSpPr txBox="1"/>
+          <p:nvPr/>
+        </p:nvSpPr>
+        <p:spPr>
+          <a:xfrm>
+            <a:off x="5802283" y="2414016"/>
+            <a:ext cx="402336" cy="182880"/>
+          </a:xfrm>
+          <a:prstGeom prst="rect">
+            <a:avLst/>
+          </a:prstGeom>
+          <a:noFill/>
+        </p:spPr>
+        <p:txBody>
+          <a:bodyPr wrap="square" lIns="0" rIns="0" tIns="0" bIns="0" anchor="t">
+            <a:spAutoFit/>
+          </a:bodyPr>
+          <a:lstStyle/>
+          <a:p>
+            <a:pPr algn="ctr">
+              <a:spcBef>
+                <a:spcPts val="0"/>
+              </a:spcBef>
+              <a:spcAft>
+                <a:spcPts val="0"/>
+              </a:spcAft>
+            </a:pPr>
+            <a:r>
+              <a:rPr sz="800" b="0">
+                <a:solidFill>
+                  <a:srgbClr val="62748A"/>
+                </a:solidFill>
+                <a:latin typeface="Microsoft YaHei"/>
+              </a:rPr>
+              <a:t>20</a:t>
+            </a:r>
+          </a:p>
+        </p:txBody>
+      </p:sp>
+      <p:sp>
+        <p:nvSpPr>
+          <p:cNvPr id="26" name="TextBox 25"/>
+          <p:cNvSpPr txBox="1"/>
+          <p:nvPr/>
+        </p:nvSpPr>
+        <p:spPr>
+          <a:xfrm>
+            <a:off x="932688" y="2702052"/>
+            <a:ext cx="365760" cy="210312"/>
+          </a:xfrm>
+          <a:prstGeom prst="rect">
+            <a:avLst/>
+          </a:prstGeom>
+          <a:noFill/>
+        </p:spPr>
+        <p:txBody>
+          <a:bodyPr wrap="square" lIns="0" rIns="0" tIns="0" bIns="0" anchor="ctr">
+            <a:spAutoFit/>
+          </a:bodyPr>
+          <a:lstStyle/>
+          <a:p>
+            <a:pPr algn="l">
+              <a:spcBef>
+                <a:spcPts val="0"/>
+              </a:spcBef>
+              <a:spcAft>
+                <a:spcPts val="0"/>
+              </a:spcAft>
+            </a:pPr>
+            <a:r>
+              <a:rPr sz="850" b="1">
+                <a:solidFill>
+                  <a:srgbClr val="23364A"/>
+                </a:solidFill>
+                <a:latin typeface="Microsoft YaHei"/>
+              </a:rPr>
+              <a:t>M01</a:t>
+            </a:r>
+          </a:p>
+        </p:txBody>
+      </p:sp>
+      <p:cxnSp>
+        <p:nvCxnSpPr>
+          <p:cNvPr id="27" name="Connector 26"/>
+          <p:cNvCxnSpPr/>
+          <p:nvPr/>
+        </p:nvCxnSpPr>
+        <p:spPr>
+          <a:xfrm>
+            <a:off x="2871418" y="2807208"/>
+            <a:ext cx="141360" cy="0"/>
+          </a:xfrm>
+          <a:prstGeom prst="line">
+            <a:avLst/>
+          </a:prstGeom>
+          <a:ln w="15240">
+            <a:solidFill>
+              <a:srgbClr val="D8E1EB"/>
+            </a:solidFill>
+          </a:ln>
+        </p:spPr>
+        <p:style>
+          <a:lnRef idx="2">
+            <a:schemeClr val="accent1"/>
+          </a:lnRef>
+          <a:fillRef idx="0">
+            <a:schemeClr val="accent1"/>
+          </a:fillRef>
+          <a:effectRef idx="1">
+            <a:schemeClr val="accent1"/>
+          </a:effectRef>
+          <a:fontRef idx="minor">
+            <a:schemeClr val="tx1"/>
+          </a:fontRef>
+        </p:style>
+      </p:cxnSp>
+      <p:sp>
+        <p:nvSpPr>
+          <p:cNvPr id="28" name="Oval 27"/>
+          <p:cNvSpPr/>
+          <p:nvPr/>
+        </p:nvSpPr>
+        <p:spPr>
+          <a:xfrm>
+            <a:off x="2811982" y="2747772"/>
+            <a:ext cx="118872" cy="118872"/>
+          </a:xfrm>
+          <a:prstGeom prst="ellipse">
+            <a:avLst/>
+          </a:prstGeom>
+          <a:solidFill>
+            <a:srgbClr val="3568A8"/>
+          </a:solidFill>
+          <a:ln>
+            <a:noFill/>
+          </a:ln>
+        </p:spPr>
+        <p:style>
+          <a:lnRef idx="1">
+            <a:schemeClr val="accent1"/>
+          </a:lnRef>
+          <a:fillRef idx="3">
+            <a:schemeClr val="accent1"/>
+          </a:fillRef>
+          <a:effectRef idx="2">
+            <a:schemeClr val="accent1"/>
+          </a:effectRef>
+          <a:fontRef idx="minor">
+            <a:schemeClr val="lt1"/>
+          </a:fontRef>
+        </p:style>
+        <p:txBody>
+          <a:bodyPr rtlCol="0" anchor="ctr"/>
+          <a:lstStyle/>
+          <a:p>
+            <a:pPr algn="ctr"/>
+          </a:p>
+        </p:txBody>
+      </p:sp>
+      <p:sp>
+        <p:nvSpPr>
+          <p:cNvPr id="29" name="Oval 28"/>
+          <p:cNvSpPr/>
+          <p:nvPr/>
+        </p:nvSpPr>
+        <p:spPr>
+          <a:xfrm>
+            <a:off x="2953342" y="2747772"/>
+            <a:ext cx="118872" cy="118872"/>
+          </a:xfrm>
+          <a:prstGeom prst="ellipse">
+            <a:avLst/>
+          </a:prstGeom>
+          <a:solidFill>
+            <a:srgbClr val="E38B36"/>
+          </a:solidFill>
+          <a:ln>
+            <a:noFill/>
+          </a:ln>
+        </p:spPr>
+        <p:style>
+          <a:lnRef idx="1">
+            <a:schemeClr val="accent1"/>
+          </a:lnRef>
+          <a:fillRef idx="3">
+            <a:schemeClr val="accent1"/>
+          </a:fillRef>
+          <a:effectRef idx="2">
+            <a:schemeClr val="accent1"/>
+          </a:effectRef>
+          <a:fontRef idx="minor">
+            <a:schemeClr val="lt1"/>
+          </a:fontRef>
+        </p:style>
+        <p:txBody>
+          <a:bodyPr rtlCol="0" anchor="ctr"/>
+          <a:lstStyle/>
+          <a:p>
+            <a:pPr algn="ctr"/>
+          </a:p>
+        </p:txBody>
+      </p:sp>
+      <p:sp>
+        <p:nvSpPr>
+          <p:cNvPr id="30" name="TextBox 29"/>
+          <p:cNvSpPr txBox="1"/>
+          <p:nvPr/>
+        </p:nvSpPr>
+        <p:spPr>
+          <a:xfrm>
+            <a:off x="932688" y="2976372"/>
+            <a:ext cx="365760" cy="210312"/>
+          </a:xfrm>
+          <a:prstGeom prst="rect">
+            <a:avLst/>
+          </a:prstGeom>
+          <a:noFill/>
+        </p:spPr>
+        <p:txBody>
+          <a:bodyPr wrap="square" lIns="0" rIns="0" tIns="0" bIns="0" anchor="ctr">
+            <a:spAutoFit/>
+          </a:bodyPr>
+          <a:lstStyle/>
+          <a:p>
+            <a:pPr algn="l">
+              <a:spcBef>
+                <a:spcPts val="0"/>
+              </a:spcBef>
+              <a:spcAft>
+                <a:spcPts val="0"/>
+              </a:spcAft>
+            </a:pPr>
+            <a:r>
+              <a:rPr sz="850" b="1">
+                <a:solidFill>
+                  <a:srgbClr val="23364A"/>
+                </a:solidFill>
+                <a:latin typeface="Microsoft YaHei"/>
+              </a:rPr>
+              <a:t>M02</a:t>
+            </a:r>
+          </a:p>
+        </p:txBody>
+      </p:sp>
+      <p:cxnSp>
+        <p:nvCxnSpPr>
+          <p:cNvPr id="31" name="Connector 30"/>
+          <p:cNvCxnSpPr/>
+          <p:nvPr/>
+        </p:nvCxnSpPr>
+        <p:spPr>
+          <a:xfrm flipH="1">
+            <a:off x="2728951" y="3081528"/>
+            <a:ext cx="731850" cy="0"/>
+          </a:xfrm>
+          <a:prstGeom prst="line">
+            <a:avLst/>
+          </a:prstGeom>
+          <a:ln w="15240">
+            <a:solidFill>
+              <a:srgbClr val="D8E1EB"/>
+            </a:solidFill>
+          </a:ln>
+        </p:spPr>
+        <p:style>
+          <a:lnRef idx="2">
+            <a:schemeClr val="accent1"/>
+          </a:lnRef>
+          <a:fillRef idx="0">
+            <a:schemeClr val="accent1"/>
+          </a:fillRef>
+          <a:effectRef idx="1">
+            <a:schemeClr val="accent1"/>
+          </a:effectRef>
+          <a:fontRef idx="minor">
+            <a:schemeClr val="tx1"/>
+          </a:fontRef>
+        </p:style>
+      </p:cxnSp>
+      <p:sp>
+        <p:nvSpPr>
+          <p:cNvPr id="32" name="Oval 31"/>
+          <p:cNvSpPr/>
+          <p:nvPr/>
+        </p:nvSpPr>
+        <p:spPr>
+          <a:xfrm>
+            <a:off x="3401365" y="3022092"/>
+            <a:ext cx="118872" cy="118872"/>
+          </a:xfrm>
+          <a:prstGeom prst="ellipse">
+            <a:avLst/>
+          </a:prstGeom>
+          <a:solidFill>
+            <a:srgbClr val="3568A8"/>
+          </a:solidFill>
+          <a:ln>
+            <a:noFill/>
+          </a:ln>
+        </p:spPr>
+        <p:style>
+          <a:lnRef idx="1">
+            <a:schemeClr val="accent1"/>
+          </a:lnRef>
+          <a:fillRef idx="3">
+            <a:schemeClr val="accent1"/>
+          </a:fillRef>
+          <a:effectRef idx="2">
+            <a:schemeClr val="accent1"/>
+          </a:effectRef>
+          <a:fontRef idx="minor">
+            <a:schemeClr val="lt1"/>
+          </a:fontRef>
+        </p:style>
+        <p:txBody>
+          <a:bodyPr rtlCol="0" anchor="ctr"/>
+          <a:lstStyle/>
+          <a:p>
+            <a:pPr algn="ctr"/>
+          </a:p>
+        </p:txBody>
+      </p:sp>
+      <p:sp>
+        <p:nvSpPr>
+          <p:cNvPr id="33" name="Oval 32"/>
+          <p:cNvSpPr/>
+          <p:nvPr/>
+        </p:nvSpPr>
+        <p:spPr>
+          <a:xfrm>
+            <a:off x="2669515" y="3022092"/>
+            <a:ext cx="118872" cy="118872"/>
+          </a:xfrm>
+          <a:prstGeom prst="ellipse">
+            <a:avLst/>
+          </a:prstGeom>
+          <a:solidFill>
+            <a:srgbClr val="E38B36"/>
+          </a:solidFill>
+          <a:ln>
+            <a:noFill/>
+          </a:ln>
+        </p:spPr>
+        <p:style>
+          <a:lnRef idx="1">
+            <a:schemeClr val="accent1"/>
+          </a:lnRef>
+          <a:fillRef idx="3">
+            <a:schemeClr val="accent1"/>
+          </a:fillRef>
+          <a:effectRef idx="2">
+            <a:schemeClr val="accent1"/>
+          </a:effectRef>
+          <a:fontRef idx="minor">
+            <a:schemeClr val="lt1"/>
+          </a:fontRef>
+        </p:style>
+        <p:txBody>
+          <a:bodyPr rtlCol="0" anchor="ctr"/>
+          <a:lstStyle/>
+          <a:p>
+            <a:pPr algn="ctr"/>
+          </a:p>
+        </p:txBody>
+      </p:sp>
+      <p:sp>
+        <p:nvSpPr>
+          <p:cNvPr id="34" name="TextBox 33"/>
+          <p:cNvSpPr txBox="1"/>
+          <p:nvPr/>
+        </p:nvSpPr>
+        <p:spPr>
+          <a:xfrm>
+            <a:off x="932688" y="3250692"/>
+            <a:ext cx="365760" cy="210312"/>
+          </a:xfrm>
+          <a:prstGeom prst="rect">
+            <a:avLst/>
+          </a:prstGeom>
+          <a:noFill/>
+        </p:spPr>
+        <p:txBody>
+          <a:bodyPr wrap="square" lIns="0" rIns="0" tIns="0" bIns="0" anchor="ctr">
+            <a:spAutoFit/>
+          </a:bodyPr>
+          <a:lstStyle/>
+          <a:p>
+            <a:pPr algn="l">
+              <a:spcBef>
+                <a:spcPts val="0"/>
+              </a:spcBef>
+              <a:spcAft>
+                <a:spcPts val="0"/>
+              </a:spcAft>
+            </a:pPr>
+            <a:r>
+              <a:rPr sz="850" b="1">
+                <a:solidFill>
+                  <a:srgbClr val="23364A"/>
+                </a:solidFill>
+                <a:latin typeface="Microsoft YaHei"/>
+              </a:rPr>
+              <a:t>M03</a:t>
+            </a:r>
+          </a:p>
+        </p:txBody>
+      </p:sp>
+      <p:cxnSp>
+        <p:nvCxnSpPr>
+          <p:cNvPr id="35" name="Connector 34"/>
+          <p:cNvCxnSpPr/>
+          <p:nvPr/>
+        </p:nvCxnSpPr>
+        <p:spPr>
+          <a:xfrm>
+            <a:off x="2017240" y="3355848"/>
+            <a:ext cx="235476" cy="0"/>
+          </a:xfrm>
+          <a:prstGeom prst="line">
+            <a:avLst/>
+          </a:prstGeom>
+          <a:ln w="15240">
+            <a:solidFill>
+              <a:srgbClr val="D8E1EB"/>
+            </a:solidFill>
+          </a:ln>
+        </p:spPr>
+        <p:style>
+          <a:lnRef idx="2">
+            <a:schemeClr val="accent1"/>
+          </a:lnRef>
+          <a:fillRef idx="0">
+            <a:schemeClr val="accent1"/>
+          </a:fillRef>
+          <a:effectRef idx="1">
+            <a:schemeClr val="accent1"/>
+          </a:effectRef>
+          <a:fontRef idx="minor">
+            <a:schemeClr val="tx1"/>
+          </a:fontRef>
+        </p:style>
+      </p:cxnSp>
+      <p:sp>
+        <p:nvSpPr>
+          <p:cNvPr id="36" name="Oval 35"/>
+          <p:cNvSpPr/>
+          <p:nvPr/>
+        </p:nvSpPr>
+        <p:spPr>
+          <a:xfrm>
+            <a:off x="1957804" y="3296412"/>
+            <a:ext cx="118872" cy="118872"/>
+          </a:xfrm>
+          <a:prstGeom prst="ellipse">
+            <a:avLst/>
+          </a:prstGeom>
+          <a:solidFill>
+            <a:srgbClr val="3568A8"/>
+          </a:solidFill>
+          <a:ln>
+            <a:noFill/>
+          </a:ln>
+        </p:spPr>
+        <p:style>
+          <a:lnRef idx="1">
+            <a:schemeClr val="accent1"/>
+          </a:lnRef>
+          <a:fillRef idx="3">
+            <a:schemeClr val="accent1"/>
+          </a:fillRef>
+          <a:effectRef idx="2">
+            <a:schemeClr val="accent1"/>
+          </a:effectRef>
+          <a:fontRef idx="minor">
+            <a:schemeClr val="lt1"/>
+          </a:fontRef>
+        </p:style>
+        <p:txBody>
+          <a:bodyPr rtlCol="0" anchor="ctr"/>
+          <a:lstStyle/>
+          <a:p>
+            <a:pPr algn="ctr"/>
+          </a:p>
+        </p:txBody>
+      </p:sp>
+      <p:sp>
+        <p:nvSpPr>
+          <p:cNvPr id="37" name="Oval 36"/>
+          <p:cNvSpPr/>
+          <p:nvPr/>
+        </p:nvSpPr>
+        <p:spPr>
+          <a:xfrm>
+            <a:off x="2193280" y="3296412"/>
+            <a:ext cx="118872" cy="118872"/>
+          </a:xfrm>
+          <a:prstGeom prst="ellipse">
+            <a:avLst/>
+          </a:prstGeom>
+          <a:solidFill>
+            <a:srgbClr val="E38B36"/>
+          </a:solidFill>
+          <a:ln>
+            <a:noFill/>
+          </a:ln>
+        </p:spPr>
+        <p:style>
+          <a:lnRef idx="1">
+            <a:schemeClr val="accent1"/>
+          </a:lnRef>
+          <a:fillRef idx="3">
+            <a:schemeClr val="accent1"/>
+          </a:fillRef>
+          <a:effectRef idx="2">
+            <a:schemeClr val="accent1"/>
+          </a:effectRef>
+          <a:fontRef idx="minor">
+            <a:schemeClr val="lt1"/>
+          </a:fontRef>
+        </p:style>
+        <p:txBody>
+          <a:bodyPr rtlCol="0" anchor="ctr"/>
+          <a:lstStyle/>
+          <a:p>
+            <a:pPr algn="ctr"/>
+          </a:p>
+        </p:txBody>
+      </p:sp>
+      <p:sp>
+        <p:nvSpPr>
+          <p:cNvPr id="38" name="TextBox 37"/>
+          <p:cNvSpPr txBox="1"/>
+          <p:nvPr/>
+        </p:nvSpPr>
+        <p:spPr>
+          <a:xfrm>
+            <a:off x="932688" y="3525012"/>
+            <a:ext cx="365760" cy="210312"/>
+          </a:xfrm>
+          <a:prstGeom prst="rect">
+            <a:avLst/>
+          </a:prstGeom>
+          <a:noFill/>
+        </p:spPr>
+        <p:txBody>
+          <a:bodyPr wrap="square" lIns="0" rIns="0" tIns="0" bIns="0" anchor="ctr">
+            <a:spAutoFit/>
+          </a:bodyPr>
+          <a:lstStyle/>
+          <a:p>
+            <a:pPr algn="l">
+              <a:spcBef>
+                <a:spcPts val="0"/>
+              </a:spcBef>
+              <a:spcAft>
+                <a:spcPts val="0"/>
+              </a:spcAft>
+            </a:pPr>
+            <a:r>
+              <a:rPr sz="850" b="1">
+                <a:solidFill>
+                  <a:srgbClr val="23364A"/>
+                </a:solidFill>
+                <a:latin typeface="Microsoft YaHei"/>
+              </a:rPr>
+              <a:t>M04</a:t>
+            </a:r>
+          </a:p>
+        </p:txBody>
+      </p:sp>
+      <p:cxnSp>
+        <p:nvCxnSpPr>
+          <p:cNvPr id="39" name="Connector 38"/>
+          <p:cNvCxnSpPr/>
+          <p:nvPr/>
+        </p:nvCxnSpPr>
+        <p:spPr>
+          <a:xfrm>
+            <a:off x="4214588" y="3630168"/>
+            <a:ext cx="1421139" cy="0"/>
+          </a:xfrm>
+          <a:prstGeom prst="line">
+            <a:avLst/>
+          </a:prstGeom>
+          <a:ln w="15240">
+            <a:solidFill>
+              <a:srgbClr val="D8E1EB"/>
+            </a:solidFill>
+          </a:ln>
+        </p:spPr>
+        <p:style>
+          <a:lnRef idx="2">
+            <a:schemeClr val="accent1"/>
+          </a:lnRef>
+          <a:fillRef idx="0">
+            <a:schemeClr val="accent1"/>
+          </a:fillRef>
+          <a:effectRef idx="1">
+            <a:schemeClr val="accent1"/>
+          </a:effectRef>
+          <a:fontRef idx="minor">
+            <a:schemeClr val="tx1"/>
+          </a:fontRef>
+        </p:style>
+      </p:cxnSp>
+      <p:sp>
+        <p:nvSpPr>
+          <p:cNvPr id="40" name="Oval 39"/>
+          <p:cNvSpPr/>
+          <p:nvPr/>
+        </p:nvSpPr>
+        <p:spPr>
+          <a:xfrm>
+            <a:off x="4155152" y="3570732"/>
+            <a:ext cx="118872" cy="118872"/>
+          </a:xfrm>
+          <a:prstGeom prst="ellipse">
+            <a:avLst/>
+          </a:prstGeom>
+          <a:solidFill>
+            <a:srgbClr val="3568A8"/>
+          </a:solidFill>
+          <a:ln>
+            <a:noFill/>
+          </a:ln>
+        </p:spPr>
+        <p:style>
+          <a:lnRef idx="1">
+            <a:schemeClr val="accent1"/>
+          </a:lnRef>
+          <a:fillRef idx="3">
+            <a:schemeClr val="accent1"/>
+          </a:fillRef>
+          <a:effectRef idx="2">
+            <a:schemeClr val="accent1"/>
+          </a:effectRef>
+          <a:fontRef idx="minor">
+            <a:schemeClr val="lt1"/>
+          </a:fontRef>
+        </p:style>
+        <p:txBody>
+          <a:bodyPr rtlCol="0" anchor="ctr"/>
+          <a:lstStyle/>
+          <a:p>
+            <a:pPr algn="ctr"/>
+          </a:p>
+        </p:txBody>
+      </p:sp>
+      <p:sp>
+        <p:nvSpPr>
+          <p:cNvPr id="41" name="Oval 40"/>
+          <p:cNvSpPr/>
+          <p:nvPr/>
+        </p:nvSpPr>
+        <p:spPr>
+          <a:xfrm>
+            <a:off x="5576291" y="3570732"/>
+            <a:ext cx="118872" cy="118872"/>
+          </a:xfrm>
+          <a:prstGeom prst="ellipse">
+            <a:avLst/>
+          </a:prstGeom>
+          <a:solidFill>
+            <a:srgbClr val="E38B36"/>
+          </a:solidFill>
+          <a:ln>
+            <a:noFill/>
+          </a:ln>
+        </p:spPr>
+        <p:style>
+          <a:lnRef idx="1">
+            <a:schemeClr val="accent1"/>
+          </a:lnRef>
+          <a:fillRef idx="3">
+            <a:schemeClr val="accent1"/>
+          </a:fillRef>
+          <a:effectRef idx="2">
+            <a:schemeClr val="accent1"/>
+          </a:effectRef>
+          <a:fontRef idx="minor">
+            <a:schemeClr val="lt1"/>
+          </a:fontRef>
+        </p:style>
+        <p:txBody>
+          <a:bodyPr rtlCol="0" anchor="ctr"/>
+          <a:lstStyle/>
+          <a:p>
+            <a:pPr algn="ctr"/>
+          </a:p>
+        </p:txBody>
+      </p:sp>
+      <p:sp>
+        <p:nvSpPr>
+          <p:cNvPr id="42" name="TextBox 41"/>
+          <p:cNvSpPr txBox="1"/>
+          <p:nvPr/>
+        </p:nvSpPr>
+        <p:spPr>
+          <a:xfrm>
+            <a:off x="932688" y="3799332"/>
+            <a:ext cx="365760" cy="210312"/>
+          </a:xfrm>
+          <a:prstGeom prst="rect">
+            <a:avLst/>
+          </a:prstGeom>
+          <a:noFill/>
+        </p:spPr>
+        <p:txBody>
+          <a:bodyPr wrap="square" lIns="0" rIns="0" tIns="0" bIns="0" anchor="ctr">
+            <a:spAutoFit/>
+          </a:bodyPr>
+          <a:lstStyle/>
+          <a:p>
+            <a:pPr algn="l">
+              <a:spcBef>
+                <a:spcPts val="0"/>
+              </a:spcBef>
+              <a:spcAft>
+                <a:spcPts val="0"/>
+              </a:spcAft>
+            </a:pPr>
+            <a:r>
+              <a:rPr sz="850" b="1">
+                <a:solidFill>
+                  <a:srgbClr val="23364A"/>
+                </a:solidFill>
+                <a:latin typeface="Microsoft YaHei"/>
+              </a:rPr>
+              <a:t>M05</a:t>
+            </a:r>
+          </a:p>
+        </p:txBody>
+      </p:sp>
+      <p:cxnSp>
+        <p:nvCxnSpPr>
+          <p:cNvPr id="43" name="Connector 42"/>
+          <p:cNvCxnSpPr/>
+          <p:nvPr/>
+        </p:nvCxnSpPr>
+        <p:spPr>
+          <a:xfrm flipH="1">
+            <a:off x="5784607" y="3904488"/>
+            <a:ext cx="352268" cy="0"/>
+          </a:xfrm>
+          <a:prstGeom prst="line">
+            <a:avLst/>
+          </a:prstGeom>
+          <a:ln w="15240">
+            <a:solidFill>
+              <a:srgbClr val="D8E1EB"/>
+            </a:solidFill>
+          </a:ln>
+        </p:spPr>
+        <p:style>
+          <a:lnRef idx="2">
+            <a:schemeClr val="accent1"/>
+          </a:lnRef>
+          <a:fillRef idx="0">
+            <a:schemeClr val="accent1"/>
+          </a:fillRef>
+          <a:effectRef idx="1">
+            <a:schemeClr val="accent1"/>
+          </a:effectRef>
+          <a:fontRef idx="minor">
+            <a:schemeClr val="tx1"/>
+          </a:fontRef>
+        </p:style>
+      </p:cxnSp>
+      <p:sp>
+        <p:nvSpPr>
+          <p:cNvPr id="44" name="Oval 43"/>
+          <p:cNvSpPr/>
+          <p:nvPr/>
+        </p:nvSpPr>
+        <p:spPr>
+          <a:xfrm>
+            <a:off x="6077439" y="3845052"/>
+            <a:ext cx="118872" cy="118872"/>
+          </a:xfrm>
+          <a:prstGeom prst="ellipse">
+            <a:avLst/>
+          </a:prstGeom>
+          <a:solidFill>
+            <a:srgbClr val="3568A8"/>
+          </a:solidFill>
+          <a:ln>
+            <a:noFill/>
+          </a:ln>
+        </p:spPr>
+        <p:style>
+          <a:lnRef idx="1">
+            <a:schemeClr val="accent1"/>
+          </a:lnRef>
+          <a:fillRef idx="3">
+            <a:schemeClr val="accent1"/>
+          </a:fillRef>
+          <a:effectRef idx="2">
+            <a:schemeClr val="accent1"/>
+          </a:effectRef>
+          <a:fontRef idx="minor">
+            <a:schemeClr val="lt1"/>
+          </a:fontRef>
+        </p:style>
+        <p:txBody>
+          <a:bodyPr rtlCol="0" anchor="ctr"/>
+          <a:lstStyle/>
+          <a:p>
+            <a:pPr algn="ctr"/>
+          </a:p>
+        </p:txBody>
+      </p:sp>
+      <p:sp>
+        <p:nvSpPr>
+          <p:cNvPr id="45" name="Oval 44"/>
+          <p:cNvSpPr/>
+          <p:nvPr/>
+        </p:nvSpPr>
+        <p:spPr>
+          <a:xfrm>
+            <a:off x="5725171" y="3845052"/>
+            <a:ext cx="118872" cy="118872"/>
+          </a:xfrm>
+          <a:prstGeom prst="ellipse">
+            <a:avLst/>
+          </a:prstGeom>
+          <a:solidFill>
+            <a:srgbClr val="E38B36"/>
+          </a:solidFill>
+          <a:ln>
+            <a:noFill/>
+          </a:ln>
+        </p:spPr>
+        <p:style>
+          <a:lnRef idx="1">
+            <a:schemeClr val="accent1"/>
+          </a:lnRef>
+          <a:fillRef idx="3">
+            <a:schemeClr val="accent1"/>
+          </a:fillRef>
+          <a:effectRef idx="2">
+            <a:schemeClr val="accent1"/>
+          </a:effectRef>
+          <a:fontRef idx="minor">
+            <a:schemeClr val="lt1"/>
+          </a:fontRef>
+        </p:style>
+        <p:txBody>
+          <a:bodyPr rtlCol="0" anchor="ctr"/>
+          <a:lstStyle/>
+          <a:p>
+            <a:pPr algn="ctr"/>
+          </a:p>
+        </p:txBody>
+      </p:sp>
+      <p:sp>
+        <p:nvSpPr>
+          <p:cNvPr id="46" name="TextBox 45"/>
+          <p:cNvSpPr txBox="1"/>
+          <p:nvPr/>
+        </p:nvSpPr>
+        <p:spPr>
+          <a:xfrm>
+            <a:off x="5309119" y="3817620"/>
+            <a:ext cx="365760" cy="173736"/>
+          </a:xfrm>
+          <a:prstGeom prst="rect">
+            <a:avLst/>
+          </a:prstGeom>
+          <a:noFill/>
+        </p:spPr>
+        <p:txBody>
+          <a:bodyPr wrap="square" lIns="0" rIns="0" tIns="0" bIns="0" anchor="ctr">
+            <a:spAutoFit/>
+          </a:bodyPr>
+          <a:lstStyle/>
+          <a:p>
+            <a:pPr algn="r">
+              <a:spcBef>
+                <a:spcPts val="0"/>
+              </a:spcBef>
+              <a:spcAft>
+                <a:spcPts val="0"/>
+              </a:spcAft>
+            </a:pPr>
+            <a:r>
+              <a:rPr sz="800" b="1">
+                <a:solidFill>
+                  <a:srgbClr val="E38B36"/>
+                </a:solidFill>
+                <a:latin typeface="Microsoft YaHei"/>
+              </a:rPr>
+              <a:t>19.1</a:t>
+            </a:r>
+          </a:p>
+        </p:txBody>
+      </p:sp>
+      <p:sp>
+        <p:nvSpPr>
+          <p:cNvPr id="47" name="TextBox 46"/>
+          <p:cNvSpPr txBox="1"/>
+          <p:nvPr/>
+        </p:nvSpPr>
+        <p:spPr>
+          <a:xfrm>
+            <a:off x="6246603" y="3817620"/>
+            <a:ext cx="365760" cy="173736"/>
+          </a:xfrm>
+          <a:prstGeom prst="rect">
+            <a:avLst/>
+          </a:prstGeom>
+          <a:noFill/>
+        </p:spPr>
+        <p:txBody>
+          <a:bodyPr wrap="square" lIns="0" rIns="0" tIns="0" bIns="0" anchor="ctr">
+            <a:spAutoFit/>
+          </a:bodyPr>
+          <a:lstStyle/>
+          <a:p>
+            <a:pPr algn="l">
+              <a:spcBef>
+                <a:spcPts val="0"/>
+              </a:spcBef>
+              <a:spcAft>
+                <a:spcPts val="0"/>
+              </a:spcAft>
+            </a:pPr>
+            <a:r>
+              <a:rPr sz="800" b="1">
+                <a:solidFill>
+                  <a:srgbClr val="3568A8"/>
+                </a:solidFill>
+                <a:latin typeface="Microsoft YaHei"/>
+              </a:rPr>
+              <a:t>20.6</a:t>
+            </a:r>
+          </a:p>
+        </p:txBody>
+      </p:sp>
+      <p:sp>
+        <p:nvSpPr>
+          <p:cNvPr id="48" name="TextBox 47"/>
+          <p:cNvSpPr txBox="1"/>
+          <p:nvPr/>
+        </p:nvSpPr>
+        <p:spPr>
+          <a:xfrm>
+            <a:off x="932688" y="4073652"/>
+            <a:ext cx="365760" cy="210312"/>
+          </a:xfrm>
+          <a:prstGeom prst="rect">
+            <a:avLst/>
+          </a:prstGeom>
+          <a:noFill/>
+        </p:spPr>
+        <p:txBody>
+          <a:bodyPr wrap="square" lIns="0" rIns="0" tIns="0" bIns="0" anchor="ctr">
+            <a:spAutoFit/>
+          </a:bodyPr>
+          <a:lstStyle/>
+          <a:p>
+            <a:pPr algn="l">
+              <a:spcBef>
+                <a:spcPts val="0"/>
+              </a:spcBef>
+              <a:spcAft>
+                <a:spcPts val="0"/>
+              </a:spcAft>
+            </a:pPr>
+            <a:r>
+              <a:rPr sz="850" b="1">
+                <a:solidFill>
+                  <a:srgbClr val="23364A"/>
+                </a:solidFill>
+                <a:latin typeface="Microsoft YaHei"/>
+              </a:rPr>
+              <a:t>M06</a:t>
+            </a:r>
+          </a:p>
+        </p:txBody>
+      </p:sp>
+      <p:cxnSp>
+        <p:nvCxnSpPr>
+          <p:cNvPr id="49" name="Connector 48"/>
+          <p:cNvCxnSpPr/>
+          <p:nvPr/>
+        </p:nvCxnSpPr>
+        <p:spPr>
+          <a:xfrm>
+            <a:off x="2602194" y="4178808"/>
+            <a:ext cx="179098" cy="0"/>
+          </a:xfrm>
+          <a:prstGeom prst="line">
+            <a:avLst/>
+          </a:prstGeom>
+          <a:ln w="15240">
+            <a:solidFill>
+              <a:srgbClr val="D8E1EB"/>
+            </a:solidFill>
+          </a:ln>
+        </p:spPr>
+        <p:style>
+          <a:lnRef idx="2">
+            <a:schemeClr val="accent1"/>
+          </a:lnRef>
+          <a:fillRef idx="0">
+            <a:schemeClr val="accent1"/>
+          </a:fillRef>
+          <a:effectRef idx="1">
+            <a:schemeClr val="accent1"/>
+          </a:effectRef>
+          <a:fontRef idx="minor">
+            <a:schemeClr val="tx1"/>
+          </a:fontRef>
+        </p:style>
+      </p:cxnSp>
+      <p:sp>
+        <p:nvSpPr>
+          <p:cNvPr id="50" name="Oval 49"/>
+          <p:cNvSpPr/>
+          <p:nvPr/>
+        </p:nvSpPr>
+        <p:spPr>
+          <a:xfrm>
+            <a:off x="2542758" y="4119372"/>
+            <a:ext cx="118872" cy="118872"/>
+          </a:xfrm>
+          <a:prstGeom prst="ellipse">
+            <a:avLst/>
+          </a:prstGeom>
+          <a:solidFill>
+            <a:srgbClr val="3568A8"/>
+          </a:solidFill>
+          <a:ln>
+            <a:noFill/>
+          </a:ln>
+        </p:spPr>
+        <p:style>
+          <a:lnRef idx="1">
+            <a:schemeClr val="accent1"/>
+          </a:lnRef>
+          <a:fillRef idx="3">
+            <a:schemeClr val="accent1"/>
+          </a:fillRef>
+          <a:effectRef idx="2">
+            <a:schemeClr val="accent1"/>
+          </a:effectRef>
+          <a:fontRef idx="minor">
+            <a:schemeClr val="lt1"/>
+          </a:fontRef>
+        </p:style>
+        <p:txBody>
+          <a:bodyPr rtlCol="0" anchor="ctr"/>
+          <a:lstStyle/>
+          <a:p>
+            <a:pPr algn="ctr"/>
+          </a:p>
+        </p:txBody>
+      </p:sp>
+      <p:sp>
+        <p:nvSpPr>
+          <p:cNvPr id="51" name="Oval 50"/>
+          <p:cNvSpPr/>
+          <p:nvPr/>
+        </p:nvSpPr>
+        <p:spPr>
+          <a:xfrm>
+            <a:off x="2721856" y="4119372"/>
+            <a:ext cx="118872" cy="118872"/>
+          </a:xfrm>
+          <a:prstGeom prst="ellipse">
+            <a:avLst/>
+          </a:prstGeom>
+          <a:solidFill>
+            <a:srgbClr val="E38B36"/>
+          </a:solidFill>
+          <a:ln>
+            <a:noFill/>
+          </a:ln>
+        </p:spPr>
+        <p:style>
+          <a:lnRef idx="1">
+            <a:schemeClr val="accent1"/>
+          </a:lnRef>
+          <a:fillRef idx="3">
+            <a:schemeClr val="accent1"/>
+          </a:fillRef>
+          <a:effectRef idx="2">
+            <a:schemeClr val="accent1"/>
+          </a:effectRef>
+          <a:fontRef idx="minor">
+            <a:schemeClr val="lt1"/>
+          </a:fontRef>
+        </p:style>
+        <p:txBody>
+          <a:bodyPr rtlCol="0" anchor="ctr"/>
+          <a:lstStyle/>
+          <a:p>
+            <a:pPr algn="ctr"/>
+          </a:p>
+        </p:txBody>
+      </p:sp>
+      <p:sp>
+        <p:nvSpPr>
+          <p:cNvPr id="52" name="TextBox 51"/>
+          <p:cNvSpPr txBox="1"/>
+          <p:nvPr/>
+        </p:nvSpPr>
+        <p:spPr>
+          <a:xfrm>
+            <a:off x="932688" y="4347972"/>
+            <a:ext cx="365760" cy="210312"/>
+          </a:xfrm>
+          <a:prstGeom prst="rect">
+            <a:avLst/>
+          </a:prstGeom>
+          <a:noFill/>
+        </p:spPr>
+        <p:txBody>
+          <a:bodyPr wrap="square" lIns="0" rIns="0" tIns="0" bIns="0" anchor="ctr">
+            <a:spAutoFit/>
+          </a:bodyPr>
+          <a:lstStyle/>
+          <a:p>
+            <a:pPr algn="l">
+              <a:spcBef>
+                <a:spcPts val="0"/>
+              </a:spcBef>
+              <a:spcAft>
+                <a:spcPts val="0"/>
+              </a:spcAft>
+            </a:pPr>
+            <a:r>
+              <a:rPr sz="850" b="1">
+                <a:solidFill>
+                  <a:srgbClr val="23364A"/>
+                </a:solidFill>
+                <a:latin typeface="Microsoft YaHei"/>
+              </a:rPr>
+              <a:t>M07</a:t>
+            </a:r>
+          </a:p>
+        </p:txBody>
+      </p:sp>
+      <p:cxnSp>
+        <p:nvCxnSpPr>
+          <p:cNvPr id="53" name="Connector 52"/>
+          <p:cNvCxnSpPr/>
+          <p:nvPr/>
+        </p:nvCxnSpPr>
+        <p:spPr>
+          <a:xfrm flipH="1">
+            <a:off x="3499255" y="4453128"/>
+            <a:ext cx="1374242" cy="0"/>
+          </a:xfrm>
+          <a:prstGeom prst="line">
+            <a:avLst/>
+          </a:prstGeom>
+          <a:ln w="15240">
+            <a:solidFill>
+              <a:srgbClr val="D8E1EB"/>
+            </a:solidFill>
+          </a:ln>
+        </p:spPr>
+        <p:style>
+          <a:lnRef idx="2">
+            <a:schemeClr val="accent1"/>
+          </a:lnRef>
+          <a:fillRef idx="0">
+            <a:schemeClr val="accent1"/>
+          </a:fillRef>
+          <a:effectRef idx="1">
+            <a:schemeClr val="accent1"/>
+          </a:effectRef>
+          <a:fontRef idx="minor">
+            <a:schemeClr val="tx1"/>
+          </a:fontRef>
+        </p:style>
+      </p:cxnSp>
+      <p:sp>
+        <p:nvSpPr>
+          <p:cNvPr id="54" name="Oval 53"/>
+          <p:cNvSpPr/>
+          <p:nvPr/>
+        </p:nvSpPr>
+        <p:spPr>
+          <a:xfrm>
+            <a:off x="4814061" y="4393692"/>
+            <a:ext cx="118872" cy="118872"/>
+          </a:xfrm>
+          <a:prstGeom prst="ellipse">
+            <a:avLst/>
+          </a:prstGeom>
+          <a:solidFill>
+            <a:srgbClr val="3568A8"/>
+          </a:solidFill>
+          <a:ln>
+            <a:noFill/>
+          </a:ln>
+        </p:spPr>
+        <p:style>
+          <a:lnRef idx="1">
+            <a:schemeClr val="accent1"/>
+          </a:lnRef>
+          <a:fillRef idx="3">
+            <a:schemeClr val="accent1"/>
+          </a:fillRef>
+          <a:effectRef idx="2">
+            <a:schemeClr val="accent1"/>
+          </a:effectRef>
+          <a:fontRef idx="minor">
+            <a:schemeClr val="lt1"/>
+          </a:fontRef>
+        </p:style>
+        <p:txBody>
+          <a:bodyPr rtlCol="0" anchor="ctr"/>
+          <a:lstStyle/>
+          <a:p>
+            <a:pPr algn="ctr"/>
+          </a:p>
+        </p:txBody>
+      </p:sp>
+      <p:sp>
+        <p:nvSpPr>
+          <p:cNvPr id="55" name="Oval 54"/>
+          <p:cNvSpPr/>
+          <p:nvPr/>
+        </p:nvSpPr>
+        <p:spPr>
+          <a:xfrm>
+            <a:off x="3439819" y="4393692"/>
+            <a:ext cx="118872" cy="118872"/>
+          </a:xfrm>
+          <a:prstGeom prst="ellipse">
+            <a:avLst/>
+          </a:prstGeom>
+          <a:solidFill>
+            <a:srgbClr val="E38B36"/>
+          </a:solidFill>
+          <a:ln>
+            <a:noFill/>
+          </a:ln>
+        </p:spPr>
+        <p:style>
+          <a:lnRef idx="1">
+            <a:schemeClr val="accent1"/>
+          </a:lnRef>
+          <a:fillRef idx="3">
+            <a:schemeClr val="accent1"/>
+          </a:fillRef>
+          <a:effectRef idx="2">
+            <a:schemeClr val="accent1"/>
+          </a:effectRef>
+          <a:fontRef idx="minor">
+            <a:schemeClr val="lt1"/>
+          </a:fontRef>
+        </p:style>
+        <p:txBody>
+          <a:bodyPr rtlCol="0" anchor="ctr"/>
+          <a:lstStyle/>
+          <a:p>
+            <a:pPr algn="ctr"/>
+          </a:p>
+        </p:txBody>
+      </p:sp>
+      <p:sp>
+        <p:nvSpPr>
+          <p:cNvPr id="56" name="TextBox 55"/>
+          <p:cNvSpPr txBox="1"/>
+          <p:nvPr/>
+        </p:nvSpPr>
+        <p:spPr>
+          <a:xfrm>
+            <a:off x="932688" y="4622292"/>
+            <a:ext cx="365760" cy="210312"/>
+          </a:xfrm>
+          <a:prstGeom prst="rect">
+            <a:avLst/>
+          </a:prstGeom>
+          <a:noFill/>
+        </p:spPr>
+        <p:txBody>
+          <a:bodyPr wrap="square" lIns="0" rIns="0" tIns="0" bIns="0" anchor="ctr">
+            <a:spAutoFit/>
+          </a:bodyPr>
+          <a:lstStyle/>
+          <a:p>
+            <a:pPr algn="l">
+              <a:spcBef>
+                <a:spcPts val="0"/>
+              </a:spcBef>
+              <a:spcAft>
+                <a:spcPts val="0"/>
+              </a:spcAft>
+            </a:pPr>
+            <a:r>
+              <a:rPr sz="850" b="1">
+                <a:solidFill>
+                  <a:srgbClr val="23364A"/>
+                </a:solidFill>
+                <a:latin typeface="Microsoft YaHei"/>
+              </a:rPr>
+              <a:t>M08</a:t>
+            </a:r>
+          </a:p>
+        </p:txBody>
+      </p:sp>
+      <p:cxnSp>
+        <p:nvCxnSpPr>
+          <p:cNvPr id="57" name="Connector 56"/>
+          <p:cNvCxnSpPr/>
+          <p:nvPr/>
+        </p:nvCxnSpPr>
+        <p:spPr>
+          <a:xfrm flipH="1">
+            <a:off x="1852697" y="4727448"/>
+            <a:ext cx="62306" cy="0"/>
+          </a:xfrm>
+          <a:prstGeom prst="line">
+            <a:avLst/>
+          </a:prstGeom>
+          <a:ln w="15240">
+            <a:solidFill>
+              <a:srgbClr val="D8E1EB"/>
+            </a:solidFill>
+          </a:ln>
+        </p:spPr>
+        <p:style>
+          <a:lnRef idx="2">
+            <a:schemeClr val="accent1"/>
+          </a:lnRef>
+          <a:fillRef idx="0">
+            <a:schemeClr val="accent1"/>
+          </a:fillRef>
+          <a:effectRef idx="1">
+            <a:schemeClr val="accent1"/>
+          </a:effectRef>
+          <a:fontRef idx="minor">
+            <a:schemeClr val="tx1"/>
+          </a:fontRef>
+        </p:style>
+      </p:cxnSp>
+      <p:sp>
+        <p:nvSpPr>
+          <p:cNvPr id="58" name="Oval 57"/>
+          <p:cNvSpPr/>
+          <p:nvPr/>
+        </p:nvSpPr>
+        <p:spPr>
+          <a:xfrm>
+            <a:off x="1855567" y="4668012"/>
+            <a:ext cx="118872" cy="118872"/>
+          </a:xfrm>
+          <a:prstGeom prst="ellipse">
+            <a:avLst/>
+          </a:prstGeom>
+          <a:solidFill>
+            <a:srgbClr val="3568A8"/>
+          </a:solidFill>
+          <a:ln>
+            <a:noFill/>
+          </a:ln>
+        </p:spPr>
+        <p:style>
+          <a:lnRef idx="1">
+            <a:schemeClr val="accent1"/>
+          </a:lnRef>
+          <a:fillRef idx="3">
+            <a:schemeClr val="accent1"/>
+          </a:fillRef>
+          <a:effectRef idx="2">
+            <a:schemeClr val="accent1"/>
+          </a:effectRef>
+          <a:fontRef idx="minor">
+            <a:schemeClr val="lt1"/>
+          </a:fontRef>
+        </p:style>
+        <p:txBody>
+          <a:bodyPr rtlCol="0" anchor="ctr"/>
+          <a:lstStyle/>
+          <a:p>
+            <a:pPr algn="ctr"/>
+          </a:p>
+        </p:txBody>
+      </p:sp>
+      <p:sp>
+        <p:nvSpPr>
+          <p:cNvPr id="59" name="Oval 58"/>
+          <p:cNvSpPr/>
+          <p:nvPr/>
+        </p:nvSpPr>
+        <p:spPr>
+          <a:xfrm>
+            <a:off x="1793261" y="4668012"/>
+            <a:ext cx="118872" cy="118872"/>
+          </a:xfrm>
+          <a:prstGeom prst="ellipse">
+            <a:avLst/>
+          </a:prstGeom>
+          <a:solidFill>
+            <a:srgbClr val="E38B36"/>
+          </a:solidFill>
+          <a:ln>
+            <a:noFill/>
+          </a:ln>
+        </p:spPr>
+        <p:style>
+          <a:lnRef idx="1">
+            <a:schemeClr val="accent1"/>
+          </a:lnRef>
+          <a:fillRef idx="3">
+            <a:schemeClr val="accent1"/>
+          </a:fillRef>
+          <a:effectRef idx="2">
+            <a:schemeClr val="accent1"/>
+          </a:effectRef>
+          <a:fontRef idx="minor">
+            <a:schemeClr val="lt1"/>
+          </a:fontRef>
+        </p:style>
+        <p:txBody>
+          <a:bodyPr rtlCol="0" anchor="ctr"/>
+          <a:lstStyle/>
+          <a:p>
+            <a:pPr algn="ctr"/>
+          </a:p>
+        </p:txBody>
+      </p:sp>
+      <p:sp>
+        <p:nvSpPr>
+          <p:cNvPr id="60" name="TextBox 59"/>
+          <p:cNvSpPr txBox="1"/>
+          <p:nvPr/>
+        </p:nvSpPr>
+        <p:spPr>
+          <a:xfrm>
+            <a:off x="932688" y="4896612"/>
+            <a:ext cx="365760" cy="210312"/>
+          </a:xfrm>
+          <a:prstGeom prst="rect">
+            <a:avLst/>
+          </a:prstGeom>
+          <a:noFill/>
+        </p:spPr>
+        <p:txBody>
+          <a:bodyPr wrap="square" lIns="0" rIns="0" tIns="0" bIns="0" anchor="ctr">
+            <a:spAutoFit/>
+          </a:bodyPr>
+          <a:lstStyle/>
+          <a:p>
+            <a:pPr algn="l">
+              <a:spcBef>
+                <a:spcPts val="0"/>
+              </a:spcBef>
+              <a:spcAft>
+                <a:spcPts val="0"/>
+              </a:spcAft>
+            </a:pPr>
+            <a:r>
+              <a:rPr sz="850" b="1">
+                <a:solidFill>
+                  <a:srgbClr val="23364A"/>
+                </a:solidFill>
+                <a:latin typeface="Microsoft YaHei"/>
+              </a:rPr>
+              <a:t>M09</a:t>
+            </a:r>
+          </a:p>
+        </p:txBody>
+      </p:sp>
+      <p:cxnSp>
+        <p:nvCxnSpPr>
+          <p:cNvPr id="61" name="Connector 60"/>
+          <p:cNvCxnSpPr/>
+          <p:nvPr/>
+        </p:nvCxnSpPr>
+        <p:spPr>
+          <a:xfrm>
+            <a:off x="1389888" y="5001768"/>
+            <a:ext cx="866035" cy="0"/>
+          </a:xfrm>
+          <a:prstGeom prst="line">
+            <a:avLst/>
+          </a:prstGeom>
+          <a:ln w="15240">
+            <a:solidFill>
+              <a:srgbClr val="D8E1EB"/>
+            </a:solidFill>
+          </a:ln>
+        </p:spPr>
+        <p:style>
+          <a:lnRef idx="2">
+            <a:schemeClr val="accent1"/>
+          </a:lnRef>
+          <a:fillRef idx="0">
+            <a:schemeClr val="accent1"/>
+          </a:fillRef>
+          <a:effectRef idx="1">
+            <a:schemeClr val="accent1"/>
+          </a:effectRef>
+          <a:fontRef idx="minor">
+            <a:schemeClr val="tx1"/>
+          </a:fontRef>
+        </p:style>
+      </p:cxnSp>
+      <p:sp>
+        <p:nvSpPr>
+          <p:cNvPr id="62" name="Oval 61"/>
+          <p:cNvSpPr/>
+          <p:nvPr/>
+        </p:nvSpPr>
+        <p:spPr>
+          <a:xfrm>
+            <a:off x="1330452" y="4942331"/>
+            <a:ext cx="118872" cy="118872"/>
+          </a:xfrm>
+          <a:prstGeom prst="ellipse">
+            <a:avLst/>
+          </a:prstGeom>
+          <a:solidFill>
+            <a:srgbClr val="3568A8"/>
+          </a:solidFill>
+          <a:ln>
+            <a:noFill/>
+          </a:ln>
+        </p:spPr>
+        <p:style>
+          <a:lnRef idx="1">
+            <a:schemeClr val="accent1"/>
+          </a:lnRef>
+          <a:fillRef idx="3">
+            <a:schemeClr val="accent1"/>
+          </a:fillRef>
+          <a:effectRef idx="2">
+            <a:schemeClr val="accent1"/>
+          </a:effectRef>
+          <a:fontRef idx="minor">
+            <a:schemeClr val="lt1"/>
+          </a:fontRef>
+        </p:style>
+        <p:txBody>
+          <a:bodyPr rtlCol="0" anchor="ctr"/>
+          <a:lstStyle/>
+          <a:p>
+            <a:pPr algn="ctr"/>
+          </a:p>
+        </p:txBody>
+      </p:sp>
+      <p:sp>
+        <p:nvSpPr>
+          <p:cNvPr id="63" name="Oval 62"/>
+          <p:cNvSpPr/>
+          <p:nvPr/>
+        </p:nvSpPr>
+        <p:spPr>
+          <a:xfrm>
+            <a:off x="2196487" y="4942331"/>
+            <a:ext cx="118872" cy="118872"/>
+          </a:xfrm>
+          <a:prstGeom prst="ellipse">
+            <a:avLst/>
+          </a:prstGeom>
+          <a:solidFill>
+            <a:srgbClr val="E38B36"/>
+          </a:solidFill>
+          <a:ln>
+            <a:noFill/>
+          </a:ln>
+        </p:spPr>
+        <p:style>
+          <a:lnRef idx="1">
+            <a:schemeClr val="accent1"/>
+          </a:lnRef>
+          <a:fillRef idx="3">
+            <a:schemeClr val="accent1"/>
+          </a:fillRef>
+          <a:effectRef idx="2">
+            <a:schemeClr val="accent1"/>
+          </a:effectRef>
+          <a:fontRef idx="minor">
+            <a:schemeClr val="lt1"/>
+          </a:fontRef>
+        </p:style>
+        <p:txBody>
+          <a:bodyPr rtlCol="0" anchor="ctr"/>
+          <a:lstStyle/>
+          <a:p>
+            <a:pPr algn="ctr"/>
+          </a:p>
+        </p:txBody>
+      </p:sp>
+      <p:sp>
+        <p:nvSpPr>
+          <p:cNvPr id="64" name="TextBox 63"/>
+          <p:cNvSpPr txBox="1"/>
+          <p:nvPr/>
+        </p:nvSpPr>
+        <p:spPr>
+          <a:xfrm>
+            <a:off x="932688" y="5170932"/>
+            <a:ext cx="365760" cy="210312"/>
+          </a:xfrm>
+          <a:prstGeom prst="rect">
+            <a:avLst/>
+          </a:prstGeom>
+          <a:noFill/>
+        </p:spPr>
+        <p:txBody>
+          <a:bodyPr wrap="square" lIns="0" rIns="0" tIns="0" bIns="0" anchor="ctr">
+            <a:spAutoFit/>
+          </a:bodyPr>
+          <a:lstStyle/>
+          <a:p>
+            <a:pPr algn="l">
+              <a:spcBef>
+                <a:spcPts val="0"/>
+              </a:spcBef>
+              <a:spcAft>
+                <a:spcPts val="0"/>
+              </a:spcAft>
+            </a:pPr>
+            <a:r>
+              <a:rPr sz="850" b="1">
+                <a:solidFill>
+                  <a:srgbClr val="23364A"/>
+                </a:solidFill>
+                <a:latin typeface="Microsoft YaHei"/>
+              </a:rPr>
+              <a:t>M10</a:t>
+            </a:r>
+          </a:p>
+        </p:txBody>
+      </p:sp>
+      <p:cxnSp>
+        <p:nvCxnSpPr>
+          <p:cNvPr id="65" name="Connector 64"/>
+          <p:cNvCxnSpPr/>
+          <p:nvPr/>
+        </p:nvCxnSpPr>
+        <p:spPr>
+          <a:xfrm>
+            <a:off x="4196018" y="5276088"/>
+            <a:ext cx="1432581" cy="0"/>
+          </a:xfrm>
+          <a:prstGeom prst="line">
+            <a:avLst/>
+          </a:prstGeom>
+          <a:ln w="15240">
+            <a:solidFill>
+              <a:srgbClr val="D8E1EB"/>
+            </a:solidFill>
+          </a:ln>
+        </p:spPr>
+        <p:style>
+          <a:lnRef idx="2">
+            <a:schemeClr val="accent1"/>
+          </a:lnRef>
+          <a:fillRef idx="0">
+            <a:schemeClr val="accent1"/>
+          </a:fillRef>
+          <a:effectRef idx="1">
+            <a:schemeClr val="accent1"/>
+          </a:effectRef>
+          <a:fontRef idx="minor">
+            <a:schemeClr val="tx1"/>
+          </a:fontRef>
+        </p:style>
+      </p:cxnSp>
+      <p:sp>
+        <p:nvSpPr>
+          <p:cNvPr id="66" name="Oval 65"/>
+          <p:cNvSpPr/>
+          <p:nvPr/>
+        </p:nvSpPr>
+        <p:spPr>
+          <a:xfrm>
+            <a:off x="4136582" y="5216652"/>
+            <a:ext cx="118872" cy="118872"/>
+          </a:xfrm>
+          <a:prstGeom prst="ellipse">
+            <a:avLst/>
+          </a:prstGeom>
+          <a:solidFill>
+            <a:srgbClr val="3568A8"/>
+          </a:solidFill>
+          <a:ln>
+            <a:noFill/>
+          </a:ln>
+        </p:spPr>
+        <p:style>
+          <a:lnRef idx="1">
+            <a:schemeClr val="accent1"/>
+          </a:lnRef>
+          <a:fillRef idx="3">
+            <a:schemeClr val="accent1"/>
+          </a:fillRef>
+          <a:effectRef idx="2">
+            <a:schemeClr val="accent1"/>
+          </a:effectRef>
+          <a:fontRef idx="minor">
+            <a:schemeClr val="lt1"/>
+          </a:fontRef>
+        </p:style>
+        <p:txBody>
+          <a:bodyPr rtlCol="0" anchor="ctr"/>
+          <a:lstStyle/>
+          <a:p>
+            <a:pPr algn="ctr"/>
+          </a:p>
+        </p:txBody>
+      </p:sp>
+      <p:sp>
+        <p:nvSpPr>
+          <p:cNvPr id="67" name="Oval 66"/>
+          <p:cNvSpPr/>
+          <p:nvPr/>
+        </p:nvSpPr>
+        <p:spPr>
+          <a:xfrm>
+            <a:off x="5569163" y="5216652"/>
+            <a:ext cx="118872" cy="118872"/>
+          </a:xfrm>
+          <a:prstGeom prst="ellipse">
+            <a:avLst/>
+          </a:prstGeom>
+          <a:solidFill>
+            <a:srgbClr val="E38B36"/>
+          </a:solidFill>
+          <a:ln>
+            <a:noFill/>
+          </a:ln>
+        </p:spPr>
+        <p:style>
+          <a:lnRef idx="1">
+            <a:schemeClr val="accent1"/>
+          </a:lnRef>
+          <a:fillRef idx="3">
+            <a:schemeClr val="accent1"/>
+          </a:fillRef>
+          <a:effectRef idx="2">
+            <a:schemeClr val="accent1"/>
+          </a:effectRef>
+          <a:fontRef idx="minor">
+            <a:schemeClr val="lt1"/>
+          </a:fontRef>
+        </p:style>
+        <p:txBody>
+          <a:bodyPr rtlCol="0" anchor="ctr"/>
+          <a:lstStyle/>
+          <a:p>
+            <a:pPr algn="ctr"/>
+          </a:p>
+        </p:txBody>
+      </p:sp>
+      <p:sp>
+        <p:nvSpPr>
+          <p:cNvPr id="68" name="TextBox 67"/>
+          <p:cNvSpPr txBox="1"/>
+          <p:nvPr/>
+        </p:nvSpPr>
+        <p:spPr>
+          <a:xfrm>
+            <a:off x="941832" y="5513832"/>
+            <a:ext cx="6446520" cy="182880"/>
+          </a:xfrm>
+          <a:prstGeom prst="rect">
+            <a:avLst/>
+          </a:prstGeom>
+          <a:noFill/>
+        </p:spPr>
+        <p:txBody>
+          <a:bodyPr wrap="square" lIns="0" rIns="0" tIns="0" bIns="0" anchor="t">
+            <a:spAutoFit/>
+          </a:bodyPr>
+          <a:lstStyle/>
+          <a:p>
+            <a:pPr algn="ctr">
+              <a:spcBef>
+                <a:spcPts val="0"/>
+              </a:spcBef>
+              <a:spcAft>
+                <a:spcPts val="0"/>
+              </a:spcAft>
+            </a:pPr>
+            <a:r>
+              <a:rPr sz="850" b="1">
+                <a:solidFill>
+                  <a:srgbClr val="3568A8"/>
+                </a:solidFill>
+                <a:latin typeface="Microsoft YaHei"/>
+              </a:rPr>
+              <a:t>M05　课程教学与培养目标：在两组文本中均居篇幅占比首位</a:t>
+            </a:r>
+          </a:p>
+        </p:txBody>
+      </p:sp>
+      <p:sp>
+        <p:nvSpPr>
+          <p:cNvPr id="69" name="Rounded Rectangle 68"/>
+          <p:cNvSpPr/>
+          <p:nvPr/>
+        </p:nvSpPr>
+        <p:spPr>
+          <a:xfrm>
+            <a:off x="7936992" y="1993392"/>
+            <a:ext cx="3401568" cy="3767328"/>
+          </a:xfrm>
+          <a:prstGeom prst="roundRect">
+            <a:avLst/>
+          </a:prstGeom>
+          <a:solidFill>
+            <a:srgbClr val="EAF1F8"/>
+          </a:solidFill>
+          <a:ln>
+            <a:noFill/>
+          </a:ln>
+        </p:spPr>
+        <p:style>
+          <a:lnRef idx="1">
+            <a:schemeClr val="accent1"/>
+          </a:lnRef>
+          <a:fillRef idx="3">
+            <a:schemeClr val="accent1"/>
+          </a:fillRef>
+          <a:effectRef idx="2">
+            <a:schemeClr val="accent1"/>
+          </a:effectRef>
+          <a:fontRef idx="minor">
+            <a:schemeClr val="lt1"/>
+          </a:fontRef>
+        </p:style>
+        <p:txBody>
+          <a:bodyPr rtlCol="0" anchor="ctr"/>
+          <a:lstStyle/>
+          <a:p>
+            <a:pPr algn="ctr"/>
+          </a:p>
+        </p:txBody>
+      </p:sp>
+      <p:sp>
+        <p:nvSpPr>
+          <p:cNvPr id="70" name="TextBox 69"/>
+          <p:cNvSpPr txBox="1"/>
+          <p:nvPr/>
+        </p:nvSpPr>
+        <p:spPr>
+          <a:xfrm>
+            <a:off x="8183879" y="2167128"/>
+            <a:ext cx="2907792" cy="274320"/>
+          </a:xfrm>
+          <a:prstGeom prst="rect">
+            <a:avLst/>
+          </a:prstGeom>
+          <a:noFill/>
+        </p:spPr>
+        <p:txBody>
+          <a:bodyPr wrap="square" lIns="0" rIns="0" tIns="0" bIns="0" anchor="t">
+            <a:spAutoFit/>
+          </a:bodyPr>
+          <a:lstStyle/>
+          <a:p>
+            <a:pPr algn="l">
+              <a:spcBef>
+                <a:spcPts val="0"/>
+              </a:spcBef>
+              <a:spcAft>
+                <a:spcPts val="0"/>
+              </a:spcAft>
+            </a:pPr>
+            <a:r>
+              <a:rPr sz="1100" b="1">
+                <a:solidFill>
+                  <a:srgbClr val="3568A8"/>
+                </a:solidFill>
+                <a:latin typeface="Microsoft YaHei"/>
+              </a:rPr>
+              <a:t>开篇比例（%）</a:t>
+            </a:r>
+          </a:p>
+        </p:txBody>
+      </p:sp>
+      <p:sp>
+        <p:nvSpPr>
+          <p:cNvPr id="71" name="Rounded Rectangle 70"/>
+          <p:cNvSpPr/>
+          <p:nvPr/>
+        </p:nvSpPr>
+        <p:spPr>
+          <a:xfrm>
+            <a:off x="8183879" y="2633472"/>
+            <a:ext cx="2907792" cy="1188720"/>
+          </a:xfrm>
+          <a:prstGeom prst="roundRect">
+            <a:avLst/>
+          </a:prstGeom>
+          <a:solidFill>
+            <a:srgbClr val="FFFFFF"/>
+          </a:solidFill>
+          <a:ln>
+            <a:noFill/>
+          </a:ln>
+        </p:spPr>
+        <p:style>
+          <a:lnRef idx="1">
+            <a:schemeClr val="accent1"/>
+          </a:lnRef>
+          <a:fillRef idx="3">
+            <a:schemeClr val="accent1"/>
+          </a:fillRef>
+          <a:effectRef idx="2">
+            <a:schemeClr val="accent1"/>
+          </a:effectRef>
+          <a:fontRef idx="minor">
+            <a:schemeClr val="lt1"/>
+          </a:fontRef>
+        </p:style>
+        <p:txBody>
+          <a:bodyPr rtlCol="0" anchor="ctr"/>
+          <a:lstStyle/>
+          <a:p>
+            <a:pPr algn="ctr"/>
+          </a:p>
+        </p:txBody>
+      </p:sp>
+      <p:sp>
+        <p:nvSpPr>
+          <p:cNvPr id="72" name="TextBox 71"/>
+          <p:cNvSpPr txBox="1"/>
+          <p:nvPr/>
+        </p:nvSpPr>
+        <p:spPr>
+          <a:xfrm>
+            <a:off x="8339327" y="2724912"/>
+            <a:ext cx="2596896" cy="228600"/>
+          </a:xfrm>
+          <a:prstGeom prst="rect">
+            <a:avLst/>
+          </a:prstGeom>
+          <a:noFill/>
+        </p:spPr>
+        <p:txBody>
+          <a:bodyPr wrap="square" lIns="0" rIns="0" tIns="0" bIns="0" anchor="t">
+            <a:spAutoFit/>
+          </a:bodyPr>
+          <a:lstStyle/>
+          <a:p>
+            <a:pPr algn="l">
+              <a:spcBef>
+                <a:spcPts val="0"/>
+              </a:spcBef>
+              <a:spcAft>
+                <a:spcPts val="0"/>
+              </a:spcAft>
+            </a:pPr>
+            <a:r>
+              <a:rPr sz="1000" b="1">
+                <a:solidFill>
+                  <a:srgbClr val="17324D"/>
+                </a:solidFill>
+                <a:latin typeface="Microsoft YaHei"/>
+              </a:rPr>
+              <a:t>M02　历史沿革与学脉传承</a:t>
+            </a:r>
+          </a:p>
+        </p:txBody>
+      </p:sp>
+      <p:sp>
+        <p:nvSpPr>
+          <p:cNvPr id="73" name="TextBox 72"/>
+          <p:cNvSpPr txBox="1"/>
+          <p:nvPr/>
+        </p:nvSpPr>
+        <p:spPr>
+          <a:xfrm>
+            <a:off x="8339327" y="3017520"/>
+            <a:ext cx="347472" cy="182880"/>
+          </a:xfrm>
+          <a:prstGeom prst="rect">
+            <a:avLst/>
+          </a:prstGeom>
+          <a:noFill/>
+        </p:spPr>
+        <p:txBody>
+          <a:bodyPr wrap="square" lIns="0" rIns="0" tIns="0" bIns="0" anchor="ctr">
+            <a:spAutoFit/>
+          </a:bodyPr>
+          <a:lstStyle/>
+          <a:p>
+            <a:pPr algn="l">
+              <a:spcBef>
+                <a:spcPts val="0"/>
+              </a:spcBef>
+              <a:spcAft>
+                <a:spcPts val="0"/>
+              </a:spcAft>
+            </a:pPr>
+            <a:r>
+              <a:rPr sz="850" b="0">
+                <a:solidFill>
+                  <a:srgbClr val="62748A"/>
+                </a:solidFill>
+                <a:latin typeface="Microsoft YaHei"/>
+              </a:rPr>
+              <a:t>中国</a:t>
+            </a:r>
+          </a:p>
+        </p:txBody>
+      </p:sp>
+      <p:sp>
+        <p:nvSpPr>
+          <p:cNvPr id="74" name="Rounded Rectangle 73"/>
+          <p:cNvSpPr/>
+          <p:nvPr/>
+        </p:nvSpPr>
+        <p:spPr>
+          <a:xfrm>
+            <a:off x="8732520" y="3067812"/>
+            <a:ext cx="1099748" cy="91440"/>
+          </a:xfrm>
+          <a:prstGeom prst="roundRect">
+            <a:avLst/>
+          </a:prstGeom>
+          <a:solidFill>
+            <a:srgbClr val="3568A8"/>
+          </a:solidFill>
+          <a:ln>
+            <a:noFill/>
+          </a:ln>
+        </p:spPr>
+        <p:style>
+          <a:lnRef idx="1">
+            <a:schemeClr val="accent1"/>
+          </a:lnRef>
+          <a:fillRef idx="3">
+            <a:schemeClr val="accent1"/>
+          </a:fillRef>
+          <a:effectRef idx="2">
+            <a:schemeClr val="accent1"/>
+          </a:effectRef>
+          <a:fontRef idx="minor">
+            <a:schemeClr val="lt1"/>
+          </a:fontRef>
+        </p:style>
+        <p:txBody>
+          <a:bodyPr rtlCol="0" anchor="ctr"/>
+          <a:lstStyle/>
+          <a:p>
+            <a:pPr algn="ctr"/>
+          </a:p>
+        </p:txBody>
+      </p:sp>
+      <p:sp>
+        <p:nvSpPr>
+          <p:cNvPr id="75" name="TextBox 74"/>
+          <p:cNvSpPr txBox="1"/>
+          <p:nvPr/>
+        </p:nvSpPr>
+        <p:spPr>
+          <a:xfrm>
+            <a:off x="9887132" y="3035808"/>
+            <a:ext cx="420624" cy="155448"/>
+          </a:xfrm>
+          <a:prstGeom prst="rect">
+            <a:avLst/>
+          </a:prstGeom>
+          <a:noFill/>
+        </p:spPr>
+        <p:txBody>
+          <a:bodyPr wrap="square" lIns="0" rIns="0" tIns="0" bIns="0" anchor="ctr">
+            <a:spAutoFit/>
+          </a:bodyPr>
+          <a:lstStyle/>
+          <a:p>
+            <a:pPr algn="l">
+              <a:spcBef>
+                <a:spcPts val="0"/>
+              </a:spcBef>
+              <a:spcAft>
+                <a:spcPts val="0"/>
+              </a:spcAft>
+            </a:pPr>
+            <a:r>
+              <a:rPr sz="800" b="1">
+                <a:solidFill>
+                  <a:srgbClr val="3568A8"/>
+                </a:solidFill>
+                <a:latin typeface="Microsoft YaHei"/>
+              </a:rPr>
+              <a:t>63.3</a:t>
+            </a:r>
+          </a:p>
+        </p:txBody>
+      </p:sp>
+      <p:sp>
+        <p:nvSpPr>
+          <p:cNvPr id="76" name="TextBox 75"/>
+          <p:cNvSpPr txBox="1"/>
+          <p:nvPr/>
+        </p:nvSpPr>
+        <p:spPr>
+          <a:xfrm>
+            <a:off x="8339327" y="3291839"/>
+            <a:ext cx="347472" cy="182880"/>
+          </a:xfrm>
+          <a:prstGeom prst="rect">
+            <a:avLst/>
+          </a:prstGeom>
+          <a:noFill/>
+        </p:spPr>
+        <p:txBody>
+          <a:bodyPr wrap="square" lIns="0" rIns="0" tIns="0" bIns="0" anchor="ctr">
+            <a:spAutoFit/>
+          </a:bodyPr>
+          <a:lstStyle/>
+          <a:p>
+            <a:pPr algn="l">
+              <a:spcBef>
+                <a:spcPts val="0"/>
+              </a:spcBef>
+              <a:spcAft>
+                <a:spcPts val="0"/>
+              </a:spcAft>
+            </a:pPr>
+            <a:r>
+              <a:rPr sz="850" b="0">
+                <a:solidFill>
+                  <a:srgbClr val="62748A"/>
+                </a:solidFill>
+                <a:latin typeface="Microsoft YaHei"/>
+              </a:rPr>
+              <a:t>美国</a:t>
+            </a:r>
+          </a:p>
+        </p:txBody>
+      </p:sp>
+      <p:sp>
+        <p:nvSpPr>
+          <p:cNvPr id="77" name="Rounded Rectangle 76"/>
+          <p:cNvSpPr/>
+          <p:nvPr/>
+        </p:nvSpPr>
+        <p:spPr>
+          <a:xfrm>
+            <a:off x="8732520" y="3342132"/>
+            <a:ext cx="404804" cy="91440"/>
+          </a:xfrm>
+          <a:prstGeom prst="roundRect">
+            <a:avLst/>
+          </a:prstGeom>
+          <a:solidFill>
+            <a:srgbClr val="E38B36"/>
+          </a:solidFill>
+          <a:ln>
+            <a:noFill/>
+          </a:ln>
+        </p:spPr>
+        <p:style>
+          <a:lnRef idx="1">
+            <a:schemeClr val="accent1"/>
+          </a:lnRef>
+          <a:fillRef idx="3">
+            <a:schemeClr val="accent1"/>
+          </a:fillRef>
+          <a:effectRef idx="2">
+            <a:schemeClr val="accent1"/>
+          </a:effectRef>
+          <a:fontRef idx="minor">
+            <a:schemeClr val="lt1"/>
+          </a:fontRef>
+        </p:style>
+        <p:txBody>
+          <a:bodyPr rtlCol="0" anchor="ctr"/>
+          <a:lstStyle/>
+          <a:p>
+            <a:pPr algn="ctr"/>
+          </a:p>
+        </p:txBody>
+      </p:sp>
+      <p:sp>
+        <p:nvSpPr>
+          <p:cNvPr id="78" name="TextBox 77"/>
+          <p:cNvSpPr txBox="1"/>
+          <p:nvPr/>
+        </p:nvSpPr>
+        <p:spPr>
+          <a:xfrm>
+            <a:off x="9192188" y="3310127"/>
+            <a:ext cx="420624" cy="155448"/>
+          </a:xfrm>
+          <a:prstGeom prst="rect">
+            <a:avLst/>
+          </a:prstGeom>
+          <a:noFill/>
+        </p:spPr>
+        <p:txBody>
+          <a:bodyPr wrap="square" lIns="0" rIns="0" tIns="0" bIns="0" anchor="ctr">
+            <a:spAutoFit/>
+          </a:bodyPr>
+          <a:lstStyle/>
+          <a:p>
+            <a:pPr algn="l">
+              <a:spcBef>
+                <a:spcPts val="0"/>
+              </a:spcBef>
+              <a:spcAft>
+                <a:spcPts val="0"/>
+              </a:spcAft>
+            </a:pPr>
+            <a:r>
+              <a:rPr sz="800" b="1">
+                <a:solidFill>
+                  <a:srgbClr val="E38B36"/>
+                </a:solidFill>
+                <a:latin typeface="Microsoft YaHei"/>
+              </a:rPr>
+              <a:t>23.3</a:t>
+            </a:r>
+          </a:p>
+        </p:txBody>
+      </p:sp>
+      <p:sp>
+        <p:nvSpPr>
+          <p:cNvPr id="79" name="TextBox 78"/>
+          <p:cNvSpPr txBox="1"/>
+          <p:nvPr/>
+        </p:nvSpPr>
+        <p:spPr>
+          <a:xfrm>
+            <a:off x="8339327" y="3593591"/>
+            <a:ext cx="2596896" cy="173736"/>
+          </a:xfrm>
+          <a:prstGeom prst="rect">
+            <a:avLst/>
+          </a:prstGeom>
+          <a:noFill/>
+        </p:spPr>
+        <p:txBody>
+          <a:bodyPr wrap="square" lIns="0" rIns="0" tIns="0" bIns="0" anchor="t">
+            <a:spAutoFit/>
+          </a:bodyPr>
+          <a:lstStyle/>
+          <a:p>
+            <a:pPr algn="ctr">
+              <a:spcBef>
+                <a:spcPts val="0"/>
+              </a:spcBef>
+              <a:spcAft>
+                <a:spcPts val="0"/>
+              </a:spcAft>
+            </a:pPr>
+            <a:r>
+              <a:rPr sz="880" b="1">
+                <a:solidFill>
+                  <a:srgbClr val="3568A8"/>
+                </a:solidFill>
+                <a:latin typeface="Microsoft YaHei"/>
+              </a:rPr>
+              <a:t>中国更常以历史开篇</a:t>
+            </a:r>
+          </a:p>
+        </p:txBody>
+      </p:sp>
+      <p:sp>
+        <p:nvSpPr>
+          <p:cNvPr id="80" name="Rounded Rectangle 79"/>
+          <p:cNvSpPr/>
+          <p:nvPr/>
+        </p:nvSpPr>
+        <p:spPr>
+          <a:xfrm>
+            <a:off x="8183879" y="3986783"/>
+            <a:ext cx="2907792" cy="1188720"/>
+          </a:xfrm>
+          <a:prstGeom prst="roundRect">
+            <a:avLst/>
+          </a:prstGeom>
+          <a:solidFill>
+            <a:srgbClr val="FFFFFF"/>
+          </a:solidFill>
+          <a:ln>
+            <a:noFill/>
+          </a:ln>
+        </p:spPr>
+        <p:style>
+          <a:lnRef idx="1">
+            <a:schemeClr val="accent1"/>
+          </a:lnRef>
+          <a:fillRef idx="3">
+            <a:schemeClr val="accent1"/>
+          </a:fillRef>
+          <a:effectRef idx="2">
+            <a:schemeClr val="accent1"/>
+          </a:effectRef>
+          <a:fontRef idx="minor">
+            <a:schemeClr val="lt1"/>
+          </a:fontRef>
+        </p:style>
+        <p:txBody>
+          <a:bodyPr rtlCol="0" anchor="ctr"/>
+          <a:lstStyle/>
+          <a:p>
+            <a:pPr algn="ctr"/>
+          </a:p>
+        </p:txBody>
+      </p:sp>
+      <p:sp>
+        <p:nvSpPr>
+          <p:cNvPr id="81" name="TextBox 80"/>
+          <p:cNvSpPr txBox="1"/>
+          <p:nvPr/>
+        </p:nvSpPr>
+        <p:spPr>
+          <a:xfrm>
+            <a:off x="8339327" y="4078223"/>
+            <a:ext cx="2596896" cy="228600"/>
+          </a:xfrm>
+          <a:prstGeom prst="rect">
+            <a:avLst/>
+          </a:prstGeom>
+          <a:noFill/>
+        </p:spPr>
+        <p:txBody>
+          <a:bodyPr wrap="square" lIns="0" rIns="0" tIns="0" bIns="0" anchor="t">
+            <a:spAutoFit/>
+          </a:bodyPr>
+          <a:lstStyle/>
+          <a:p>
+            <a:pPr algn="l">
+              <a:spcBef>
+                <a:spcPts val="0"/>
+              </a:spcBef>
+              <a:spcAft>
+                <a:spcPts val="0"/>
+              </a:spcAft>
+            </a:pPr>
+            <a:r>
+              <a:rPr sz="1000" b="1">
+                <a:solidFill>
+                  <a:srgbClr val="17324D"/>
+                </a:solidFill>
+                <a:latin typeface="Microsoft YaHei"/>
+              </a:rPr>
+              <a:t>M05　课程教学与培养目标</a:t>
+            </a:r>
+          </a:p>
+        </p:txBody>
+      </p:sp>
+      <p:sp>
+        <p:nvSpPr>
+          <p:cNvPr id="82" name="TextBox 81"/>
+          <p:cNvSpPr txBox="1"/>
+          <p:nvPr/>
+        </p:nvSpPr>
+        <p:spPr>
+          <a:xfrm>
+            <a:off x="8339327" y="4370831"/>
+            <a:ext cx="347472" cy="182880"/>
+          </a:xfrm>
+          <a:prstGeom prst="rect">
+            <a:avLst/>
+          </a:prstGeom>
+          <a:noFill/>
+        </p:spPr>
+        <p:txBody>
+          <a:bodyPr wrap="square" lIns="0" rIns="0" tIns="0" bIns="0" anchor="ctr">
+            <a:spAutoFit/>
+          </a:bodyPr>
+          <a:lstStyle/>
+          <a:p>
+            <a:pPr algn="l">
+              <a:spcBef>
+                <a:spcPts val="0"/>
+              </a:spcBef>
+              <a:spcAft>
+                <a:spcPts val="0"/>
+              </a:spcAft>
+            </a:pPr>
+            <a:r>
+              <a:rPr sz="850" b="0">
+                <a:solidFill>
+                  <a:srgbClr val="62748A"/>
+                </a:solidFill>
+                <a:latin typeface="Microsoft YaHei"/>
+              </a:rPr>
+              <a:t>中国</a:t>
+            </a:r>
+          </a:p>
+        </p:txBody>
+      </p:sp>
+      <p:sp>
+        <p:nvSpPr>
+          <p:cNvPr id="83" name="Rounded Rectangle 82"/>
+          <p:cNvSpPr/>
+          <p:nvPr/>
+        </p:nvSpPr>
+        <p:spPr>
+          <a:xfrm>
+            <a:off x="8732520" y="4421123"/>
+            <a:ext cx="116403" cy="91440"/>
+          </a:xfrm>
+          <a:prstGeom prst="roundRect">
+            <a:avLst/>
+          </a:prstGeom>
+          <a:solidFill>
+            <a:srgbClr val="3568A8"/>
+          </a:solidFill>
+          <a:ln>
+            <a:noFill/>
+          </a:ln>
+        </p:spPr>
+        <p:style>
+          <a:lnRef idx="1">
+            <a:schemeClr val="accent1"/>
+          </a:lnRef>
+          <a:fillRef idx="3">
+            <a:schemeClr val="accent1"/>
+          </a:fillRef>
+          <a:effectRef idx="2">
+            <a:schemeClr val="accent1"/>
+          </a:effectRef>
+          <a:fontRef idx="minor">
+            <a:schemeClr val="lt1"/>
+          </a:fontRef>
+        </p:style>
+        <p:txBody>
+          <a:bodyPr rtlCol="0" anchor="ctr"/>
+          <a:lstStyle/>
+          <a:p>
+            <a:pPr algn="ctr"/>
+          </a:p>
+        </p:txBody>
+      </p:sp>
+      <p:sp>
+        <p:nvSpPr>
+          <p:cNvPr id="84" name="TextBox 83"/>
+          <p:cNvSpPr txBox="1"/>
+          <p:nvPr/>
+        </p:nvSpPr>
+        <p:spPr>
+          <a:xfrm>
+            <a:off x="8903787" y="4389119"/>
+            <a:ext cx="420624" cy="155448"/>
+          </a:xfrm>
+          <a:prstGeom prst="rect">
+            <a:avLst/>
+          </a:prstGeom>
+          <a:noFill/>
+        </p:spPr>
+        <p:txBody>
+          <a:bodyPr wrap="square" lIns="0" rIns="0" tIns="0" bIns="0" anchor="ctr">
+            <a:spAutoFit/>
+          </a:bodyPr>
+          <a:lstStyle/>
+          <a:p>
+            <a:pPr algn="l">
+              <a:spcBef>
+                <a:spcPts val="0"/>
+              </a:spcBef>
+              <a:spcAft>
+                <a:spcPts val="0"/>
+              </a:spcAft>
+            </a:pPr>
+            <a:r>
+              <a:rPr sz="800" b="1">
+                <a:solidFill>
+                  <a:srgbClr val="3568A8"/>
+                </a:solidFill>
+                <a:latin typeface="Microsoft YaHei"/>
+              </a:rPr>
+              <a:t>6.7</a:t>
+            </a:r>
+          </a:p>
+        </p:txBody>
+      </p:sp>
+      <p:sp>
+        <p:nvSpPr>
+          <p:cNvPr id="85" name="TextBox 84"/>
+          <p:cNvSpPr txBox="1"/>
+          <p:nvPr/>
+        </p:nvSpPr>
+        <p:spPr>
+          <a:xfrm>
+            <a:off x="8339327" y="4645151"/>
+            <a:ext cx="347472" cy="182880"/>
+          </a:xfrm>
+          <a:prstGeom prst="rect">
+            <a:avLst/>
+          </a:prstGeom>
+          <a:noFill/>
+        </p:spPr>
+        <p:txBody>
+          <a:bodyPr wrap="square" lIns="0" rIns="0" tIns="0" bIns="0" anchor="ctr">
+            <a:spAutoFit/>
+          </a:bodyPr>
+          <a:lstStyle/>
+          <a:p>
+            <a:pPr algn="l">
+              <a:spcBef>
+                <a:spcPts val="0"/>
+              </a:spcBef>
+              <a:spcAft>
+                <a:spcPts val="0"/>
+              </a:spcAft>
+            </a:pPr>
+            <a:r>
+              <a:rPr sz="850" b="0">
+                <a:solidFill>
+                  <a:srgbClr val="62748A"/>
+                </a:solidFill>
+                <a:latin typeface="Microsoft YaHei"/>
+              </a:rPr>
+              <a:t>美国</a:t>
+            </a:r>
+          </a:p>
+        </p:txBody>
+      </p:sp>
+      <p:sp>
+        <p:nvSpPr>
+          <p:cNvPr id="86" name="Rounded Rectangle 85"/>
+          <p:cNvSpPr/>
+          <p:nvPr/>
+        </p:nvSpPr>
+        <p:spPr>
+          <a:xfrm>
+            <a:off x="8732520" y="4695443"/>
+            <a:ext cx="463875" cy="91440"/>
+          </a:xfrm>
+          <a:prstGeom prst="roundRect">
+            <a:avLst/>
+          </a:prstGeom>
+          <a:solidFill>
+            <a:srgbClr val="E38B36"/>
+          </a:solidFill>
+          <a:ln>
+            <a:noFill/>
+          </a:ln>
+        </p:spPr>
+        <p:style>
+          <a:lnRef idx="1">
+            <a:schemeClr val="accent1"/>
+          </a:lnRef>
+          <a:fillRef idx="3">
+            <a:schemeClr val="accent1"/>
+          </a:fillRef>
+          <a:effectRef idx="2">
+            <a:schemeClr val="accent1"/>
+          </a:effectRef>
+          <a:fontRef idx="minor">
+            <a:schemeClr val="lt1"/>
+          </a:fontRef>
+        </p:style>
+        <p:txBody>
+          <a:bodyPr rtlCol="0" anchor="ctr"/>
+          <a:lstStyle/>
+          <a:p>
+            <a:pPr algn="ctr"/>
+          </a:p>
+        </p:txBody>
+      </p:sp>
+      <p:sp>
+        <p:nvSpPr>
+          <p:cNvPr id="87" name="TextBox 86"/>
+          <p:cNvSpPr txBox="1"/>
+          <p:nvPr/>
+        </p:nvSpPr>
+        <p:spPr>
+          <a:xfrm>
+            <a:off x="9251259" y="4663439"/>
+            <a:ext cx="420624" cy="155448"/>
+          </a:xfrm>
+          <a:prstGeom prst="rect">
+            <a:avLst/>
+          </a:prstGeom>
+          <a:noFill/>
+        </p:spPr>
+        <p:txBody>
+          <a:bodyPr wrap="square" lIns="0" rIns="0" tIns="0" bIns="0" anchor="ctr">
+            <a:spAutoFit/>
+          </a:bodyPr>
+          <a:lstStyle/>
+          <a:p>
+            <a:pPr algn="l">
+              <a:spcBef>
+                <a:spcPts val="0"/>
+              </a:spcBef>
+              <a:spcAft>
+                <a:spcPts val="0"/>
+              </a:spcAft>
+            </a:pPr>
+            <a:r>
+              <a:rPr sz="800" b="1">
+                <a:solidFill>
+                  <a:srgbClr val="E38B36"/>
+                </a:solidFill>
+                <a:latin typeface="Microsoft YaHei"/>
+              </a:rPr>
+              <a:t>26.7</a:t>
+            </a:r>
+          </a:p>
+        </p:txBody>
+      </p:sp>
+      <p:sp>
+        <p:nvSpPr>
+          <p:cNvPr id="88" name="TextBox 87"/>
+          <p:cNvSpPr txBox="1"/>
+          <p:nvPr/>
+        </p:nvSpPr>
+        <p:spPr>
+          <a:xfrm>
+            <a:off x="8339327" y="4946903"/>
+            <a:ext cx="2596896" cy="173736"/>
+          </a:xfrm>
+          <a:prstGeom prst="rect">
+            <a:avLst/>
+          </a:prstGeom>
+          <a:noFill/>
+        </p:spPr>
+        <p:txBody>
+          <a:bodyPr wrap="square" lIns="0" rIns="0" tIns="0" bIns="0" anchor="t">
+            <a:spAutoFit/>
+          </a:bodyPr>
+          <a:lstStyle/>
+          <a:p>
+            <a:pPr algn="ctr">
+              <a:spcBef>
+                <a:spcPts val="0"/>
+              </a:spcBef>
+              <a:spcAft>
+                <a:spcPts val="0"/>
+              </a:spcAft>
+            </a:pPr>
+            <a:r>
+              <a:rPr sz="880" b="1">
+                <a:solidFill>
+                  <a:srgbClr val="E38B36"/>
+                </a:solidFill>
+                <a:latin typeface="Microsoft YaHei"/>
+              </a:rPr>
+              <a:t>美国更常以课程教学开篇</a:t>
+            </a:r>
+          </a:p>
+        </p:txBody>
+      </p:sp>
+      <p:sp>
+        <p:nvSpPr>
+          <p:cNvPr id="89" name="TextBox 88"/>
+          <p:cNvSpPr txBox="1"/>
+          <p:nvPr/>
+        </p:nvSpPr>
+        <p:spPr>
+          <a:xfrm>
+            <a:off x="8183879" y="5376672"/>
+            <a:ext cx="2907792" cy="329184"/>
+          </a:xfrm>
+          <a:prstGeom prst="rect">
+            <a:avLst/>
+          </a:prstGeom>
+          <a:noFill/>
+        </p:spPr>
+        <p:txBody>
+          <a:bodyPr wrap="square" lIns="0" rIns="0" tIns="0" bIns="0" anchor="t">
+            <a:spAutoFit/>
+          </a:bodyPr>
+          <a:lstStyle/>
+          <a:p>
+            <a:pPr algn="ctr">
+              <a:spcBef>
+                <a:spcPts val="0"/>
+              </a:spcBef>
+              <a:spcAft>
+                <a:spcPts val="0"/>
+              </a:spcAft>
+            </a:pPr>
+            <a:r>
+              <a:rPr sz="819" b="0">
+                <a:solidFill>
+                  <a:srgbClr val="62748A"/>
+                </a:solidFill>
+                <a:latin typeface="Microsoft YaHei"/>
+              </a:rPr>
+              <a:t>开篇＝该语步为文本首个语步</a:t>
+            </a:r>
+          </a:p>
+          <a:p>
+            <a:pPr algn="ctr">
+              <a:spcBef>
+                <a:spcPts val="0"/>
+              </a:spcBef>
+              <a:spcAft>
+                <a:spcPts val="0"/>
+              </a:spcAft>
+            </a:pPr>
+            <a:r>
+              <a:rPr sz="819" b="0">
+                <a:solidFill>
+                  <a:srgbClr val="62748A"/>
+                </a:solidFill>
+                <a:latin typeface="Microsoft YaHei"/>
+              </a:rPr>
+              <a:t>完整首次位置热图见附录</a:t>
+            </a:r>
+          </a:p>
+        </p:txBody>
+      </p:sp>
+      <p:sp>
+        <p:nvSpPr>
+          <p:cNvPr id="90" name="TextBox 89"/>
+          <p:cNvSpPr txBox="1"/>
+          <p:nvPr/>
+        </p:nvSpPr>
+        <p:spPr>
+          <a:xfrm>
+            <a:off x="768096" y="5852160"/>
+            <a:ext cx="7040880" cy="182880"/>
+          </a:xfrm>
+          <a:prstGeom prst="rect">
+            <a:avLst/>
+          </a:prstGeom>
+          <a:noFill/>
+        </p:spPr>
+        <p:txBody>
+          <a:bodyPr wrap="square" lIns="0" rIns="0" tIns="0" bIns="0" anchor="t">
+            <a:spAutoFit/>
+          </a:bodyPr>
+          <a:lstStyle/>
+          <a:p>
+            <a:pPr algn="l">
+              <a:spcBef>
+                <a:spcPts val="0"/>
+              </a:spcBef>
+              <a:spcAft>
+                <a:spcPts val="0"/>
+              </a:spcAft>
+            </a:pPr>
+            <a:r>
+              <a:rPr sz="850" b="0">
+                <a:solidFill>
+                  <a:srgbClr val="62748A"/>
+                </a:solidFill>
+                <a:latin typeface="Microsoft YaHei"/>
+              </a:rPr>
+              <a:t>注：篇幅占比＝语步词数／文本独立词数，图中取各组中位数。</a:t>
+            </a:r>
+          </a:p>
+        </p:txBody>
+      </p:sp>
+      <p:cxnSp>
+        <p:nvCxnSpPr>
+          <p:cNvPr id="91" name="Connector 90"/>
+          <p:cNvCxnSpPr/>
+          <p:nvPr/>
+        </p:nvCxnSpPr>
+        <p:spPr>
+          <a:xfrm>
+            <a:off x="731520" y="6144768"/>
+            <a:ext cx="10744200" cy="0"/>
+          </a:xfrm>
+          <a:prstGeom prst="line">
+            <a:avLst/>
+          </a:prstGeom>
+          <a:ln w="10160">
+            <a:solidFill>
+              <a:srgbClr val="D8E1EB"/>
+            </a:solidFill>
+          </a:ln>
+        </p:spPr>
+        <p:style>
+          <a:lnRef idx="2">
+            <a:schemeClr val="accent1"/>
+          </a:lnRef>
+          <a:fillRef idx="0">
+            <a:schemeClr val="accent1"/>
+          </a:fillRef>
+          <a:effectRef idx="1">
+            <a:schemeClr val="accent1"/>
+          </a:effectRef>
+          <a:fontRef idx="minor">
+            <a:schemeClr val="tx1"/>
+          </a:fontRef>
+        </p:style>
+      </p:cxnSp>
+      <p:sp>
+        <p:nvSpPr>
+          <p:cNvPr id="92" name="TextBox 91"/>
+          <p:cNvSpPr txBox="1"/>
+          <p:nvPr/>
+        </p:nvSpPr>
+        <p:spPr>
+          <a:xfrm>
+            <a:off x="731520" y="6318504"/>
+            <a:ext cx="7772400" cy="256032"/>
+          </a:xfrm>
+          <a:prstGeom prst="rect">
+            <a:avLst/>
+          </a:prstGeom>
+          <a:noFill/>
+        </p:spPr>
+        <p:txBody>
+          <a:bodyPr wrap="square" lIns="0" rIns="0" tIns="0" bIns="0" anchor="t">
+            <a:spAutoFit/>
+          </a:bodyPr>
+          <a:lstStyle/>
+          <a:p>
+            <a:pPr algn="l">
+              <a:spcBef>
+                <a:spcPts val="0"/>
+              </a:spcBef>
+              <a:spcAft>
+                <a:spcPts val="0"/>
+              </a:spcAft>
+            </a:pPr>
+            <a:r>
+              <a:rPr sz="900" b="0">
+                <a:solidFill>
+                  <a:srgbClr val="62748A"/>
+                </a:solidFill>
+                <a:latin typeface="Microsoft YaHei"/>
+              </a:rPr>
+              <a:t>基于语料库技术的中美外语院系英文简介话语比较分析</a:t>
+            </a:r>
+          </a:p>
+        </p:txBody>
+      </p:sp>
+      <p:sp>
+        <p:nvSpPr>
+          <p:cNvPr id="93" name="TextBox 92"/>
+          <p:cNvSpPr txBox="1"/>
+          <p:nvPr/>
+        </p:nvSpPr>
+        <p:spPr>
+          <a:xfrm>
+            <a:off x="10881360" y="6318504"/>
+            <a:ext cx="594360" cy="256032"/>
+          </a:xfrm>
+          <a:prstGeom prst="rect">
+            <a:avLst/>
+          </a:prstGeom>
+          <a:noFill/>
+        </p:spPr>
+        <p:txBody>
+          <a:bodyPr wrap="square" lIns="0" rIns="0" tIns="0" bIns="0" anchor="t">
+            <a:spAutoFit/>
+          </a:bodyPr>
+          <a:lstStyle/>
+          <a:p>
+            <a:pPr algn="r">
+              <a:spcBef>
+                <a:spcPts val="0"/>
+              </a:spcBef>
+              <a:spcAft>
+                <a:spcPts val="0"/>
+              </a:spcAft>
+            </a:pPr>
+            <a:r>
+              <a:rPr sz="1000" b="0">
+                <a:solidFill>
+                  <a:srgbClr val="62748A"/>
+                </a:solidFill>
+                <a:latin typeface="Microsoft YaHei"/>
+              </a:rPr>
+              <a:t>06 / 08</a:t>
             </a:r>
           </a:p>
         </p:txBody>

</xml_diff>

<commit_message>
Add editable language realization slide
Co-authored-by: arena-agent <297053741+arena-agent@users.noreply.github.com>
</commit_message>
<xml_diff>
--- a/midterm-report/presentation/中美外语院系英文简介_5分钟汇报.pptx
+++ b/midterm-report/presentation/中美外语院系英文简介_5分钟汇报.pptx
@@ -11,6 +11,7 @@
     <p:sldId id="259" r:id="rId10"/>
     <p:sldId id="260" r:id="rId11"/>
     <p:sldId id="261" r:id="rId12"/>
+    <p:sldId id="262" r:id="rId13"/>
   </p:sldIdLst>
   <p:sldSz cx="12191695" cy="6858000" type="screen4x3"/>
   <p:notesSz cx="6858000" cy="9144000"/>
@@ -20655,6 +20656,2663 @@
                 <a:latin typeface="Microsoft YaHei"/>
               </a:rPr>
               <a:t>06 / 08</a:t>
+            </a:r>
+          </a:p>
+        </p:txBody>
+      </p:sp>
+    </p:spTree>
+  </p:cSld>
+  <p:clrMapOvr>
+    <a:masterClrMapping/>
+  </p:clrMapOvr>
+</p:sld>
+</file>
+
+<file path=ppt/slides/slide7.xml><?xml version="1.0" encoding="utf-8"?>
+<p:sld xmlns:a="http://schemas.openxmlformats.org/drawingml/2006/main" xmlns:p="http://schemas.openxmlformats.org/presentationml/2006/main" xmlns:r="http://schemas.openxmlformats.org/officeDocument/2006/relationships">
+  <p:cSld>
+    <p:spTree>
+      <p:nvGrpSpPr>
+        <p:cNvPr id="1" name=""/>
+        <p:cNvGrpSpPr/>
+        <p:nvPr/>
+      </p:nvGrpSpPr>
+      <p:grpSpPr/>
+      <p:sp>
+        <p:nvSpPr>
+          <p:cNvPr id="2" name="Rectangle 1"/>
+          <p:cNvSpPr/>
+          <p:nvPr/>
+        </p:nvSpPr>
+        <p:spPr>
+          <a:xfrm>
+            <a:off x="0" y="0"/>
+            <a:ext cx="12191695" cy="6858000"/>
+          </a:xfrm>
+          <a:prstGeom prst="rect">
+            <a:avLst/>
+          </a:prstGeom>
+          <a:solidFill>
+            <a:srgbClr val="F7F9FC"/>
+          </a:solidFill>
+          <a:ln>
+            <a:noFill/>
+          </a:ln>
+        </p:spPr>
+        <p:style>
+          <a:lnRef idx="1">
+            <a:schemeClr val="accent1"/>
+          </a:lnRef>
+          <a:fillRef idx="3">
+            <a:schemeClr val="accent1"/>
+          </a:fillRef>
+          <a:effectRef idx="2">
+            <a:schemeClr val="accent1"/>
+          </a:effectRef>
+          <a:fontRef idx="minor">
+            <a:schemeClr val="lt1"/>
+          </a:fontRef>
+        </p:style>
+        <p:txBody>
+          <a:bodyPr rtlCol="0" anchor="ctr"/>
+          <a:lstStyle/>
+          <a:p>
+            <a:pPr algn="ctr"/>
+          </a:p>
+        </p:txBody>
+      </p:sp>
+      <p:sp>
+        <p:nvSpPr>
+          <p:cNvPr id="3" name="Rectangle 2"/>
+          <p:cNvSpPr/>
+          <p:nvPr/>
+        </p:nvSpPr>
+        <p:spPr>
+          <a:xfrm>
+            <a:off x="0" y="0"/>
+            <a:ext cx="146304" cy="6858000"/>
+          </a:xfrm>
+          <a:prstGeom prst="rect">
+            <a:avLst/>
+          </a:prstGeom>
+          <a:solidFill>
+            <a:srgbClr val="17324D"/>
+          </a:solidFill>
+          <a:ln>
+            <a:noFill/>
+          </a:ln>
+        </p:spPr>
+        <p:style>
+          <a:lnRef idx="1">
+            <a:schemeClr val="accent1"/>
+          </a:lnRef>
+          <a:fillRef idx="3">
+            <a:schemeClr val="accent1"/>
+          </a:fillRef>
+          <a:effectRef idx="2">
+            <a:schemeClr val="accent1"/>
+          </a:effectRef>
+          <a:fontRef idx="minor">
+            <a:schemeClr val="lt1"/>
+          </a:fontRef>
+        </p:style>
+        <p:txBody>
+          <a:bodyPr rtlCol="0" anchor="ctr"/>
+          <a:lstStyle/>
+          <a:p>
+            <a:pPr algn="ctr"/>
+          </a:p>
+        </p:txBody>
+      </p:sp>
+      <p:sp>
+        <p:nvSpPr>
+          <p:cNvPr id="4" name="Rectangle 3"/>
+          <p:cNvSpPr/>
+          <p:nvPr/>
+        </p:nvSpPr>
+        <p:spPr>
+          <a:xfrm>
+            <a:off x="146304" y="0"/>
+            <a:ext cx="50292" cy="841248"/>
+          </a:xfrm>
+          <a:prstGeom prst="rect">
+            <a:avLst/>
+          </a:prstGeom>
+          <a:solidFill>
+            <a:srgbClr val="E38B36"/>
+          </a:solidFill>
+          <a:ln>
+            <a:noFill/>
+          </a:ln>
+        </p:spPr>
+        <p:style>
+          <a:lnRef idx="1">
+            <a:schemeClr val="accent1"/>
+          </a:lnRef>
+          <a:fillRef idx="3">
+            <a:schemeClr val="accent1"/>
+          </a:fillRef>
+          <a:effectRef idx="2">
+            <a:schemeClr val="accent1"/>
+          </a:effectRef>
+          <a:fontRef idx="minor">
+            <a:schemeClr val="lt1"/>
+          </a:fontRef>
+        </p:style>
+        <p:txBody>
+          <a:bodyPr rtlCol="0" anchor="ctr"/>
+          <a:lstStyle/>
+          <a:p>
+            <a:pPr algn="ctr"/>
+          </a:p>
+        </p:txBody>
+      </p:sp>
+      <p:sp>
+        <p:nvSpPr>
+          <p:cNvPr id="5" name="TextBox 4"/>
+          <p:cNvSpPr txBox="1"/>
+          <p:nvPr/>
+        </p:nvSpPr>
+        <p:spPr>
+          <a:xfrm>
+            <a:off x="731520" y="438912"/>
+            <a:ext cx="3840480" cy="274320"/>
+          </a:xfrm>
+          <a:prstGeom prst="rect">
+            <a:avLst/>
+          </a:prstGeom>
+          <a:noFill/>
+        </p:spPr>
+        <p:txBody>
+          <a:bodyPr wrap="square" lIns="0" rIns="0" tIns="0" bIns="0" anchor="t">
+            <a:spAutoFit/>
+          </a:bodyPr>
+          <a:lstStyle/>
+          <a:p>
+            <a:pPr algn="l">
+              <a:spcBef>
+                <a:spcPts val="0"/>
+              </a:spcBef>
+              <a:spcAft>
+                <a:spcPts val="0"/>
+              </a:spcAft>
+            </a:pPr>
+            <a:r>
+              <a:rPr sz="1100" b="1">
+                <a:solidFill>
+                  <a:srgbClr val="3568A8"/>
+                </a:solidFill>
+                <a:latin typeface="Microsoft YaHei"/>
+              </a:rPr>
+              <a:t>05　研究结果｜语言实现</a:t>
+            </a:r>
+          </a:p>
+        </p:txBody>
+      </p:sp>
+      <p:sp>
+        <p:nvSpPr>
+          <p:cNvPr id="6" name="TextBox 5"/>
+          <p:cNvSpPr txBox="1"/>
+          <p:nvPr/>
+        </p:nvSpPr>
+        <p:spPr>
+          <a:xfrm>
+            <a:off x="731520" y="768096"/>
+            <a:ext cx="9875520" cy="475488"/>
+          </a:xfrm>
+          <a:prstGeom prst="rect">
+            <a:avLst/>
+          </a:prstGeom>
+          <a:noFill/>
+        </p:spPr>
+        <p:txBody>
+          <a:bodyPr wrap="square" lIns="0" rIns="0" tIns="0" bIns="0" anchor="t">
+            <a:spAutoFit/>
+          </a:bodyPr>
+          <a:lstStyle/>
+          <a:p>
+            <a:pPr algn="l">
+              <a:spcBef>
+                <a:spcPts val="0"/>
+              </a:spcBef>
+              <a:spcAft>
+                <a:spcPts val="0"/>
+              </a:spcAft>
+            </a:pPr>
+            <a:r>
+              <a:rPr sz="2600" b="1">
+                <a:solidFill>
+                  <a:srgbClr val="17324D"/>
+                </a:solidFill>
+                <a:latin typeface="Microsoft YaHei"/>
+              </a:rPr>
+              <a:t>语言实现：相同语步，不同表达重心</a:t>
+            </a:r>
+          </a:p>
+        </p:txBody>
+      </p:sp>
+      <p:sp>
+        <p:nvSpPr>
+          <p:cNvPr id="7" name="TextBox 6"/>
+          <p:cNvSpPr txBox="1"/>
+          <p:nvPr/>
+        </p:nvSpPr>
+        <p:spPr>
+          <a:xfrm>
+            <a:off x="731520" y="1307592"/>
+            <a:ext cx="10515600" cy="384048"/>
+          </a:xfrm>
+          <a:prstGeom prst="rect">
+            <a:avLst/>
+          </a:prstGeom>
+          <a:noFill/>
+        </p:spPr>
+        <p:txBody>
+          <a:bodyPr wrap="square" lIns="0" rIns="0" tIns="0" bIns="0" anchor="ctr">
+            <a:spAutoFit/>
+          </a:bodyPr>
+          <a:lstStyle/>
+          <a:p>
+            <a:pPr algn="l">
+              <a:spcBef>
+                <a:spcPts val="0"/>
+              </a:spcBef>
+              <a:spcAft>
+                <a:spcPts val="0"/>
+              </a:spcAft>
+            </a:pPr>
+            <a:r>
+              <a:rPr sz="1400" b="0">
+                <a:solidFill>
+                  <a:srgbClr val="23364A"/>
+                </a:solidFill>
+                <a:latin typeface="Microsoft YaHei"/>
+              </a:rPr>
+              <a:t>关键词差异主要体现在议题选择与语义组合，而非语步是否出现</a:t>
+            </a:r>
+          </a:p>
+        </p:txBody>
+      </p:sp>
+      <p:sp>
+        <p:nvSpPr>
+          <p:cNvPr id="8" name="Rectangle 7"/>
+          <p:cNvSpPr/>
+          <p:nvPr/>
+        </p:nvSpPr>
+        <p:spPr>
+          <a:xfrm>
+            <a:off x="731520" y="1773936"/>
+            <a:ext cx="594360" cy="41148"/>
+          </a:xfrm>
+          <a:prstGeom prst="rect">
+            <a:avLst/>
+          </a:prstGeom>
+          <a:solidFill>
+            <a:srgbClr val="E38B36"/>
+          </a:solidFill>
+          <a:ln>
+            <a:noFill/>
+          </a:ln>
+        </p:spPr>
+        <p:style>
+          <a:lnRef idx="1">
+            <a:schemeClr val="accent1"/>
+          </a:lnRef>
+          <a:fillRef idx="3">
+            <a:schemeClr val="accent1"/>
+          </a:fillRef>
+          <a:effectRef idx="2">
+            <a:schemeClr val="accent1"/>
+          </a:effectRef>
+          <a:fontRef idx="minor">
+            <a:schemeClr val="lt1"/>
+          </a:fontRef>
+        </p:style>
+        <p:txBody>
+          <a:bodyPr rtlCol="0" anchor="ctr"/>
+          <a:lstStyle/>
+          <a:p>
+            <a:pPr algn="ctr"/>
+          </a:p>
+        </p:txBody>
+      </p:sp>
+      <p:sp>
+        <p:nvSpPr>
+          <p:cNvPr id="9" name="Rounded Rectangle 8"/>
+          <p:cNvSpPr/>
+          <p:nvPr/>
+        </p:nvSpPr>
+        <p:spPr>
+          <a:xfrm>
+            <a:off x="731520" y="1993392"/>
+            <a:ext cx="5193792" cy="1664208"/>
+          </a:xfrm>
+          <a:prstGeom prst="roundRect">
+            <a:avLst/>
+          </a:prstGeom>
+          <a:solidFill>
+            <a:srgbClr val="FFFFFF"/>
+          </a:solidFill>
+          <a:ln w="10160">
+            <a:solidFill>
+              <a:srgbClr val="D8E1EB"/>
+            </a:solidFill>
+          </a:ln>
+        </p:spPr>
+        <p:style>
+          <a:lnRef idx="1">
+            <a:schemeClr val="accent1"/>
+          </a:lnRef>
+          <a:fillRef idx="3">
+            <a:schemeClr val="accent1"/>
+          </a:fillRef>
+          <a:effectRef idx="2">
+            <a:schemeClr val="accent1"/>
+          </a:effectRef>
+          <a:fontRef idx="minor">
+            <a:schemeClr val="lt1"/>
+          </a:fontRef>
+        </p:style>
+        <p:txBody>
+          <a:bodyPr rtlCol="0" anchor="ctr"/>
+          <a:lstStyle/>
+          <a:p>
+            <a:pPr algn="ctr"/>
+          </a:p>
+        </p:txBody>
+      </p:sp>
+      <p:sp>
+        <p:nvSpPr>
+          <p:cNvPr id="10" name="Rectangle 9"/>
+          <p:cNvSpPr/>
+          <p:nvPr/>
+        </p:nvSpPr>
+        <p:spPr>
+          <a:xfrm>
+            <a:off x="731520" y="1993392"/>
+            <a:ext cx="5193792" cy="54864"/>
+          </a:xfrm>
+          <a:prstGeom prst="rect">
+            <a:avLst/>
+          </a:prstGeom>
+          <a:solidFill>
+            <a:srgbClr val="17324D"/>
+          </a:solidFill>
+          <a:ln>
+            <a:noFill/>
+          </a:ln>
+        </p:spPr>
+        <p:style>
+          <a:lnRef idx="1">
+            <a:schemeClr val="accent1"/>
+          </a:lnRef>
+          <a:fillRef idx="3">
+            <a:schemeClr val="accent1"/>
+          </a:fillRef>
+          <a:effectRef idx="2">
+            <a:schemeClr val="accent1"/>
+          </a:effectRef>
+          <a:fontRef idx="minor">
+            <a:schemeClr val="lt1"/>
+          </a:fontRef>
+        </p:style>
+        <p:txBody>
+          <a:bodyPr rtlCol="0" anchor="ctr"/>
+          <a:lstStyle/>
+          <a:p>
+            <a:pPr algn="ctr"/>
+          </a:p>
+        </p:txBody>
+      </p:sp>
+      <p:sp>
+        <p:nvSpPr>
+          <p:cNvPr id="11" name="TextBox 10"/>
+          <p:cNvSpPr txBox="1"/>
+          <p:nvPr/>
+        </p:nvSpPr>
+        <p:spPr>
+          <a:xfrm>
+            <a:off x="914400" y="2130552"/>
+            <a:ext cx="502920" cy="274320"/>
+          </a:xfrm>
+          <a:prstGeom prst="rect">
+            <a:avLst/>
+          </a:prstGeom>
+          <a:noFill/>
+        </p:spPr>
+        <p:txBody>
+          <a:bodyPr wrap="square" lIns="0" rIns="0" tIns="0" bIns="0" anchor="ctr">
+            <a:spAutoFit/>
+          </a:bodyPr>
+          <a:lstStyle/>
+          <a:p>
+            <a:pPr algn="l">
+              <a:spcBef>
+                <a:spcPts val="0"/>
+              </a:spcBef>
+              <a:spcAft>
+                <a:spcPts val="0"/>
+              </a:spcAft>
+            </a:pPr>
+            <a:r>
+              <a:rPr sz="1400" b="1">
+                <a:solidFill>
+                  <a:srgbClr val="3568A8"/>
+                </a:solidFill>
+                <a:latin typeface="Microsoft YaHei"/>
+              </a:rPr>
+              <a:t>M03</a:t>
+            </a:r>
+          </a:p>
+        </p:txBody>
+      </p:sp>
+      <p:sp>
+        <p:nvSpPr>
+          <p:cNvPr id="12" name="TextBox 11"/>
+          <p:cNvSpPr txBox="1"/>
+          <p:nvPr/>
+        </p:nvSpPr>
+        <p:spPr>
+          <a:xfrm>
+            <a:off x="1517904" y="2130552"/>
+            <a:ext cx="4187952" cy="274320"/>
+          </a:xfrm>
+          <a:prstGeom prst="rect">
+            <a:avLst/>
+          </a:prstGeom>
+          <a:noFill/>
+        </p:spPr>
+        <p:txBody>
+          <a:bodyPr wrap="square" lIns="0" rIns="0" tIns="0" bIns="0" anchor="ctr">
+            <a:spAutoFit/>
+          </a:bodyPr>
+          <a:lstStyle/>
+          <a:p>
+            <a:pPr algn="l">
+              <a:spcBef>
+                <a:spcPts val="0"/>
+              </a:spcBef>
+              <a:spcAft>
+                <a:spcPts val="0"/>
+              </a:spcAft>
+            </a:pPr>
+            <a:r>
+              <a:rPr sz="1250" b="1">
+                <a:solidFill>
+                  <a:srgbClr val="17324D"/>
+                </a:solidFill>
+                <a:latin typeface="Microsoft YaHei"/>
+              </a:rPr>
+              <a:t>使命愿景与公共价值</a:t>
+            </a:r>
+          </a:p>
+        </p:txBody>
+      </p:sp>
+      <p:cxnSp>
+        <p:nvCxnSpPr>
+          <p:cNvPr id="13" name="Connector 12"/>
+          <p:cNvCxnSpPr/>
+          <p:nvPr/>
+        </p:nvCxnSpPr>
+        <p:spPr>
+          <a:xfrm>
+            <a:off x="914400" y="2459736"/>
+            <a:ext cx="4828032" cy="0"/>
+          </a:xfrm>
+          <a:prstGeom prst="line">
+            <a:avLst/>
+          </a:prstGeom>
+          <a:ln w="8890">
+            <a:solidFill>
+              <a:srgbClr val="D8E1EB"/>
+            </a:solidFill>
+          </a:ln>
+        </p:spPr>
+        <p:style>
+          <a:lnRef idx="2">
+            <a:schemeClr val="accent1"/>
+          </a:lnRef>
+          <a:fillRef idx="0">
+            <a:schemeClr val="accent1"/>
+          </a:fillRef>
+          <a:effectRef idx="1">
+            <a:schemeClr val="accent1"/>
+          </a:effectRef>
+          <a:fontRef idx="minor">
+            <a:schemeClr val="tx1"/>
+          </a:fontRef>
+        </p:style>
+      </p:cxnSp>
+      <p:sp>
+        <p:nvSpPr>
+          <p:cNvPr id="14" name="Rounded Rectangle 13"/>
+          <p:cNvSpPr/>
+          <p:nvPr/>
+        </p:nvSpPr>
+        <p:spPr>
+          <a:xfrm>
+            <a:off x="914400" y="2551176"/>
+            <a:ext cx="493776" cy="237744"/>
+          </a:xfrm>
+          <a:prstGeom prst="roundRect">
+            <a:avLst/>
+          </a:prstGeom>
+          <a:solidFill>
+            <a:srgbClr val="EAF1F8"/>
+          </a:solidFill>
+          <a:ln>
+            <a:noFill/>
+          </a:ln>
+        </p:spPr>
+        <p:style>
+          <a:lnRef idx="1">
+            <a:schemeClr val="accent1"/>
+          </a:lnRef>
+          <a:fillRef idx="3">
+            <a:schemeClr val="accent1"/>
+          </a:fillRef>
+          <a:effectRef idx="2">
+            <a:schemeClr val="accent1"/>
+          </a:effectRef>
+          <a:fontRef idx="minor">
+            <a:schemeClr val="lt1"/>
+          </a:fontRef>
+        </p:style>
+        <p:txBody>
+          <a:bodyPr rtlCol="0" anchor="ctr"/>
+          <a:lstStyle/>
+          <a:p>
+            <a:pPr algn="ctr"/>
+          </a:p>
+        </p:txBody>
+      </p:sp>
+      <p:sp>
+        <p:nvSpPr>
+          <p:cNvPr id="15" name="TextBox 14"/>
+          <p:cNvSpPr txBox="1"/>
+          <p:nvPr/>
+        </p:nvSpPr>
+        <p:spPr>
+          <a:xfrm>
+            <a:off x="914400" y="2551176"/>
+            <a:ext cx="493776" cy="237744"/>
+          </a:xfrm>
+          <a:prstGeom prst="rect">
+            <a:avLst/>
+          </a:prstGeom>
+          <a:noFill/>
+        </p:spPr>
+        <p:txBody>
+          <a:bodyPr wrap="square" lIns="0" rIns="0" tIns="0" bIns="0" anchor="ctr">
+            <a:spAutoFit/>
+          </a:bodyPr>
+          <a:lstStyle/>
+          <a:p>
+            <a:pPr algn="ctr">
+              <a:spcBef>
+                <a:spcPts val="0"/>
+              </a:spcBef>
+              <a:spcAft>
+                <a:spcPts val="0"/>
+              </a:spcAft>
+            </a:pPr>
+            <a:r>
+              <a:rPr sz="900" b="1">
+                <a:solidFill>
+                  <a:srgbClr val="3568A8"/>
+                </a:solidFill>
+                <a:latin typeface="Microsoft YaHei"/>
+              </a:rPr>
+              <a:t>中国</a:t>
+            </a:r>
+          </a:p>
+        </p:txBody>
+      </p:sp>
+      <p:sp>
+        <p:nvSpPr>
+          <p:cNvPr id="16" name="TextBox 15"/>
+          <p:cNvSpPr txBox="1"/>
+          <p:nvPr/>
+        </p:nvSpPr>
+        <p:spPr>
+          <a:xfrm>
+            <a:off x="1536192" y="2542032"/>
+            <a:ext cx="4151376" cy="246888"/>
+          </a:xfrm>
+          <a:prstGeom prst="rect">
+            <a:avLst/>
+          </a:prstGeom>
+          <a:noFill/>
+        </p:spPr>
+        <p:txBody>
+          <a:bodyPr wrap="square" lIns="0" rIns="0" tIns="0" bIns="0" anchor="ctr">
+            <a:spAutoFit/>
+          </a:bodyPr>
+          <a:lstStyle/>
+          <a:p>
+            <a:pPr algn="l">
+              <a:spcBef>
+                <a:spcPts val="0"/>
+              </a:spcBef>
+              <a:spcAft>
+                <a:spcPts val="0"/>
+              </a:spcAft>
+            </a:pPr>
+            <a:r>
+              <a:rPr sz="1050" b="1">
+                <a:solidFill>
+                  <a:srgbClr val="23364A"/>
+                </a:solidFill>
+                <a:latin typeface="Microsoft YaHei"/>
+              </a:rPr>
+              <a:t>人才培养与国际／国家指向</a:t>
+            </a:r>
+          </a:p>
+        </p:txBody>
+      </p:sp>
+      <p:sp>
+        <p:nvSpPr>
+          <p:cNvPr id="17" name="TextBox 16"/>
+          <p:cNvSpPr txBox="1"/>
+          <p:nvPr/>
+        </p:nvSpPr>
+        <p:spPr>
+          <a:xfrm>
+            <a:off x="1536192" y="2816352"/>
+            <a:ext cx="4151376" cy="210312"/>
+          </a:xfrm>
+          <a:prstGeom prst="rect">
+            <a:avLst/>
+          </a:prstGeom>
+          <a:noFill/>
+        </p:spPr>
+        <p:txBody>
+          <a:bodyPr wrap="square" lIns="0" rIns="0" tIns="0" bIns="0" anchor="ctr">
+            <a:spAutoFit/>
+          </a:bodyPr>
+          <a:lstStyle/>
+          <a:p>
+            <a:pPr algn="l">
+              <a:spcBef>
+                <a:spcPts val="0"/>
+              </a:spcBef>
+              <a:spcAft>
+                <a:spcPts val="0"/>
+              </a:spcAft>
+            </a:pPr>
+            <a:r>
+              <a:rPr sz="919" b="0">
+                <a:solidFill>
+                  <a:srgbClr val="62748A"/>
+                </a:solidFill>
+                <a:latin typeface="Microsoft YaHei"/>
+              </a:rPr>
+              <a:t>talents · cultivate · aims · international</a:t>
+            </a:r>
+          </a:p>
+        </p:txBody>
+      </p:sp>
+      <p:sp>
+        <p:nvSpPr>
+          <p:cNvPr id="18" name="Rounded Rectangle 17"/>
+          <p:cNvSpPr/>
+          <p:nvPr/>
+        </p:nvSpPr>
+        <p:spPr>
+          <a:xfrm>
+            <a:off x="914400" y="3108960"/>
+            <a:ext cx="493776" cy="237744"/>
+          </a:xfrm>
+          <a:prstGeom prst="roundRect">
+            <a:avLst/>
+          </a:prstGeom>
+          <a:solidFill>
+            <a:srgbClr val="FFF3E5"/>
+          </a:solidFill>
+          <a:ln>
+            <a:noFill/>
+          </a:ln>
+        </p:spPr>
+        <p:style>
+          <a:lnRef idx="1">
+            <a:schemeClr val="accent1"/>
+          </a:lnRef>
+          <a:fillRef idx="3">
+            <a:schemeClr val="accent1"/>
+          </a:fillRef>
+          <a:effectRef idx="2">
+            <a:schemeClr val="accent1"/>
+          </a:effectRef>
+          <a:fontRef idx="minor">
+            <a:schemeClr val="lt1"/>
+          </a:fontRef>
+        </p:style>
+        <p:txBody>
+          <a:bodyPr rtlCol="0" anchor="ctr"/>
+          <a:lstStyle/>
+          <a:p>
+            <a:pPr algn="ctr"/>
+          </a:p>
+        </p:txBody>
+      </p:sp>
+      <p:sp>
+        <p:nvSpPr>
+          <p:cNvPr id="19" name="TextBox 18"/>
+          <p:cNvSpPr txBox="1"/>
+          <p:nvPr/>
+        </p:nvSpPr>
+        <p:spPr>
+          <a:xfrm>
+            <a:off x="914400" y="3108960"/>
+            <a:ext cx="493776" cy="237744"/>
+          </a:xfrm>
+          <a:prstGeom prst="rect">
+            <a:avLst/>
+          </a:prstGeom>
+          <a:noFill/>
+        </p:spPr>
+        <p:txBody>
+          <a:bodyPr wrap="square" lIns="0" rIns="0" tIns="0" bIns="0" anchor="ctr">
+            <a:spAutoFit/>
+          </a:bodyPr>
+          <a:lstStyle/>
+          <a:p>
+            <a:pPr algn="ctr">
+              <a:spcBef>
+                <a:spcPts val="0"/>
+              </a:spcBef>
+              <a:spcAft>
+                <a:spcPts val="0"/>
+              </a:spcAft>
+            </a:pPr>
+            <a:r>
+              <a:rPr sz="900" b="1">
+                <a:solidFill>
+                  <a:srgbClr val="E38B36"/>
+                </a:solidFill>
+                <a:latin typeface="Microsoft YaHei"/>
+              </a:rPr>
+              <a:t>美国</a:t>
+            </a:r>
+          </a:p>
+        </p:txBody>
+      </p:sp>
+      <p:sp>
+        <p:nvSpPr>
+          <p:cNvPr id="20" name="TextBox 19"/>
+          <p:cNvSpPr txBox="1"/>
+          <p:nvPr/>
+        </p:nvSpPr>
+        <p:spPr>
+          <a:xfrm>
+            <a:off x="1536192" y="3099816"/>
+            <a:ext cx="4151376" cy="246888"/>
+          </a:xfrm>
+          <a:prstGeom prst="rect">
+            <a:avLst/>
+          </a:prstGeom>
+          <a:noFill/>
+        </p:spPr>
+        <p:txBody>
+          <a:bodyPr wrap="square" lIns="0" rIns="0" tIns="0" bIns="0" anchor="ctr">
+            <a:spAutoFit/>
+          </a:bodyPr>
+          <a:lstStyle/>
+          <a:p>
+            <a:pPr algn="l">
+              <a:spcBef>
+                <a:spcPts val="0"/>
+              </a:spcBef>
+              <a:spcAft>
+                <a:spcPts val="0"/>
+              </a:spcAft>
+            </a:pPr>
+            <a:r>
+              <a:rPr sz="1050" b="1">
+                <a:solidFill>
+                  <a:srgbClr val="23364A"/>
+                </a:solidFill>
+                <a:latin typeface="Microsoft YaHei"/>
+              </a:rPr>
+              <a:t>公共价值与共同体</a:t>
+            </a:r>
+          </a:p>
+        </p:txBody>
+      </p:sp>
+      <p:sp>
+        <p:nvSpPr>
+          <p:cNvPr id="21" name="TextBox 20"/>
+          <p:cNvSpPr txBox="1"/>
+          <p:nvPr/>
+        </p:nvSpPr>
+        <p:spPr>
+          <a:xfrm>
+            <a:off x="1536192" y="3374136"/>
+            <a:ext cx="4151376" cy="210312"/>
+          </a:xfrm>
+          <a:prstGeom prst="rect">
+            <a:avLst/>
+          </a:prstGeom>
+          <a:noFill/>
+        </p:spPr>
+        <p:txBody>
+          <a:bodyPr wrap="square" lIns="0" rIns="0" tIns="0" bIns="0" anchor="ctr">
+            <a:spAutoFit/>
+          </a:bodyPr>
+          <a:lstStyle/>
+          <a:p>
+            <a:pPr algn="l">
+              <a:spcBef>
+                <a:spcPts val="0"/>
+              </a:spcBef>
+              <a:spcAft>
+                <a:spcPts val="0"/>
+              </a:spcAft>
+            </a:pPr>
+            <a:r>
+              <a:rPr sz="919" b="0">
+                <a:solidFill>
+                  <a:srgbClr val="62748A"/>
+                </a:solidFill>
+                <a:latin typeface="Microsoft YaHei"/>
+              </a:rPr>
+              <a:t>diversity · equity · inclusion · community</a:t>
+            </a:r>
+          </a:p>
+        </p:txBody>
+      </p:sp>
+      <p:sp>
+        <p:nvSpPr>
+          <p:cNvPr id="22" name="Rounded Rectangle 21"/>
+          <p:cNvSpPr/>
+          <p:nvPr/>
+        </p:nvSpPr>
+        <p:spPr>
+          <a:xfrm>
+            <a:off x="6144768" y="1993392"/>
+            <a:ext cx="5193792" cy="1664208"/>
+          </a:xfrm>
+          <a:prstGeom prst="roundRect">
+            <a:avLst/>
+          </a:prstGeom>
+          <a:solidFill>
+            <a:srgbClr val="FFFFFF"/>
+          </a:solidFill>
+          <a:ln w="10160">
+            <a:solidFill>
+              <a:srgbClr val="D8E1EB"/>
+            </a:solidFill>
+          </a:ln>
+        </p:spPr>
+        <p:style>
+          <a:lnRef idx="1">
+            <a:schemeClr val="accent1"/>
+          </a:lnRef>
+          <a:fillRef idx="3">
+            <a:schemeClr val="accent1"/>
+          </a:fillRef>
+          <a:effectRef idx="2">
+            <a:schemeClr val="accent1"/>
+          </a:effectRef>
+          <a:fontRef idx="minor">
+            <a:schemeClr val="lt1"/>
+          </a:fontRef>
+        </p:style>
+        <p:txBody>
+          <a:bodyPr rtlCol="0" anchor="ctr"/>
+          <a:lstStyle/>
+          <a:p>
+            <a:pPr algn="ctr"/>
+          </a:p>
+        </p:txBody>
+      </p:sp>
+      <p:sp>
+        <p:nvSpPr>
+          <p:cNvPr id="23" name="Rectangle 22"/>
+          <p:cNvSpPr/>
+          <p:nvPr/>
+        </p:nvSpPr>
+        <p:spPr>
+          <a:xfrm>
+            <a:off x="6144768" y="1993392"/>
+            <a:ext cx="5193792" cy="54864"/>
+          </a:xfrm>
+          <a:prstGeom prst="rect">
+            <a:avLst/>
+          </a:prstGeom>
+          <a:solidFill>
+            <a:srgbClr val="17324D"/>
+          </a:solidFill>
+          <a:ln>
+            <a:noFill/>
+          </a:ln>
+        </p:spPr>
+        <p:style>
+          <a:lnRef idx="1">
+            <a:schemeClr val="accent1"/>
+          </a:lnRef>
+          <a:fillRef idx="3">
+            <a:schemeClr val="accent1"/>
+          </a:fillRef>
+          <a:effectRef idx="2">
+            <a:schemeClr val="accent1"/>
+          </a:effectRef>
+          <a:fontRef idx="minor">
+            <a:schemeClr val="lt1"/>
+          </a:fontRef>
+        </p:style>
+        <p:txBody>
+          <a:bodyPr rtlCol="0" anchor="ctr"/>
+          <a:lstStyle/>
+          <a:p>
+            <a:pPr algn="ctr"/>
+          </a:p>
+        </p:txBody>
+      </p:sp>
+      <p:sp>
+        <p:nvSpPr>
+          <p:cNvPr id="24" name="TextBox 23"/>
+          <p:cNvSpPr txBox="1"/>
+          <p:nvPr/>
+        </p:nvSpPr>
+        <p:spPr>
+          <a:xfrm>
+            <a:off x="6327648" y="2130552"/>
+            <a:ext cx="502920" cy="274320"/>
+          </a:xfrm>
+          <a:prstGeom prst="rect">
+            <a:avLst/>
+          </a:prstGeom>
+          <a:noFill/>
+        </p:spPr>
+        <p:txBody>
+          <a:bodyPr wrap="square" lIns="0" rIns="0" tIns="0" bIns="0" anchor="ctr">
+            <a:spAutoFit/>
+          </a:bodyPr>
+          <a:lstStyle/>
+          <a:p>
+            <a:pPr algn="l">
+              <a:spcBef>
+                <a:spcPts val="0"/>
+              </a:spcBef>
+              <a:spcAft>
+                <a:spcPts val="0"/>
+              </a:spcAft>
+            </a:pPr>
+            <a:r>
+              <a:rPr sz="1400" b="1">
+                <a:solidFill>
+                  <a:srgbClr val="3568A8"/>
+                </a:solidFill>
+                <a:latin typeface="Microsoft YaHei"/>
+              </a:rPr>
+              <a:t>M04</a:t>
+            </a:r>
+          </a:p>
+        </p:txBody>
+      </p:sp>
+      <p:sp>
+        <p:nvSpPr>
+          <p:cNvPr id="25" name="TextBox 24"/>
+          <p:cNvSpPr txBox="1"/>
+          <p:nvPr/>
+        </p:nvSpPr>
+        <p:spPr>
+          <a:xfrm>
+            <a:off x="6931152" y="2130552"/>
+            <a:ext cx="4187952" cy="274320"/>
+          </a:xfrm>
+          <a:prstGeom prst="rect">
+            <a:avLst/>
+          </a:prstGeom>
+          <a:noFill/>
+        </p:spPr>
+        <p:txBody>
+          <a:bodyPr wrap="square" lIns="0" rIns="0" tIns="0" bIns="0" anchor="ctr">
+            <a:spAutoFit/>
+          </a:bodyPr>
+          <a:lstStyle/>
+          <a:p>
+            <a:pPr algn="l">
+              <a:spcBef>
+                <a:spcPts val="0"/>
+              </a:spcBef>
+              <a:spcAft>
+                <a:spcPts val="0"/>
+              </a:spcAft>
+            </a:pPr>
+            <a:r>
+              <a:rPr sz="1250" b="1">
+                <a:solidFill>
+                  <a:srgbClr val="17324D"/>
+                </a:solidFill>
+                <a:latin typeface="Microsoft YaHei"/>
+              </a:rPr>
+              <a:t>学科价值与研究取向</a:t>
+            </a:r>
+          </a:p>
+        </p:txBody>
+      </p:sp>
+      <p:cxnSp>
+        <p:nvCxnSpPr>
+          <p:cNvPr id="26" name="Connector 25"/>
+          <p:cNvCxnSpPr/>
+          <p:nvPr/>
+        </p:nvCxnSpPr>
+        <p:spPr>
+          <a:xfrm>
+            <a:off x="6327648" y="2459736"/>
+            <a:ext cx="4828032" cy="0"/>
+          </a:xfrm>
+          <a:prstGeom prst="line">
+            <a:avLst/>
+          </a:prstGeom>
+          <a:ln w="8890">
+            <a:solidFill>
+              <a:srgbClr val="D8E1EB"/>
+            </a:solidFill>
+          </a:ln>
+        </p:spPr>
+        <p:style>
+          <a:lnRef idx="2">
+            <a:schemeClr val="accent1"/>
+          </a:lnRef>
+          <a:fillRef idx="0">
+            <a:schemeClr val="accent1"/>
+          </a:fillRef>
+          <a:effectRef idx="1">
+            <a:schemeClr val="accent1"/>
+          </a:effectRef>
+          <a:fontRef idx="minor">
+            <a:schemeClr val="tx1"/>
+          </a:fontRef>
+        </p:style>
+      </p:cxnSp>
+      <p:sp>
+        <p:nvSpPr>
+          <p:cNvPr id="27" name="Rounded Rectangle 26"/>
+          <p:cNvSpPr/>
+          <p:nvPr/>
+        </p:nvSpPr>
+        <p:spPr>
+          <a:xfrm>
+            <a:off x="6327648" y="2551176"/>
+            <a:ext cx="493776" cy="237744"/>
+          </a:xfrm>
+          <a:prstGeom prst="roundRect">
+            <a:avLst/>
+          </a:prstGeom>
+          <a:solidFill>
+            <a:srgbClr val="EAF1F8"/>
+          </a:solidFill>
+          <a:ln>
+            <a:noFill/>
+          </a:ln>
+        </p:spPr>
+        <p:style>
+          <a:lnRef idx="1">
+            <a:schemeClr val="accent1"/>
+          </a:lnRef>
+          <a:fillRef idx="3">
+            <a:schemeClr val="accent1"/>
+          </a:fillRef>
+          <a:effectRef idx="2">
+            <a:schemeClr val="accent1"/>
+          </a:effectRef>
+          <a:fontRef idx="minor">
+            <a:schemeClr val="lt1"/>
+          </a:fontRef>
+        </p:style>
+        <p:txBody>
+          <a:bodyPr rtlCol="0" anchor="ctr"/>
+          <a:lstStyle/>
+          <a:p>
+            <a:pPr algn="ctr"/>
+          </a:p>
+        </p:txBody>
+      </p:sp>
+      <p:sp>
+        <p:nvSpPr>
+          <p:cNvPr id="28" name="TextBox 27"/>
+          <p:cNvSpPr txBox="1"/>
+          <p:nvPr/>
+        </p:nvSpPr>
+        <p:spPr>
+          <a:xfrm>
+            <a:off x="6327648" y="2551176"/>
+            <a:ext cx="493776" cy="237744"/>
+          </a:xfrm>
+          <a:prstGeom prst="rect">
+            <a:avLst/>
+          </a:prstGeom>
+          <a:noFill/>
+        </p:spPr>
+        <p:txBody>
+          <a:bodyPr wrap="square" lIns="0" rIns="0" tIns="0" bIns="0" anchor="ctr">
+            <a:spAutoFit/>
+          </a:bodyPr>
+          <a:lstStyle/>
+          <a:p>
+            <a:pPr algn="ctr">
+              <a:spcBef>
+                <a:spcPts val="0"/>
+              </a:spcBef>
+              <a:spcAft>
+                <a:spcPts val="0"/>
+              </a:spcAft>
+            </a:pPr>
+            <a:r>
+              <a:rPr sz="900" b="1">
+                <a:solidFill>
+                  <a:srgbClr val="3568A8"/>
+                </a:solidFill>
+                <a:latin typeface="Microsoft YaHei"/>
+              </a:rPr>
+              <a:t>中国</a:t>
+            </a:r>
+          </a:p>
+        </p:txBody>
+      </p:sp>
+      <p:sp>
+        <p:nvSpPr>
+          <p:cNvPr id="29" name="TextBox 28"/>
+          <p:cNvSpPr txBox="1"/>
+          <p:nvPr/>
+        </p:nvSpPr>
+        <p:spPr>
+          <a:xfrm>
+            <a:off x="6949440" y="2542032"/>
+            <a:ext cx="4151376" cy="246888"/>
+          </a:xfrm>
+          <a:prstGeom prst="rect">
+            <a:avLst/>
+          </a:prstGeom>
+          <a:noFill/>
+        </p:spPr>
+        <p:txBody>
+          <a:bodyPr wrap="square" lIns="0" rIns="0" tIns="0" bIns="0" anchor="ctr">
+            <a:spAutoFit/>
+          </a:bodyPr>
+          <a:lstStyle/>
+          <a:p>
+            <a:pPr algn="l">
+              <a:spcBef>
+                <a:spcPts val="0"/>
+              </a:spcBef>
+              <a:spcAft>
+                <a:spcPts val="0"/>
+              </a:spcAft>
+            </a:pPr>
+            <a:r>
+              <a:rPr sz="1050" b="1">
+                <a:solidFill>
+                  <a:srgbClr val="23364A"/>
+                </a:solidFill>
+                <a:latin typeface="Microsoft YaHei"/>
+              </a:rPr>
+              <a:t>学科名称与研究范畴</a:t>
+            </a:r>
+          </a:p>
+        </p:txBody>
+      </p:sp>
+      <p:sp>
+        <p:nvSpPr>
+          <p:cNvPr id="30" name="TextBox 29"/>
+          <p:cNvSpPr txBox="1"/>
+          <p:nvPr/>
+        </p:nvSpPr>
+        <p:spPr>
+          <a:xfrm>
+            <a:off x="6949440" y="2816352"/>
+            <a:ext cx="4151376" cy="210312"/>
+          </a:xfrm>
+          <a:prstGeom prst="rect">
+            <a:avLst/>
+          </a:prstGeom>
+          <a:noFill/>
+        </p:spPr>
+        <p:txBody>
+          <a:bodyPr wrap="square" lIns="0" rIns="0" tIns="0" bIns="0" anchor="ctr">
+            <a:spAutoFit/>
+          </a:bodyPr>
+          <a:lstStyle/>
+          <a:p>
+            <a:pPr algn="l">
+              <a:spcBef>
+                <a:spcPts val="0"/>
+              </a:spcBef>
+              <a:spcAft>
+                <a:spcPts val="0"/>
+              </a:spcAft>
+            </a:pPr>
+            <a:r>
+              <a:rPr sz="919" b="0">
+                <a:solidFill>
+                  <a:srgbClr val="62748A"/>
+                </a:solidFill>
+                <a:latin typeface="Microsoft YaHei"/>
+              </a:rPr>
+              <a:t>foreign · translation · linguistics · literature</a:t>
+            </a:r>
+          </a:p>
+        </p:txBody>
+      </p:sp>
+      <p:sp>
+        <p:nvSpPr>
+          <p:cNvPr id="31" name="Rounded Rectangle 30"/>
+          <p:cNvSpPr/>
+          <p:nvPr/>
+        </p:nvSpPr>
+        <p:spPr>
+          <a:xfrm>
+            <a:off x="6327648" y="3108960"/>
+            <a:ext cx="493776" cy="237744"/>
+          </a:xfrm>
+          <a:prstGeom prst="roundRect">
+            <a:avLst/>
+          </a:prstGeom>
+          <a:solidFill>
+            <a:srgbClr val="FFF3E5"/>
+          </a:solidFill>
+          <a:ln>
+            <a:noFill/>
+          </a:ln>
+        </p:spPr>
+        <p:style>
+          <a:lnRef idx="1">
+            <a:schemeClr val="accent1"/>
+          </a:lnRef>
+          <a:fillRef idx="3">
+            <a:schemeClr val="accent1"/>
+          </a:fillRef>
+          <a:effectRef idx="2">
+            <a:schemeClr val="accent1"/>
+          </a:effectRef>
+          <a:fontRef idx="minor">
+            <a:schemeClr val="lt1"/>
+          </a:fontRef>
+        </p:style>
+        <p:txBody>
+          <a:bodyPr rtlCol="0" anchor="ctr"/>
+          <a:lstStyle/>
+          <a:p>
+            <a:pPr algn="ctr"/>
+          </a:p>
+        </p:txBody>
+      </p:sp>
+      <p:sp>
+        <p:nvSpPr>
+          <p:cNvPr id="32" name="TextBox 31"/>
+          <p:cNvSpPr txBox="1"/>
+          <p:nvPr/>
+        </p:nvSpPr>
+        <p:spPr>
+          <a:xfrm>
+            <a:off x="6327648" y="3108960"/>
+            <a:ext cx="493776" cy="237744"/>
+          </a:xfrm>
+          <a:prstGeom prst="rect">
+            <a:avLst/>
+          </a:prstGeom>
+          <a:noFill/>
+        </p:spPr>
+        <p:txBody>
+          <a:bodyPr wrap="square" lIns="0" rIns="0" tIns="0" bIns="0" anchor="ctr">
+            <a:spAutoFit/>
+          </a:bodyPr>
+          <a:lstStyle/>
+          <a:p>
+            <a:pPr algn="ctr">
+              <a:spcBef>
+                <a:spcPts val="0"/>
+              </a:spcBef>
+              <a:spcAft>
+                <a:spcPts val="0"/>
+              </a:spcAft>
+            </a:pPr>
+            <a:r>
+              <a:rPr sz="900" b="1">
+                <a:solidFill>
+                  <a:srgbClr val="E38B36"/>
+                </a:solidFill>
+                <a:latin typeface="Microsoft YaHei"/>
+              </a:rPr>
+              <a:t>美国</a:t>
+            </a:r>
+          </a:p>
+        </p:txBody>
+      </p:sp>
+      <p:sp>
+        <p:nvSpPr>
+          <p:cNvPr id="33" name="TextBox 32"/>
+          <p:cNvSpPr txBox="1"/>
+          <p:nvPr/>
+        </p:nvSpPr>
+        <p:spPr>
+          <a:xfrm>
+            <a:off x="6949440" y="3099816"/>
+            <a:ext cx="4151376" cy="246888"/>
+          </a:xfrm>
+          <a:prstGeom prst="rect">
+            <a:avLst/>
+          </a:prstGeom>
+          <a:noFill/>
+        </p:spPr>
+        <p:txBody>
+          <a:bodyPr wrap="square" lIns="0" rIns="0" tIns="0" bIns="0" anchor="ctr">
+            <a:spAutoFit/>
+          </a:bodyPr>
+          <a:lstStyle/>
+          <a:p>
+            <a:pPr algn="l">
+              <a:spcBef>
+                <a:spcPts val="0"/>
+              </a:spcBef>
+              <a:spcAft>
+                <a:spcPts val="0"/>
+              </a:spcAft>
+            </a:pPr>
+            <a:r>
+              <a:rPr sz="1050" b="1">
+                <a:solidFill>
+                  <a:srgbClr val="23364A"/>
+                </a:solidFill>
+                <a:latin typeface="Microsoft YaHei"/>
+              </a:rPr>
+              <a:t>研究主题与兴趣</a:t>
+            </a:r>
+          </a:p>
+        </p:txBody>
+      </p:sp>
+      <p:sp>
+        <p:nvSpPr>
+          <p:cNvPr id="34" name="TextBox 33"/>
+          <p:cNvSpPr txBox="1"/>
+          <p:nvPr/>
+        </p:nvSpPr>
+        <p:spPr>
+          <a:xfrm>
+            <a:off x="6949440" y="3374136"/>
+            <a:ext cx="4151376" cy="210312"/>
+          </a:xfrm>
+          <a:prstGeom prst="rect">
+            <a:avLst/>
+          </a:prstGeom>
+          <a:noFill/>
+        </p:spPr>
+        <p:txBody>
+          <a:bodyPr wrap="square" lIns="0" rIns="0" tIns="0" bIns="0" anchor="ctr">
+            <a:spAutoFit/>
+          </a:bodyPr>
+          <a:lstStyle/>
+          <a:p>
+            <a:pPr algn="l">
+              <a:spcBef>
+                <a:spcPts val="0"/>
+              </a:spcBef>
+              <a:spcAft>
+                <a:spcPts val="0"/>
+              </a:spcAft>
+            </a:pPr>
+            <a:r>
+              <a:rPr sz="919" b="0">
+                <a:solidFill>
+                  <a:srgbClr val="62748A"/>
+                </a:solidFill>
+                <a:latin typeface="Microsoft YaHei"/>
+              </a:rPr>
+              <a:t>historical · gender · race · art</a:t>
+            </a:r>
+          </a:p>
+        </p:txBody>
+      </p:sp>
+      <p:sp>
+        <p:nvSpPr>
+          <p:cNvPr id="35" name="Rounded Rectangle 34"/>
+          <p:cNvSpPr/>
+          <p:nvPr/>
+        </p:nvSpPr>
+        <p:spPr>
+          <a:xfrm>
+            <a:off x="731520" y="3858768"/>
+            <a:ext cx="5193792" cy="1664208"/>
+          </a:xfrm>
+          <a:prstGeom prst="roundRect">
+            <a:avLst/>
+          </a:prstGeom>
+          <a:solidFill>
+            <a:srgbClr val="FFFFFF"/>
+          </a:solidFill>
+          <a:ln w="10160">
+            <a:solidFill>
+              <a:srgbClr val="D8E1EB"/>
+            </a:solidFill>
+          </a:ln>
+        </p:spPr>
+        <p:style>
+          <a:lnRef idx="1">
+            <a:schemeClr val="accent1"/>
+          </a:lnRef>
+          <a:fillRef idx="3">
+            <a:schemeClr val="accent1"/>
+          </a:fillRef>
+          <a:effectRef idx="2">
+            <a:schemeClr val="accent1"/>
+          </a:effectRef>
+          <a:fontRef idx="minor">
+            <a:schemeClr val="lt1"/>
+          </a:fontRef>
+        </p:style>
+        <p:txBody>
+          <a:bodyPr rtlCol="0" anchor="ctr"/>
+          <a:lstStyle/>
+          <a:p>
+            <a:pPr algn="ctr"/>
+          </a:p>
+        </p:txBody>
+      </p:sp>
+      <p:sp>
+        <p:nvSpPr>
+          <p:cNvPr id="36" name="Rectangle 35"/>
+          <p:cNvSpPr/>
+          <p:nvPr/>
+        </p:nvSpPr>
+        <p:spPr>
+          <a:xfrm>
+            <a:off x="731520" y="3858768"/>
+            <a:ext cx="5193792" cy="54864"/>
+          </a:xfrm>
+          <a:prstGeom prst="rect">
+            <a:avLst/>
+          </a:prstGeom>
+          <a:solidFill>
+            <a:srgbClr val="17324D"/>
+          </a:solidFill>
+          <a:ln>
+            <a:noFill/>
+          </a:ln>
+        </p:spPr>
+        <p:style>
+          <a:lnRef idx="1">
+            <a:schemeClr val="accent1"/>
+          </a:lnRef>
+          <a:fillRef idx="3">
+            <a:schemeClr val="accent1"/>
+          </a:fillRef>
+          <a:effectRef idx="2">
+            <a:schemeClr val="accent1"/>
+          </a:effectRef>
+          <a:fontRef idx="minor">
+            <a:schemeClr val="lt1"/>
+          </a:fontRef>
+        </p:style>
+        <p:txBody>
+          <a:bodyPr rtlCol="0" anchor="ctr"/>
+          <a:lstStyle/>
+          <a:p>
+            <a:pPr algn="ctr"/>
+          </a:p>
+        </p:txBody>
+      </p:sp>
+      <p:sp>
+        <p:nvSpPr>
+          <p:cNvPr id="37" name="TextBox 36"/>
+          <p:cNvSpPr txBox="1"/>
+          <p:nvPr/>
+        </p:nvSpPr>
+        <p:spPr>
+          <a:xfrm>
+            <a:off x="914400" y="3995928"/>
+            <a:ext cx="502920" cy="274320"/>
+          </a:xfrm>
+          <a:prstGeom prst="rect">
+            <a:avLst/>
+          </a:prstGeom>
+          <a:noFill/>
+        </p:spPr>
+        <p:txBody>
+          <a:bodyPr wrap="square" lIns="0" rIns="0" tIns="0" bIns="0" anchor="ctr">
+            <a:spAutoFit/>
+          </a:bodyPr>
+          <a:lstStyle/>
+          <a:p>
+            <a:pPr algn="l">
+              <a:spcBef>
+                <a:spcPts val="0"/>
+              </a:spcBef>
+              <a:spcAft>
+                <a:spcPts val="0"/>
+              </a:spcAft>
+            </a:pPr>
+            <a:r>
+              <a:rPr sz="1400" b="1">
+                <a:solidFill>
+                  <a:srgbClr val="3568A8"/>
+                </a:solidFill>
+                <a:latin typeface="Microsoft YaHei"/>
+              </a:rPr>
+              <a:t>M05</a:t>
+            </a:r>
+          </a:p>
+        </p:txBody>
+      </p:sp>
+      <p:sp>
+        <p:nvSpPr>
+          <p:cNvPr id="38" name="TextBox 37"/>
+          <p:cNvSpPr txBox="1"/>
+          <p:nvPr/>
+        </p:nvSpPr>
+        <p:spPr>
+          <a:xfrm>
+            <a:off x="1517904" y="3995928"/>
+            <a:ext cx="4187952" cy="274320"/>
+          </a:xfrm>
+          <a:prstGeom prst="rect">
+            <a:avLst/>
+          </a:prstGeom>
+          <a:noFill/>
+        </p:spPr>
+        <p:txBody>
+          <a:bodyPr wrap="square" lIns="0" rIns="0" tIns="0" bIns="0" anchor="ctr">
+            <a:spAutoFit/>
+          </a:bodyPr>
+          <a:lstStyle/>
+          <a:p>
+            <a:pPr algn="l">
+              <a:spcBef>
+                <a:spcPts val="0"/>
+              </a:spcBef>
+              <a:spcAft>
+                <a:spcPts val="0"/>
+              </a:spcAft>
+            </a:pPr>
+            <a:r>
+              <a:rPr sz="1250" b="1">
+                <a:solidFill>
+                  <a:srgbClr val="17324D"/>
+                </a:solidFill>
+                <a:latin typeface="Microsoft YaHei"/>
+              </a:rPr>
+              <a:t>课程教学与培养目标</a:t>
+            </a:r>
+          </a:p>
+        </p:txBody>
+      </p:sp>
+      <p:cxnSp>
+        <p:nvCxnSpPr>
+          <p:cNvPr id="39" name="Connector 38"/>
+          <p:cNvCxnSpPr/>
+          <p:nvPr/>
+        </p:nvCxnSpPr>
+        <p:spPr>
+          <a:xfrm>
+            <a:off x="914400" y="4325112"/>
+            <a:ext cx="4828032" cy="0"/>
+          </a:xfrm>
+          <a:prstGeom prst="line">
+            <a:avLst/>
+          </a:prstGeom>
+          <a:ln w="8890">
+            <a:solidFill>
+              <a:srgbClr val="D8E1EB"/>
+            </a:solidFill>
+          </a:ln>
+        </p:spPr>
+        <p:style>
+          <a:lnRef idx="2">
+            <a:schemeClr val="accent1"/>
+          </a:lnRef>
+          <a:fillRef idx="0">
+            <a:schemeClr val="accent1"/>
+          </a:fillRef>
+          <a:effectRef idx="1">
+            <a:schemeClr val="accent1"/>
+          </a:effectRef>
+          <a:fontRef idx="minor">
+            <a:schemeClr val="tx1"/>
+          </a:fontRef>
+        </p:style>
+      </p:cxnSp>
+      <p:sp>
+        <p:nvSpPr>
+          <p:cNvPr id="40" name="Rounded Rectangle 39"/>
+          <p:cNvSpPr/>
+          <p:nvPr/>
+        </p:nvSpPr>
+        <p:spPr>
+          <a:xfrm>
+            <a:off x="914400" y="4416552"/>
+            <a:ext cx="493776" cy="237744"/>
+          </a:xfrm>
+          <a:prstGeom prst="roundRect">
+            <a:avLst/>
+          </a:prstGeom>
+          <a:solidFill>
+            <a:srgbClr val="EAF1F8"/>
+          </a:solidFill>
+          <a:ln>
+            <a:noFill/>
+          </a:ln>
+        </p:spPr>
+        <p:style>
+          <a:lnRef idx="1">
+            <a:schemeClr val="accent1"/>
+          </a:lnRef>
+          <a:fillRef idx="3">
+            <a:schemeClr val="accent1"/>
+          </a:fillRef>
+          <a:effectRef idx="2">
+            <a:schemeClr val="accent1"/>
+          </a:effectRef>
+          <a:fontRef idx="minor">
+            <a:schemeClr val="lt1"/>
+          </a:fontRef>
+        </p:style>
+        <p:txBody>
+          <a:bodyPr rtlCol="0" anchor="ctr"/>
+          <a:lstStyle/>
+          <a:p>
+            <a:pPr algn="ctr"/>
+          </a:p>
+        </p:txBody>
+      </p:sp>
+      <p:sp>
+        <p:nvSpPr>
+          <p:cNvPr id="41" name="TextBox 40"/>
+          <p:cNvSpPr txBox="1"/>
+          <p:nvPr/>
+        </p:nvSpPr>
+        <p:spPr>
+          <a:xfrm>
+            <a:off x="914400" y="4416552"/>
+            <a:ext cx="493776" cy="237744"/>
+          </a:xfrm>
+          <a:prstGeom prst="rect">
+            <a:avLst/>
+          </a:prstGeom>
+          <a:noFill/>
+        </p:spPr>
+        <p:txBody>
+          <a:bodyPr wrap="square" lIns="0" rIns="0" tIns="0" bIns="0" anchor="ctr">
+            <a:spAutoFit/>
+          </a:bodyPr>
+          <a:lstStyle/>
+          <a:p>
+            <a:pPr algn="ctr">
+              <a:spcBef>
+                <a:spcPts val="0"/>
+              </a:spcBef>
+              <a:spcAft>
+                <a:spcPts val="0"/>
+              </a:spcAft>
+            </a:pPr>
+            <a:r>
+              <a:rPr sz="900" b="1">
+                <a:solidFill>
+                  <a:srgbClr val="3568A8"/>
+                </a:solidFill>
+                <a:latin typeface="Microsoft YaHei"/>
+              </a:rPr>
+              <a:t>中国</a:t>
+            </a:r>
+          </a:p>
+        </p:txBody>
+      </p:sp>
+      <p:sp>
+        <p:nvSpPr>
+          <p:cNvPr id="42" name="TextBox 41"/>
+          <p:cNvSpPr txBox="1"/>
+          <p:nvPr/>
+        </p:nvSpPr>
+        <p:spPr>
+          <a:xfrm>
+            <a:off x="1536192" y="4407408"/>
+            <a:ext cx="4151376" cy="246888"/>
+          </a:xfrm>
+          <a:prstGeom prst="rect">
+            <a:avLst/>
+          </a:prstGeom>
+          <a:noFill/>
+        </p:spPr>
+        <p:txBody>
+          <a:bodyPr wrap="square" lIns="0" rIns="0" tIns="0" bIns="0" anchor="ctr">
+            <a:spAutoFit/>
+          </a:bodyPr>
+          <a:lstStyle/>
+          <a:p>
+            <a:pPr algn="l">
+              <a:spcBef>
+                <a:spcPts val="0"/>
+              </a:spcBef>
+              <a:spcAft>
+                <a:spcPts val="0"/>
+              </a:spcAft>
+            </a:pPr>
+            <a:r>
+              <a:rPr sz="1050" b="1">
+                <a:solidFill>
+                  <a:srgbClr val="23364A"/>
+                </a:solidFill>
+                <a:latin typeface="Microsoft YaHei"/>
+              </a:rPr>
+              <a:t>项目供给与能力培养</a:t>
+            </a:r>
+          </a:p>
+        </p:txBody>
+      </p:sp>
+      <p:sp>
+        <p:nvSpPr>
+          <p:cNvPr id="43" name="TextBox 42"/>
+          <p:cNvSpPr txBox="1"/>
+          <p:nvPr/>
+        </p:nvSpPr>
+        <p:spPr>
+          <a:xfrm>
+            <a:off x="1536192" y="4681728"/>
+            <a:ext cx="4151376" cy="210312"/>
+          </a:xfrm>
+          <a:prstGeom prst="rect">
+            <a:avLst/>
+          </a:prstGeom>
+          <a:noFill/>
+        </p:spPr>
+        <p:txBody>
+          <a:bodyPr wrap="square" lIns="0" rIns="0" tIns="0" bIns="0" anchor="ctr">
+            <a:spAutoFit/>
+          </a:bodyPr>
+          <a:lstStyle/>
+          <a:p>
+            <a:pPr algn="l">
+              <a:spcBef>
+                <a:spcPts val="0"/>
+              </a:spcBef>
+              <a:spcAft>
+                <a:spcPts val="0"/>
+              </a:spcAft>
+            </a:pPr>
+            <a:r>
+              <a:rPr sz="919" b="0">
+                <a:solidFill>
+                  <a:srgbClr val="62748A"/>
+                </a:solidFill>
+                <a:latin typeface="Microsoft YaHei"/>
+              </a:rPr>
+              <a:t>doctoral · teaching · talents · cross-cultural</a:t>
+            </a:r>
+          </a:p>
+        </p:txBody>
+      </p:sp>
+      <p:sp>
+        <p:nvSpPr>
+          <p:cNvPr id="44" name="Rounded Rectangle 43"/>
+          <p:cNvSpPr/>
+          <p:nvPr/>
+        </p:nvSpPr>
+        <p:spPr>
+          <a:xfrm>
+            <a:off x="914400" y="4974336"/>
+            <a:ext cx="493776" cy="237744"/>
+          </a:xfrm>
+          <a:prstGeom prst="roundRect">
+            <a:avLst/>
+          </a:prstGeom>
+          <a:solidFill>
+            <a:srgbClr val="FFF3E5"/>
+          </a:solidFill>
+          <a:ln>
+            <a:noFill/>
+          </a:ln>
+        </p:spPr>
+        <p:style>
+          <a:lnRef idx="1">
+            <a:schemeClr val="accent1"/>
+          </a:lnRef>
+          <a:fillRef idx="3">
+            <a:schemeClr val="accent1"/>
+          </a:fillRef>
+          <a:effectRef idx="2">
+            <a:schemeClr val="accent1"/>
+          </a:effectRef>
+          <a:fontRef idx="minor">
+            <a:schemeClr val="lt1"/>
+          </a:fontRef>
+        </p:style>
+        <p:txBody>
+          <a:bodyPr rtlCol="0" anchor="ctr"/>
+          <a:lstStyle/>
+          <a:p>
+            <a:pPr algn="ctr"/>
+          </a:p>
+        </p:txBody>
+      </p:sp>
+      <p:sp>
+        <p:nvSpPr>
+          <p:cNvPr id="45" name="TextBox 44"/>
+          <p:cNvSpPr txBox="1"/>
+          <p:nvPr/>
+        </p:nvSpPr>
+        <p:spPr>
+          <a:xfrm>
+            <a:off x="914400" y="4974336"/>
+            <a:ext cx="493776" cy="237744"/>
+          </a:xfrm>
+          <a:prstGeom prst="rect">
+            <a:avLst/>
+          </a:prstGeom>
+          <a:noFill/>
+        </p:spPr>
+        <p:txBody>
+          <a:bodyPr wrap="square" lIns="0" rIns="0" tIns="0" bIns="0" anchor="ctr">
+            <a:spAutoFit/>
+          </a:bodyPr>
+          <a:lstStyle/>
+          <a:p>
+            <a:pPr algn="ctr">
+              <a:spcBef>
+                <a:spcPts val="0"/>
+              </a:spcBef>
+              <a:spcAft>
+                <a:spcPts val="0"/>
+              </a:spcAft>
+            </a:pPr>
+            <a:r>
+              <a:rPr sz="900" b="1">
+                <a:solidFill>
+                  <a:srgbClr val="E38B36"/>
+                </a:solidFill>
+                <a:latin typeface="Microsoft YaHei"/>
+              </a:rPr>
+              <a:t>美国</a:t>
+            </a:r>
+          </a:p>
+        </p:txBody>
+      </p:sp>
+      <p:sp>
+        <p:nvSpPr>
+          <p:cNvPr id="46" name="TextBox 45"/>
+          <p:cNvSpPr txBox="1"/>
+          <p:nvPr/>
+        </p:nvSpPr>
+        <p:spPr>
+          <a:xfrm>
+            <a:off x="1536192" y="4965192"/>
+            <a:ext cx="4151376" cy="246888"/>
+          </a:xfrm>
+          <a:prstGeom prst="rect">
+            <a:avLst/>
+          </a:prstGeom>
+          <a:noFill/>
+        </p:spPr>
+        <p:txBody>
+          <a:bodyPr wrap="square" lIns="0" rIns="0" tIns="0" bIns="0" anchor="ctr">
+            <a:spAutoFit/>
+          </a:bodyPr>
+          <a:lstStyle/>
+          <a:p>
+            <a:pPr algn="l">
+              <a:spcBef>
+                <a:spcPts val="0"/>
+              </a:spcBef>
+              <a:spcAft>
+                <a:spcPts val="0"/>
+              </a:spcAft>
+            </a:pPr>
+            <a:r>
+              <a:rPr sz="1050" b="1">
+                <a:solidFill>
+                  <a:srgbClr val="23364A"/>
+                </a:solidFill>
+                <a:latin typeface="Microsoft YaHei"/>
+              </a:rPr>
+              <a:t>学习机会与职业发展</a:t>
+            </a:r>
+          </a:p>
+        </p:txBody>
+      </p:sp>
+      <p:sp>
+        <p:nvSpPr>
+          <p:cNvPr id="47" name="TextBox 46"/>
+          <p:cNvSpPr txBox="1"/>
+          <p:nvPr/>
+        </p:nvSpPr>
+        <p:spPr>
+          <a:xfrm>
+            <a:off x="1536192" y="5239512"/>
+            <a:ext cx="4151376" cy="210312"/>
+          </a:xfrm>
+          <a:prstGeom prst="rect">
+            <a:avLst/>
+          </a:prstGeom>
+          <a:noFill/>
+        </p:spPr>
+        <p:txBody>
+          <a:bodyPr wrap="square" lIns="0" rIns="0" tIns="0" bIns="0" anchor="ctr">
+            <a:spAutoFit/>
+          </a:bodyPr>
+          <a:lstStyle/>
+          <a:p>
+            <a:pPr algn="l">
+              <a:spcBef>
+                <a:spcPts val="0"/>
+              </a:spcBef>
+              <a:spcAft>
+                <a:spcPts val="0"/>
+              </a:spcAft>
+            </a:pPr>
+            <a:r>
+              <a:rPr sz="919" b="0">
+                <a:solidFill>
+                  <a:srgbClr val="62748A"/>
+                </a:solidFill>
+                <a:latin typeface="Microsoft YaHei"/>
+              </a:rPr>
+              <a:t>minor · offerings · seminar · opportunities · careers</a:t>
+            </a:r>
+          </a:p>
+        </p:txBody>
+      </p:sp>
+      <p:sp>
+        <p:nvSpPr>
+          <p:cNvPr id="48" name="Rounded Rectangle 47"/>
+          <p:cNvSpPr/>
+          <p:nvPr/>
+        </p:nvSpPr>
+        <p:spPr>
+          <a:xfrm>
+            <a:off x="6144768" y="3858768"/>
+            <a:ext cx="5193792" cy="1664208"/>
+          </a:xfrm>
+          <a:prstGeom prst="roundRect">
+            <a:avLst/>
+          </a:prstGeom>
+          <a:solidFill>
+            <a:srgbClr val="FFFFFF"/>
+          </a:solidFill>
+          <a:ln w="10160">
+            <a:solidFill>
+              <a:srgbClr val="D8E1EB"/>
+            </a:solidFill>
+          </a:ln>
+        </p:spPr>
+        <p:style>
+          <a:lnRef idx="1">
+            <a:schemeClr val="accent1"/>
+          </a:lnRef>
+          <a:fillRef idx="3">
+            <a:schemeClr val="accent1"/>
+          </a:fillRef>
+          <a:effectRef idx="2">
+            <a:schemeClr val="accent1"/>
+          </a:effectRef>
+          <a:fontRef idx="minor">
+            <a:schemeClr val="lt1"/>
+          </a:fontRef>
+        </p:style>
+        <p:txBody>
+          <a:bodyPr rtlCol="0" anchor="ctr"/>
+          <a:lstStyle/>
+          <a:p>
+            <a:pPr algn="ctr"/>
+          </a:p>
+        </p:txBody>
+      </p:sp>
+      <p:sp>
+        <p:nvSpPr>
+          <p:cNvPr id="49" name="Rectangle 48"/>
+          <p:cNvSpPr/>
+          <p:nvPr/>
+        </p:nvSpPr>
+        <p:spPr>
+          <a:xfrm>
+            <a:off x="6144768" y="3858768"/>
+            <a:ext cx="5193792" cy="54864"/>
+          </a:xfrm>
+          <a:prstGeom prst="rect">
+            <a:avLst/>
+          </a:prstGeom>
+          <a:solidFill>
+            <a:srgbClr val="17324D"/>
+          </a:solidFill>
+          <a:ln>
+            <a:noFill/>
+          </a:ln>
+        </p:spPr>
+        <p:style>
+          <a:lnRef idx="1">
+            <a:schemeClr val="accent1"/>
+          </a:lnRef>
+          <a:fillRef idx="3">
+            <a:schemeClr val="accent1"/>
+          </a:fillRef>
+          <a:effectRef idx="2">
+            <a:schemeClr val="accent1"/>
+          </a:effectRef>
+          <a:fontRef idx="minor">
+            <a:schemeClr val="lt1"/>
+          </a:fontRef>
+        </p:style>
+        <p:txBody>
+          <a:bodyPr rtlCol="0" anchor="ctr"/>
+          <a:lstStyle/>
+          <a:p>
+            <a:pPr algn="ctr"/>
+          </a:p>
+        </p:txBody>
+      </p:sp>
+      <p:sp>
+        <p:nvSpPr>
+          <p:cNvPr id="50" name="TextBox 49"/>
+          <p:cNvSpPr txBox="1"/>
+          <p:nvPr/>
+        </p:nvSpPr>
+        <p:spPr>
+          <a:xfrm>
+            <a:off x="6327648" y="3995928"/>
+            <a:ext cx="502920" cy="274320"/>
+          </a:xfrm>
+          <a:prstGeom prst="rect">
+            <a:avLst/>
+          </a:prstGeom>
+          <a:noFill/>
+        </p:spPr>
+        <p:txBody>
+          <a:bodyPr wrap="square" lIns="0" rIns="0" tIns="0" bIns="0" anchor="ctr">
+            <a:spAutoFit/>
+          </a:bodyPr>
+          <a:lstStyle/>
+          <a:p>
+            <a:pPr algn="l">
+              <a:spcBef>
+                <a:spcPts val="0"/>
+              </a:spcBef>
+              <a:spcAft>
+                <a:spcPts val="0"/>
+              </a:spcAft>
+            </a:pPr>
+            <a:r>
+              <a:rPr sz="1400" b="1">
+                <a:solidFill>
+                  <a:srgbClr val="3568A8"/>
+                </a:solidFill>
+                <a:latin typeface="Microsoft YaHei"/>
+              </a:rPr>
+              <a:t>M08</a:t>
+            </a:r>
+          </a:p>
+        </p:txBody>
+      </p:sp>
+      <p:sp>
+        <p:nvSpPr>
+          <p:cNvPr id="51" name="TextBox 50"/>
+          <p:cNvSpPr txBox="1"/>
+          <p:nvPr/>
+        </p:nvSpPr>
+        <p:spPr>
+          <a:xfrm>
+            <a:off x="6931152" y="3995928"/>
+            <a:ext cx="4187952" cy="274320"/>
+          </a:xfrm>
+          <a:prstGeom prst="rect">
+            <a:avLst/>
+          </a:prstGeom>
+          <a:noFill/>
+        </p:spPr>
+        <p:txBody>
+          <a:bodyPr wrap="square" lIns="0" rIns="0" tIns="0" bIns="0" anchor="ctr">
+            <a:spAutoFit/>
+          </a:bodyPr>
+          <a:lstStyle/>
+          <a:p>
+            <a:pPr algn="l">
+              <a:spcBef>
+                <a:spcPts val="0"/>
+              </a:spcBef>
+              <a:spcAft>
+                <a:spcPts val="0"/>
+              </a:spcAft>
+            </a:pPr>
+            <a:r>
+              <a:rPr sz="1250" b="1">
+                <a:solidFill>
+                  <a:srgbClr val="17324D"/>
+                </a:solidFill>
+                <a:latin typeface="Microsoft YaHei"/>
+              </a:rPr>
+              <a:t>合作网络与社会服务</a:t>
+            </a:r>
+          </a:p>
+        </p:txBody>
+      </p:sp>
+      <p:cxnSp>
+        <p:nvCxnSpPr>
+          <p:cNvPr id="52" name="Connector 51"/>
+          <p:cNvCxnSpPr/>
+          <p:nvPr/>
+        </p:nvCxnSpPr>
+        <p:spPr>
+          <a:xfrm>
+            <a:off x="6327648" y="4325112"/>
+            <a:ext cx="4828032" cy="0"/>
+          </a:xfrm>
+          <a:prstGeom prst="line">
+            <a:avLst/>
+          </a:prstGeom>
+          <a:ln w="8890">
+            <a:solidFill>
+              <a:srgbClr val="D8E1EB"/>
+            </a:solidFill>
+          </a:ln>
+        </p:spPr>
+        <p:style>
+          <a:lnRef idx="2">
+            <a:schemeClr val="accent1"/>
+          </a:lnRef>
+          <a:fillRef idx="0">
+            <a:schemeClr val="accent1"/>
+          </a:fillRef>
+          <a:effectRef idx="1">
+            <a:schemeClr val="accent1"/>
+          </a:effectRef>
+          <a:fontRef idx="minor">
+            <a:schemeClr val="tx1"/>
+          </a:fontRef>
+        </p:style>
+      </p:cxnSp>
+      <p:sp>
+        <p:nvSpPr>
+          <p:cNvPr id="53" name="Rounded Rectangle 52"/>
+          <p:cNvSpPr/>
+          <p:nvPr/>
+        </p:nvSpPr>
+        <p:spPr>
+          <a:xfrm>
+            <a:off x="6327648" y="4416552"/>
+            <a:ext cx="493776" cy="237744"/>
+          </a:xfrm>
+          <a:prstGeom prst="roundRect">
+            <a:avLst/>
+          </a:prstGeom>
+          <a:solidFill>
+            <a:srgbClr val="EAF1F8"/>
+          </a:solidFill>
+          <a:ln>
+            <a:noFill/>
+          </a:ln>
+        </p:spPr>
+        <p:style>
+          <a:lnRef idx="1">
+            <a:schemeClr val="accent1"/>
+          </a:lnRef>
+          <a:fillRef idx="3">
+            <a:schemeClr val="accent1"/>
+          </a:fillRef>
+          <a:effectRef idx="2">
+            <a:schemeClr val="accent1"/>
+          </a:effectRef>
+          <a:fontRef idx="minor">
+            <a:schemeClr val="lt1"/>
+          </a:fontRef>
+        </p:style>
+        <p:txBody>
+          <a:bodyPr rtlCol="0" anchor="ctr"/>
+          <a:lstStyle/>
+          <a:p>
+            <a:pPr algn="ctr"/>
+          </a:p>
+        </p:txBody>
+      </p:sp>
+      <p:sp>
+        <p:nvSpPr>
+          <p:cNvPr id="54" name="TextBox 53"/>
+          <p:cNvSpPr txBox="1"/>
+          <p:nvPr/>
+        </p:nvSpPr>
+        <p:spPr>
+          <a:xfrm>
+            <a:off x="6327648" y="4416552"/>
+            <a:ext cx="493776" cy="237744"/>
+          </a:xfrm>
+          <a:prstGeom prst="rect">
+            <a:avLst/>
+          </a:prstGeom>
+          <a:noFill/>
+        </p:spPr>
+        <p:txBody>
+          <a:bodyPr wrap="square" lIns="0" rIns="0" tIns="0" bIns="0" anchor="ctr">
+            <a:spAutoFit/>
+          </a:bodyPr>
+          <a:lstStyle/>
+          <a:p>
+            <a:pPr algn="ctr">
+              <a:spcBef>
+                <a:spcPts val="0"/>
+              </a:spcBef>
+              <a:spcAft>
+                <a:spcPts val="0"/>
+              </a:spcAft>
+            </a:pPr>
+            <a:r>
+              <a:rPr sz="900" b="1">
+                <a:solidFill>
+                  <a:srgbClr val="3568A8"/>
+                </a:solidFill>
+                <a:latin typeface="Microsoft YaHei"/>
+              </a:rPr>
+              <a:t>中国</a:t>
+            </a:r>
+          </a:p>
+        </p:txBody>
+      </p:sp>
+      <p:sp>
+        <p:nvSpPr>
+          <p:cNvPr id="55" name="TextBox 54"/>
+          <p:cNvSpPr txBox="1"/>
+          <p:nvPr/>
+        </p:nvSpPr>
+        <p:spPr>
+          <a:xfrm>
+            <a:off x="6949440" y="4407408"/>
+            <a:ext cx="4151376" cy="246888"/>
+          </a:xfrm>
+          <a:prstGeom prst="rect">
+            <a:avLst/>
+          </a:prstGeom>
+          <a:noFill/>
+        </p:spPr>
+        <p:txBody>
+          <a:bodyPr wrap="square" lIns="0" rIns="0" tIns="0" bIns="0" anchor="ctr">
+            <a:spAutoFit/>
+          </a:bodyPr>
+          <a:lstStyle/>
+          <a:p>
+            <a:pPr algn="l">
+              <a:spcBef>
+                <a:spcPts val="0"/>
+              </a:spcBef>
+              <a:spcAft>
+                <a:spcPts val="0"/>
+              </a:spcAft>
+            </a:pPr>
+            <a:r>
+              <a:rPr sz="1050" b="1">
+                <a:solidFill>
+                  <a:srgbClr val="23364A"/>
+                </a:solidFill>
+                <a:latin typeface="Microsoft YaHei"/>
+              </a:rPr>
+              <a:t>国际交流、合作与培训</a:t>
+            </a:r>
+          </a:p>
+        </p:txBody>
+      </p:sp>
+      <p:sp>
+        <p:nvSpPr>
+          <p:cNvPr id="56" name="TextBox 55"/>
+          <p:cNvSpPr txBox="1"/>
+          <p:nvPr/>
+        </p:nvSpPr>
+        <p:spPr>
+          <a:xfrm>
+            <a:off x="6949440" y="4681728"/>
+            <a:ext cx="4151376" cy="210312"/>
+          </a:xfrm>
+          <a:prstGeom prst="rect">
+            <a:avLst/>
+          </a:prstGeom>
+          <a:noFill/>
+        </p:spPr>
+        <p:txBody>
+          <a:bodyPr wrap="square" lIns="0" rIns="0" tIns="0" bIns="0" anchor="ctr">
+            <a:spAutoFit/>
+          </a:bodyPr>
+          <a:lstStyle/>
+          <a:p>
+            <a:pPr algn="l">
+              <a:spcBef>
+                <a:spcPts val="0"/>
+              </a:spcBef>
+              <a:spcAft>
+                <a:spcPts val="0"/>
+              </a:spcAft>
+            </a:pPr>
+            <a:r>
+              <a:rPr sz="919" b="0">
+                <a:solidFill>
+                  <a:srgbClr val="62748A"/>
+                </a:solidFill>
+                <a:latin typeface="Microsoft YaHei"/>
+              </a:rPr>
+              <a:t>international · exchange · cooperation · joint · training</a:t>
+            </a:r>
+          </a:p>
+        </p:txBody>
+      </p:sp>
+      <p:sp>
+        <p:nvSpPr>
+          <p:cNvPr id="57" name="Rounded Rectangle 56"/>
+          <p:cNvSpPr/>
+          <p:nvPr/>
+        </p:nvSpPr>
+        <p:spPr>
+          <a:xfrm>
+            <a:off x="6327648" y="4974336"/>
+            <a:ext cx="493776" cy="237744"/>
+          </a:xfrm>
+          <a:prstGeom prst="roundRect">
+            <a:avLst/>
+          </a:prstGeom>
+          <a:solidFill>
+            <a:srgbClr val="FFF3E5"/>
+          </a:solidFill>
+          <a:ln>
+            <a:noFill/>
+          </a:ln>
+        </p:spPr>
+        <p:style>
+          <a:lnRef idx="1">
+            <a:schemeClr val="accent1"/>
+          </a:lnRef>
+          <a:fillRef idx="3">
+            <a:schemeClr val="accent1"/>
+          </a:fillRef>
+          <a:effectRef idx="2">
+            <a:schemeClr val="accent1"/>
+          </a:effectRef>
+          <a:fontRef idx="minor">
+            <a:schemeClr val="lt1"/>
+          </a:fontRef>
+        </p:style>
+        <p:txBody>
+          <a:bodyPr rtlCol="0" anchor="ctr"/>
+          <a:lstStyle/>
+          <a:p>
+            <a:pPr algn="ctr"/>
+          </a:p>
+        </p:txBody>
+      </p:sp>
+      <p:sp>
+        <p:nvSpPr>
+          <p:cNvPr id="58" name="TextBox 57"/>
+          <p:cNvSpPr txBox="1"/>
+          <p:nvPr/>
+        </p:nvSpPr>
+        <p:spPr>
+          <a:xfrm>
+            <a:off x="6327648" y="4974336"/>
+            <a:ext cx="493776" cy="237744"/>
+          </a:xfrm>
+          <a:prstGeom prst="rect">
+            <a:avLst/>
+          </a:prstGeom>
+          <a:noFill/>
+        </p:spPr>
+        <p:txBody>
+          <a:bodyPr wrap="square" lIns="0" rIns="0" tIns="0" bIns="0" anchor="ctr">
+            <a:spAutoFit/>
+          </a:bodyPr>
+          <a:lstStyle/>
+          <a:p>
+            <a:pPr algn="ctr">
+              <a:spcBef>
+                <a:spcPts val="0"/>
+              </a:spcBef>
+              <a:spcAft>
+                <a:spcPts val="0"/>
+              </a:spcAft>
+            </a:pPr>
+            <a:r>
+              <a:rPr sz="900" b="1">
+                <a:solidFill>
+                  <a:srgbClr val="E38B36"/>
+                </a:solidFill>
+                <a:latin typeface="Microsoft YaHei"/>
+              </a:rPr>
+              <a:t>美国</a:t>
+            </a:r>
+          </a:p>
+        </p:txBody>
+      </p:sp>
+      <p:sp>
+        <p:nvSpPr>
+          <p:cNvPr id="59" name="TextBox 58"/>
+          <p:cNvSpPr txBox="1"/>
+          <p:nvPr/>
+        </p:nvSpPr>
+        <p:spPr>
+          <a:xfrm>
+            <a:off x="6949440" y="4965192"/>
+            <a:ext cx="4151376" cy="246888"/>
+          </a:xfrm>
+          <a:prstGeom prst="rect">
+            <a:avLst/>
+          </a:prstGeom>
+          <a:noFill/>
+        </p:spPr>
+        <p:txBody>
+          <a:bodyPr wrap="square" lIns="0" rIns="0" tIns="0" bIns="0" anchor="ctr">
+            <a:spAutoFit/>
+          </a:bodyPr>
+          <a:lstStyle/>
+          <a:p>
+            <a:pPr algn="l">
+              <a:spcBef>
+                <a:spcPts val="0"/>
+              </a:spcBef>
+              <a:spcAft>
+                <a:spcPts val="0"/>
+              </a:spcAft>
+            </a:pPr>
+            <a:r>
+              <a:rPr sz="1050" b="1">
+                <a:solidFill>
+                  <a:srgbClr val="23364A"/>
+                </a:solidFill>
+                <a:latin typeface="Microsoft YaHei"/>
+              </a:rPr>
+              <a:t>海外学习与公共参与</a:t>
+            </a:r>
+          </a:p>
+        </p:txBody>
+      </p:sp>
+      <p:sp>
+        <p:nvSpPr>
+          <p:cNvPr id="60" name="TextBox 59"/>
+          <p:cNvSpPr txBox="1"/>
+          <p:nvPr/>
+        </p:nvSpPr>
+        <p:spPr>
+          <a:xfrm>
+            <a:off x="6949440" y="5239512"/>
+            <a:ext cx="4151376" cy="210312"/>
+          </a:xfrm>
+          <a:prstGeom prst="rect">
+            <a:avLst/>
+          </a:prstGeom>
+          <a:noFill/>
+        </p:spPr>
+        <p:txBody>
+          <a:bodyPr wrap="square" lIns="0" rIns="0" tIns="0" bIns="0" anchor="ctr">
+            <a:spAutoFit/>
+          </a:bodyPr>
+          <a:lstStyle/>
+          <a:p>
+            <a:pPr algn="l">
+              <a:spcBef>
+                <a:spcPts val="0"/>
+              </a:spcBef>
+              <a:spcAft>
+                <a:spcPts val="0"/>
+              </a:spcAft>
+            </a:pPr>
+            <a:r>
+              <a:rPr sz="919" b="0">
+                <a:solidFill>
+                  <a:srgbClr val="62748A"/>
+                </a:solidFill>
+                <a:latin typeface="Microsoft YaHei"/>
+              </a:rPr>
+              <a:t>abroad · outreach · community · engagement · public</a:t>
+            </a:r>
+          </a:p>
+        </p:txBody>
+      </p:sp>
+      <p:sp>
+        <p:nvSpPr>
+          <p:cNvPr id="61" name="TextBox 60"/>
+          <p:cNvSpPr txBox="1"/>
+          <p:nvPr/>
+        </p:nvSpPr>
+        <p:spPr>
+          <a:xfrm>
+            <a:off x="768096" y="5760720"/>
+            <a:ext cx="10515600" cy="182880"/>
+          </a:xfrm>
+          <a:prstGeom prst="rect">
+            <a:avLst/>
+          </a:prstGeom>
+          <a:noFill/>
+        </p:spPr>
+        <p:txBody>
+          <a:bodyPr wrap="square" lIns="0" rIns="0" tIns="0" bIns="0" anchor="t">
+            <a:spAutoFit/>
+          </a:bodyPr>
+          <a:lstStyle/>
+          <a:p>
+            <a:pPr algn="l">
+              <a:spcBef>
+                <a:spcPts val="0"/>
+              </a:spcBef>
+              <a:spcAft>
+                <a:spcPts val="0"/>
+              </a:spcAft>
+            </a:pPr>
+            <a:r>
+              <a:rPr sz="850" b="0">
+                <a:solidFill>
+                  <a:srgbClr val="62748A"/>
+                </a:solidFill>
+                <a:latin typeface="Microsoft YaHei"/>
+              </a:rPr>
+              <a:t>注：页面列出代表性区分词项；完整每万词频次、log2比率与BH校正q值见附录。</a:t>
+            </a:r>
+          </a:p>
+        </p:txBody>
+      </p:sp>
+      <p:cxnSp>
+        <p:nvCxnSpPr>
+          <p:cNvPr id="62" name="Connector 61"/>
+          <p:cNvCxnSpPr/>
+          <p:nvPr/>
+        </p:nvCxnSpPr>
+        <p:spPr>
+          <a:xfrm>
+            <a:off x="731520" y="6144768"/>
+            <a:ext cx="10744200" cy="0"/>
+          </a:xfrm>
+          <a:prstGeom prst="line">
+            <a:avLst/>
+          </a:prstGeom>
+          <a:ln w="10160">
+            <a:solidFill>
+              <a:srgbClr val="D8E1EB"/>
+            </a:solidFill>
+          </a:ln>
+        </p:spPr>
+        <p:style>
+          <a:lnRef idx="2">
+            <a:schemeClr val="accent1"/>
+          </a:lnRef>
+          <a:fillRef idx="0">
+            <a:schemeClr val="accent1"/>
+          </a:fillRef>
+          <a:effectRef idx="1">
+            <a:schemeClr val="accent1"/>
+          </a:effectRef>
+          <a:fontRef idx="minor">
+            <a:schemeClr val="tx1"/>
+          </a:fontRef>
+        </p:style>
+      </p:cxnSp>
+      <p:sp>
+        <p:nvSpPr>
+          <p:cNvPr id="63" name="TextBox 62"/>
+          <p:cNvSpPr txBox="1"/>
+          <p:nvPr/>
+        </p:nvSpPr>
+        <p:spPr>
+          <a:xfrm>
+            <a:off x="731520" y="6318504"/>
+            <a:ext cx="7772400" cy="256032"/>
+          </a:xfrm>
+          <a:prstGeom prst="rect">
+            <a:avLst/>
+          </a:prstGeom>
+          <a:noFill/>
+        </p:spPr>
+        <p:txBody>
+          <a:bodyPr wrap="square" lIns="0" rIns="0" tIns="0" bIns="0" anchor="t">
+            <a:spAutoFit/>
+          </a:bodyPr>
+          <a:lstStyle/>
+          <a:p>
+            <a:pPr algn="l">
+              <a:spcBef>
+                <a:spcPts val="0"/>
+              </a:spcBef>
+              <a:spcAft>
+                <a:spcPts val="0"/>
+              </a:spcAft>
+            </a:pPr>
+            <a:r>
+              <a:rPr sz="900" b="0">
+                <a:solidFill>
+                  <a:srgbClr val="62748A"/>
+                </a:solidFill>
+                <a:latin typeface="Microsoft YaHei"/>
+              </a:rPr>
+              <a:t>基于语料库技术的中美外语院系英文简介话语比较分析</a:t>
+            </a:r>
+          </a:p>
+        </p:txBody>
+      </p:sp>
+      <p:sp>
+        <p:nvSpPr>
+          <p:cNvPr id="64" name="TextBox 63"/>
+          <p:cNvSpPr txBox="1"/>
+          <p:nvPr/>
+        </p:nvSpPr>
+        <p:spPr>
+          <a:xfrm>
+            <a:off x="10881360" y="6318504"/>
+            <a:ext cx="594360" cy="256032"/>
+          </a:xfrm>
+          <a:prstGeom prst="rect">
+            <a:avLst/>
+          </a:prstGeom>
+          <a:noFill/>
+        </p:spPr>
+        <p:txBody>
+          <a:bodyPr wrap="square" lIns="0" rIns="0" tIns="0" bIns="0" anchor="t">
+            <a:spAutoFit/>
+          </a:bodyPr>
+          <a:lstStyle/>
+          <a:p>
+            <a:pPr algn="r">
+              <a:spcBef>
+                <a:spcPts val="0"/>
+              </a:spcBef>
+              <a:spcAft>
+                <a:spcPts val="0"/>
+              </a:spcAft>
+            </a:pPr>
+            <a:r>
+              <a:rPr sz="1000" b="0">
+                <a:solidFill>
+                  <a:srgbClr val="62748A"/>
+                </a:solidFill>
+                <a:latin typeface="Microsoft YaHei"/>
+              </a:rPr>
+              <a:t>07 / 08</a:t>
             </a:r>
           </a:p>
         </p:txBody>

</xml_diff>

<commit_message>
Complete eight-slide midterm presentation
Co-authored-by: arena-agent <297053741+arena-agent@users.noreply.github.com>
</commit_message>
<xml_diff>
--- a/midterm-report/presentation/中美外语院系英文简介_5分钟汇报.pptx
+++ b/midterm-report/presentation/中美外语院系英文简介_5分钟汇报.pptx
@@ -12,6 +12,7 @@
     <p:sldId id="260" r:id="rId11"/>
     <p:sldId id="261" r:id="rId12"/>
     <p:sldId id="262" r:id="rId13"/>
+    <p:sldId id="263" r:id="rId14"/>
   </p:sldIdLst>
   <p:sldSz cx="12191695" cy="6858000" type="screen4x3"/>
   <p:notesSz cx="6858000" cy="9144000"/>
@@ -23313,6 +23314,2024 @@
                 <a:latin typeface="Microsoft YaHei"/>
               </a:rPr>
               <a:t>07 / 08</a:t>
+            </a:r>
+          </a:p>
+        </p:txBody>
+      </p:sp>
+    </p:spTree>
+  </p:cSld>
+  <p:clrMapOvr>
+    <a:masterClrMapping/>
+  </p:clrMapOvr>
+</p:sld>
+</file>
+
+<file path=ppt/slides/slide8.xml><?xml version="1.0" encoding="utf-8"?>
+<p:sld xmlns:a="http://schemas.openxmlformats.org/drawingml/2006/main" xmlns:p="http://schemas.openxmlformats.org/presentationml/2006/main" xmlns:r="http://schemas.openxmlformats.org/officeDocument/2006/relationships">
+  <p:cSld>
+    <p:spTree>
+      <p:nvGrpSpPr>
+        <p:cNvPr id="1" name=""/>
+        <p:cNvGrpSpPr/>
+        <p:nvPr/>
+      </p:nvGrpSpPr>
+      <p:grpSpPr/>
+      <p:sp>
+        <p:nvSpPr>
+          <p:cNvPr id="2" name="Rectangle 1"/>
+          <p:cNvSpPr/>
+          <p:nvPr/>
+        </p:nvSpPr>
+        <p:spPr>
+          <a:xfrm>
+            <a:off x="0" y="0"/>
+            <a:ext cx="12191695" cy="6858000"/>
+          </a:xfrm>
+          <a:prstGeom prst="rect">
+            <a:avLst/>
+          </a:prstGeom>
+          <a:solidFill>
+            <a:srgbClr val="F7F9FC"/>
+          </a:solidFill>
+          <a:ln>
+            <a:noFill/>
+          </a:ln>
+        </p:spPr>
+        <p:style>
+          <a:lnRef idx="1">
+            <a:schemeClr val="accent1"/>
+          </a:lnRef>
+          <a:fillRef idx="3">
+            <a:schemeClr val="accent1"/>
+          </a:fillRef>
+          <a:effectRef idx="2">
+            <a:schemeClr val="accent1"/>
+          </a:effectRef>
+          <a:fontRef idx="minor">
+            <a:schemeClr val="lt1"/>
+          </a:fontRef>
+        </p:style>
+        <p:txBody>
+          <a:bodyPr rtlCol="0" anchor="ctr"/>
+          <a:lstStyle/>
+          <a:p>
+            <a:pPr algn="ctr"/>
+          </a:p>
+        </p:txBody>
+      </p:sp>
+      <p:sp>
+        <p:nvSpPr>
+          <p:cNvPr id="3" name="Rectangle 2"/>
+          <p:cNvSpPr/>
+          <p:nvPr/>
+        </p:nvSpPr>
+        <p:spPr>
+          <a:xfrm>
+            <a:off x="0" y="0"/>
+            <a:ext cx="146304" cy="6858000"/>
+          </a:xfrm>
+          <a:prstGeom prst="rect">
+            <a:avLst/>
+          </a:prstGeom>
+          <a:solidFill>
+            <a:srgbClr val="17324D"/>
+          </a:solidFill>
+          <a:ln>
+            <a:noFill/>
+          </a:ln>
+        </p:spPr>
+        <p:style>
+          <a:lnRef idx="1">
+            <a:schemeClr val="accent1"/>
+          </a:lnRef>
+          <a:fillRef idx="3">
+            <a:schemeClr val="accent1"/>
+          </a:fillRef>
+          <a:effectRef idx="2">
+            <a:schemeClr val="accent1"/>
+          </a:effectRef>
+          <a:fontRef idx="minor">
+            <a:schemeClr val="lt1"/>
+          </a:fontRef>
+        </p:style>
+        <p:txBody>
+          <a:bodyPr rtlCol="0" anchor="ctr"/>
+          <a:lstStyle/>
+          <a:p>
+            <a:pPr algn="ctr"/>
+          </a:p>
+        </p:txBody>
+      </p:sp>
+      <p:sp>
+        <p:nvSpPr>
+          <p:cNvPr id="4" name="Rectangle 3"/>
+          <p:cNvSpPr/>
+          <p:nvPr/>
+        </p:nvSpPr>
+        <p:spPr>
+          <a:xfrm>
+            <a:off x="146304" y="0"/>
+            <a:ext cx="50292" cy="841248"/>
+          </a:xfrm>
+          <a:prstGeom prst="rect">
+            <a:avLst/>
+          </a:prstGeom>
+          <a:solidFill>
+            <a:srgbClr val="E38B36"/>
+          </a:solidFill>
+          <a:ln>
+            <a:noFill/>
+          </a:ln>
+        </p:spPr>
+        <p:style>
+          <a:lnRef idx="1">
+            <a:schemeClr val="accent1"/>
+          </a:lnRef>
+          <a:fillRef idx="3">
+            <a:schemeClr val="accent1"/>
+          </a:fillRef>
+          <a:effectRef idx="2">
+            <a:schemeClr val="accent1"/>
+          </a:effectRef>
+          <a:fontRef idx="minor">
+            <a:schemeClr val="lt1"/>
+          </a:fontRef>
+        </p:style>
+        <p:txBody>
+          <a:bodyPr rtlCol="0" anchor="ctr"/>
+          <a:lstStyle/>
+          <a:p>
+            <a:pPr algn="ctr"/>
+          </a:p>
+        </p:txBody>
+      </p:sp>
+      <p:sp>
+        <p:nvSpPr>
+          <p:cNvPr id="5" name="TextBox 4"/>
+          <p:cNvSpPr txBox="1"/>
+          <p:nvPr/>
+        </p:nvSpPr>
+        <p:spPr>
+          <a:xfrm>
+            <a:off x="731520" y="438912"/>
+            <a:ext cx="3840480" cy="274320"/>
+          </a:xfrm>
+          <a:prstGeom prst="rect">
+            <a:avLst/>
+          </a:prstGeom>
+          <a:noFill/>
+        </p:spPr>
+        <p:txBody>
+          <a:bodyPr wrap="square" lIns="0" rIns="0" tIns="0" bIns="0" anchor="t">
+            <a:spAutoFit/>
+          </a:bodyPr>
+          <a:lstStyle/>
+          <a:p>
+            <a:pPr algn="l">
+              <a:spcBef>
+                <a:spcPts val="0"/>
+              </a:spcBef>
+              <a:spcAft>
+                <a:spcPts val="0"/>
+              </a:spcAft>
+            </a:pPr>
+            <a:r>
+              <a:rPr sz="1100" b="1">
+                <a:solidFill>
+                  <a:srgbClr val="3568A8"/>
+                </a:solidFill>
+                <a:latin typeface="Microsoft YaHei"/>
+              </a:rPr>
+              <a:t>06　下一阶段计划</a:t>
+            </a:r>
+          </a:p>
+        </p:txBody>
+      </p:sp>
+      <p:sp>
+        <p:nvSpPr>
+          <p:cNvPr id="6" name="TextBox 5"/>
+          <p:cNvSpPr txBox="1"/>
+          <p:nvPr/>
+        </p:nvSpPr>
+        <p:spPr>
+          <a:xfrm>
+            <a:off x="731520" y="768096"/>
+            <a:ext cx="10241280" cy="475488"/>
+          </a:xfrm>
+          <a:prstGeom prst="rect">
+            <a:avLst/>
+          </a:prstGeom>
+          <a:noFill/>
+        </p:spPr>
+        <p:txBody>
+          <a:bodyPr wrap="square" lIns="0" rIns="0" tIns="0" bIns="0" anchor="t">
+            <a:spAutoFit/>
+          </a:bodyPr>
+          <a:lstStyle/>
+          <a:p>
+            <a:pPr algn="l">
+              <a:spcBef>
+                <a:spcPts val="0"/>
+              </a:spcBef>
+              <a:spcAft>
+                <a:spcPts val="0"/>
+              </a:spcAft>
+            </a:pPr>
+            <a:r>
+              <a:rPr sz="2600" b="1">
+                <a:solidFill>
+                  <a:srgbClr val="17324D"/>
+                </a:solidFill>
+                <a:latin typeface="Microsoft YaHei"/>
+              </a:rPr>
+              <a:t>下一阶段：解释差异并转化研究成果</a:t>
+            </a:r>
+          </a:p>
+        </p:txBody>
+      </p:sp>
+      <p:sp>
+        <p:nvSpPr>
+          <p:cNvPr id="7" name="TextBox 6"/>
+          <p:cNvSpPr txBox="1"/>
+          <p:nvPr/>
+        </p:nvSpPr>
+        <p:spPr>
+          <a:xfrm>
+            <a:off x="731520" y="1307592"/>
+            <a:ext cx="10515600" cy="384048"/>
+          </a:xfrm>
+          <a:prstGeom prst="rect">
+            <a:avLst/>
+          </a:prstGeom>
+          <a:noFill/>
+        </p:spPr>
+        <p:txBody>
+          <a:bodyPr wrap="square" lIns="0" rIns="0" tIns="0" bIns="0" anchor="ctr">
+            <a:spAutoFit/>
+          </a:bodyPr>
+          <a:lstStyle/>
+          <a:p>
+            <a:pPr algn="l">
+              <a:spcBef>
+                <a:spcPts val="0"/>
+              </a:spcBef>
+              <a:spcAft>
+                <a:spcPts val="0"/>
+              </a:spcAft>
+            </a:pPr>
+            <a:r>
+              <a:rPr sz="1400" b="0">
+                <a:solidFill>
+                  <a:srgbClr val="23364A"/>
+                </a:solidFill>
+                <a:latin typeface="Microsoft YaHei"/>
+              </a:rPr>
+              <a:t>在定量比较基础上，回答差异为何形成，并将研究发现转化为写作建议与论文</a:t>
+            </a:r>
+          </a:p>
+        </p:txBody>
+      </p:sp>
+      <p:sp>
+        <p:nvSpPr>
+          <p:cNvPr id="8" name="Rectangle 7"/>
+          <p:cNvSpPr/>
+          <p:nvPr/>
+        </p:nvSpPr>
+        <p:spPr>
+          <a:xfrm>
+            <a:off x="731520" y="1773936"/>
+            <a:ext cx="594360" cy="41148"/>
+          </a:xfrm>
+          <a:prstGeom prst="rect">
+            <a:avLst/>
+          </a:prstGeom>
+          <a:solidFill>
+            <a:srgbClr val="E38B36"/>
+          </a:solidFill>
+          <a:ln>
+            <a:noFill/>
+          </a:ln>
+        </p:spPr>
+        <p:style>
+          <a:lnRef idx="1">
+            <a:schemeClr val="accent1"/>
+          </a:lnRef>
+          <a:fillRef idx="3">
+            <a:schemeClr val="accent1"/>
+          </a:fillRef>
+          <a:effectRef idx="2">
+            <a:schemeClr val="accent1"/>
+          </a:effectRef>
+          <a:fontRef idx="minor">
+            <a:schemeClr val="lt1"/>
+          </a:fontRef>
+        </p:style>
+        <p:txBody>
+          <a:bodyPr rtlCol="0" anchor="ctr"/>
+          <a:lstStyle/>
+          <a:p>
+            <a:pPr algn="ctr"/>
+          </a:p>
+        </p:txBody>
+      </p:sp>
+      <p:sp>
+        <p:nvSpPr>
+          <p:cNvPr id="9" name="Rounded Rectangle 8"/>
+          <p:cNvSpPr/>
+          <p:nvPr/>
+        </p:nvSpPr>
+        <p:spPr>
+          <a:xfrm>
+            <a:off x="731520" y="2103120"/>
+            <a:ext cx="2331720" cy="3182112"/>
+          </a:xfrm>
+          <a:prstGeom prst="roundRect">
+            <a:avLst/>
+          </a:prstGeom>
+          <a:solidFill>
+            <a:srgbClr val="EAF1F8"/>
+          </a:solidFill>
+          <a:ln>
+            <a:noFill/>
+          </a:ln>
+        </p:spPr>
+        <p:style>
+          <a:lnRef idx="1">
+            <a:schemeClr val="accent1"/>
+          </a:lnRef>
+          <a:fillRef idx="3">
+            <a:schemeClr val="accent1"/>
+          </a:fillRef>
+          <a:effectRef idx="2">
+            <a:schemeClr val="accent1"/>
+          </a:effectRef>
+          <a:fontRef idx="minor">
+            <a:schemeClr val="lt1"/>
+          </a:fontRef>
+        </p:style>
+        <p:txBody>
+          <a:bodyPr rtlCol="0" anchor="ctr"/>
+          <a:lstStyle/>
+          <a:p>
+            <a:pPr algn="ctr"/>
+          </a:p>
+        </p:txBody>
+      </p:sp>
+      <p:sp>
+        <p:nvSpPr>
+          <p:cNvPr id="10" name="Rounded Rectangle 9"/>
+          <p:cNvSpPr/>
+          <p:nvPr/>
+        </p:nvSpPr>
+        <p:spPr>
+          <a:xfrm>
+            <a:off x="950976" y="2350008"/>
+            <a:ext cx="713232" cy="274320"/>
+          </a:xfrm>
+          <a:prstGeom prst="roundRect">
+            <a:avLst/>
+          </a:prstGeom>
+          <a:solidFill>
+            <a:srgbClr val="3568A8"/>
+          </a:solidFill>
+          <a:ln>
+            <a:noFill/>
+          </a:ln>
+        </p:spPr>
+        <p:style>
+          <a:lnRef idx="1">
+            <a:schemeClr val="accent1"/>
+          </a:lnRef>
+          <a:fillRef idx="3">
+            <a:schemeClr val="accent1"/>
+          </a:fillRef>
+          <a:effectRef idx="2">
+            <a:schemeClr val="accent1"/>
+          </a:effectRef>
+          <a:fontRef idx="minor">
+            <a:schemeClr val="lt1"/>
+          </a:fontRef>
+        </p:style>
+        <p:txBody>
+          <a:bodyPr rtlCol="0" anchor="ctr"/>
+          <a:lstStyle/>
+          <a:p>
+            <a:pPr algn="ctr"/>
+          </a:p>
+        </p:txBody>
+      </p:sp>
+      <p:sp>
+        <p:nvSpPr>
+          <p:cNvPr id="11" name="TextBox 10"/>
+          <p:cNvSpPr txBox="1"/>
+          <p:nvPr/>
+        </p:nvSpPr>
+        <p:spPr>
+          <a:xfrm>
+            <a:off x="950976" y="2350008"/>
+            <a:ext cx="713232" cy="274320"/>
+          </a:xfrm>
+          <a:prstGeom prst="rect">
+            <a:avLst/>
+          </a:prstGeom>
+          <a:noFill/>
+        </p:spPr>
+        <p:txBody>
+          <a:bodyPr wrap="square" lIns="0" rIns="0" tIns="0" bIns="0" anchor="ctr">
+            <a:spAutoFit/>
+          </a:bodyPr>
+          <a:lstStyle/>
+          <a:p>
+            <a:pPr algn="ctr">
+              <a:spcBef>
+                <a:spcPts val="0"/>
+              </a:spcBef>
+              <a:spcAft>
+                <a:spcPts val="0"/>
+              </a:spcAft>
+            </a:pPr>
+            <a:r>
+              <a:rPr sz="900" b="1">
+                <a:solidFill>
+                  <a:srgbClr val="FFFFFF"/>
+                </a:solidFill>
+                <a:latin typeface="Microsoft YaHei"/>
+              </a:rPr>
+              <a:t>已完成</a:t>
+            </a:r>
+          </a:p>
+        </p:txBody>
+      </p:sp>
+      <p:sp>
+        <p:nvSpPr>
+          <p:cNvPr id="12" name="TextBox 11"/>
+          <p:cNvSpPr txBox="1"/>
+          <p:nvPr/>
+        </p:nvSpPr>
+        <p:spPr>
+          <a:xfrm>
+            <a:off x="950976" y="2761488"/>
+            <a:ext cx="1892807" cy="347472"/>
+          </a:xfrm>
+          <a:prstGeom prst="rect">
+            <a:avLst/>
+          </a:prstGeom>
+          <a:noFill/>
+        </p:spPr>
+        <p:txBody>
+          <a:bodyPr wrap="square" lIns="0" rIns="0" tIns="0" bIns="0" anchor="t">
+            <a:spAutoFit/>
+          </a:bodyPr>
+          <a:lstStyle/>
+          <a:p>
+            <a:pPr algn="l">
+              <a:spcBef>
+                <a:spcPts val="0"/>
+              </a:spcBef>
+              <a:spcAft>
+                <a:spcPts val="0"/>
+              </a:spcAft>
+            </a:pPr>
+            <a:r>
+              <a:rPr sz="1500" b="1">
+                <a:solidFill>
+                  <a:srgbClr val="17324D"/>
+                </a:solidFill>
+                <a:latin typeface="Microsoft YaHei"/>
+              </a:rPr>
+              <a:t>现有定量基础</a:t>
+            </a:r>
+          </a:p>
+        </p:txBody>
+      </p:sp>
+      <p:sp>
+        <p:nvSpPr>
+          <p:cNvPr id="13" name="Oval 12"/>
+          <p:cNvSpPr/>
+          <p:nvPr/>
+        </p:nvSpPr>
+        <p:spPr>
+          <a:xfrm>
+            <a:off x="969264" y="3438144"/>
+            <a:ext cx="109728" cy="109728"/>
+          </a:xfrm>
+          <a:prstGeom prst="ellipse">
+            <a:avLst/>
+          </a:prstGeom>
+          <a:solidFill>
+            <a:srgbClr val="3568A8"/>
+          </a:solidFill>
+          <a:ln>
+            <a:noFill/>
+          </a:ln>
+        </p:spPr>
+        <p:style>
+          <a:lnRef idx="1">
+            <a:schemeClr val="accent1"/>
+          </a:lnRef>
+          <a:fillRef idx="3">
+            <a:schemeClr val="accent1"/>
+          </a:fillRef>
+          <a:effectRef idx="2">
+            <a:schemeClr val="accent1"/>
+          </a:effectRef>
+          <a:fontRef idx="minor">
+            <a:schemeClr val="lt1"/>
+          </a:fontRef>
+        </p:style>
+        <p:txBody>
+          <a:bodyPr rtlCol="0" anchor="ctr"/>
+          <a:lstStyle/>
+          <a:p>
+            <a:pPr algn="ctr"/>
+          </a:p>
+        </p:txBody>
+      </p:sp>
+      <p:sp>
+        <p:nvSpPr>
+          <p:cNvPr id="14" name="TextBox 13"/>
+          <p:cNvSpPr txBox="1"/>
+          <p:nvPr/>
+        </p:nvSpPr>
+        <p:spPr>
+          <a:xfrm>
+            <a:off x="1207008" y="3364992"/>
+            <a:ext cx="1618488" cy="256032"/>
+          </a:xfrm>
+          <a:prstGeom prst="rect">
+            <a:avLst/>
+          </a:prstGeom>
+          <a:noFill/>
+        </p:spPr>
+        <p:txBody>
+          <a:bodyPr wrap="square" lIns="0" rIns="0" tIns="0" bIns="0" anchor="ctr">
+            <a:spAutoFit/>
+          </a:bodyPr>
+          <a:lstStyle/>
+          <a:p>
+            <a:pPr algn="l">
+              <a:spcBef>
+                <a:spcPts val="0"/>
+              </a:spcBef>
+              <a:spcAft>
+                <a:spcPts val="0"/>
+              </a:spcAft>
+            </a:pPr>
+            <a:r>
+              <a:rPr sz="1050" b="0">
+                <a:solidFill>
+                  <a:srgbClr val="23364A"/>
+                </a:solidFill>
+                <a:latin typeface="Microsoft YaHei"/>
+              </a:rPr>
+              <a:t>60个院系文本</a:t>
+            </a:r>
+          </a:p>
+        </p:txBody>
+      </p:sp>
+      <p:sp>
+        <p:nvSpPr>
+          <p:cNvPr id="15" name="Oval 14"/>
+          <p:cNvSpPr/>
+          <p:nvPr/>
+        </p:nvSpPr>
+        <p:spPr>
+          <a:xfrm>
+            <a:off x="969264" y="3877056"/>
+            <a:ext cx="109728" cy="109728"/>
+          </a:xfrm>
+          <a:prstGeom prst="ellipse">
+            <a:avLst/>
+          </a:prstGeom>
+          <a:solidFill>
+            <a:srgbClr val="3568A8"/>
+          </a:solidFill>
+          <a:ln>
+            <a:noFill/>
+          </a:ln>
+        </p:spPr>
+        <p:style>
+          <a:lnRef idx="1">
+            <a:schemeClr val="accent1"/>
+          </a:lnRef>
+          <a:fillRef idx="3">
+            <a:schemeClr val="accent1"/>
+          </a:fillRef>
+          <a:effectRef idx="2">
+            <a:schemeClr val="accent1"/>
+          </a:effectRef>
+          <a:fontRef idx="minor">
+            <a:schemeClr val="lt1"/>
+          </a:fontRef>
+        </p:style>
+        <p:txBody>
+          <a:bodyPr rtlCol="0" anchor="ctr"/>
+          <a:lstStyle/>
+          <a:p>
+            <a:pPr algn="ctr"/>
+          </a:p>
+        </p:txBody>
+      </p:sp>
+      <p:sp>
+        <p:nvSpPr>
+          <p:cNvPr id="16" name="TextBox 15"/>
+          <p:cNvSpPr txBox="1"/>
+          <p:nvPr/>
+        </p:nvSpPr>
+        <p:spPr>
+          <a:xfrm>
+            <a:off x="1207008" y="3803904"/>
+            <a:ext cx="1618488" cy="256032"/>
+          </a:xfrm>
+          <a:prstGeom prst="rect">
+            <a:avLst/>
+          </a:prstGeom>
+          <a:noFill/>
+        </p:spPr>
+        <p:txBody>
+          <a:bodyPr wrap="square" lIns="0" rIns="0" tIns="0" bIns="0" anchor="ctr">
+            <a:spAutoFit/>
+          </a:bodyPr>
+          <a:lstStyle/>
+          <a:p>
+            <a:pPr algn="l">
+              <a:spcBef>
+                <a:spcPts val="0"/>
+              </a:spcBef>
+              <a:spcAft>
+                <a:spcPts val="0"/>
+              </a:spcAft>
+            </a:pPr>
+            <a:r>
+              <a:rPr sz="1050" b="0">
+                <a:solidFill>
+                  <a:srgbClr val="23364A"/>
+                </a:solidFill>
+                <a:latin typeface="Microsoft YaHei"/>
+              </a:rPr>
+              <a:t>10个核心语步</a:t>
+            </a:r>
+          </a:p>
+        </p:txBody>
+      </p:sp>
+      <p:sp>
+        <p:nvSpPr>
+          <p:cNvPr id="17" name="Oval 16"/>
+          <p:cNvSpPr/>
+          <p:nvPr/>
+        </p:nvSpPr>
+        <p:spPr>
+          <a:xfrm>
+            <a:off x="969264" y="4315968"/>
+            <a:ext cx="109728" cy="109728"/>
+          </a:xfrm>
+          <a:prstGeom prst="ellipse">
+            <a:avLst/>
+          </a:prstGeom>
+          <a:solidFill>
+            <a:srgbClr val="3568A8"/>
+          </a:solidFill>
+          <a:ln>
+            <a:noFill/>
+          </a:ln>
+        </p:spPr>
+        <p:style>
+          <a:lnRef idx="1">
+            <a:schemeClr val="accent1"/>
+          </a:lnRef>
+          <a:fillRef idx="3">
+            <a:schemeClr val="accent1"/>
+          </a:fillRef>
+          <a:effectRef idx="2">
+            <a:schemeClr val="accent1"/>
+          </a:effectRef>
+          <a:fontRef idx="minor">
+            <a:schemeClr val="lt1"/>
+          </a:fontRef>
+        </p:style>
+        <p:txBody>
+          <a:bodyPr rtlCol="0" anchor="ctr"/>
+          <a:lstStyle/>
+          <a:p>
+            <a:pPr algn="ctr"/>
+          </a:p>
+        </p:txBody>
+      </p:sp>
+      <p:sp>
+        <p:nvSpPr>
+          <p:cNvPr id="18" name="TextBox 17"/>
+          <p:cNvSpPr txBox="1"/>
+          <p:nvPr/>
+        </p:nvSpPr>
+        <p:spPr>
+          <a:xfrm>
+            <a:off x="1207008" y="4242816"/>
+            <a:ext cx="1618488" cy="256032"/>
+          </a:xfrm>
+          <a:prstGeom prst="rect">
+            <a:avLst/>
+          </a:prstGeom>
+          <a:noFill/>
+        </p:spPr>
+        <p:txBody>
+          <a:bodyPr wrap="square" lIns="0" rIns="0" tIns="0" bIns="0" anchor="ctr">
+            <a:spAutoFit/>
+          </a:bodyPr>
+          <a:lstStyle/>
+          <a:p>
+            <a:pPr algn="l">
+              <a:spcBef>
+                <a:spcPts val="0"/>
+              </a:spcBef>
+              <a:spcAft>
+                <a:spcPts val="0"/>
+              </a:spcAft>
+            </a:pPr>
+            <a:r>
+              <a:rPr sz="1050" b="0">
+                <a:solidFill>
+                  <a:srgbClr val="23364A"/>
+                </a:solidFill>
+                <a:latin typeface="Microsoft YaHei"/>
+              </a:rPr>
+              <a:t>语步分布与语言实现</a:t>
+            </a:r>
+          </a:p>
+        </p:txBody>
+      </p:sp>
+      <p:cxnSp>
+        <p:nvCxnSpPr>
+          <p:cNvPr id="19" name="Connector 18"/>
+          <p:cNvCxnSpPr/>
+          <p:nvPr/>
+        </p:nvCxnSpPr>
+        <p:spPr>
+          <a:xfrm>
+            <a:off x="950976" y="4736592"/>
+            <a:ext cx="1883664" cy="0"/>
+          </a:xfrm>
+          <a:prstGeom prst="line">
+            <a:avLst/>
+          </a:prstGeom>
+          <a:ln w="10160">
+            <a:solidFill>
+              <a:srgbClr val="C9D9E9"/>
+            </a:solidFill>
+          </a:ln>
+        </p:spPr>
+        <p:style>
+          <a:lnRef idx="2">
+            <a:schemeClr val="accent1"/>
+          </a:lnRef>
+          <a:fillRef idx="0">
+            <a:schemeClr val="accent1"/>
+          </a:fillRef>
+          <a:effectRef idx="1">
+            <a:schemeClr val="accent1"/>
+          </a:effectRef>
+          <a:fontRef idx="minor">
+            <a:schemeClr val="tx1"/>
+          </a:fontRef>
+        </p:style>
+      </p:cxnSp>
+      <p:sp>
+        <p:nvSpPr>
+          <p:cNvPr id="20" name="TextBox 19"/>
+          <p:cNvSpPr txBox="1"/>
+          <p:nvPr/>
+        </p:nvSpPr>
+        <p:spPr>
+          <a:xfrm>
+            <a:off x="950976" y="4901184"/>
+            <a:ext cx="1892807" cy="237744"/>
+          </a:xfrm>
+          <a:prstGeom prst="rect">
+            <a:avLst/>
+          </a:prstGeom>
+          <a:noFill/>
+        </p:spPr>
+        <p:txBody>
+          <a:bodyPr wrap="square" lIns="0" rIns="0" tIns="0" bIns="0" anchor="t">
+            <a:spAutoFit/>
+          </a:bodyPr>
+          <a:lstStyle/>
+          <a:p>
+            <a:pPr algn="l">
+              <a:spcBef>
+                <a:spcPts val="0"/>
+              </a:spcBef>
+              <a:spcAft>
+                <a:spcPts val="0"/>
+              </a:spcAft>
+            </a:pPr>
+            <a:r>
+              <a:rPr sz="950" b="1">
+                <a:solidFill>
+                  <a:srgbClr val="3568A8"/>
+                </a:solidFill>
+                <a:latin typeface="Microsoft YaHei"/>
+              </a:rPr>
+              <a:t>提供可解释的文本证据</a:t>
+            </a:r>
+          </a:p>
+        </p:txBody>
+      </p:sp>
+      <p:sp>
+        <p:nvSpPr>
+          <p:cNvPr id="21" name="Rounded Rectangle 20"/>
+          <p:cNvSpPr/>
+          <p:nvPr/>
+        </p:nvSpPr>
+        <p:spPr>
+          <a:xfrm>
+            <a:off x="3456432" y="2103120"/>
+            <a:ext cx="3401568" cy="3182112"/>
+          </a:xfrm>
+          <a:prstGeom prst="roundRect">
+            <a:avLst/>
+          </a:prstGeom>
+          <a:solidFill>
+            <a:srgbClr val="FFFFFF"/>
+          </a:solidFill>
+          <a:ln w="12700">
+            <a:solidFill>
+              <a:srgbClr val="2B7A78"/>
+            </a:solidFill>
+          </a:ln>
+        </p:spPr>
+        <p:style>
+          <a:lnRef idx="1">
+            <a:schemeClr val="accent1"/>
+          </a:lnRef>
+          <a:fillRef idx="3">
+            <a:schemeClr val="accent1"/>
+          </a:fillRef>
+          <a:effectRef idx="2">
+            <a:schemeClr val="accent1"/>
+          </a:effectRef>
+          <a:fontRef idx="minor">
+            <a:schemeClr val="lt1"/>
+          </a:fontRef>
+        </p:style>
+        <p:txBody>
+          <a:bodyPr rtlCol="0" anchor="ctr"/>
+          <a:lstStyle/>
+          <a:p>
+            <a:pPr algn="ctr"/>
+          </a:p>
+        </p:txBody>
+      </p:sp>
+      <p:sp>
+        <p:nvSpPr>
+          <p:cNvPr id="22" name="Rectangle 21"/>
+          <p:cNvSpPr/>
+          <p:nvPr/>
+        </p:nvSpPr>
+        <p:spPr>
+          <a:xfrm>
+            <a:off x="3456432" y="2103120"/>
+            <a:ext cx="3401568" cy="64008"/>
+          </a:xfrm>
+          <a:prstGeom prst="rect">
+            <a:avLst/>
+          </a:prstGeom>
+          <a:solidFill>
+            <a:srgbClr val="2B7A78"/>
+          </a:solidFill>
+          <a:ln>
+            <a:noFill/>
+          </a:ln>
+        </p:spPr>
+        <p:style>
+          <a:lnRef idx="1">
+            <a:schemeClr val="accent1"/>
+          </a:lnRef>
+          <a:fillRef idx="3">
+            <a:schemeClr val="accent1"/>
+          </a:fillRef>
+          <a:effectRef idx="2">
+            <a:schemeClr val="accent1"/>
+          </a:effectRef>
+          <a:fontRef idx="minor">
+            <a:schemeClr val="lt1"/>
+          </a:fontRef>
+        </p:style>
+        <p:txBody>
+          <a:bodyPr rtlCol="0" anchor="ctr"/>
+          <a:lstStyle/>
+          <a:p>
+            <a:pPr algn="ctr"/>
+          </a:p>
+        </p:txBody>
+      </p:sp>
+      <p:sp>
+        <p:nvSpPr>
+          <p:cNvPr id="23" name="TextBox 22"/>
+          <p:cNvSpPr txBox="1"/>
+          <p:nvPr/>
+        </p:nvSpPr>
+        <p:spPr>
+          <a:xfrm>
+            <a:off x="3675887" y="2359152"/>
+            <a:ext cx="2962656" cy="347472"/>
+          </a:xfrm>
+          <a:prstGeom prst="rect">
+            <a:avLst/>
+          </a:prstGeom>
+          <a:noFill/>
+        </p:spPr>
+        <p:txBody>
+          <a:bodyPr wrap="square" lIns="0" rIns="0" tIns="0" bIns="0" anchor="t">
+            <a:spAutoFit/>
+          </a:bodyPr>
+          <a:lstStyle/>
+          <a:p>
+            <a:pPr algn="l">
+              <a:spcBef>
+                <a:spcPts val="0"/>
+              </a:spcBef>
+              <a:spcAft>
+                <a:spcPts val="0"/>
+              </a:spcAft>
+            </a:pPr>
+            <a:r>
+              <a:rPr sz="1500" b="1">
+                <a:solidFill>
+                  <a:srgbClr val="17324D"/>
+                </a:solidFill>
+                <a:latin typeface="Microsoft YaHei"/>
+              </a:rPr>
+              <a:t>01　质性解释</a:t>
+            </a:r>
+          </a:p>
+        </p:txBody>
+      </p:sp>
+      <p:sp>
+        <p:nvSpPr>
+          <p:cNvPr id="24" name="TextBox 23"/>
+          <p:cNvSpPr txBox="1"/>
+          <p:nvPr/>
+        </p:nvSpPr>
+        <p:spPr>
+          <a:xfrm>
+            <a:off x="3675887" y="2770632"/>
+            <a:ext cx="2962656" cy="256032"/>
+          </a:xfrm>
+          <a:prstGeom prst="rect">
+            <a:avLst/>
+          </a:prstGeom>
+          <a:noFill/>
+        </p:spPr>
+        <p:txBody>
+          <a:bodyPr wrap="square" lIns="0" rIns="0" tIns="0" bIns="0" anchor="t">
+            <a:spAutoFit/>
+          </a:bodyPr>
+          <a:lstStyle/>
+          <a:p>
+            <a:pPr algn="l">
+              <a:spcBef>
+                <a:spcPts val="0"/>
+              </a:spcBef>
+              <a:spcAft>
+                <a:spcPts val="0"/>
+              </a:spcAft>
+            </a:pPr>
+            <a:r>
+              <a:rPr sz="1000" b="0">
+                <a:solidFill>
+                  <a:srgbClr val="62748A"/>
+                </a:solidFill>
+                <a:latin typeface="Microsoft YaHei"/>
+              </a:rPr>
+              <a:t>结合典型文本与语境例证</a:t>
+            </a:r>
+          </a:p>
+        </p:txBody>
+      </p:sp>
+      <p:sp>
+        <p:nvSpPr>
+          <p:cNvPr id="25" name="Rounded Rectangle 24"/>
+          <p:cNvSpPr/>
+          <p:nvPr/>
+        </p:nvSpPr>
+        <p:spPr>
+          <a:xfrm>
+            <a:off x="3675887" y="3182112"/>
+            <a:ext cx="2962656" cy="347472"/>
+          </a:xfrm>
+          <a:prstGeom prst="roundRect">
+            <a:avLst/>
+          </a:prstGeom>
+          <a:solidFill>
+            <a:srgbClr val="E8F4F2"/>
+          </a:solidFill>
+          <a:ln>
+            <a:noFill/>
+          </a:ln>
+        </p:spPr>
+        <p:style>
+          <a:lnRef idx="1">
+            <a:schemeClr val="accent1"/>
+          </a:lnRef>
+          <a:fillRef idx="3">
+            <a:schemeClr val="accent1"/>
+          </a:fillRef>
+          <a:effectRef idx="2">
+            <a:schemeClr val="accent1"/>
+          </a:effectRef>
+          <a:fontRef idx="minor">
+            <a:schemeClr val="lt1"/>
+          </a:fontRef>
+        </p:style>
+        <p:txBody>
+          <a:bodyPr rtlCol="0" anchor="ctr"/>
+          <a:lstStyle/>
+          <a:p>
+            <a:pPr algn="ctr"/>
+          </a:p>
+        </p:txBody>
+      </p:sp>
+      <p:sp>
+        <p:nvSpPr>
+          <p:cNvPr id="26" name="TextBox 25"/>
+          <p:cNvSpPr txBox="1"/>
+          <p:nvPr/>
+        </p:nvSpPr>
+        <p:spPr>
+          <a:xfrm>
+            <a:off x="3675887" y="3182112"/>
+            <a:ext cx="2962656" cy="347472"/>
+          </a:xfrm>
+          <a:prstGeom prst="rect">
+            <a:avLst/>
+          </a:prstGeom>
+          <a:noFill/>
+        </p:spPr>
+        <p:txBody>
+          <a:bodyPr wrap="square" lIns="0" rIns="0" tIns="0" bIns="0" anchor="ctr">
+            <a:spAutoFit/>
+          </a:bodyPr>
+          <a:lstStyle/>
+          <a:p>
+            <a:pPr algn="ctr">
+              <a:spcBef>
+                <a:spcPts val="0"/>
+              </a:spcBef>
+              <a:spcAft>
+                <a:spcPts val="0"/>
+              </a:spcAft>
+            </a:pPr>
+            <a:r>
+              <a:rPr sz="1050" b="1">
+                <a:solidFill>
+                  <a:srgbClr val="2B7A78"/>
+                </a:solidFill>
+                <a:latin typeface="Microsoft YaHei"/>
+              </a:rPr>
+              <a:t>跨文化话语分析</a:t>
+            </a:r>
+          </a:p>
+        </p:txBody>
+      </p:sp>
+      <p:sp>
+        <p:nvSpPr>
+          <p:cNvPr id="27" name="Rounded Rectangle 26"/>
+          <p:cNvSpPr/>
+          <p:nvPr/>
+        </p:nvSpPr>
+        <p:spPr>
+          <a:xfrm>
+            <a:off x="3675887" y="3639312"/>
+            <a:ext cx="2962656" cy="347472"/>
+          </a:xfrm>
+          <a:prstGeom prst="roundRect">
+            <a:avLst/>
+          </a:prstGeom>
+          <a:solidFill>
+            <a:srgbClr val="E8F4F2"/>
+          </a:solidFill>
+          <a:ln>
+            <a:noFill/>
+          </a:ln>
+        </p:spPr>
+        <p:style>
+          <a:lnRef idx="1">
+            <a:schemeClr val="accent1"/>
+          </a:lnRef>
+          <a:fillRef idx="3">
+            <a:schemeClr val="accent1"/>
+          </a:fillRef>
+          <a:effectRef idx="2">
+            <a:schemeClr val="accent1"/>
+          </a:effectRef>
+          <a:fontRef idx="minor">
+            <a:schemeClr val="lt1"/>
+          </a:fontRef>
+        </p:style>
+        <p:txBody>
+          <a:bodyPr rtlCol="0" anchor="ctr"/>
+          <a:lstStyle/>
+          <a:p>
+            <a:pPr algn="ctr"/>
+          </a:p>
+        </p:txBody>
+      </p:sp>
+      <p:sp>
+        <p:nvSpPr>
+          <p:cNvPr id="28" name="TextBox 27"/>
+          <p:cNvSpPr txBox="1"/>
+          <p:nvPr/>
+        </p:nvSpPr>
+        <p:spPr>
+          <a:xfrm>
+            <a:off x="3675887" y="3639312"/>
+            <a:ext cx="2962656" cy="347472"/>
+          </a:xfrm>
+          <a:prstGeom prst="rect">
+            <a:avLst/>
+          </a:prstGeom>
+          <a:noFill/>
+        </p:spPr>
+        <p:txBody>
+          <a:bodyPr wrap="square" lIns="0" rIns="0" tIns="0" bIns="0" anchor="ctr">
+            <a:spAutoFit/>
+          </a:bodyPr>
+          <a:lstStyle/>
+          <a:p>
+            <a:pPr algn="ctr">
+              <a:spcBef>
+                <a:spcPts val="0"/>
+              </a:spcBef>
+              <a:spcAft>
+                <a:spcPts val="0"/>
+              </a:spcAft>
+            </a:pPr>
+            <a:r>
+              <a:rPr sz="1050" b="1">
+                <a:solidFill>
+                  <a:srgbClr val="2B7A78"/>
+                </a:solidFill>
+                <a:latin typeface="Microsoft YaHei"/>
+              </a:rPr>
+              <a:t>批评话语分析</a:t>
+            </a:r>
+          </a:p>
+        </p:txBody>
+      </p:sp>
+      <p:sp>
+        <p:nvSpPr>
+          <p:cNvPr id="29" name="Rounded Rectangle 28"/>
+          <p:cNvSpPr/>
+          <p:nvPr/>
+        </p:nvSpPr>
+        <p:spPr>
+          <a:xfrm>
+            <a:off x="3675887" y="4096512"/>
+            <a:ext cx="2962656" cy="347472"/>
+          </a:xfrm>
+          <a:prstGeom prst="roundRect">
+            <a:avLst/>
+          </a:prstGeom>
+          <a:solidFill>
+            <a:srgbClr val="E8F4F2"/>
+          </a:solidFill>
+          <a:ln>
+            <a:noFill/>
+          </a:ln>
+        </p:spPr>
+        <p:style>
+          <a:lnRef idx="1">
+            <a:schemeClr val="accent1"/>
+          </a:lnRef>
+          <a:fillRef idx="3">
+            <a:schemeClr val="accent1"/>
+          </a:fillRef>
+          <a:effectRef idx="2">
+            <a:schemeClr val="accent1"/>
+          </a:effectRef>
+          <a:fontRef idx="minor">
+            <a:schemeClr val="lt1"/>
+          </a:fontRef>
+        </p:style>
+        <p:txBody>
+          <a:bodyPr rtlCol="0" anchor="ctr"/>
+          <a:lstStyle/>
+          <a:p>
+            <a:pPr algn="ctr"/>
+          </a:p>
+        </p:txBody>
+      </p:sp>
+      <p:sp>
+        <p:nvSpPr>
+          <p:cNvPr id="30" name="TextBox 29"/>
+          <p:cNvSpPr txBox="1"/>
+          <p:nvPr/>
+        </p:nvSpPr>
+        <p:spPr>
+          <a:xfrm>
+            <a:off x="3675887" y="4096512"/>
+            <a:ext cx="2962656" cy="347472"/>
+          </a:xfrm>
+          <a:prstGeom prst="rect">
+            <a:avLst/>
+          </a:prstGeom>
+          <a:noFill/>
+        </p:spPr>
+        <p:txBody>
+          <a:bodyPr wrap="square" lIns="0" rIns="0" tIns="0" bIns="0" anchor="ctr">
+            <a:spAutoFit/>
+          </a:bodyPr>
+          <a:lstStyle/>
+          <a:p>
+            <a:pPr algn="ctr">
+              <a:spcBef>
+                <a:spcPts val="0"/>
+              </a:spcBef>
+              <a:spcAft>
+                <a:spcPts val="0"/>
+              </a:spcAft>
+            </a:pPr>
+            <a:r>
+              <a:rPr sz="1050" b="1">
+                <a:solidFill>
+                  <a:srgbClr val="2B7A78"/>
+                </a:solidFill>
+                <a:latin typeface="Microsoft YaHei"/>
+              </a:rPr>
+              <a:t>社会文化语境解释</a:t>
+            </a:r>
+          </a:p>
+        </p:txBody>
+      </p:sp>
+      <p:sp>
+        <p:nvSpPr>
+          <p:cNvPr id="31" name="TextBox 30"/>
+          <p:cNvSpPr txBox="1"/>
+          <p:nvPr/>
+        </p:nvSpPr>
+        <p:spPr>
+          <a:xfrm>
+            <a:off x="3675887" y="4700016"/>
+            <a:ext cx="2962656" cy="411480"/>
+          </a:xfrm>
+          <a:prstGeom prst="rect">
+            <a:avLst/>
+          </a:prstGeom>
+          <a:noFill/>
+        </p:spPr>
+        <p:txBody>
+          <a:bodyPr wrap="square" lIns="0" rIns="0" tIns="0" bIns="0" anchor="t">
+            <a:spAutoFit/>
+          </a:bodyPr>
+          <a:lstStyle/>
+          <a:p>
+            <a:pPr algn="ctr">
+              <a:spcBef>
+                <a:spcPts val="0"/>
+              </a:spcBef>
+              <a:spcAft>
+                <a:spcPts val="0"/>
+              </a:spcAft>
+            </a:pPr>
+            <a:r>
+              <a:rPr sz="1000" b="0">
+                <a:solidFill>
+                  <a:srgbClr val="23364A"/>
+                </a:solidFill>
+                <a:latin typeface="Microsoft YaHei"/>
+              </a:rPr>
+              <a:t>重点解释差异背后的</a:t>
+            </a:r>
+          </a:p>
+          <a:p>
+            <a:pPr algn="ctr">
+              <a:spcBef>
+                <a:spcPts val="0"/>
+              </a:spcBef>
+              <a:spcAft>
+                <a:spcPts val="0"/>
+              </a:spcAft>
+            </a:pPr>
+            <a:r>
+              <a:rPr sz="1000" b="0">
+                <a:solidFill>
+                  <a:srgbClr val="23364A"/>
+                </a:solidFill>
+                <a:latin typeface="Microsoft YaHei"/>
+              </a:rPr>
+              <a:t>制度、政策与文化动因</a:t>
+            </a:r>
+          </a:p>
+        </p:txBody>
+      </p:sp>
+      <p:sp>
+        <p:nvSpPr>
+          <p:cNvPr id="32" name="Rounded Rectangle 31"/>
+          <p:cNvSpPr/>
+          <p:nvPr/>
+        </p:nvSpPr>
+        <p:spPr>
+          <a:xfrm>
+            <a:off x="7452360" y="2103120"/>
+            <a:ext cx="3886200" cy="3182112"/>
+          </a:xfrm>
+          <a:prstGeom prst="roundRect">
+            <a:avLst/>
+          </a:prstGeom>
+          <a:solidFill>
+            <a:srgbClr val="FFFFFF"/>
+          </a:solidFill>
+          <a:ln w="12700">
+            <a:solidFill>
+              <a:srgbClr val="E38B36"/>
+            </a:solidFill>
+          </a:ln>
+        </p:spPr>
+        <p:style>
+          <a:lnRef idx="1">
+            <a:schemeClr val="accent1"/>
+          </a:lnRef>
+          <a:fillRef idx="3">
+            <a:schemeClr val="accent1"/>
+          </a:fillRef>
+          <a:effectRef idx="2">
+            <a:schemeClr val="accent1"/>
+          </a:effectRef>
+          <a:fontRef idx="minor">
+            <a:schemeClr val="lt1"/>
+          </a:fontRef>
+        </p:style>
+        <p:txBody>
+          <a:bodyPr rtlCol="0" anchor="ctr"/>
+          <a:lstStyle/>
+          <a:p>
+            <a:pPr algn="ctr"/>
+          </a:p>
+        </p:txBody>
+      </p:sp>
+      <p:sp>
+        <p:nvSpPr>
+          <p:cNvPr id="33" name="Rectangle 32"/>
+          <p:cNvSpPr/>
+          <p:nvPr/>
+        </p:nvSpPr>
+        <p:spPr>
+          <a:xfrm>
+            <a:off x="7452360" y="2103120"/>
+            <a:ext cx="3886200" cy="64008"/>
+          </a:xfrm>
+          <a:prstGeom prst="rect">
+            <a:avLst/>
+          </a:prstGeom>
+          <a:solidFill>
+            <a:srgbClr val="E38B36"/>
+          </a:solidFill>
+          <a:ln>
+            <a:noFill/>
+          </a:ln>
+        </p:spPr>
+        <p:style>
+          <a:lnRef idx="1">
+            <a:schemeClr val="accent1"/>
+          </a:lnRef>
+          <a:fillRef idx="3">
+            <a:schemeClr val="accent1"/>
+          </a:fillRef>
+          <a:effectRef idx="2">
+            <a:schemeClr val="accent1"/>
+          </a:effectRef>
+          <a:fontRef idx="minor">
+            <a:schemeClr val="lt1"/>
+          </a:fontRef>
+        </p:style>
+        <p:txBody>
+          <a:bodyPr rtlCol="0" anchor="ctr"/>
+          <a:lstStyle/>
+          <a:p>
+            <a:pPr algn="ctr"/>
+          </a:p>
+        </p:txBody>
+      </p:sp>
+      <p:sp>
+        <p:nvSpPr>
+          <p:cNvPr id="34" name="TextBox 33"/>
+          <p:cNvSpPr txBox="1"/>
+          <p:nvPr/>
+        </p:nvSpPr>
+        <p:spPr>
+          <a:xfrm>
+            <a:off x="7680960" y="2359152"/>
+            <a:ext cx="3429000" cy="347472"/>
+          </a:xfrm>
+          <a:prstGeom prst="rect">
+            <a:avLst/>
+          </a:prstGeom>
+          <a:noFill/>
+        </p:spPr>
+        <p:txBody>
+          <a:bodyPr wrap="square" lIns="0" rIns="0" tIns="0" bIns="0" anchor="t">
+            <a:spAutoFit/>
+          </a:bodyPr>
+          <a:lstStyle/>
+          <a:p>
+            <a:pPr algn="l">
+              <a:spcBef>
+                <a:spcPts val="0"/>
+              </a:spcBef>
+              <a:spcAft>
+                <a:spcPts val="0"/>
+              </a:spcAft>
+            </a:pPr>
+            <a:r>
+              <a:rPr sz="1500" b="1">
+                <a:solidFill>
+                  <a:srgbClr val="17324D"/>
+                </a:solidFill>
+                <a:latin typeface="Microsoft YaHei"/>
+              </a:rPr>
+              <a:t>02　成果转化</a:t>
+            </a:r>
+          </a:p>
+        </p:txBody>
+      </p:sp>
+      <p:sp>
+        <p:nvSpPr>
+          <p:cNvPr id="35" name="Rounded Rectangle 34"/>
+          <p:cNvSpPr/>
+          <p:nvPr/>
+        </p:nvSpPr>
+        <p:spPr>
+          <a:xfrm>
+            <a:off x="7680960" y="2871216"/>
+            <a:ext cx="3429000" cy="896112"/>
+          </a:xfrm>
+          <a:prstGeom prst="roundRect">
+            <a:avLst/>
+          </a:prstGeom>
+          <a:solidFill>
+            <a:srgbClr val="FFF3E5"/>
+          </a:solidFill>
+          <a:ln>
+            <a:noFill/>
+          </a:ln>
+        </p:spPr>
+        <p:style>
+          <a:lnRef idx="1">
+            <a:schemeClr val="accent1"/>
+          </a:lnRef>
+          <a:fillRef idx="3">
+            <a:schemeClr val="accent1"/>
+          </a:fillRef>
+          <a:effectRef idx="2">
+            <a:schemeClr val="accent1"/>
+          </a:effectRef>
+          <a:fontRef idx="minor">
+            <a:schemeClr val="lt1"/>
+          </a:fontRef>
+        </p:style>
+        <p:txBody>
+          <a:bodyPr rtlCol="0" anchor="ctr"/>
+          <a:lstStyle/>
+          <a:p>
+            <a:pPr algn="ctr"/>
+          </a:p>
+        </p:txBody>
+      </p:sp>
+      <p:sp>
+        <p:nvSpPr>
+          <p:cNvPr id="36" name="TextBox 35"/>
+          <p:cNvSpPr txBox="1"/>
+          <p:nvPr/>
+        </p:nvSpPr>
+        <p:spPr>
+          <a:xfrm>
+            <a:off x="7882127" y="3008376"/>
+            <a:ext cx="3026664" cy="256032"/>
+          </a:xfrm>
+          <a:prstGeom prst="rect">
+            <a:avLst/>
+          </a:prstGeom>
+          <a:noFill/>
+        </p:spPr>
+        <p:txBody>
+          <a:bodyPr wrap="square" lIns="0" rIns="0" tIns="0" bIns="0" anchor="t">
+            <a:spAutoFit/>
+          </a:bodyPr>
+          <a:lstStyle/>
+          <a:p>
+            <a:pPr algn="l">
+              <a:spcBef>
+                <a:spcPts val="0"/>
+              </a:spcBef>
+              <a:spcAft>
+                <a:spcPts val="0"/>
+              </a:spcAft>
+            </a:pPr>
+            <a:r>
+              <a:rPr sz="1200" b="1">
+                <a:solidFill>
+                  <a:srgbClr val="E38B36"/>
+                </a:solidFill>
+                <a:latin typeface="Microsoft YaHei"/>
+              </a:rPr>
+              <a:t>话语策略建议库</a:t>
+            </a:r>
+          </a:p>
+        </p:txBody>
+      </p:sp>
+      <p:sp>
+        <p:nvSpPr>
+          <p:cNvPr id="37" name="TextBox 36"/>
+          <p:cNvSpPr txBox="1"/>
+          <p:nvPr/>
+        </p:nvSpPr>
+        <p:spPr>
+          <a:xfrm>
+            <a:off x="7882127" y="3310128"/>
+            <a:ext cx="3026664" cy="365760"/>
+          </a:xfrm>
+          <a:prstGeom prst="rect">
+            <a:avLst/>
+          </a:prstGeom>
+          <a:noFill/>
+        </p:spPr>
+        <p:txBody>
+          <a:bodyPr wrap="square" lIns="0" rIns="0" tIns="0" bIns="0" anchor="t">
+            <a:spAutoFit/>
+          </a:bodyPr>
+          <a:lstStyle/>
+          <a:p>
+            <a:pPr algn="l">
+              <a:spcBef>
+                <a:spcPts val="0"/>
+              </a:spcBef>
+              <a:spcAft>
+                <a:spcPts val="0"/>
+              </a:spcAft>
+            </a:pPr>
+            <a:r>
+              <a:rPr sz="950" b="0">
+                <a:solidFill>
+                  <a:srgbClr val="23364A"/>
+                </a:solidFill>
+                <a:latin typeface="Microsoft YaHei"/>
+              </a:rPr>
+              <a:t>语步组织 · 核心概念 · 国际化</a:t>
+            </a:r>
+          </a:p>
+          <a:p>
+            <a:pPr algn="l">
+              <a:spcBef>
+                <a:spcPts val="0"/>
+              </a:spcBef>
+              <a:spcAft>
+                <a:spcPts val="0"/>
+              </a:spcAft>
+            </a:pPr>
+            <a:r>
+              <a:rPr sz="950" b="0">
+                <a:solidFill>
+                  <a:srgbClr val="23364A"/>
+                </a:solidFill>
+                <a:latin typeface="Microsoft YaHei"/>
+              </a:rPr>
+              <a:t>工具性—人文性目标平衡</a:t>
+            </a:r>
+          </a:p>
+        </p:txBody>
+      </p:sp>
+      <p:sp>
+        <p:nvSpPr>
+          <p:cNvPr id="38" name="Rounded Rectangle 37"/>
+          <p:cNvSpPr/>
+          <p:nvPr/>
+        </p:nvSpPr>
+        <p:spPr>
+          <a:xfrm>
+            <a:off x="7680960" y="3995928"/>
+            <a:ext cx="3429000" cy="896112"/>
+          </a:xfrm>
+          <a:prstGeom prst="roundRect">
+            <a:avLst/>
+          </a:prstGeom>
+          <a:solidFill>
+            <a:srgbClr val="EAF1F8"/>
+          </a:solidFill>
+          <a:ln>
+            <a:noFill/>
+          </a:ln>
+        </p:spPr>
+        <p:style>
+          <a:lnRef idx="1">
+            <a:schemeClr val="accent1"/>
+          </a:lnRef>
+          <a:fillRef idx="3">
+            <a:schemeClr val="accent1"/>
+          </a:fillRef>
+          <a:effectRef idx="2">
+            <a:schemeClr val="accent1"/>
+          </a:effectRef>
+          <a:fontRef idx="minor">
+            <a:schemeClr val="lt1"/>
+          </a:fontRef>
+        </p:style>
+        <p:txBody>
+          <a:bodyPr rtlCol="0" anchor="ctr"/>
+          <a:lstStyle/>
+          <a:p>
+            <a:pPr algn="ctr"/>
+          </a:p>
+        </p:txBody>
+      </p:sp>
+      <p:sp>
+        <p:nvSpPr>
+          <p:cNvPr id="39" name="TextBox 38"/>
+          <p:cNvSpPr txBox="1"/>
+          <p:nvPr/>
+        </p:nvSpPr>
+        <p:spPr>
+          <a:xfrm>
+            <a:off x="7882127" y="4133087"/>
+            <a:ext cx="3026664" cy="256032"/>
+          </a:xfrm>
+          <a:prstGeom prst="rect">
+            <a:avLst/>
+          </a:prstGeom>
+          <a:noFill/>
+        </p:spPr>
+        <p:txBody>
+          <a:bodyPr wrap="square" lIns="0" rIns="0" tIns="0" bIns="0" anchor="t">
+            <a:spAutoFit/>
+          </a:bodyPr>
+          <a:lstStyle/>
+          <a:p>
+            <a:pPr algn="l">
+              <a:spcBef>
+                <a:spcPts val="0"/>
+              </a:spcBef>
+              <a:spcAft>
+                <a:spcPts val="0"/>
+              </a:spcAft>
+            </a:pPr>
+            <a:r>
+              <a:rPr sz="1200" b="1">
+                <a:solidFill>
+                  <a:srgbClr val="3568A8"/>
+                </a:solidFill>
+                <a:latin typeface="Microsoft YaHei"/>
+              </a:rPr>
+              <a:t>研究论文</a:t>
+            </a:r>
+          </a:p>
+        </p:txBody>
+      </p:sp>
+      <p:sp>
+        <p:nvSpPr>
+          <p:cNvPr id="40" name="TextBox 39"/>
+          <p:cNvSpPr txBox="1"/>
+          <p:nvPr/>
+        </p:nvSpPr>
+        <p:spPr>
+          <a:xfrm>
+            <a:off x="7882127" y="4434840"/>
+            <a:ext cx="3026664" cy="365760"/>
+          </a:xfrm>
+          <a:prstGeom prst="rect">
+            <a:avLst/>
+          </a:prstGeom>
+          <a:noFill/>
+        </p:spPr>
+        <p:txBody>
+          <a:bodyPr wrap="square" lIns="0" rIns="0" tIns="0" bIns="0" anchor="t">
+            <a:spAutoFit/>
+          </a:bodyPr>
+          <a:lstStyle/>
+          <a:p>
+            <a:pPr algn="l">
+              <a:spcBef>
+                <a:spcPts val="0"/>
+              </a:spcBef>
+              <a:spcAft>
+                <a:spcPts val="0"/>
+              </a:spcAft>
+            </a:pPr>
+            <a:r>
+              <a:rPr sz="950" b="0">
+                <a:solidFill>
+                  <a:srgbClr val="23364A"/>
+                </a:solidFill>
+                <a:latin typeface="Microsoft YaHei"/>
+              </a:rPr>
+              <a:t>整合定量结果与质性解释</a:t>
+            </a:r>
+          </a:p>
+          <a:p>
+            <a:pPr algn="l">
+              <a:spcBef>
+                <a:spcPts val="0"/>
+              </a:spcBef>
+              <a:spcAft>
+                <a:spcPts val="0"/>
+              </a:spcAft>
+            </a:pPr>
+            <a:r>
+              <a:rPr sz="950" b="0">
+                <a:solidFill>
+                  <a:srgbClr val="23364A"/>
+                </a:solidFill>
+                <a:latin typeface="Microsoft YaHei"/>
+              </a:rPr>
+              <a:t>完成论文撰写与修改</a:t>
+            </a:r>
+          </a:p>
+        </p:txBody>
+      </p:sp>
+      <p:sp>
+        <p:nvSpPr>
+          <p:cNvPr id="41" name="Chevron 40"/>
+          <p:cNvSpPr/>
+          <p:nvPr/>
+        </p:nvSpPr>
+        <p:spPr>
+          <a:xfrm>
+            <a:off x="3182112" y="3465576"/>
+            <a:ext cx="146304" cy="329184"/>
+          </a:xfrm>
+          <a:prstGeom prst="chevron">
+            <a:avLst/>
+          </a:prstGeom>
+          <a:solidFill>
+            <a:srgbClr val="2B7A78"/>
+          </a:solidFill>
+          <a:ln>
+            <a:noFill/>
+          </a:ln>
+        </p:spPr>
+        <p:style>
+          <a:lnRef idx="1">
+            <a:schemeClr val="accent1"/>
+          </a:lnRef>
+          <a:fillRef idx="3">
+            <a:schemeClr val="accent1"/>
+          </a:fillRef>
+          <a:effectRef idx="2">
+            <a:schemeClr val="accent1"/>
+          </a:effectRef>
+          <a:fontRef idx="minor">
+            <a:schemeClr val="lt1"/>
+          </a:fontRef>
+        </p:style>
+        <p:txBody>
+          <a:bodyPr rtlCol="0" anchor="ctr"/>
+          <a:lstStyle/>
+          <a:p>
+            <a:pPr algn="ctr"/>
+          </a:p>
+        </p:txBody>
+      </p:sp>
+      <p:sp>
+        <p:nvSpPr>
+          <p:cNvPr id="42" name="Chevron 41"/>
+          <p:cNvSpPr/>
+          <p:nvPr/>
+        </p:nvSpPr>
+        <p:spPr>
+          <a:xfrm>
+            <a:off x="7150608" y="3465576"/>
+            <a:ext cx="146304" cy="329184"/>
+          </a:xfrm>
+          <a:prstGeom prst="chevron">
+            <a:avLst/>
+          </a:prstGeom>
+          <a:solidFill>
+            <a:srgbClr val="E38B36"/>
+          </a:solidFill>
+          <a:ln>
+            <a:noFill/>
+          </a:ln>
+        </p:spPr>
+        <p:style>
+          <a:lnRef idx="1">
+            <a:schemeClr val="accent1"/>
+          </a:lnRef>
+          <a:fillRef idx="3">
+            <a:schemeClr val="accent1"/>
+          </a:fillRef>
+          <a:effectRef idx="2">
+            <a:schemeClr val="accent1"/>
+          </a:effectRef>
+          <a:fontRef idx="minor">
+            <a:schemeClr val="lt1"/>
+          </a:fontRef>
+        </p:style>
+        <p:txBody>
+          <a:bodyPr rtlCol="0" anchor="ctr"/>
+          <a:lstStyle/>
+          <a:p>
+            <a:pPr algn="ctr"/>
+          </a:p>
+        </p:txBody>
+      </p:sp>
+      <p:sp>
+        <p:nvSpPr>
+          <p:cNvPr id="43" name="Rounded Rectangle 42"/>
+          <p:cNvSpPr/>
+          <p:nvPr/>
+        </p:nvSpPr>
+        <p:spPr>
+          <a:xfrm>
+            <a:off x="731520" y="5522976"/>
+            <a:ext cx="10607040" cy="393192"/>
+          </a:xfrm>
+          <a:prstGeom prst="roundRect">
+            <a:avLst/>
+          </a:prstGeom>
+          <a:solidFill>
+            <a:srgbClr val="17324D"/>
+          </a:solidFill>
+          <a:ln>
+            <a:noFill/>
+          </a:ln>
+        </p:spPr>
+        <p:style>
+          <a:lnRef idx="1">
+            <a:schemeClr val="accent1"/>
+          </a:lnRef>
+          <a:fillRef idx="3">
+            <a:schemeClr val="accent1"/>
+          </a:fillRef>
+          <a:effectRef idx="2">
+            <a:schemeClr val="accent1"/>
+          </a:effectRef>
+          <a:fontRef idx="minor">
+            <a:schemeClr val="lt1"/>
+          </a:fontRef>
+        </p:style>
+        <p:txBody>
+          <a:bodyPr rtlCol="0" anchor="ctr"/>
+          <a:lstStyle/>
+          <a:p>
+            <a:pPr algn="ctr"/>
+          </a:p>
+        </p:txBody>
+      </p:sp>
+      <p:sp>
+        <p:nvSpPr>
+          <p:cNvPr id="44" name="TextBox 43"/>
+          <p:cNvSpPr txBox="1"/>
+          <p:nvPr/>
+        </p:nvSpPr>
+        <p:spPr>
+          <a:xfrm>
+            <a:off x="932688" y="5522976"/>
+            <a:ext cx="10204704" cy="393192"/>
+          </a:xfrm>
+          <a:prstGeom prst="rect">
+            <a:avLst/>
+          </a:prstGeom>
+          <a:noFill/>
+        </p:spPr>
+        <p:txBody>
+          <a:bodyPr wrap="square" lIns="0" rIns="0" tIns="0" bIns="0" anchor="ctr">
+            <a:spAutoFit/>
+          </a:bodyPr>
+          <a:lstStyle/>
+          <a:p>
+            <a:pPr algn="ctr">
+              <a:spcBef>
+                <a:spcPts val="0"/>
+              </a:spcBef>
+              <a:spcAft>
+                <a:spcPts val="0"/>
+              </a:spcAft>
+            </a:pPr>
+            <a:r>
+              <a:rPr sz="1100" b="1">
+                <a:solidFill>
+                  <a:srgbClr val="FFFFFF"/>
+                </a:solidFill>
+                <a:latin typeface="Microsoft YaHei"/>
+              </a:rPr>
+              <a:t>由“有何差异”推进到“为何形成、如何服务英文简介写作”</a:t>
+            </a:r>
+          </a:p>
+        </p:txBody>
+      </p:sp>
+      <p:cxnSp>
+        <p:nvCxnSpPr>
+          <p:cNvPr id="45" name="Connector 44"/>
+          <p:cNvCxnSpPr/>
+          <p:nvPr/>
+        </p:nvCxnSpPr>
+        <p:spPr>
+          <a:xfrm>
+            <a:off x="731520" y="6144768"/>
+            <a:ext cx="10744200" cy="0"/>
+          </a:xfrm>
+          <a:prstGeom prst="line">
+            <a:avLst/>
+          </a:prstGeom>
+          <a:ln w="10160">
+            <a:solidFill>
+              <a:srgbClr val="D8E1EB"/>
+            </a:solidFill>
+          </a:ln>
+        </p:spPr>
+        <p:style>
+          <a:lnRef idx="2">
+            <a:schemeClr val="accent1"/>
+          </a:lnRef>
+          <a:fillRef idx="0">
+            <a:schemeClr val="accent1"/>
+          </a:fillRef>
+          <a:effectRef idx="1">
+            <a:schemeClr val="accent1"/>
+          </a:effectRef>
+          <a:fontRef idx="minor">
+            <a:schemeClr val="tx1"/>
+          </a:fontRef>
+        </p:style>
+      </p:cxnSp>
+      <p:sp>
+        <p:nvSpPr>
+          <p:cNvPr id="46" name="TextBox 45"/>
+          <p:cNvSpPr txBox="1"/>
+          <p:nvPr/>
+        </p:nvSpPr>
+        <p:spPr>
+          <a:xfrm>
+            <a:off x="731520" y="6318504"/>
+            <a:ext cx="7772400" cy="256032"/>
+          </a:xfrm>
+          <a:prstGeom prst="rect">
+            <a:avLst/>
+          </a:prstGeom>
+          <a:noFill/>
+        </p:spPr>
+        <p:txBody>
+          <a:bodyPr wrap="square" lIns="0" rIns="0" tIns="0" bIns="0" anchor="t">
+            <a:spAutoFit/>
+          </a:bodyPr>
+          <a:lstStyle/>
+          <a:p>
+            <a:pPr algn="l">
+              <a:spcBef>
+                <a:spcPts val="0"/>
+              </a:spcBef>
+              <a:spcAft>
+                <a:spcPts val="0"/>
+              </a:spcAft>
+            </a:pPr>
+            <a:r>
+              <a:rPr sz="900" b="0">
+                <a:solidFill>
+                  <a:srgbClr val="62748A"/>
+                </a:solidFill>
+                <a:latin typeface="Microsoft YaHei"/>
+              </a:rPr>
+              <a:t>基于语料库技术的中美外语院系英文简介话语比较分析</a:t>
+            </a:r>
+          </a:p>
+        </p:txBody>
+      </p:sp>
+      <p:sp>
+        <p:nvSpPr>
+          <p:cNvPr id="47" name="TextBox 46"/>
+          <p:cNvSpPr txBox="1"/>
+          <p:nvPr/>
+        </p:nvSpPr>
+        <p:spPr>
+          <a:xfrm>
+            <a:off x="10881360" y="6318504"/>
+            <a:ext cx="594360" cy="256032"/>
+          </a:xfrm>
+          <a:prstGeom prst="rect">
+            <a:avLst/>
+          </a:prstGeom>
+          <a:noFill/>
+        </p:spPr>
+        <p:txBody>
+          <a:bodyPr wrap="square" lIns="0" rIns="0" tIns="0" bIns="0" anchor="t">
+            <a:spAutoFit/>
+          </a:bodyPr>
+          <a:lstStyle/>
+          <a:p>
+            <a:pPr algn="r">
+              <a:spcBef>
+                <a:spcPts val="0"/>
+              </a:spcBef>
+              <a:spcAft>
+                <a:spcPts val="0"/>
+              </a:spcAft>
+            </a:pPr>
+            <a:r>
+              <a:rPr sz="1000" b="0">
+                <a:solidFill>
+                  <a:srgbClr val="62748A"/>
+                </a:solidFill>
+                <a:latin typeface="Microsoft YaHei"/>
+              </a:rPr>
+              <a:t>08 / 08</a:t>
             </a:r>
           </a:p>
         </p:txBody>

</xml_diff>

<commit_message>
Add closing thanks slide
Co-authored-by: arena-agent <297053741+arena-agent@users.noreply.github.com>
</commit_message>
<xml_diff>
--- a/midterm-report/presentation/中美外语院系英文简介_5分钟汇报.pptx
+++ b/midterm-report/presentation/中美外语院系英文简介_5分钟汇报.pptx
@@ -13,6 +13,7 @@
     <p:sldId id="261" r:id="rId12"/>
     <p:sldId id="262" r:id="rId13"/>
     <p:sldId id="263" r:id="rId14"/>
+    <p:sldId id="264" r:id="rId15"/>
   </p:sldIdLst>
   <p:sldSz cx="12191695" cy="6858000" type="screen4x3"/>
   <p:notesSz cx="6858000" cy="9144000"/>
@@ -4998,7 +4999,7 @@
                 </a:solidFill>
                 <a:latin typeface="Microsoft YaHei"/>
               </a:rPr>
-              <a:t>01 / 08</a:t>
+              <a:t>01 / 09</a:t>
             </a:r>
           </a:p>
         </p:txBody>
@@ -7197,7 +7198,7 @@
                 </a:solidFill>
                 <a:latin typeface="Microsoft YaHei"/>
               </a:rPr>
-              <a:t>02 / 08</a:t>
+              <a:t>02 / 09</a:t>
             </a:r>
           </a:p>
         </p:txBody>
@@ -10095,7 +10096,7 @@
                 </a:solidFill>
                 <a:latin typeface="Microsoft YaHei"/>
               </a:rPr>
-              <a:t>03 / 08</a:t>
+              <a:t>03 / 09</a:t>
             </a:r>
           </a:p>
         </p:txBody>
@@ -12957,7 +12958,7 @@
                 </a:solidFill>
                 <a:latin typeface="Microsoft YaHei"/>
               </a:rPr>
-              <a:t>04 / 08</a:t>
+              <a:t>04 / 09</a:t>
             </a:r>
           </a:p>
         </p:txBody>
@@ -16830,7 +16831,7 @@
                 </a:solidFill>
                 <a:latin typeface="Microsoft YaHei"/>
               </a:rPr>
-              <a:t>05 / 08</a:t>
+              <a:t>05 / 09</a:t>
             </a:r>
           </a:p>
         </p:txBody>
@@ -20656,7 +20657,7 @@
                 </a:solidFill>
                 <a:latin typeface="Microsoft YaHei"/>
               </a:rPr>
-              <a:t>06 / 08</a:t>
+              <a:t>06 / 09</a:t>
             </a:r>
           </a:p>
         </p:txBody>
@@ -23313,7 +23314,7 @@
                 </a:solidFill>
                 <a:latin typeface="Microsoft YaHei"/>
               </a:rPr>
-              <a:t>07 / 08</a:t>
+              <a:t>07 / 09</a:t>
             </a:r>
           </a:p>
         </p:txBody>
@@ -25331,7 +25332,900 @@
                 </a:solidFill>
                 <a:latin typeface="Microsoft YaHei"/>
               </a:rPr>
-              <a:t>08 / 08</a:t>
+              <a:t>08 / 09</a:t>
+            </a:r>
+          </a:p>
+        </p:txBody>
+      </p:sp>
+    </p:spTree>
+  </p:cSld>
+  <p:clrMapOvr>
+    <a:masterClrMapping/>
+  </p:clrMapOvr>
+</p:sld>
+</file>
+
+<file path=ppt/slides/slide9.xml><?xml version="1.0" encoding="utf-8"?>
+<p:sld xmlns:a="http://schemas.openxmlformats.org/drawingml/2006/main" xmlns:p="http://schemas.openxmlformats.org/presentationml/2006/main" xmlns:r="http://schemas.openxmlformats.org/officeDocument/2006/relationships">
+  <p:cSld>
+    <p:spTree>
+      <p:nvGrpSpPr>
+        <p:cNvPr id="1" name=""/>
+        <p:cNvGrpSpPr/>
+        <p:nvPr/>
+      </p:nvGrpSpPr>
+      <p:grpSpPr/>
+      <p:sp>
+        <p:nvSpPr>
+          <p:cNvPr id="2" name="Rectangle 1"/>
+          <p:cNvSpPr/>
+          <p:nvPr/>
+        </p:nvSpPr>
+        <p:spPr>
+          <a:xfrm>
+            <a:off x="0" y="0"/>
+            <a:ext cx="12191695" cy="6858000"/>
+          </a:xfrm>
+          <a:prstGeom prst="rect">
+            <a:avLst/>
+          </a:prstGeom>
+          <a:solidFill>
+            <a:srgbClr val="17324D"/>
+          </a:solidFill>
+          <a:ln>
+            <a:noFill/>
+          </a:ln>
+        </p:spPr>
+        <p:style>
+          <a:lnRef idx="1">
+            <a:schemeClr val="accent1"/>
+          </a:lnRef>
+          <a:fillRef idx="3">
+            <a:schemeClr val="accent1"/>
+          </a:fillRef>
+          <a:effectRef idx="2">
+            <a:schemeClr val="accent1"/>
+          </a:effectRef>
+          <a:fontRef idx="minor">
+            <a:schemeClr val="lt1"/>
+          </a:fontRef>
+        </p:style>
+        <p:txBody>
+          <a:bodyPr rtlCol="0" anchor="ctr"/>
+          <a:lstStyle/>
+          <a:p>
+            <a:pPr algn="ctr"/>
+          </a:p>
+        </p:txBody>
+      </p:sp>
+      <p:sp>
+        <p:nvSpPr>
+          <p:cNvPr id="3" name="Rectangle 2"/>
+          <p:cNvSpPr/>
+          <p:nvPr/>
+        </p:nvSpPr>
+        <p:spPr>
+          <a:xfrm>
+            <a:off x="0" y="0"/>
+            <a:ext cx="146304" cy="6858000"/>
+          </a:xfrm>
+          <a:prstGeom prst="rect">
+            <a:avLst/>
+          </a:prstGeom>
+          <a:solidFill>
+            <a:srgbClr val="E38B36"/>
+          </a:solidFill>
+          <a:ln>
+            <a:noFill/>
+          </a:ln>
+        </p:spPr>
+        <p:style>
+          <a:lnRef idx="1">
+            <a:schemeClr val="accent1"/>
+          </a:lnRef>
+          <a:fillRef idx="3">
+            <a:schemeClr val="accent1"/>
+          </a:fillRef>
+          <a:effectRef idx="2">
+            <a:schemeClr val="accent1"/>
+          </a:effectRef>
+          <a:fontRef idx="minor">
+            <a:schemeClr val="lt1"/>
+          </a:fontRef>
+        </p:style>
+        <p:txBody>
+          <a:bodyPr rtlCol="0" anchor="ctr"/>
+          <a:lstStyle/>
+          <a:p>
+            <a:pPr algn="ctr"/>
+          </a:p>
+        </p:txBody>
+      </p:sp>
+      <p:sp>
+        <p:nvSpPr>
+          <p:cNvPr id="4" name="Rectangle 3"/>
+          <p:cNvSpPr/>
+          <p:nvPr/>
+        </p:nvSpPr>
+        <p:spPr>
+          <a:xfrm>
+            <a:off x="146304" y="0"/>
+            <a:ext cx="50292" cy="1170432"/>
+          </a:xfrm>
+          <a:prstGeom prst="rect">
+            <a:avLst/>
+          </a:prstGeom>
+          <a:solidFill>
+            <a:srgbClr val="3568A8"/>
+          </a:solidFill>
+          <a:ln>
+            <a:noFill/>
+          </a:ln>
+        </p:spPr>
+        <p:style>
+          <a:lnRef idx="1">
+            <a:schemeClr val="accent1"/>
+          </a:lnRef>
+          <a:fillRef idx="3">
+            <a:schemeClr val="accent1"/>
+          </a:fillRef>
+          <a:effectRef idx="2">
+            <a:schemeClr val="accent1"/>
+          </a:effectRef>
+          <a:fontRef idx="minor">
+            <a:schemeClr val="lt1"/>
+          </a:fontRef>
+        </p:style>
+        <p:txBody>
+          <a:bodyPr rtlCol="0" anchor="ctr"/>
+          <a:lstStyle/>
+          <a:p>
+            <a:pPr algn="ctr"/>
+          </a:p>
+        </p:txBody>
+      </p:sp>
+      <p:sp>
+        <p:nvSpPr>
+          <p:cNvPr id="5" name="TextBox 4"/>
+          <p:cNvSpPr txBox="1"/>
+          <p:nvPr/>
+        </p:nvSpPr>
+        <p:spPr>
+          <a:xfrm>
+            <a:off x="768096" y="603504"/>
+            <a:ext cx="5943600" cy="310896"/>
+          </a:xfrm>
+          <a:prstGeom prst="rect">
+            <a:avLst/>
+          </a:prstGeom>
+          <a:noFill/>
+        </p:spPr>
+        <p:txBody>
+          <a:bodyPr wrap="square" lIns="0" rIns="0" tIns="0" bIns="0" anchor="t">
+            <a:spAutoFit/>
+          </a:bodyPr>
+          <a:lstStyle/>
+          <a:p>
+            <a:pPr algn="l">
+              <a:spcBef>
+                <a:spcPts val="0"/>
+              </a:spcBef>
+              <a:spcAft>
+                <a:spcPts val="0"/>
+              </a:spcAft>
+            </a:pPr>
+            <a:r>
+              <a:rPr sz="1200" b="1">
+                <a:solidFill>
+                  <a:srgbClr val="E38B36"/>
+                </a:solidFill>
+                <a:latin typeface="Microsoft YaHei"/>
+              </a:rPr>
+              <a:t>本科生创新训练培育项目｜中期汇报</a:t>
+            </a:r>
+          </a:p>
+        </p:txBody>
+      </p:sp>
+      <p:sp>
+        <p:nvSpPr>
+          <p:cNvPr id="6" name="TextBox 5"/>
+          <p:cNvSpPr txBox="1"/>
+          <p:nvPr/>
+        </p:nvSpPr>
+        <p:spPr>
+          <a:xfrm>
+            <a:off x="768096" y="1828800"/>
+            <a:ext cx="9875520" cy="749808"/>
+          </a:xfrm>
+          <a:prstGeom prst="rect">
+            <a:avLst/>
+          </a:prstGeom>
+          <a:noFill/>
+        </p:spPr>
+        <p:txBody>
+          <a:bodyPr wrap="square" lIns="0" rIns="0" tIns="0" bIns="0" anchor="ctr">
+            <a:spAutoFit/>
+          </a:bodyPr>
+          <a:lstStyle/>
+          <a:p>
+            <a:pPr algn="l">
+              <a:spcBef>
+                <a:spcPts val="0"/>
+              </a:spcBef>
+              <a:spcAft>
+                <a:spcPts val="0"/>
+              </a:spcAft>
+            </a:pPr>
+            <a:r>
+              <a:rPr sz="3500" b="1">
+                <a:solidFill>
+                  <a:srgbClr val="FFFFFF"/>
+                </a:solidFill>
+                <a:latin typeface="Microsoft YaHei"/>
+              </a:rPr>
+              <a:t>谢谢各位评委老师</a:t>
+            </a:r>
+          </a:p>
+        </p:txBody>
+      </p:sp>
+      <p:sp>
+        <p:nvSpPr>
+          <p:cNvPr id="7" name="TextBox 6"/>
+          <p:cNvSpPr txBox="1"/>
+          <p:nvPr/>
+        </p:nvSpPr>
+        <p:spPr>
+          <a:xfrm>
+            <a:off x="786384" y="2770632"/>
+            <a:ext cx="5486400" cy="438912"/>
+          </a:xfrm>
+          <a:prstGeom prst="rect">
+            <a:avLst/>
+          </a:prstGeom>
+          <a:noFill/>
+        </p:spPr>
+        <p:txBody>
+          <a:bodyPr wrap="square" lIns="0" rIns="0" tIns="0" bIns="0" anchor="ctr">
+            <a:spAutoFit/>
+          </a:bodyPr>
+          <a:lstStyle/>
+          <a:p>
+            <a:pPr algn="l">
+              <a:spcBef>
+                <a:spcPts val="0"/>
+              </a:spcBef>
+              <a:spcAft>
+                <a:spcPts val="0"/>
+              </a:spcAft>
+            </a:pPr>
+            <a:r>
+              <a:rPr sz="1900" b="0">
+                <a:solidFill>
+                  <a:srgbClr val="D8E1EB"/>
+                </a:solidFill>
+                <a:latin typeface="Microsoft YaHei"/>
+              </a:rPr>
+              <a:t>恳请批评指正</a:t>
+            </a:r>
+          </a:p>
+        </p:txBody>
+      </p:sp>
+      <p:sp>
+        <p:nvSpPr>
+          <p:cNvPr id="8" name="Rectangle 7"/>
+          <p:cNvSpPr/>
+          <p:nvPr/>
+        </p:nvSpPr>
+        <p:spPr>
+          <a:xfrm>
+            <a:off x="786384" y="3493008"/>
+            <a:ext cx="713232" cy="45720"/>
+          </a:xfrm>
+          <a:prstGeom prst="rect">
+            <a:avLst/>
+          </a:prstGeom>
+          <a:solidFill>
+            <a:srgbClr val="E38B36"/>
+          </a:solidFill>
+          <a:ln>
+            <a:noFill/>
+          </a:ln>
+        </p:spPr>
+        <p:style>
+          <a:lnRef idx="1">
+            <a:schemeClr val="accent1"/>
+          </a:lnRef>
+          <a:fillRef idx="3">
+            <a:schemeClr val="accent1"/>
+          </a:fillRef>
+          <a:effectRef idx="2">
+            <a:schemeClr val="accent1"/>
+          </a:effectRef>
+          <a:fontRef idx="minor">
+            <a:schemeClr val="lt1"/>
+          </a:fontRef>
+        </p:style>
+        <p:txBody>
+          <a:bodyPr rtlCol="0" anchor="ctr"/>
+          <a:lstStyle/>
+          <a:p>
+            <a:pPr algn="ctr"/>
+          </a:p>
+        </p:txBody>
+      </p:sp>
+      <p:sp>
+        <p:nvSpPr>
+          <p:cNvPr id="9" name="TextBox 8"/>
+          <p:cNvSpPr txBox="1"/>
+          <p:nvPr/>
+        </p:nvSpPr>
+        <p:spPr>
+          <a:xfrm>
+            <a:off x="786384" y="3913632"/>
+            <a:ext cx="9875520" cy="384048"/>
+          </a:xfrm>
+          <a:prstGeom prst="rect">
+            <a:avLst/>
+          </a:prstGeom>
+          <a:noFill/>
+        </p:spPr>
+        <p:txBody>
+          <a:bodyPr wrap="square" lIns="0" rIns="0" tIns="0" bIns="0" anchor="ctr">
+            <a:spAutoFit/>
+          </a:bodyPr>
+          <a:lstStyle/>
+          <a:p>
+            <a:pPr algn="l">
+              <a:spcBef>
+                <a:spcPts val="0"/>
+              </a:spcBef>
+              <a:spcAft>
+                <a:spcPts val="0"/>
+              </a:spcAft>
+            </a:pPr>
+            <a:r>
+              <a:rPr sz="1300" b="0">
+                <a:solidFill>
+                  <a:srgbClr val="D8E1EB"/>
+                </a:solidFill>
+                <a:latin typeface="Microsoft YaHei"/>
+              </a:rPr>
+              <a:t>基于语料库技术的中美外语院系英文简介话语比较分析</a:t>
+            </a:r>
+          </a:p>
+        </p:txBody>
+      </p:sp>
+      <p:cxnSp>
+        <p:nvCxnSpPr>
+          <p:cNvPr id="10" name="Connector 9"/>
+          <p:cNvCxnSpPr/>
+          <p:nvPr/>
+        </p:nvCxnSpPr>
+        <p:spPr>
+          <a:xfrm>
+            <a:off x="9052560" y="1280160"/>
+            <a:ext cx="0" cy="3950208"/>
+          </a:xfrm>
+          <a:prstGeom prst="line">
+            <a:avLst/>
+          </a:prstGeom>
+          <a:ln w="12700">
+            <a:solidFill>
+              <a:srgbClr val="456078"/>
+            </a:solidFill>
+          </a:ln>
+        </p:spPr>
+        <p:style>
+          <a:lnRef idx="2">
+            <a:schemeClr val="accent1"/>
+          </a:lnRef>
+          <a:fillRef idx="0">
+            <a:schemeClr val="accent1"/>
+          </a:fillRef>
+          <a:effectRef idx="1">
+            <a:schemeClr val="accent1"/>
+          </a:effectRef>
+          <a:fontRef idx="minor">
+            <a:schemeClr val="tx1"/>
+          </a:fontRef>
+        </p:style>
+      </p:cxnSp>
+      <p:sp>
+        <p:nvSpPr>
+          <p:cNvPr id="11" name="Oval 10"/>
+          <p:cNvSpPr/>
+          <p:nvPr/>
+        </p:nvSpPr>
+        <p:spPr>
+          <a:xfrm>
+            <a:off x="9381744" y="1591056"/>
+            <a:ext cx="475488" cy="475488"/>
+          </a:xfrm>
+          <a:prstGeom prst="ellipse">
+            <a:avLst/>
+          </a:prstGeom>
+          <a:solidFill>
+            <a:srgbClr val="3568A8"/>
+          </a:solidFill>
+          <a:ln>
+            <a:noFill/>
+          </a:ln>
+        </p:spPr>
+        <p:style>
+          <a:lnRef idx="1">
+            <a:schemeClr val="accent1"/>
+          </a:lnRef>
+          <a:fillRef idx="3">
+            <a:schemeClr val="accent1"/>
+          </a:fillRef>
+          <a:effectRef idx="2">
+            <a:schemeClr val="accent1"/>
+          </a:effectRef>
+          <a:fontRef idx="minor">
+            <a:schemeClr val="lt1"/>
+          </a:fontRef>
+        </p:style>
+        <p:txBody>
+          <a:bodyPr rtlCol="0" anchor="ctr"/>
+          <a:lstStyle/>
+          <a:p>
+            <a:pPr algn="ctr"/>
+          </a:p>
+        </p:txBody>
+      </p:sp>
+      <p:sp>
+        <p:nvSpPr>
+          <p:cNvPr id="12" name="TextBox 11"/>
+          <p:cNvSpPr txBox="1"/>
+          <p:nvPr/>
+        </p:nvSpPr>
+        <p:spPr>
+          <a:xfrm>
+            <a:off x="9381744" y="1591056"/>
+            <a:ext cx="475488" cy="475488"/>
+          </a:xfrm>
+          <a:prstGeom prst="rect">
+            <a:avLst/>
+          </a:prstGeom>
+          <a:noFill/>
+        </p:spPr>
+        <p:txBody>
+          <a:bodyPr wrap="square" lIns="0" rIns="0" tIns="0" bIns="0" anchor="ctr">
+            <a:spAutoFit/>
+          </a:bodyPr>
+          <a:lstStyle/>
+          <a:p>
+            <a:pPr algn="ctr">
+              <a:spcBef>
+                <a:spcPts val="0"/>
+              </a:spcBef>
+              <a:spcAft>
+                <a:spcPts val="0"/>
+              </a:spcAft>
+            </a:pPr>
+            <a:r>
+              <a:rPr sz="1100" b="1">
+                <a:solidFill>
+                  <a:srgbClr val="FFFFFF"/>
+                </a:solidFill>
+                <a:latin typeface="Microsoft YaHei"/>
+              </a:rPr>
+              <a:t>01</a:t>
+            </a:r>
+          </a:p>
+        </p:txBody>
+      </p:sp>
+      <p:sp>
+        <p:nvSpPr>
+          <p:cNvPr id="13" name="TextBox 12"/>
+          <p:cNvSpPr txBox="1"/>
+          <p:nvPr/>
+        </p:nvSpPr>
+        <p:spPr>
+          <a:xfrm>
+            <a:off x="10076688" y="1627632"/>
+            <a:ext cx="1325880" cy="402336"/>
+          </a:xfrm>
+          <a:prstGeom prst="rect">
+            <a:avLst/>
+          </a:prstGeom>
+          <a:noFill/>
+        </p:spPr>
+        <p:txBody>
+          <a:bodyPr wrap="square" lIns="0" rIns="0" tIns="0" bIns="0" anchor="ctr">
+            <a:spAutoFit/>
+          </a:bodyPr>
+          <a:lstStyle/>
+          <a:p>
+            <a:pPr algn="l">
+              <a:spcBef>
+                <a:spcPts val="0"/>
+              </a:spcBef>
+              <a:spcAft>
+                <a:spcPts val="0"/>
+              </a:spcAft>
+            </a:pPr>
+            <a:r>
+              <a:rPr sz="1300" b="1">
+                <a:solidFill>
+                  <a:srgbClr val="FFFFFF"/>
+                </a:solidFill>
+                <a:latin typeface="Microsoft YaHei"/>
+              </a:rPr>
+              <a:t>语步分布</a:t>
+            </a:r>
+          </a:p>
+        </p:txBody>
+      </p:sp>
+      <p:sp>
+        <p:nvSpPr>
+          <p:cNvPr id="14" name="Oval 13"/>
+          <p:cNvSpPr/>
+          <p:nvPr/>
+        </p:nvSpPr>
+        <p:spPr>
+          <a:xfrm>
+            <a:off x="9381744" y="2761488"/>
+            <a:ext cx="475488" cy="475488"/>
+          </a:xfrm>
+          <a:prstGeom prst="ellipse">
+            <a:avLst/>
+          </a:prstGeom>
+          <a:solidFill>
+            <a:srgbClr val="2B7A78"/>
+          </a:solidFill>
+          <a:ln>
+            <a:noFill/>
+          </a:ln>
+        </p:spPr>
+        <p:style>
+          <a:lnRef idx="1">
+            <a:schemeClr val="accent1"/>
+          </a:lnRef>
+          <a:fillRef idx="3">
+            <a:schemeClr val="accent1"/>
+          </a:fillRef>
+          <a:effectRef idx="2">
+            <a:schemeClr val="accent1"/>
+          </a:effectRef>
+          <a:fontRef idx="minor">
+            <a:schemeClr val="lt1"/>
+          </a:fontRef>
+        </p:style>
+        <p:txBody>
+          <a:bodyPr rtlCol="0" anchor="ctr"/>
+          <a:lstStyle/>
+          <a:p>
+            <a:pPr algn="ctr"/>
+          </a:p>
+        </p:txBody>
+      </p:sp>
+      <p:sp>
+        <p:nvSpPr>
+          <p:cNvPr id="15" name="TextBox 14"/>
+          <p:cNvSpPr txBox="1"/>
+          <p:nvPr/>
+        </p:nvSpPr>
+        <p:spPr>
+          <a:xfrm>
+            <a:off x="9381744" y="2761488"/>
+            <a:ext cx="475488" cy="475488"/>
+          </a:xfrm>
+          <a:prstGeom prst="rect">
+            <a:avLst/>
+          </a:prstGeom>
+          <a:noFill/>
+        </p:spPr>
+        <p:txBody>
+          <a:bodyPr wrap="square" lIns="0" rIns="0" tIns="0" bIns="0" anchor="ctr">
+            <a:spAutoFit/>
+          </a:bodyPr>
+          <a:lstStyle/>
+          <a:p>
+            <a:pPr algn="ctr">
+              <a:spcBef>
+                <a:spcPts val="0"/>
+              </a:spcBef>
+              <a:spcAft>
+                <a:spcPts val="0"/>
+              </a:spcAft>
+            </a:pPr>
+            <a:r>
+              <a:rPr sz="1100" b="1">
+                <a:solidFill>
+                  <a:srgbClr val="FFFFFF"/>
+                </a:solidFill>
+                <a:latin typeface="Microsoft YaHei"/>
+              </a:rPr>
+              <a:t>02</a:t>
+            </a:r>
+          </a:p>
+        </p:txBody>
+      </p:sp>
+      <p:sp>
+        <p:nvSpPr>
+          <p:cNvPr id="16" name="TextBox 15"/>
+          <p:cNvSpPr txBox="1"/>
+          <p:nvPr/>
+        </p:nvSpPr>
+        <p:spPr>
+          <a:xfrm>
+            <a:off x="10076688" y="2798064"/>
+            <a:ext cx="1325880" cy="402336"/>
+          </a:xfrm>
+          <a:prstGeom prst="rect">
+            <a:avLst/>
+          </a:prstGeom>
+          <a:noFill/>
+        </p:spPr>
+        <p:txBody>
+          <a:bodyPr wrap="square" lIns="0" rIns="0" tIns="0" bIns="0" anchor="ctr">
+            <a:spAutoFit/>
+          </a:bodyPr>
+          <a:lstStyle/>
+          <a:p>
+            <a:pPr algn="l">
+              <a:spcBef>
+                <a:spcPts val="0"/>
+              </a:spcBef>
+              <a:spcAft>
+                <a:spcPts val="0"/>
+              </a:spcAft>
+            </a:pPr>
+            <a:r>
+              <a:rPr sz="1300" b="1">
+                <a:solidFill>
+                  <a:srgbClr val="FFFFFF"/>
+                </a:solidFill>
+                <a:latin typeface="Microsoft YaHei"/>
+              </a:rPr>
+              <a:t>语言实现</a:t>
+            </a:r>
+          </a:p>
+        </p:txBody>
+      </p:sp>
+      <p:sp>
+        <p:nvSpPr>
+          <p:cNvPr id="17" name="Oval 16"/>
+          <p:cNvSpPr/>
+          <p:nvPr/>
+        </p:nvSpPr>
+        <p:spPr>
+          <a:xfrm>
+            <a:off x="9381744" y="3931920"/>
+            <a:ext cx="475488" cy="475488"/>
+          </a:xfrm>
+          <a:prstGeom prst="ellipse">
+            <a:avLst/>
+          </a:prstGeom>
+          <a:solidFill>
+            <a:srgbClr val="E38B36"/>
+          </a:solidFill>
+          <a:ln>
+            <a:noFill/>
+          </a:ln>
+        </p:spPr>
+        <p:style>
+          <a:lnRef idx="1">
+            <a:schemeClr val="accent1"/>
+          </a:lnRef>
+          <a:fillRef idx="3">
+            <a:schemeClr val="accent1"/>
+          </a:fillRef>
+          <a:effectRef idx="2">
+            <a:schemeClr val="accent1"/>
+          </a:effectRef>
+          <a:fontRef idx="minor">
+            <a:schemeClr val="lt1"/>
+          </a:fontRef>
+        </p:style>
+        <p:txBody>
+          <a:bodyPr rtlCol="0" anchor="ctr"/>
+          <a:lstStyle/>
+          <a:p>
+            <a:pPr algn="ctr"/>
+          </a:p>
+        </p:txBody>
+      </p:sp>
+      <p:sp>
+        <p:nvSpPr>
+          <p:cNvPr id="18" name="TextBox 17"/>
+          <p:cNvSpPr txBox="1"/>
+          <p:nvPr/>
+        </p:nvSpPr>
+        <p:spPr>
+          <a:xfrm>
+            <a:off x="9381744" y="3931920"/>
+            <a:ext cx="475488" cy="475488"/>
+          </a:xfrm>
+          <a:prstGeom prst="rect">
+            <a:avLst/>
+          </a:prstGeom>
+          <a:noFill/>
+        </p:spPr>
+        <p:txBody>
+          <a:bodyPr wrap="square" lIns="0" rIns="0" tIns="0" bIns="0" anchor="ctr">
+            <a:spAutoFit/>
+          </a:bodyPr>
+          <a:lstStyle/>
+          <a:p>
+            <a:pPr algn="ctr">
+              <a:spcBef>
+                <a:spcPts val="0"/>
+              </a:spcBef>
+              <a:spcAft>
+                <a:spcPts val="0"/>
+              </a:spcAft>
+            </a:pPr>
+            <a:r>
+              <a:rPr sz="1100" b="1">
+                <a:solidFill>
+                  <a:srgbClr val="FFFFFF"/>
+                </a:solidFill>
+                <a:latin typeface="Microsoft YaHei"/>
+              </a:rPr>
+              <a:t>03</a:t>
+            </a:r>
+          </a:p>
+        </p:txBody>
+      </p:sp>
+      <p:sp>
+        <p:nvSpPr>
+          <p:cNvPr id="19" name="TextBox 18"/>
+          <p:cNvSpPr txBox="1"/>
+          <p:nvPr/>
+        </p:nvSpPr>
+        <p:spPr>
+          <a:xfrm>
+            <a:off x="10076688" y="3968496"/>
+            <a:ext cx="1325880" cy="402336"/>
+          </a:xfrm>
+          <a:prstGeom prst="rect">
+            <a:avLst/>
+          </a:prstGeom>
+          <a:noFill/>
+        </p:spPr>
+        <p:txBody>
+          <a:bodyPr wrap="square" lIns="0" rIns="0" tIns="0" bIns="0" anchor="ctr">
+            <a:spAutoFit/>
+          </a:bodyPr>
+          <a:lstStyle/>
+          <a:p>
+            <a:pPr algn="l">
+              <a:spcBef>
+                <a:spcPts val="0"/>
+              </a:spcBef>
+              <a:spcAft>
+                <a:spcPts val="0"/>
+              </a:spcAft>
+            </a:pPr>
+            <a:r>
+              <a:rPr sz="1300" b="1">
+                <a:solidFill>
+                  <a:srgbClr val="FFFFFF"/>
+                </a:solidFill>
+                <a:latin typeface="Microsoft YaHei"/>
+              </a:rPr>
+              <a:t>语境解释</a:t>
+            </a:r>
+          </a:p>
+        </p:txBody>
+      </p:sp>
+      <p:cxnSp>
+        <p:nvCxnSpPr>
+          <p:cNvPr id="20" name="Connector 19"/>
+          <p:cNvCxnSpPr/>
+          <p:nvPr/>
+        </p:nvCxnSpPr>
+        <p:spPr>
+          <a:xfrm>
+            <a:off x="786384" y="5897880"/>
+            <a:ext cx="10625328" cy="0"/>
+          </a:xfrm>
+          <a:prstGeom prst="line">
+            <a:avLst/>
+          </a:prstGeom>
+          <a:ln w="10160">
+            <a:solidFill>
+              <a:srgbClr val="456078"/>
+            </a:solidFill>
+          </a:ln>
+        </p:spPr>
+        <p:style>
+          <a:lnRef idx="2">
+            <a:schemeClr val="accent1"/>
+          </a:lnRef>
+          <a:fillRef idx="0">
+            <a:schemeClr val="accent1"/>
+          </a:fillRef>
+          <a:effectRef idx="1">
+            <a:schemeClr val="accent1"/>
+          </a:effectRef>
+          <a:fontRef idx="minor">
+            <a:schemeClr val="tx1"/>
+          </a:fontRef>
+        </p:style>
+      </p:cxnSp>
+      <p:sp>
+        <p:nvSpPr>
+          <p:cNvPr id="21" name="TextBox 20"/>
+          <p:cNvSpPr txBox="1"/>
+          <p:nvPr/>
+        </p:nvSpPr>
+        <p:spPr>
+          <a:xfrm>
+            <a:off x="786384" y="6144768"/>
+            <a:ext cx="2743200" cy="292608"/>
+          </a:xfrm>
+          <a:prstGeom prst="rect">
+            <a:avLst/>
+          </a:prstGeom>
+          <a:noFill/>
+        </p:spPr>
+        <p:txBody>
+          <a:bodyPr wrap="square" lIns="0" rIns="0" tIns="0" bIns="0" anchor="t">
+            <a:spAutoFit/>
+          </a:bodyPr>
+          <a:lstStyle/>
+          <a:p>
+            <a:pPr algn="l">
+              <a:spcBef>
+                <a:spcPts val="0"/>
+              </a:spcBef>
+              <a:spcAft>
+                <a:spcPts val="0"/>
+              </a:spcAft>
+            </a:pPr>
+            <a:r>
+              <a:rPr sz="1200" b="1">
+                <a:solidFill>
+                  <a:srgbClr val="FFFFFF"/>
+                </a:solidFill>
+                <a:latin typeface="Microsoft YaHei"/>
+              </a:rPr>
+              <a:t>外语学院</a:t>
+            </a:r>
+          </a:p>
+        </p:txBody>
+      </p:sp>
+      <p:sp>
+        <p:nvSpPr>
+          <p:cNvPr id="22" name="TextBox 21"/>
+          <p:cNvSpPr txBox="1"/>
+          <p:nvPr/>
+        </p:nvSpPr>
+        <p:spPr>
+          <a:xfrm>
+            <a:off x="10753344" y="6144768"/>
+            <a:ext cx="658368" cy="292608"/>
+          </a:xfrm>
+          <a:prstGeom prst="rect">
+            <a:avLst/>
+          </a:prstGeom>
+          <a:noFill/>
+        </p:spPr>
+        <p:txBody>
+          <a:bodyPr wrap="square" lIns="0" rIns="0" tIns="0" bIns="0" anchor="t">
+            <a:spAutoFit/>
+          </a:bodyPr>
+          <a:lstStyle/>
+          <a:p>
+            <a:pPr algn="r">
+              <a:spcBef>
+                <a:spcPts val="0"/>
+              </a:spcBef>
+              <a:spcAft>
+                <a:spcPts val="0"/>
+              </a:spcAft>
+            </a:pPr>
+            <a:r>
+              <a:rPr sz="1000" b="0">
+                <a:solidFill>
+                  <a:srgbClr val="AAB8C6"/>
+                </a:solidFill>
+                <a:latin typeface="Microsoft YaHei"/>
+              </a:rPr>
+              <a:t>09 / 09</a:t>
             </a:r>
           </a:p>
         </p:txBody>

</xml_diff>